<commit_message>
docs: refine final report slide
</commit_message>
<xml_diff>
--- a/outputs/EGO1_Flappy_Bird_FPGA_8頁書面型PPT報告.pptx
+++ b/outputs/EGO1_Flappy_Bird_FPGA_8頁書面型PPT報告.pptx
@@ -2,20 +2,20 @@
 <file path=ppt/presentation.xml><?xml version="1.0" encoding="utf-8"?>
 <p:presentation xmlns:p="http://schemas.openxmlformats.org/presentationml/2006/main">
   <p:sldMasterIdLst>
-    <p:sldMasterId xmlns:r="http://schemas.openxmlformats.org/officeDocument/2006/relationships" id="2147483648" r:id="R5e004f9c9b774be6"/>
+    <p:sldMasterId xmlns:r="http://schemas.openxmlformats.org/officeDocument/2006/relationships" id="2147483648" r:id="Rd3a2e73c0dbb4ba1"/>
   </p:sldMasterIdLst>
   <p:notesMasterIdLst>
-    <p:notesMasterId xmlns:r="http://schemas.openxmlformats.org/officeDocument/2006/relationships" r:id="R1f13cfbca28f435d"/>
+    <p:notesMasterId xmlns:r="http://schemas.openxmlformats.org/officeDocument/2006/relationships" r:id="R1daa58ef58e34be4"/>
   </p:notesMasterIdLst>
   <p:sldIdLst>
-    <p:sldId xmlns:r="http://schemas.openxmlformats.org/officeDocument/2006/relationships" id="256" r:id="Rfcd56a3f64f3486f"/>
-    <p:sldId xmlns:r="http://schemas.openxmlformats.org/officeDocument/2006/relationships" id="257" r:id="R560b83fdeb5a40c9"/>
-    <p:sldId xmlns:r="http://schemas.openxmlformats.org/officeDocument/2006/relationships" id="258" r:id="R34244c7838f7461b"/>
-    <p:sldId xmlns:r="http://schemas.openxmlformats.org/officeDocument/2006/relationships" id="259" r:id="R910b588047854017"/>
-    <p:sldId xmlns:r="http://schemas.openxmlformats.org/officeDocument/2006/relationships" id="260" r:id="Ra6394d5c60fa4f6f"/>
-    <p:sldId xmlns:r="http://schemas.openxmlformats.org/officeDocument/2006/relationships" id="261" r:id="R29668cd5b59c4cd3"/>
-    <p:sldId xmlns:r="http://schemas.openxmlformats.org/officeDocument/2006/relationships" id="262" r:id="Re48c93496c1a4bc5"/>
-    <p:sldId xmlns:r="http://schemas.openxmlformats.org/officeDocument/2006/relationships" id="263" r:id="R4ca85f7806a74ee9"/>
+    <p:sldId xmlns:r="http://schemas.openxmlformats.org/officeDocument/2006/relationships" id="256" r:id="R80a2884de4e74103"/>
+    <p:sldId xmlns:r="http://schemas.openxmlformats.org/officeDocument/2006/relationships" id="257" r:id="R89c6cf09f30d4d39"/>
+    <p:sldId xmlns:r="http://schemas.openxmlformats.org/officeDocument/2006/relationships" id="258" r:id="Ra25e4857ca834849"/>
+    <p:sldId xmlns:r="http://schemas.openxmlformats.org/officeDocument/2006/relationships" id="259" r:id="R7bd3b9c7293f409c"/>
+    <p:sldId xmlns:r="http://schemas.openxmlformats.org/officeDocument/2006/relationships" id="260" r:id="R4cf2b7e14d6d4e64"/>
+    <p:sldId xmlns:r="http://schemas.openxmlformats.org/officeDocument/2006/relationships" id="261" r:id="R9688f6d5a66f4a58"/>
+    <p:sldId xmlns:r="http://schemas.openxmlformats.org/officeDocument/2006/relationships" id="262" r:id="Rfc5d4758c7b541c8"/>
+    <p:sldId xmlns:r="http://schemas.openxmlformats.org/officeDocument/2006/relationships" id="263" r:id="Rb744c0a4b1214c19"/>
   </p:sldIdLst>
   <p:sldSz cx="12192000" cy="6858000"/>
   <p:notesSz cx="6858000" cy="9144000"/>
@@ -1070,7 +1070,7 @@
   </p:cSld>
   <p:clrMap bg1="lt1" tx1="dk1" bg2="lt2" tx2="dk2" accent1="accent1" accent2="accent2" accent3="accent3" accent4="accent4" accent5="accent5" accent6="accent6" hlink="hlink" folHlink="folHlink"/>
   <p:sldLayoutIdLst>
-    <p:sldLayoutId xmlns:r="http://schemas.openxmlformats.org/officeDocument/2006/relationships" id="2147483649" r:id="R241739a0fba74958"/>
+    <p:sldLayoutId xmlns:r="http://schemas.openxmlformats.org/officeDocument/2006/relationships" id="2147483649" r:id="R02bfb9dd273a48e9"/>
   </p:sldLayoutIdLst>
   <p:txStyles>
     <p:titleStyle>
@@ -1621,7 +1621,7 @@
           <p:cNvPr id="17" name="">
             <a:extLst xmlns:a="http://schemas.openxmlformats.org/drawingml/2006/main">
               <a:ext uri="{FF2B5EF4-FFF2-40B4-BE49-F238E27FC236}">
-                <a16:creationId xmlns:a16="http://schemas.microsoft.com/office/drawing/2014/main" id="{20F03FB1-5B4A-4B0B-B9AE-63CD5B687732}"/>
+                <a16:creationId xmlns:a16="http://schemas.microsoft.com/office/drawing/2014/main" id="{F0AAC191-B0CD-4DB6-97F3-A029F5C4144A}"/>
               </a:ext>
             </a:extLst>
           </p:cNvPr>
@@ -1688,7 +1688,7 @@
           <p:cNvPr id="2" name="">
             <a:extLst xmlns:a="http://schemas.openxmlformats.org/drawingml/2006/main">
               <a:ext uri="{FF2B5EF4-FFF2-40B4-BE49-F238E27FC236}">
-                <a16:creationId xmlns:a16="http://schemas.microsoft.com/office/drawing/2014/main" id="{E6092D2E-3B0A-4937-98DC-4F4ED6827042}"/>
+                <a16:creationId xmlns:a16="http://schemas.microsoft.com/office/drawing/2014/main" id="{472BE39A-3A52-4146-8F29-F6BD26C69740}"/>
               </a:ext>
             </a:extLst>
           </p:cNvPr>
@@ -1738,7 +1738,7 @@
           <p:cNvPr id="3" name="">
             <a:extLst xmlns:a="http://schemas.openxmlformats.org/drawingml/2006/main">
               <a:ext uri="{FF2B5EF4-FFF2-40B4-BE49-F238E27FC236}">
-                <a16:creationId xmlns:a16="http://schemas.microsoft.com/office/drawing/2014/main" id="{7F636963-C423-4421-806D-F42235AD8518}"/>
+                <a16:creationId xmlns:a16="http://schemas.microsoft.com/office/drawing/2014/main" id="{E59BCC3D-4AE4-4991-BFE6-A3A378CB076B}"/>
               </a:ext>
             </a:extLst>
           </p:cNvPr>
@@ -1788,7 +1788,7 @@
           <p:cNvPr id="4" name="">
             <a:extLst xmlns:a="http://schemas.openxmlformats.org/drawingml/2006/main">
               <a:ext uri="{FF2B5EF4-FFF2-40B4-BE49-F238E27FC236}">
-                <a16:creationId xmlns:a16="http://schemas.microsoft.com/office/drawing/2014/main" id="{0C53DC53-23EB-41A5-B63D-FAC82ACA0388}"/>
+                <a16:creationId xmlns:a16="http://schemas.microsoft.com/office/drawing/2014/main" id="{D39A265A-AEFB-49D6-A18C-EB0B975C2517}"/>
               </a:ext>
             </a:extLst>
           </p:cNvPr>
@@ -1838,7 +1838,7 @@
           <p:cNvPr id="5" name="">
             <a:extLst xmlns:a="http://schemas.openxmlformats.org/drawingml/2006/main">
               <a:ext uri="{FF2B5EF4-FFF2-40B4-BE49-F238E27FC236}">
-                <a16:creationId xmlns:a16="http://schemas.microsoft.com/office/drawing/2014/main" id="{732AF642-5F7B-4B61-BC63-E27641C83281}"/>
+                <a16:creationId xmlns:a16="http://schemas.microsoft.com/office/drawing/2014/main" id="{D25FBBD8-0DF7-4D8C-A74B-995C40C9ABE7}"/>
               </a:ext>
             </a:extLst>
           </p:cNvPr>
@@ -1888,7 +1888,7 @@
           <p:cNvPr id="6" name="">
             <a:extLst xmlns:a="http://schemas.openxmlformats.org/drawingml/2006/main">
               <a:ext uri="{FF2B5EF4-FFF2-40B4-BE49-F238E27FC236}">
-                <a16:creationId xmlns:a16="http://schemas.microsoft.com/office/drawing/2014/main" id="{D3C04089-7F85-4442-A7DC-546C6085E272}"/>
+                <a16:creationId xmlns:a16="http://schemas.microsoft.com/office/drawing/2014/main" id="{EFE74758-2D0E-4AB7-8F3D-89346309014C}"/>
               </a:ext>
             </a:extLst>
           </p:cNvPr>
@@ -1938,7 +1938,7 @@
           <p:cNvPr id="7" name="">
             <a:extLst xmlns:a="http://schemas.openxmlformats.org/drawingml/2006/main">
               <a:ext uri="{FF2B5EF4-FFF2-40B4-BE49-F238E27FC236}">
-                <a16:creationId xmlns:a16="http://schemas.microsoft.com/office/drawing/2014/main" id="{E72AF363-7640-4390-82EA-681DEA8632D3}"/>
+                <a16:creationId xmlns:a16="http://schemas.microsoft.com/office/drawing/2014/main" id="{C0C3B11A-BB70-4F78-94CF-D0A928BF575B}"/>
               </a:ext>
             </a:extLst>
           </p:cNvPr>
@@ -1988,7 +1988,7 @@
           <p:cNvPr id="8" name="">
             <a:extLst xmlns:a="http://schemas.openxmlformats.org/drawingml/2006/main">
               <a:ext uri="{FF2B5EF4-FFF2-40B4-BE49-F238E27FC236}">
-                <a16:creationId xmlns:a16="http://schemas.microsoft.com/office/drawing/2014/main" id="{C4CE0D8E-6CEE-4450-A680-2C8172C5E3C0}"/>
+                <a16:creationId xmlns:a16="http://schemas.microsoft.com/office/drawing/2014/main" id="{A2882B7E-0161-4A4B-91E7-1BE5C897E0E8}"/>
               </a:ext>
             </a:extLst>
           </p:cNvPr>
@@ -2021,7 +2021,7 @@
           <p:cNvPr id="9" name="">
             <a:extLst xmlns:a="http://schemas.openxmlformats.org/drawingml/2006/main">
               <a:ext uri="{FF2B5EF4-FFF2-40B4-BE49-F238E27FC236}">
-                <a16:creationId xmlns:a16="http://schemas.microsoft.com/office/drawing/2014/main" id="{7709A356-9B79-4FC3-B98D-6A4AC2851EF8}"/>
+                <a16:creationId xmlns:a16="http://schemas.microsoft.com/office/drawing/2014/main" id="{2F8C7BA0-AA7C-4DAD-8BC0-AD3945E556CF}"/>
               </a:ext>
             </a:extLst>
           </p:cNvPr>
@@ -2088,7 +2088,7 @@
           <p:cNvPr id="10" name="">
             <a:extLst xmlns:a="http://schemas.openxmlformats.org/drawingml/2006/main">
               <a:ext uri="{FF2B5EF4-FFF2-40B4-BE49-F238E27FC236}">
-                <a16:creationId xmlns:a16="http://schemas.microsoft.com/office/drawing/2014/main" id="{8BB60155-5A80-48B9-B826-ACB3C0C81213}"/>
+                <a16:creationId xmlns:a16="http://schemas.microsoft.com/office/drawing/2014/main" id="{64EEB4BB-6414-4486-BC6F-89E48861FE0C}"/>
               </a:ext>
             </a:extLst>
           </p:cNvPr>
@@ -2121,7 +2121,7 @@
           <p:cNvPr id="11" name="">
             <a:extLst xmlns:a="http://schemas.openxmlformats.org/drawingml/2006/main">
               <a:ext uri="{FF2B5EF4-FFF2-40B4-BE49-F238E27FC236}">
-                <a16:creationId xmlns:a16="http://schemas.microsoft.com/office/drawing/2014/main" id="{C347A0EC-2995-47E1-B8C9-22D3F501B52F}"/>
+                <a16:creationId xmlns:a16="http://schemas.microsoft.com/office/drawing/2014/main" id="{94BF5384-1C4C-4647-B67C-485FF310A441}"/>
               </a:ext>
             </a:extLst>
           </p:cNvPr>
@@ -2188,7 +2188,7 @@
           <p:cNvPr id="12" name="">
             <a:extLst xmlns:a="http://schemas.openxmlformats.org/drawingml/2006/main">
               <a:ext uri="{FF2B5EF4-FFF2-40B4-BE49-F238E27FC236}">
-                <a16:creationId xmlns:a16="http://schemas.microsoft.com/office/drawing/2014/main" id="{78B65A85-D63E-42A3-BD38-18588974C6DD}"/>
+                <a16:creationId xmlns:a16="http://schemas.microsoft.com/office/drawing/2014/main" id="{715125B1-5C35-4B37-A10F-EF14F18A8654}"/>
               </a:ext>
             </a:extLst>
           </p:cNvPr>
@@ -2221,7 +2221,7 @@
           <p:cNvPr id="13" name="">
             <a:extLst xmlns:a="http://schemas.openxmlformats.org/drawingml/2006/main">
               <a:ext uri="{FF2B5EF4-FFF2-40B4-BE49-F238E27FC236}">
-                <a16:creationId xmlns:a16="http://schemas.microsoft.com/office/drawing/2014/main" id="{E8695AD4-6B28-4590-997B-4E2CE7F741BB}"/>
+                <a16:creationId xmlns:a16="http://schemas.microsoft.com/office/drawing/2014/main" id="{8FFC6CF8-EE8F-48D6-B1D3-7C8A59CD03A0}"/>
               </a:ext>
             </a:extLst>
           </p:cNvPr>
@@ -2288,7 +2288,7 @@
           <p:cNvPr id="14" name="">
             <a:extLst xmlns:a="http://schemas.openxmlformats.org/drawingml/2006/main">
               <a:ext uri="{FF2B5EF4-FFF2-40B4-BE49-F238E27FC236}">
-                <a16:creationId xmlns:a16="http://schemas.microsoft.com/office/drawing/2014/main" id="{6EA4A46E-8F66-49B5-A71C-01708BF397B7}"/>
+                <a16:creationId xmlns:a16="http://schemas.microsoft.com/office/drawing/2014/main" id="{F6A93361-3A8E-4D70-888D-EBF37F0D2792}"/>
               </a:ext>
             </a:extLst>
           </p:cNvPr>
@@ -2321,7 +2321,7 @@
           <p:cNvPr id="15" name="">
             <a:extLst xmlns:a="http://schemas.openxmlformats.org/drawingml/2006/main">
               <a:ext uri="{FF2B5EF4-FFF2-40B4-BE49-F238E27FC236}">
-                <a16:creationId xmlns:a16="http://schemas.microsoft.com/office/drawing/2014/main" id="{45D00CFF-33C8-4980-A4AB-D48467DF7DAC}"/>
+                <a16:creationId xmlns:a16="http://schemas.microsoft.com/office/drawing/2014/main" id="{541ADA5A-4B5C-40A6-A512-8D40C0EEB543}"/>
               </a:ext>
             </a:extLst>
           </p:cNvPr>
@@ -2388,7 +2388,7 @@
           <p:cNvPr id="16" name="">
             <a:extLst xmlns:a="http://schemas.openxmlformats.org/drawingml/2006/main">
               <a:ext uri="{FF2B5EF4-FFF2-40B4-BE49-F238E27FC236}">
-                <a16:creationId xmlns:a16="http://schemas.microsoft.com/office/drawing/2014/main" id="{8320C9E4-91FA-4221-8A08-F5243617C3BD}"/>
+                <a16:creationId xmlns:a16="http://schemas.microsoft.com/office/drawing/2014/main" id="{FC678925-03D1-4C94-981C-E9AB22F601CF}"/>
               </a:ext>
             </a:extLst>
           </p:cNvPr>
@@ -2436,7 +2436,7 @@
     </p:spTree>
     <p:extLst>
       <p:ext uri="{BB962C8B-B14F-4D97-AF65-F5344CB8AC3E}">
-        <p14:creationId xmlns:p14="http://schemas.microsoft.com/office/powerpoint/2010/main" val="1078648159"/>
+        <p14:creationId xmlns:p14="http://schemas.microsoft.com/office/powerpoint/2010/main" val="966549572"/>
       </p:ext>
     </p:extLst>
   </p:cSld>
@@ -2467,7 +2467,7 @@
           <p:cNvPr id="43" name="">
             <a:extLst xmlns:a="http://schemas.openxmlformats.org/drawingml/2006/main">
               <a:ext uri="{FF2B5EF4-FFF2-40B4-BE49-F238E27FC236}">
-                <a16:creationId xmlns:a16="http://schemas.microsoft.com/office/drawing/2014/main" id="{D2A322B1-6487-4E06-8B51-314CBAF53FBA}"/>
+                <a16:creationId xmlns:a16="http://schemas.microsoft.com/office/drawing/2014/main" id="{B9614843-55F3-4A21-A652-379F1A2C18AD}"/>
               </a:ext>
             </a:extLst>
           </p:cNvPr>
@@ -2517,7 +2517,7 @@
           <p:cNvPr id="2" name="">
             <a:extLst xmlns:a="http://schemas.openxmlformats.org/drawingml/2006/main">
               <a:ext uri="{FF2B5EF4-FFF2-40B4-BE49-F238E27FC236}">
-                <a16:creationId xmlns:a16="http://schemas.microsoft.com/office/drawing/2014/main" id="{BBE9F1C3-6DF3-44D2-9677-79AF79686E70}"/>
+                <a16:creationId xmlns:a16="http://schemas.microsoft.com/office/drawing/2014/main" id="{6AD85A9F-E638-4E58-B6F3-96B42D018560}"/>
               </a:ext>
             </a:extLst>
           </p:cNvPr>
@@ -2567,7 +2567,7 @@
           <p:cNvPr id="3" name="">
             <a:extLst xmlns:a="http://schemas.openxmlformats.org/drawingml/2006/main">
               <a:ext uri="{FF2B5EF4-FFF2-40B4-BE49-F238E27FC236}">
-                <a16:creationId xmlns:a16="http://schemas.microsoft.com/office/drawing/2014/main" id="{FD6B8305-0D2E-4463-91CF-033A7CE2BF47}"/>
+                <a16:creationId xmlns:a16="http://schemas.microsoft.com/office/drawing/2014/main" id="{9A0293EE-9FC1-4402-ACDD-5066D9F3C77F}"/>
               </a:ext>
             </a:extLst>
           </p:cNvPr>
@@ -2600,7 +2600,7 @@
           <p:cNvPr id="4" name="">
             <a:extLst xmlns:a="http://schemas.openxmlformats.org/drawingml/2006/main">
               <a:ext uri="{FF2B5EF4-FFF2-40B4-BE49-F238E27FC236}">
-                <a16:creationId xmlns:a16="http://schemas.microsoft.com/office/drawing/2014/main" id="{555CC47A-0D55-4B4F-AC24-9822EC2BFFB5}"/>
+                <a16:creationId xmlns:a16="http://schemas.microsoft.com/office/drawing/2014/main" id="{BCC610BF-4C63-42E4-B029-753135F91D50}"/>
               </a:ext>
             </a:extLst>
           </p:cNvPr>
@@ -2650,7 +2650,7 @@
           <p:cNvPr id="5" name="">
             <a:extLst xmlns:a="http://schemas.openxmlformats.org/drawingml/2006/main">
               <a:ext uri="{FF2B5EF4-FFF2-40B4-BE49-F238E27FC236}">
-                <a16:creationId xmlns:a16="http://schemas.microsoft.com/office/drawing/2014/main" id="{898A5646-BFEB-48D8-949A-B17A5639D76B}"/>
+                <a16:creationId xmlns:a16="http://schemas.microsoft.com/office/drawing/2014/main" id="{9C3F1417-9425-4DBC-862C-526FB45AC4B1}"/>
               </a:ext>
             </a:extLst>
           </p:cNvPr>
@@ -2683,7 +2683,7 @@
           <p:cNvPr id="6" name="">
             <a:extLst xmlns:a="http://schemas.openxmlformats.org/drawingml/2006/main">
               <a:ext uri="{FF2B5EF4-FFF2-40B4-BE49-F238E27FC236}">
-                <a16:creationId xmlns:a16="http://schemas.microsoft.com/office/drawing/2014/main" id="{1E54714F-5A3D-48E7-88A5-0709768729D4}"/>
+                <a16:creationId xmlns:a16="http://schemas.microsoft.com/office/drawing/2014/main" id="{40F0B8BD-4C3A-44A8-94CA-D3095D07A389}"/>
               </a:ext>
             </a:extLst>
           </p:cNvPr>
@@ -2716,7 +2716,7 @@
           <p:cNvPr id="7" name="">
             <a:extLst xmlns:a="http://schemas.openxmlformats.org/drawingml/2006/main">
               <a:ext uri="{FF2B5EF4-FFF2-40B4-BE49-F238E27FC236}">
-                <a16:creationId xmlns:a16="http://schemas.microsoft.com/office/drawing/2014/main" id="{6627F497-71EE-4AAB-A23C-C0BDB2017D1A}"/>
+                <a16:creationId xmlns:a16="http://schemas.microsoft.com/office/drawing/2014/main" id="{A4FB9A1B-3661-447B-A2F5-80A268B79ED0}"/>
               </a:ext>
             </a:extLst>
           </p:cNvPr>
@@ -2766,7 +2766,7 @@
           <p:cNvPr id="8" name="">
             <a:extLst xmlns:a="http://schemas.openxmlformats.org/drawingml/2006/main">
               <a:ext uri="{FF2B5EF4-FFF2-40B4-BE49-F238E27FC236}">
-                <a16:creationId xmlns:a16="http://schemas.microsoft.com/office/drawing/2014/main" id="{62505326-38F8-4EDD-929D-1E10A81669CB}"/>
+                <a16:creationId xmlns:a16="http://schemas.microsoft.com/office/drawing/2014/main" id="{000A061E-DDDD-457D-AF57-84D4AB2BE68A}"/>
               </a:ext>
             </a:extLst>
           </p:cNvPr>
@@ -2816,7 +2816,7 @@
           <p:cNvPr id="9" name="">
             <a:extLst xmlns:a="http://schemas.openxmlformats.org/drawingml/2006/main">
               <a:ext uri="{FF2B5EF4-FFF2-40B4-BE49-F238E27FC236}">
-                <a16:creationId xmlns:a16="http://schemas.microsoft.com/office/drawing/2014/main" id="{6C4B48F9-978A-4999-824F-B87CB0AE0076}"/>
+                <a16:creationId xmlns:a16="http://schemas.microsoft.com/office/drawing/2014/main" id="{BC04D39B-C73F-4730-9708-F6B267E69A3B}"/>
               </a:ext>
             </a:extLst>
           </p:cNvPr>
@@ -2849,7 +2849,7 @@
           <p:cNvPr id="10" name="">
             <a:extLst xmlns:a="http://schemas.openxmlformats.org/drawingml/2006/main">
               <a:ext uri="{FF2B5EF4-FFF2-40B4-BE49-F238E27FC236}">
-                <a16:creationId xmlns:a16="http://schemas.microsoft.com/office/drawing/2014/main" id="{13DEF0FC-EC55-447E-8ED1-ECE18D272BFB}"/>
+                <a16:creationId xmlns:a16="http://schemas.microsoft.com/office/drawing/2014/main" id="{80F51162-71B5-4539-AEBA-F1B34E8517CD}"/>
               </a:ext>
             </a:extLst>
           </p:cNvPr>
@@ -2882,7 +2882,7 @@
           <p:cNvPr id="11" name="">
             <a:extLst xmlns:a="http://schemas.openxmlformats.org/drawingml/2006/main">
               <a:ext uri="{FF2B5EF4-FFF2-40B4-BE49-F238E27FC236}">
-                <a16:creationId xmlns:a16="http://schemas.microsoft.com/office/drawing/2014/main" id="{A5DBF87B-67C4-4130-BECD-F770381329A9}"/>
+                <a16:creationId xmlns:a16="http://schemas.microsoft.com/office/drawing/2014/main" id="{38E4CBBB-6814-4771-9326-C009A959E3AC}"/>
               </a:ext>
             </a:extLst>
           </p:cNvPr>
@@ -2932,7 +2932,7 @@
           <p:cNvPr id="12" name="">
             <a:extLst xmlns:a="http://schemas.openxmlformats.org/drawingml/2006/main">
               <a:ext uri="{FF2B5EF4-FFF2-40B4-BE49-F238E27FC236}">
-                <a16:creationId xmlns:a16="http://schemas.microsoft.com/office/drawing/2014/main" id="{09BC2DC3-BC61-4A28-827F-84EF964ABF43}"/>
+                <a16:creationId xmlns:a16="http://schemas.microsoft.com/office/drawing/2014/main" id="{FE811084-0E51-4984-83A6-6EA54458B0CF}"/>
               </a:ext>
             </a:extLst>
           </p:cNvPr>
@@ -2982,7 +2982,7 @@
           <p:cNvPr id="13" name="">
             <a:extLst xmlns:a="http://schemas.openxmlformats.org/drawingml/2006/main">
               <a:ext uri="{FF2B5EF4-FFF2-40B4-BE49-F238E27FC236}">
-                <a16:creationId xmlns:a16="http://schemas.microsoft.com/office/drawing/2014/main" id="{602EA3A3-FB33-4349-9B60-6F3FC8A91F42}"/>
+                <a16:creationId xmlns:a16="http://schemas.microsoft.com/office/drawing/2014/main" id="{2CD570F4-BD85-4D81-B6DE-E0AE8C868A99}"/>
               </a:ext>
             </a:extLst>
           </p:cNvPr>
@@ -3015,7 +3015,7 @@
           <p:cNvPr id="14" name="">
             <a:extLst xmlns:a="http://schemas.openxmlformats.org/drawingml/2006/main">
               <a:ext uri="{FF2B5EF4-FFF2-40B4-BE49-F238E27FC236}">
-                <a16:creationId xmlns:a16="http://schemas.microsoft.com/office/drawing/2014/main" id="{BCC37DF6-2DE8-4571-AFC0-A5C111E5A630}"/>
+                <a16:creationId xmlns:a16="http://schemas.microsoft.com/office/drawing/2014/main" id="{8ABA2F84-ACA5-4C21-AF30-C84D286C9E35}"/>
               </a:ext>
             </a:extLst>
           </p:cNvPr>
@@ -3048,7 +3048,7 @@
           <p:cNvPr id="15" name="">
             <a:extLst xmlns:a="http://schemas.openxmlformats.org/drawingml/2006/main">
               <a:ext uri="{FF2B5EF4-FFF2-40B4-BE49-F238E27FC236}">
-                <a16:creationId xmlns:a16="http://schemas.microsoft.com/office/drawing/2014/main" id="{182A63FD-093B-42D7-A2D3-DE2302E1029D}"/>
+                <a16:creationId xmlns:a16="http://schemas.microsoft.com/office/drawing/2014/main" id="{B870A52C-2660-455C-958B-2179363C036D}"/>
               </a:ext>
             </a:extLst>
           </p:cNvPr>
@@ -3098,7 +3098,7 @@
           <p:cNvPr id="16" name="">
             <a:extLst xmlns:a="http://schemas.openxmlformats.org/drawingml/2006/main">
               <a:ext uri="{FF2B5EF4-FFF2-40B4-BE49-F238E27FC236}">
-                <a16:creationId xmlns:a16="http://schemas.microsoft.com/office/drawing/2014/main" id="{72AD4BC1-C548-4073-9767-DF4DE777F440}"/>
+                <a16:creationId xmlns:a16="http://schemas.microsoft.com/office/drawing/2014/main" id="{CAF9F507-676B-4BD5-ADC7-3F7A93F78D2B}"/>
               </a:ext>
             </a:extLst>
           </p:cNvPr>
@@ -3148,7 +3148,7 @@
           <p:cNvPr id="17" name="">
             <a:extLst xmlns:a="http://schemas.openxmlformats.org/drawingml/2006/main">
               <a:ext uri="{FF2B5EF4-FFF2-40B4-BE49-F238E27FC236}">
-                <a16:creationId xmlns:a16="http://schemas.microsoft.com/office/drawing/2014/main" id="{144D4DA0-E95B-4620-9AEB-A128C1A3DE27}"/>
+                <a16:creationId xmlns:a16="http://schemas.microsoft.com/office/drawing/2014/main" id="{F3247BA3-3CA8-444F-9EEE-643B5317AE70}"/>
               </a:ext>
             </a:extLst>
           </p:cNvPr>
@@ -3181,7 +3181,7 @@
           <p:cNvPr id="18" name="">
             <a:extLst xmlns:a="http://schemas.openxmlformats.org/drawingml/2006/main">
               <a:ext uri="{FF2B5EF4-FFF2-40B4-BE49-F238E27FC236}">
-                <a16:creationId xmlns:a16="http://schemas.microsoft.com/office/drawing/2014/main" id="{6ADDD729-38CB-4B55-B719-79459E1A688B}"/>
+                <a16:creationId xmlns:a16="http://schemas.microsoft.com/office/drawing/2014/main" id="{21B7F551-FDF6-41E2-B893-5D377BE2D188}"/>
               </a:ext>
             </a:extLst>
           </p:cNvPr>
@@ -3231,7 +3231,7 @@
           <p:cNvPr id="19" name="">
             <a:extLst xmlns:a="http://schemas.openxmlformats.org/drawingml/2006/main">
               <a:ext uri="{FF2B5EF4-FFF2-40B4-BE49-F238E27FC236}">
-                <a16:creationId xmlns:a16="http://schemas.microsoft.com/office/drawing/2014/main" id="{C45740EA-DCB2-4CBB-8886-37F625EC6271}"/>
+                <a16:creationId xmlns:a16="http://schemas.microsoft.com/office/drawing/2014/main" id="{02A9CDF1-900D-4960-913B-55DA9A960136}"/>
               </a:ext>
             </a:extLst>
           </p:cNvPr>
@@ -3281,7 +3281,7 @@
           <p:cNvPr id="20" name="">
             <a:extLst xmlns:a="http://schemas.openxmlformats.org/drawingml/2006/main">
               <a:ext uri="{FF2B5EF4-FFF2-40B4-BE49-F238E27FC236}">
-                <a16:creationId xmlns:a16="http://schemas.microsoft.com/office/drawing/2014/main" id="{50AE889B-5ADE-4A75-9C4E-A424DE6154E0}"/>
+                <a16:creationId xmlns:a16="http://schemas.microsoft.com/office/drawing/2014/main" id="{14728700-E567-4F18-B1C1-C69D0BBC5E28}"/>
               </a:ext>
             </a:extLst>
           </p:cNvPr>
@@ -3314,7 +3314,7 @@
           <p:cNvPr id="21" name="">
             <a:extLst xmlns:a="http://schemas.openxmlformats.org/drawingml/2006/main">
               <a:ext uri="{FF2B5EF4-FFF2-40B4-BE49-F238E27FC236}">
-                <a16:creationId xmlns:a16="http://schemas.microsoft.com/office/drawing/2014/main" id="{C5E5A37B-155B-4347-82FB-9BFF2F605D3C}"/>
+                <a16:creationId xmlns:a16="http://schemas.microsoft.com/office/drawing/2014/main" id="{F6E92D76-A42A-4C36-BEB0-307A3487A146}"/>
               </a:ext>
             </a:extLst>
           </p:cNvPr>
@@ -3364,7 +3364,7 @@
           <p:cNvPr id="22" name="">
             <a:extLst xmlns:a="http://schemas.openxmlformats.org/drawingml/2006/main">
               <a:ext uri="{FF2B5EF4-FFF2-40B4-BE49-F238E27FC236}">
-                <a16:creationId xmlns:a16="http://schemas.microsoft.com/office/drawing/2014/main" id="{8CA6E36D-BD92-4D84-90CE-2BC84A5F3A3C}"/>
+                <a16:creationId xmlns:a16="http://schemas.microsoft.com/office/drawing/2014/main" id="{F068FD22-3AB6-4FBF-B169-1017177C7AC2}"/>
               </a:ext>
             </a:extLst>
           </p:cNvPr>
@@ -3414,7 +3414,7 @@
           <p:cNvPr id="23" name="">
             <a:extLst xmlns:a="http://schemas.openxmlformats.org/drawingml/2006/main">
               <a:ext uri="{FF2B5EF4-FFF2-40B4-BE49-F238E27FC236}">
-                <a16:creationId xmlns:a16="http://schemas.microsoft.com/office/drawing/2014/main" id="{59A40547-0FDB-4557-959F-AF6E5E19B53E}"/>
+                <a16:creationId xmlns:a16="http://schemas.microsoft.com/office/drawing/2014/main" id="{FA33BE45-836E-4A14-AFEC-1BC11660F7FA}"/>
               </a:ext>
             </a:extLst>
           </p:cNvPr>
@@ -3447,7 +3447,7 @@
           <p:cNvPr id="24" name="">
             <a:extLst xmlns:a="http://schemas.openxmlformats.org/drawingml/2006/main">
               <a:ext uri="{FF2B5EF4-FFF2-40B4-BE49-F238E27FC236}">
-                <a16:creationId xmlns:a16="http://schemas.microsoft.com/office/drawing/2014/main" id="{16272107-1389-4663-BD50-B4A690030771}"/>
+                <a16:creationId xmlns:a16="http://schemas.microsoft.com/office/drawing/2014/main" id="{3A16CF70-9553-46CD-BF67-5FA4724ED917}"/>
               </a:ext>
             </a:extLst>
           </p:cNvPr>
@@ -3497,7 +3497,7 @@
           <p:cNvPr id="25" name="">
             <a:extLst xmlns:a="http://schemas.openxmlformats.org/drawingml/2006/main">
               <a:ext uri="{FF2B5EF4-FFF2-40B4-BE49-F238E27FC236}">
-                <a16:creationId xmlns:a16="http://schemas.microsoft.com/office/drawing/2014/main" id="{36F2D012-7920-4EAC-B687-1B4ECB4D3894}"/>
+                <a16:creationId xmlns:a16="http://schemas.microsoft.com/office/drawing/2014/main" id="{CCA074E5-8912-4F4C-8799-840E4E46689A}"/>
               </a:ext>
             </a:extLst>
           </p:cNvPr>
@@ -3547,7 +3547,7 @@
           <p:cNvPr id="26" name="">
             <a:extLst xmlns:a="http://schemas.openxmlformats.org/drawingml/2006/main">
               <a:ext uri="{FF2B5EF4-FFF2-40B4-BE49-F238E27FC236}">
-                <a16:creationId xmlns:a16="http://schemas.microsoft.com/office/drawing/2014/main" id="{A3F02C8B-CF69-4F7E-B86B-A9EB554075D8}"/>
+                <a16:creationId xmlns:a16="http://schemas.microsoft.com/office/drawing/2014/main" id="{9484793A-0498-40C8-BD4F-36F0501B981E}"/>
               </a:ext>
             </a:extLst>
           </p:cNvPr>
@@ -3580,7 +3580,7 @@
           <p:cNvPr id="27" name="">
             <a:extLst xmlns:a="http://schemas.openxmlformats.org/drawingml/2006/main">
               <a:ext uri="{FF2B5EF4-FFF2-40B4-BE49-F238E27FC236}">
-                <a16:creationId xmlns:a16="http://schemas.microsoft.com/office/drawing/2014/main" id="{038417C4-A993-4694-962D-2275CBC7F2B1}"/>
+                <a16:creationId xmlns:a16="http://schemas.microsoft.com/office/drawing/2014/main" id="{C5E1AE86-BC7D-4B4F-8D32-77253AF955C7}"/>
               </a:ext>
             </a:extLst>
           </p:cNvPr>
@@ -3630,7 +3630,7 @@
           <p:cNvPr id="28" name="">
             <a:extLst xmlns:a="http://schemas.openxmlformats.org/drawingml/2006/main">
               <a:ext uri="{FF2B5EF4-FFF2-40B4-BE49-F238E27FC236}">
-                <a16:creationId xmlns:a16="http://schemas.microsoft.com/office/drawing/2014/main" id="{0AAE9F79-3A61-4543-98EB-B8FA02F449B0}"/>
+                <a16:creationId xmlns:a16="http://schemas.microsoft.com/office/drawing/2014/main" id="{6FFBAD72-A615-46F0-A748-C3AF2ECDF3F4}"/>
               </a:ext>
             </a:extLst>
           </p:cNvPr>
@@ -3680,7 +3680,7 @@
           <p:cNvPr id="29" name="">
             <a:extLst xmlns:a="http://schemas.openxmlformats.org/drawingml/2006/main">
               <a:ext uri="{FF2B5EF4-FFF2-40B4-BE49-F238E27FC236}">
-                <a16:creationId xmlns:a16="http://schemas.microsoft.com/office/drawing/2014/main" id="{1316B16C-E1DA-4DA5-BDF9-0F0FC722CDBF}"/>
+                <a16:creationId xmlns:a16="http://schemas.microsoft.com/office/drawing/2014/main" id="{A6983050-3581-49C7-A08C-5DF9835D8178}"/>
               </a:ext>
             </a:extLst>
           </p:cNvPr>
@@ -3713,7 +3713,7 @@
           <p:cNvPr id="30" name="">
             <a:extLst xmlns:a="http://schemas.openxmlformats.org/drawingml/2006/main">
               <a:ext uri="{FF2B5EF4-FFF2-40B4-BE49-F238E27FC236}">
-                <a16:creationId xmlns:a16="http://schemas.microsoft.com/office/drawing/2014/main" id="{B48C2FC2-9FDA-4C74-80BD-0AE5285A56A5}"/>
+                <a16:creationId xmlns:a16="http://schemas.microsoft.com/office/drawing/2014/main" id="{18DFAC31-1CDC-4050-BE0E-261D6D35D932}"/>
               </a:ext>
             </a:extLst>
           </p:cNvPr>
@@ -3763,7 +3763,7 @@
           <p:cNvPr id="31" name="">
             <a:extLst xmlns:a="http://schemas.openxmlformats.org/drawingml/2006/main">
               <a:ext uri="{FF2B5EF4-FFF2-40B4-BE49-F238E27FC236}">
-                <a16:creationId xmlns:a16="http://schemas.microsoft.com/office/drawing/2014/main" id="{7B2BA4D3-568B-4FF6-97BD-1D7907E5D4B4}"/>
+                <a16:creationId xmlns:a16="http://schemas.microsoft.com/office/drawing/2014/main" id="{45A86C34-67B7-43D8-B3C0-6022F01CD58E}"/>
               </a:ext>
             </a:extLst>
           </p:cNvPr>
@@ -3813,7 +3813,7 @@
           <p:cNvPr id="32" name="">
             <a:extLst xmlns:a="http://schemas.openxmlformats.org/drawingml/2006/main">
               <a:ext uri="{FF2B5EF4-FFF2-40B4-BE49-F238E27FC236}">
-                <a16:creationId xmlns:a16="http://schemas.microsoft.com/office/drawing/2014/main" id="{803250C2-42EF-4458-965B-FB6A3889DA18}"/>
+                <a16:creationId xmlns:a16="http://schemas.microsoft.com/office/drawing/2014/main" id="{32595F1B-72B3-4145-8461-D778362D8C0D}"/>
               </a:ext>
             </a:extLst>
           </p:cNvPr>
@@ -3846,7 +3846,7 @@
           <p:cNvPr id="33" name="">
             <a:extLst xmlns:a="http://schemas.openxmlformats.org/drawingml/2006/main">
               <a:ext uri="{FF2B5EF4-FFF2-40B4-BE49-F238E27FC236}">
-                <a16:creationId xmlns:a16="http://schemas.microsoft.com/office/drawing/2014/main" id="{780CBDE9-44D9-462F-BFC9-5A9661620CCE}"/>
+                <a16:creationId xmlns:a16="http://schemas.microsoft.com/office/drawing/2014/main" id="{66063E7C-FB59-4493-8237-838DE95D44FC}"/>
               </a:ext>
             </a:extLst>
           </p:cNvPr>
@@ -3896,7 +3896,7 @@
           <p:cNvPr id="34" name="">
             <a:extLst xmlns:a="http://schemas.openxmlformats.org/drawingml/2006/main">
               <a:ext uri="{FF2B5EF4-FFF2-40B4-BE49-F238E27FC236}">
-                <a16:creationId xmlns:a16="http://schemas.microsoft.com/office/drawing/2014/main" id="{AAA43838-B41C-474E-B847-41BDE39FAE24}"/>
+                <a16:creationId xmlns:a16="http://schemas.microsoft.com/office/drawing/2014/main" id="{761218D4-1237-46F5-936F-DE7EE183ADF0}"/>
               </a:ext>
             </a:extLst>
           </p:cNvPr>
@@ -3946,7 +3946,7 @@
           <p:cNvPr id="35" name="">
             <a:extLst xmlns:a="http://schemas.openxmlformats.org/drawingml/2006/main">
               <a:ext uri="{FF2B5EF4-FFF2-40B4-BE49-F238E27FC236}">
-                <a16:creationId xmlns:a16="http://schemas.microsoft.com/office/drawing/2014/main" id="{F71078CD-47B0-4F25-9202-20B479B3F45F}"/>
+                <a16:creationId xmlns:a16="http://schemas.microsoft.com/office/drawing/2014/main" id="{A2C01093-D5B8-4F8E-8B1C-833A386A1B1B}"/>
               </a:ext>
             </a:extLst>
           </p:cNvPr>
@@ -3979,7 +3979,7 @@
           <p:cNvPr id="36" name="">
             <a:extLst xmlns:a="http://schemas.openxmlformats.org/drawingml/2006/main">
               <a:ext uri="{FF2B5EF4-FFF2-40B4-BE49-F238E27FC236}">
-                <a16:creationId xmlns:a16="http://schemas.microsoft.com/office/drawing/2014/main" id="{46DD2C2C-7987-4124-BA20-431282E5CC49}"/>
+                <a16:creationId xmlns:a16="http://schemas.microsoft.com/office/drawing/2014/main" id="{98736C79-C2AB-4A6C-A37F-C5CD59683557}"/>
               </a:ext>
             </a:extLst>
           </p:cNvPr>
@@ -4029,7 +4029,7 @@
           <p:cNvPr id="37" name="">
             <a:extLst xmlns:a="http://schemas.openxmlformats.org/drawingml/2006/main">
               <a:ext uri="{FF2B5EF4-FFF2-40B4-BE49-F238E27FC236}">
-                <a16:creationId xmlns:a16="http://schemas.microsoft.com/office/drawing/2014/main" id="{650B4394-2FCC-40D5-BB44-4CCD9470157E}"/>
+                <a16:creationId xmlns:a16="http://schemas.microsoft.com/office/drawing/2014/main" id="{C7016A89-3442-498B-85DC-E9674AE3C786}"/>
               </a:ext>
             </a:extLst>
           </p:cNvPr>
@@ -4079,7 +4079,7 @@
           <p:cNvPr id="38" name="">
             <a:extLst xmlns:a="http://schemas.openxmlformats.org/drawingml/2006/main">
               <a:ext uri="{FF2B5EF4-FFF2-40B4-BE49-F238E27FC236}">
-                <a16:creationId xmlns:a16="http://schemas.microsoft.com/office/drawing/2014/main" id="{C0A0FF1D-179F-4BB5-92EA-7F142C18B930}"/>
+                <a16:creationId xmlns:a16="http://schemas.microsoft.com/office/drawing/2014/main" id="{F9EBC3E3-6F67-4E57-8C9F-CA325D8BE520}"/>
               </a:ext>
             </a:extLst>
           </p:cNvPr>
@@ -4129,7 +4129,7 @@
           <p:cNvPr id="39" name="">
             <a:extLst xmlns:a="http://schemas.openxmlformats.org/drawingml/2006/main">
               <a:ext uri="{FF2B5EF4-FFF2-40B4-BE49-F238E27FC236}">
-                <a16:creationId xmlns:a16="http://schemas.microsoft.com/office/drawing/2014/main" id="{0D0ED256-5FD9-4785-86D9-AA9EF01BE5CA}"/>
+                <a16:creationId xmlns:a16="http://schemas.microsoft.com/office/drawing/2014/main" id="{8B23BB2E-0895-4228-94AA-3A69B6CB38E4}"/>
               </a:ext>
             </a:extLst>
           </p:cNvPr>
@@ -4179,7 +4179,7 @@
           <p:cNvPr id="40" name="">
             <a:extLst xmlns:a="http://schemas.openxmlformats.org/drawingml/2006/main">
               <a:ext uri="{FF2B5EF4-FFF2-40B4-BE49-F238E27FC236}">
-                <a16:creationId xmlns:a16="http://schemas.microsoft.com/office/drawing/2014/main" id="{4B521DAF-5525-4819-B045-67F8DDD1F5E4}"/>
+                <a16:creationId xmlns:a16="http://schemas.microsoft.com/office/drawing/2014/main" id="{BC47FA9D-E759-426A-9049-2CA33FED89B2}"/>
               </a:ext>
             </a:extLst>
           </p:cNvPr>
@@ -4229,7 +4229,7 @@
           <p:cNvPr id="41" name="">
             <a:extLst xmlns:a="http://schemas.openxmlformats.org/drawingml/2006/main">
               <a:ext uri="{FF2B5EF4-FFF2-40B4-BE49-F238E27FC236}">
-                <a16:creationId xmlns:a16="http://schemas.microsoft.com/office/drawing/2014/main" id="{6BD60451-06F4-46CA-B8B1-8EC92D313F82}"/>
+                <a16:creationId xmlns:a16="http://schemas.microsoft.com/office/drawing/2014/main" id="{6CFCE3F4-0D3C-4982-8E28-ACB0EA49DB27}"/>
               </a:ext>
             </a:extLst>
           </p:cNvPr>
@@ -4279,7 +4279,7 @@
           <p:cNvPr id="42" name="">
             <a:extLst xmlns:a="http://schemas.openxmlformats.org/drawingml/2006/main">
               <a:ext uri="{FF2B5EF4-FFF2-40B4-BE49-F238E27FC236}">
-                <a16:creationId xmlns:a16="http://schemas.microsoft.com/office/drawing/2014/main" id="{9CD89B8E-0001-406D-8629-0886671042CE}"/>
+                <a16:creationId xmlns:a16="http://schemas.microsoft.com/office/drawing/2014/main" id="{F2889DFC-8059-47E5-9E57-521496916289}"/>
               </a:ext>
             </a:extLst>
           </p:cNvPr>
@@ -4327,7 +4327,7 @@
     </p:spTree>
     <p:extLst>
       <p:ext uri="{BB962C8B-B14F-4D97-AF65-F5344CB8AC3E}">
-        <p14:creationId xmlns:p14="http://schemas.microsoft.com/office/powerpoint/2010/main" val="1139974333"/>
+        <p14:creationId xmlns:p14="http://schemas.microsoft.com/office/powerpoint/2010/main" val="1793398574"/>
       </p:ext>
     </p:extLst>
   </p:cSld>
@@ -4358,7 +4358,7 @@
           <p:cNvPr id="34" name="">
             <a:extLst xmlns:a="http://schemas.openxmlformats.org/drawingml/2006/main">
               <a:ext uri="{FF2B5EF4-FFF2-40B4-BE49-F238E27FC236}">
-                <a16:creationId xmlns:a16="http://schemas.microsoft.com/office/drawing/2014/main" id="{0B19C6D1-B1DE-4D5D-87E5-AF2FAC8B2A6D}"/>
+                <a16:creationId xmlns:a16="http://schemas.microsoft.com/office/drawing/2014/main" id="{BB0F9580-9285-4A76-93C8-2BF977712AE9}"/>
               </a:ext>
             </a:extLst>
           </p:cNvPr>
@@ -4408,7 +4408,7 @@
           <p:cNvPr id="2" name="">
             <a:extLst xmlns:a="http://schemas.openxmlformats.org/drawingml/2006/main">
               <a:ext uri="{FF2B5EF4-FFF2-40B4-BE49-F238E27FC236}">
-                <a16:creationId xmlns:a16="http://schemas.microsoft.com/office/drawing/2014/main" id="{1A7BFCE8-F19B-4463-AA77-4F76DB78565D}"/>
+                <a16:creationId xmlns:a16="http://schemas.microsoft.com/office/drawing/2014/main" id="{EBDEC5E8-7D64-4539-9B73-3A456DC82E9B}"/>
               </a:ext>
             </a:extLst>
           </p:cNvPr>
@@ -4458,7 +4458,7 @@
           <p:cNvPr id="3" name="">
             <a:extLst xmlns:a="http://schemas.openxmlformats.org/drawingml/2006/main">
               <a:ext uri="{FF2B5EF4-FFF2-40B4-BE49-F238E27FC236}">
-                <a16:creationId xmlns:a16="http://schemas.microsoft.com/office/drawing/2014/main" id="{32CC577E-FDF9-42D0-8A29-B2C78A7360D9}"/>
+                <a16:creationId xmlns:a16="http://schemas.microsoft.com/office/drawing/2014/main" id="{3A5BE9FC-92FE-4875-9A63-B757DC3AD280}"/>
               </a:ext>
             </a:extLst>
           </p:cNvPr>
@@ -4491,7 +4491,7 @@
           <p:cNvPr id="4" name="">
             <a:extLst xmlns:a="http://schemas.openxmlformats.org/drawingml/2006/main">
               <a:ext uri="{FF2B5EF4-FFF2-40B4-BE49-F238E27FC236}">
-                <a16:creationId xmlns:a16="http://schemas.microsoft.com/office/drawing/2014/main" id="{CA6612C2-7AB7-4D5D-B31D-F28C49B148BA}"/>
+                <a16:creationId xmlns:a16="http://schemas.microsoft.com/office/drawing/2014/main" id="{8641E0F6-0016-48F5-93F5-E5DB10E2757C}"/>
               </a:ext>
             </a:extLst>
           </p:cNvPr>
@@ -4541,7 +4541,7 @@
           <p:cNvPr id="5" name="">
             <a:extLst xmlns:a="http://schemas.openxmlformats.org/drawingml/2006/main">
               <a:ext uri="{FF2B5EF4-FFF2-40B4-BE49-F238E27FC236}">
-                <a16:creationId xmlns:a16="http://schemas.microsoft.com/office/drawing/2014/main" id="{8C8CAC10-C780-4D88-B990-A8375848A757}"/>
+                <a16:creationId xmlns:a16="http://schemas.microsoft.com/office/drawing/2014/main" id="{E1C79AD0-61E4-4743-9AB4-0617B93E0EAE}"/>
               </a:ext>
             </a:extLst>
           </p:cNvPr>
@@ -4574,7 +4574,7 @@
           <p:cNvPr id="6" name="">
             <a:extLst xmlns:a="http://schemas.openxmlformats.org/drawingml/2006/main">
               <a:ext uri="{FF2B5EF4-FFF2-40B4-BE49-F238E27FC236}">
-                <a16:creationId xmlns:a16="http://schemas.microsoft.com/office/drawing/2014/main" id="{8D3E6DB3-E370-4313-B1E2-8C3369C3E6D7}"/>
+                <a16:creationId xmlns:a16="http://schemas.microsoft.com/office/drawing/2014/main" id="{1F40C20A-F149-49EB-89DE-C1B0A17ED888}"/>
               </a:ext>
             </a:extLst>
           </p:cNvPr>
@@ -4641,7 +4641,7 @@
           <p:cNvPr id="7" name="">
             <a:extLst xmlns:a="http://schemas.openxmlformats.org/drawingml/2006/main">
               <a:ext uri="{FF2B5EF4-FFF2-40B4-BE49-F238E27FC236}">
-                <a16:creationId xmlns:a16="http://schemas.microsoft.com/office/drawing/2014/main" id="{7849535E-3FCC-4B62-A058-75A8C22852C7}"/>
+                <a16:creationId xmlns:a16="http://schemas.microsoft.com/office/drawing/2014/main" id="{4151BCEB-1B36-4975-B55F-6C7D56D87981}"/>
               </a:ext>
             </a:extLst>
           </p:cNvPr>
@@ -4691,7 +4691,7 @@
           <p:cNvPr id="8" name="">
             <a:extLst xmlns:a="http://schemas.openxmlformats.org/drawingml/2006/main">
               <a:ext uri="{FF2B5EF4-FFF2-40B4-BE49-F238E27FC236}">
-                <a16:creationId xmlns:a16="http://schemas.microsoft.com/office/drawing/2014/main" id="{AD379E72-D775-40FF-BF55-88D86A377E59}"/>
+                <a16:creationId xmlns:a16="http://schemas.microsoft.com/office/drawing/2014/main" id="{A42E98BD-FEED-4987-9EA1-536E938C0E2E}"/>
               </a:ext>
             </a:extLst>
           </p:cNvPr>
@@ -4724,7 +4724,7 @@
           <p:cNvPr id="9" name="">
             <a:extLst xmlns:a="http://schemas.openxmlformats.org/drawingml/2006/main">
               <a:ext uri="{FF2B5EF4-FFF2-40B4-BE49-F238E27FC236}">
-                <a16:creationId xmlns:a16="http://schemas.microsoft.com/office/drawing/2014/main" id="{814729D5-5BFE-4FB3-9760-79462AD6FFFA}"/>
+                <a16:creationId xmlns:a16="http://schemas.microsoft.com/office/drawing/2014/main" id="{AC599502-8DA7-477F-90F3-92094AFC2639}"/>
               </a:ext>
             </a:extLst>
           </p:cNvPr>
@@ -4791,7 +4791,7 @@
           <p:cNvPr id="10" name="">
             <a:extLst xmlns:a="http://schemas.openxmlformats.org/drawingml/2006/main">
               <a:ext uri="{FF2B5EF4-FFF2-40B4-BE49-F238E27FC236}">
-                <a16:creationId xmlns:a16="http://schemas.microsoft.com/office/drawing/2014/main" id="{44A87E6E-0C56-4544-BF67-CA178A8C8A03}"/>
+                <a16:creationId xmlns:a16="http://schemas.microsoft.com/office/drawing/2014/main" id="{228B5EEC-80F7-4EBA-9DB4-EABCF2A1A522}"/>
               </a:ext>
             </a:extLst>
           </p:cNvPr>
@@ -4841,7 +4841,7 @@
           <p:cNvPr id="11" name="">
             <a:extLst xmlns:a="http://schemas.openxmlformats.org/drawingml/2006/main">
               <a:ext uri="{FF2B5EF4-FFF2-40B4-BE49-F238E27FC236}">
-                <a16:creationId xmlns:a16="http://schemas.microsoft.com/office/drawing/2014/main" id="{8239F847-3F14-4DCC-B51C-9B7FE62DB506}"/>
+                <a16:creationId xmlns:a16="http://schemas.microsoft.com/office/drawing/2014/main" id="{D40E4BEC-5164-4154-9936-1EC46D69FE39}"/>
               </a:ext>
             </a:extLst>
           </p:cNvPr>
@@ -4874,7 +4874,7 @@
           <p:cNvPr id="12" name="">
             <a:extLst xmlns:a="http://schemas.openxmlformats.org/drawingml/2006/main">
               <a:ext uri="{FF2B5EF4-FFF2-40B4-BE49-F238E27FC236}">
-                <a16:creationId xmlns:a16="http://schemas.microsoft.com/office/drawing/2014/main" id="{A0E78576-591A-4D76-B3F4-9DE8245B49D7}"/>
+                <a16:creationId xmlns:a16="http://schemas.microsoft.com/office/drawing/2014/main" id="{7E1245A2-9E43-4AB3-99AE-FE9BF558CBF4}"/>
               </a:ext>
             </a:extLst>
           </p:cNvPr>
@@ -4941,7 +4941,7 @@
           <p:cNvPr id="13" name="">
             <a:extLst xmlns:a="http://schemas.openxmlformats.org/drawingml/2006/main">
               <a:ext uri="{FF2B5EF4-FFF2-40B4-BE49-F238E27FC236}">
-                <a16:creationId xmlns:a16="http://schemas.microsoft.com/office/drawing/2014/main" id="{9A390FD1-15D9-4729-A752-1252D26C734B}"/>
+                <a16:creationId xmlns:a16="http://schemas.microsoft.com/office/drawing/2014/main" id="{D59B6754-97BF-445B-B8BF-C332EE6C425D}"/>
               </a:ext>
             </a:extLst>
           </p:cNvPr>
@@ -4991,7 +4991,7 @@
           <p:cNvPr id="14" name="">
             <a:extLst xmlns:a="http://schemas.openxmlformats.org/drawingml/2006/main">
               <a:ext uri="{FF2B5EF4-FFF2-40B4-BE49-F238E27FC236}">
-                <a16:creationId xmlns:a16="http://schemas.microsoft.com/office/drawing/2014/main" id="{2672BD10-AADF-42CA-B708-E2BFD4D09B5B}"/>
+                <a16:creationId xmlns:a16="http://schemas.microsoft.com/office/drawing/2014/main" id="{2139AA70-D20D-4B70-8EC2-C5034E1D12E9}"/>
               </a:ext>
             </a:extLst>
           </p:cNvPr>
@@ -5024,7 +5024,7 @@
           <p:cNvPr id="15" name="">
             <a:extLst xmlns:a="http://schemas.openxmlformats.org/drawingml/2006/main">
               <a:ext uri="{FF2B5EF4-FFF2-40B4-BE49-F238E27FC236}">
-                <a16:creationId xmlns:a16="http://schemas.microsoft.com/office/drawing/2014/main" id="{22B4475A-437C-4FDC-9568-CA91320E0936}"/>
+                <a16:creationId xmlns:a16="http://schemas.microsoft.com/office/drawing/2014/main" id="{C00D276A-0BC6-4A90-B792-1FFA1755160F}"/>
               </a:ext>
             </a:extLst>
           </p:cNvPr>
@@ -5091,7 +5091,7 @@
           <p:cNvPr id="16" name="">
             <a:extLst xmlns:a="http://schemas.openxmlformats.org/drawingml/2006/main">
               <a:ext uri="{FF2B5EF4-FFF2-40B4-BE49-F238E27FC236}">
-                <a16:creationId xmlns:a16="http://schemas.microsoft.com/office/drawing/2014/main" id="{1CF4799D-9F75-4FAA-B284-DC3EC4D83C03}"/>
+                <a16:creationId xmlns:a16="http://schemas.microsoft.com/office/drawing/2014/main" id="{F17B7DC6-D0C4-48E5-8002-2060D45C474F}"/>
               </a:ext>
             </a:extLst>
           </p:cNvPr>
@@ -5141,7 +5141,7 @@
           <p:cNvPr id="17" name="">
             <a:extLst xmlns:a="http://schemas.openxmlformats.org/drawingml/2006/main">
               <a:ext uri="{FF2B5EF4-FFF2-40B4-BE49-F238E27FC236}">
-                <a16:creationId xmlns:a16="http://schemas.microsoft.com/office/drawing/2014/main" id="{83F75134-5D4A-4CCC-8861-BA6A6A700D3C}"/>
+                <a16:creationId xmlns:a16="http://schemas.microsoft.com/office/drawing/2014/main" id="{FCA58C49-BBF7-4292-8D23-FEBDB2304C3E}"/>
               </a:ext>
             </a:extLst>
           </p:cNvPr>
@@ -5174,7 +5174,7 @@
           <p:cNvPr id="18" name="">
             <a:extLst xmlns:a="http://schemas.openxmlformats.org/drawingml/2006/main">
               <a:ext uri="{FF2B5EF4-FFF2-40B4-BE49-F238E27FC236}">
-                <a16:creationId xmlns:a16="http://schemas.microsoft.com/office/drawing/2014/main" id="{4B59F3D8-EB25-433C-BC50-57A865E8D387}"/>
+                <a16:creationId xmlns:a16="http://schemas.microsoft.com/office/drawing/2014/main" id="{89F30888-CB8D-40B0-85AA-51DFBFDB7BA8}"/>
               </a:ext>
             </a:extLst>
           </p:cNvPr>
@@ -5241,7 +5241,7 @@
           <p:cNvPr id="19" name="">
             <a:extLst xmlns:a="http://schemas.openxmlformats.org/drawingml/2006/main">
               <a:ext uri="{FF2B5EF4-FFF2-40B4-BE49-F238E27FC236}">
-                <a16:creationId xmlns:a16="http://schemas.microsoft.com/office/drawing/2014/main" id="{4153DACA-02D3-4A6A-9EB4-E91FB9FC817C}"/>
+                <a16:creationId xmlns:a16="http://schemas.microsoft.com/office/drawing/2014/main" id="{A78EEAC0-A935-41E0-BE37-488ACF9DB452}"/>
               </a:ext>
             </a:extLst>
           </p:cNvPr>
@@ -5291,7 +5291,7 @@
           <p:cNvPr id="20" name="">
             <a:extLst xmlns:a="http://schemas.openxmlformats.org/drawingml/2006/main">
               <a:ext uri="{FF2B5EF4-FFF2-40B4-BE49-F238E27FC236}">
-                <a16:creationId xmlns:a16="http://schemas.microsoft.com/office/drawing/2014/main" id="{A24B946D-746A-4006-8311-AE43212777B4}"/>
+                <a16:creationId xmlns:a16="http://schemas.microsoft.com/office/drawing/2014/main" id="{8756D28C-88F1-4631-BD47-1AED28D98790}"/>
               </a:ext>
             </a:extLst>
           </p:cNvPr>
@@ -5324,7 +5324,7 @@
           <p:cNvPr id="21" name="">
             <a:extLst xmlns:a="http://schemas.openxmlformats.org/drawingml/2006/main">
               <a:ext uri="{FF2B5EF4-FFF2-40B4-BE49-F238E27FC236}">
-                <a16:creationId xmlns:a16="http://schemas.microsoft.com/office/drawing/2014/main" id="{4C74D08F-D23D-4572-9FCF-BCE017A5932C}"/>
+                <a16:creationId xmlns:a16="http://schemas.microsoft.com/office/drawing/2014/main" id="{D66A7E7E-4FDA-464B-B355-99267730DCDC}"/>
               </a:ext>
             </a:extLst>
           </p:cNvPr>
@@ -5391,7 +5391,7 @@
           <p:cNvPr id="22" name="">
             <a:extLst xmlns:a="http://schemas.openxmlformats.org/drawingml/2006/main">
               <a:ext uri="{FF2B5EF4-FFF2-40B4-BE49-F238E27FC236}">
-                <a16:creationId xmlns:a16="http://schemas.microsoft.com/office/drawing/2014/main" id="{CF1950A7-A1F5-4911-865A-F69A78378473}"/>
+                <a16:creationId xmlns:a16="http://schemas.microsoft.com/office/drawing/2014/main" id="{AF927F76-D97E-450D-B3D5-57A09670B450}"/>
               </a:ext>
             </a:extLst>
           </p:cNvPr>
@@ -5441,7 +5441,7 @@
           <p:cNvPr id="23" name="">
             <a:extLst xmlns:a="http://schemas.openxmlformats.org/drawingml/2006/main">
               <a:ext uri="{FF2B5EF4-FFF2-40B4-BE49-F238E27FC236}">
-                <a16:creationId xmlns:a16="http://schemas.microsoft.com/office/drawing/2014/main" id="{C2F42015-B8A7-4E46-8088-793E35030988}"/>
+                <a16:creationId xmlns:a16="http://schemas.microsoft.com/office/drawing/2014/main" id="{42E1D216-D3A4-458C-B885-97FC10807B65}"/>
               </a:ext>
             </a:extLst>
           </p:cNvPr>
@@ -5491,7 +5491,7 @@
           <p:cNvPr id="24" name="">
             <a:extLst xmlns:a="http://schemas.openxmlformats.org/drawingml/2006/main">
               <a:ext uri="{FF2B5EF4-FFF2-40B4-BE49-F238E27FC236}">
-                <a16:creationId xmlns:a16="http://schemas.microsoft.com/office/drawing/2014/main" id="{ECA3A164-84DC-49AA-B8F2-7F2FEB8F50CE}"/>
+                <a16:creationId xmlns:a16="http://schemas.microsoft.com/office/drawing/2014/main" id="{165A8E2E-9D68-4B5D-8FDE-346CFD4D6FDF}"/>
               </a:ext>
             </a:extLst>
           </p:cNvPr>
@@ -5541,7 +5541,7 @@
           <p:cNvPr id="25" name="">
             <a:extLst xmlns:a="http://schemas.openxmlformats.org/drawingml/2006/main">
               <a:ext uri="{FF2B5EF4-FFF2-40B4-BE49-F238E27FC236}">
-                <a16:creationId xmlns:a16="http://schemas.microsoft.com/office/drawing/2014/main" id="{49A8D0C5-6977-4322-8249-4444C37D810B}"/>
+                <a16:creationId xmlns:a16="http://schemas.microsoft.com/office/drawing/2014/main" id="{B295C8D9-8A61-4B32-A540-3F75C6E5499D}"/>
               </a:ext>
             </a:extLst>
           </p:cNvPr>
@@ -5591,7 +5591,7 @@
           <p:cNvPr id="26" name="">
             <a:extLst xmlns:a="http://schemas.openxmlformats.org/drawingml/2006/main">
               <a:ext uri="{FF2B5EF4-FFF2-40B4-BE49-F238E27FC236}">
-                <a16:creationId xmlns:a16="http://schemas.microsoft.com/office/drawing/2014/main" id="{E854A301-8071-4457-83B1-DA11452E75D4}"/>
+                <a16:creationId xmlns:a16="http://schemas.microsoft.com/office/drawing/2014/main" id="{49EDEE01-B482-4FE6-A2B3-0BD534019AB3}"/>
               </a:ext>
             </a:extLst>
           </p:cNvPr>
@@ -5641,7 +5641,7 @@
           <p:cNvPr id="27" name="">
             <a:extLst xmlns:a="http://schemas.openxmlformats.org/drawingml/2006/main">
               <a:ext uri="{FF2B5EF4-FFF2-40B4-BE49-F238E27FC236}">
-                <a16:creationId xmlns:a16="http://schemas.microsoft.com/office/drawing/2014/main" id="{1905AD32-BAF6-4E29-B55C-91619581E997}"/>
+                <a16:creationId xmlns:a16="http://schemas.microsoft.com/office/drawing/2014/main" id="{B82218DF-6B7B-4D19-9850-0C632F27B956}"/>
               </a:ext>
             </a:extLst>
           </p:cNvPr>
@@ -5691,7 +5691,7 @@
           <p:cNvPr id="28" name="">
             <a:extLst xmlns:a="http://schemas.openxmlformats.org/drawingml/2006/main">
               <a:ext uri="{FF2B5EF4-FFF2-40B4-BE49-F238E27FC236}">
-                <a16:creationId xmlns:a16="http://schemas.microsoft.com/office/drawing/2014/main" id="{22C74F3F-D76D-4B46-AD0A-983DE2F82985}"/>
+                <a16:creationId xmlns:a16="http://schemas.microsoft.com/office/drawing/2014/main" id="{E6ADDA74-1C07-487E-87CF-7B0E1B7DBC65}"/>
               </a:ext>
             </a:extLst>
           </p:cNvPr>
@@ -5741,7 +5741,7 @@
           <p:cNvPr id="29" name="">
             <a:extLst xmlns:a="http://schemas.openxmlformats.org/drawingml/2006/main">
               <a:ext uri="{FF2B5EF4-FFF2-40B4-BE49-F238E27FC236}">
-                <a16:creationId xmlns:a16="http://schemas.microsoft.com/office/drawing/2014/main" id="{25148BE0-89B6-4DB2-82E9-65B3C277A3E2}"/>
+                <a16:creationId xmlns:a16="http://schemas.microsoft.com/office/drawing/2014/main" id="{78B69794-CE37-43E2-876C-BB56E69A6871}"/>
               </a:ext>
             </a:extLst>
           </p:cNvPr>
@@ -5791,7 +5791,7 @@
           <p:cNvPr id="30" name="">
             <a:extLst xmlns:a="http://schemas.openxmlformats.org/drawingml/2006/main">
               <a:ext uri="{FF2B5EF4-FFF2-40B4-BE49-F238E27FC236}">
-                <a16:creationId xmlns:a16="http://schemas.microsoft.com/office/drawing/2014/main" id="{6183B81B-E7BF-45C0-A3BD-D8F77E0C84CE}"/>
+                <a16:creationId xmlns:a16="http://schemas.microsoft.com/office/drawing/2014/main" id="{892AA204-1BDA-456B-BCF6-751A8ADD30BE}"/>
               </a:ext>
             </a:extLst>
           </p:cNvPr>
@@ -5841,7 +5841,7 @@
           <p:cNvPr id="31" name="">
             <a:extLst xmlns:a="http://schemas.openxmlformats.org/drawingml/2006/main">
               <a:ext uri="{FF2B5EF4-FFF2-40B4-BE49-F238E27FC236}">
-                <a16:creationId xmlns:a16="http://schemas.microsoft.com/office/drawing/2014/main" id="{C8E61904-73CF-4D99-9DAF-D00433B39FFC}"/>
+                <a16:creationId xmlns:a16="http://schemas.microsoft.com/office/drawing/2014/main" id="{A8FE5FBE-E373-4E58-886E-B5B8A2405094}"/>
               </a:ext>
             </a:extLst>
           </p:cNvPr>
@@ -5874,7 +5874,7 @@
           <p:cNvPr id="32" name="">
             <a:extLst xmlns:a="http://schemas.openxmlformats.org/drawingml/2006/main">
               <a:ext uri="{FF2B5EF4-FFF2-40B4-BE49-F238E27FC236}">
-                <a16:creationId xmlns:a16="http://schemas.microsoft.com/office/drawing/2014/main" id="{497BA6C2-B996-460A-8581-E2E147D0FF89}"/>
+                <a16:creationId xmlns:a16="http://schemas.microsoft.com/office/drawing/2014/main" id="{362A6D03-551C-4827-A3B8-D4DB360927CE}"/>
               </a:ext>
             </a:extLst>
           </p:cNvPr>
@@ -5924,7 +5924,7 @@
           <p:cNvPr id="33" name="">
             <a:extLst xmlns:a="http://schemas.openxmlformats.org/drawingml/2006/main">
               <a:ext uri="{FF2B5EF4-FFF2-40B4-BE49-F238E27FC236}">
-                <a16:creationId xmlns:a16="http://schemas.microsoft.com/office/drawing/2014/main" id="{A1EC50CA-43D5-47D1-AEB5-5F8FC1DD27F1}"/>
+                <a16:creationId xmlns:a16="http://schemas.microsoft.com/office/drawing/2014/main" id="{A2D30A73-38F2-459E-9A21-A4D9D0533216}"/>
               </a:ext>
             </a:extLst>
           </p:cNvPr>
@@ -6091,7 +6091,7 @@
     </p:spTree>
     <p:extLst>
       <p:ext uri="{BB962C8B-B14F-4D97-AF65-F5344CB8AC3E}">
-        <p14:creationId xmlns:p14="http://schemas.microsoft.com/office/powerpoint/2010/main" val="1071865976"/>
+        <p14:creationId xmlns:p14="http://schemas.microsoft.com/office/powerpoint/2010/main" val="635890156"/>
       </p:ext>
     </p:extLst>
   </p:cSld>
@@ -6122,7 +6122,7 @@
           <p:cNvPr id="30" name="">
             <a:extLst xmlns:a="http://schemas.openxmlformats.org/drawingml/2006/main">
               <a:ext uri="{FF2B5EF4-FFF2-40B4-BE49-F238E27FC236}">
-                <a16:creationId xmlns:a16="http://schemas.microsoft.com/office/drawing/2014/main" id="{CF29B43B-A302-4857-80D1-4AAE94021117}"/>
+                <a16:creationId xmlns:a16="http://schemas.microsoft.com/office/drawing/2014/main" id="{60BFE707-8921-4780-9FD5-1DE51A966DAE}"/>
               </a:ext>
             </a:extLst>
           </p:cNvPr>
@@ -6172,7 +6172,7 @@
           <p:cNvPr id="2" name="">
             <a:extLst xmlns:a="http://schemas.openxmlformats.org/drawingml/2006/main">
               <a:ext uri="{FF2B5EF4-FFF2-40B4-BE49-F238E27FC236}">
-                <a16:creationId xmlns:a16="http://schemas.microsoft.com/office/drawing/2014/main" id="{57529908-3DAC-46E3-BFAF-4C6FB6A8FB17}"/>
+                <a16:creationId xmlns:a16="http://schemas.microsoft.com/office/drawing/2014/main" id="{C03A9D0A-9132-4AD7-8F86-2E280BFC39B0}"/>
               </a:ext>
             </a:extLst>
           </p:cNvPr>
@@ -6222,7 +6222,7 @@
           <p:cNvPr id="3" name="">
             <a:extLst xmlns:a="http://schemas.openxmlformats.org/drawingml/2006/main">
               <a:ext uri="{FF2B5EF4-FFF2-40B4-BE49-F238E27FC236}">
-                <a16:creationId xmlns:a16="http://schemas.microsoft.com/office/drawing/2014/main" id="{28AC6C05-0017-46B9-AEBD-F4A477F0DA3D}"/>
+                <a16:creationId xmlns:a16="http://schemas.microsoft.com/office/drawing/2014/main" id="{7B5EC6C0-EE4F-4E7A-925C-0CB16945D39A}"/>
               </a:ext>
             </a:extLst>
           </p:cNvPr>
@@ -6255,7 +6255,7 @@
           <p:cNvPr id="4" name="">
             <a:extLst xmlns:a="http://schemas.openxmlformats.org/drawingml/2006/main">
               <a:ext uri="{FF2B5EF4-FFF2-40B4-BE49-F238E27FC236}">
-                <a16:creationId xmlns:a16="http://schemas.microsoft.com/office/drawing/2014/main" id="{2DDB6EF1-AA16-4F6E-B331-7BF7EB8FE0B4}"/>
+                <a16:creationId xmlns:a16="http://schemas.microsoft.com/office/drawing/2014/main" id="{09DAC40B-62F8-4CF0-956D-24F628931636}"/>
               </a:ext>
             </a:extLst>
           </p:cNvPr>
@@ -6305,7 +6305,7 @@
           <p:cNvPr id="5" name="">
             <a:extLst xmlns:a="http://schemas.openxmlformats.org/drawingml/2006/main">
               <a:ext uri="{FF2B5EF4-FFF2-40B4-BE49-F238E27FC236}">
-                <a16:creationId xmlns:a16="http://schemas.microsoft.com/office/drawing/2014/main" id="{85260CC6-737B-4AD9-94CB-178916D6235D}"/>
+                <a16:creationId xmlns:a16="http://schemas.microsoft.com/office/drawing/2014/main" id="{82544621-4DF9-43E2-A110-A047CB132ABA}"/>
               </a:ext>
             </a:extLst>
           </p:cNvPr>
@@ -6338,7 +6338,7 @@
           <p:cNvPr id="6" name="">
             <a:extLst xmlns:a="http://schemas.openxmlformats.org/drawingml/2006/main">
               <a:ext uri="{FF2B5EF4-FFF2-40B4-BE49-F238E27FC236}">
-                <a16:creationId xmlns:a16="http://schemas.microsoft.com/office/drawing/2014/main" id="{FEDE0D88-7B5E-4DFF-AEB6-80E4C3298CE3}"/>
+                <a16:creationId xmlns:a16="http://schemas.microsoft.com/office/drawing/2014/main" id="{10B04D11-DBA9-452E-B43B-95FA15F0F67B}"/>
               </a:ext>
             </a:extLst>
           </p:cNvPr>
@@ -6405,7 +6405,7 @@
           <p:cNvPr id="7" name="">
             <a:extLst xmlns:a="http://schemas.openxmlformats.org/drawingml/2006/main">
               <a:ext uri="{FF2B5EF4-FFF2-40B4-BE49-F238E27FC236}">
-                <a16:creationId xmlns:a16="http://schemas.microsoft.com/office/drawing/2014/main" id="{B6E2C61A-7BAF-47DF-8E4F-8EEFCCBEF810}"/>
+                <a16:creationId xmlns:a16="http://schemas.microsoft.com/office/drawing/2014/main" id="{8CC0F0D3-660A-4C53-8C8D-F2807540A2A2}"/>
               </a:ext>
             </a:extLst>
           </p:cNvPr>
@@ -6455,7 +6455,7 @@
           <p:cNvPr id="8" name="">
             <a:extLst xmlns:a="http://schemas.openxmlformats.org/drawingml/2006/main">
               <a:ext uri="{FF2B5EF4-FFF2-40B4-BE49-F238E27FC236}">
-                <a16:creationId xmlns:a16="http://schemas.microsoft.com/office/drawing/2014/main" id="{93B4F4C5-FFB3-43B1-8C6A-C6920CF1323A}"/>
+                <a16:creationId xmlns:a16="http://schemas.microsoft.com/office/drawing/2014/main" id="{FD6B73E2-8EF0-4D5D-98C5-DD2A66444CC5}"/>
               </a:ext>
             </a:extLst>
           </p:cNvPr>
@@ -6488,7 +6488,7 @@
           <p:cNvPr id="9" name="">
             <a:extLst xmlns:a="http://schemas.openxmlformats.org/drawingml/2006/main">
               <a:ext uri="{FF2B5EF4-FFF2-40B4-BE49-F238E27FC236}">
-                <a16:creationId xmlns:a16="http://schemas.microsoft.com/office/drawing/2014/main" id="{1DAC99AC-ABF5-4F42-A5B7-2BEC56BBDBF3}"/>
+                <a16:creationId xmlns:a16="http://schemas.microsoft.com/office/drawing/2014/main" id="{98ED4C2F-C44C-4E21-ABA4-7BDE19A3738C}"/>
               </a:ext>
             </a:extLst>
           </p:cNvPr>
@@ -6555,7 +6555,7 @@
           <p:cNvPr id="10" name="">
             <a:extLst xmlns:a="http://schemas.openxmlformats.org/drawingml/2006/main">
               <a:ext uri="{FF2B5EF4-FFF2-40B4-BE49-F238E27FC236}">
-                <a16:creationId xmlns:a16="http://schemas.microsoft.com/office/drawing/2014/main" id="{8C2FE52D-DA2A-4E28-B8A1-7E29660DACAE}"/>
+                <a16:creationId xmlns:a16="http://schemas.microsoft.com/office/drawing/2014/main" id="{F2365720-F552-424B-9177-0C0FCDB4665B}"/>
               </a:ext>
             </a:extLst>
           </p:cNvPr>
@@ -6605,7 +6605,7 @@
           <p:cNvPr id="11" name="">
             <a:extLst xmlns:a="http://schemas.openxmlformats.org/drawingml/2006/main">
               <a:ext uri="{FF2B5EF4-FFF2-40B4-BE49-F238E27FC236}">
-                <a16:creationId xmlns:a16="http://schemas.microsoft.com/office/drawing/2014/main" id="{ABD3B456-D23A-4F87-BF03-C90FDA0BE406}"/>
+                <a16:creationId xmlns:a16="http://schemas.microsoft.com/office/drawing/2014/main" id="{A41FA7A8-CF08-4A32-92D7-BD36F57DC711}"/>
               </a:ext>
             </a:extLst>
           </p:cNvPr>
@@ -6638,7 +6638,7 @@
           <p:cNvPr id="12" name="">
             <a:extLst xmlns:a="http://schemas.openxmlformats.org/drawingml/2006/main">
               <a:ext uri="{FF2B5EF4-FFF2-40B4-BE49-F238E27FC236}">
-                <a16:creationId xmlns:a16="http://schemas.microsoft.com/office/drawing/2014/main" id="{94F2B016-BBE6-4E4E-B3BE-D3E14C3CC8BD}"/>
+                <a16:creationId xmlns:a16="http://schemas.microsoft.com/office/drawing/2014/main" id="{BABA82F9-AF53-49B5-8CA6-B58480714DCC}"/>
               </a:ext>
             </a:extLst>
           </p:cNvPr>
@@ -6705,7 +6705,7 @@
           <p:cNvPr id="13" name="">
             <a:extLst xmlns:a="http://schemas.openxmlformats.org/drawingml/2006/main">
               <a:ext uri="{FF2B5EF4-FFF2-40B4-BE49-F238E27FC236}">
-                <a16:creationId xmlns:a16="http://schemas.microsoft.com/office/drawing/2014/main" id="{3BFDC8DD-3B30-400E-AAFE-055D7080C9D2}"/>
+                <a16:creationId xmlns:a16="http://schemas.microsoft.com/office/drawing/2014/main" id="{69DC2914-BF28-4543-BA5D-B2D617E8487B}"/>
               </a:ext>
             </a:extLst>
           </p:cNvPr>
@@ -6755,7 +6755,7 @@
           <p:cNvPr id="14" name="">
             <a:extLst xmlns:a="http://schemas.openxmlformats.org/drawingml/2006/main">
               <a:ext uri="{FF2B5EF4-FFF2-40B4-BE49-F238E27FC236}">
-                <a16:creationId xmlns:a16="http://schemas.microsoft.com/office/drawing/2014/main" id="{E64D8E69-311D-4CCC-9DF9-2E6ED0577C55}"/>
+                <a16:creationId xmlns:a16="http://schemas.microsoft.com/office/drawing/2014/main" id="{7D27B08B-342F-40C0-AB62-791A278DDBAA}"/>
               </a:ext>
             </a:extLst>
           </p:cNvPr>
@@ -6805,7 +6805,7 @@
           <p:cNvPr id="15" name="">
             <a:extLst xmlns:a="http://schemas.openxmlformats.org/drawingml/2006/main">
               <a:ext uri="{FF2B5EF4-FFF2-40B4-BE49-F238E27FC236}">
-                <a16:creationId xmlns:a16="http://schemas.microsoft.com/office/drawing/2014/main" id="{D3D62C70-1825-4947-95D6-DA9EA11F395D}"/>
+                <a16:creationId xmlns:a16="http://schemas.microsoft.com/office/drawing/2014/main" id="{300442A1-0B80-4D98-BB33-0C6751032BCE}"/>
               </a:ext>
             </a:extLst>
           </p:cNvPr>
@@ -6855,7 +6855,7 @@
           <p:cNvPr id="16" name="">
             <a:extLst xmlns:a="http://schemas.openxmlformats.org/drawingml/2006/main">
               <a:ext uri="{FF2B5EF4-FFF2-40B4-BE49-F238E27FC236}">
-                <a16:creationId xmlns:a16="http://schemas.microsoft.com/office/drawing/2014/main" id="{D2C89A9F-84CC-4194-BF51-C0184E382D15}"/>
+                <a16:creationId xmlns:a16="http://schemas.microsoft.com/office/drawing/2014/main" id="{2693AF63-2076-4584-A025-216164145C23}"/>
               </a:ext>
             </a:extLst>
           </p:cNvPr>
@@ -6888,7 +6888,7 @@
           <p:cNvPr id="17" name="">
             <a:extLst xmlns:a="http://schemas.openxmlformats.org/drawingml/2006/main">
               <a:ext uri="{FF2B5EF4-FFF2-40B4-BE49-F238E27FC236}">
-                <a16:creationId xmlns:a16="http://schemas.microsoft.com/office/drawing/2014/main" id="{D59970B3-EC56-416A-8CF2-161F6063DD60}"/>
+                <a16:creationId xmlns:a16="http://schemas.microsoft.com/office/drawing/2014/main" id="{284F30C9-074A-46F8-BA79-7E182AB450F9}"/>
               </a:ext>
             </a:extLst>
           </p:cNvPr>
@@ -6938,7 +6938,7 @@
           <p:cNvPr id="18" name="">
             <a:extLst xmlns:a="http://schemas.openxmlformats.org/drawingml/2006/main">
               <a:ext uri="{FF2B5EF4-FFF2-40B4-BE49-F238E27FC236}">
-                <a16:creationId xmlns:a16="http://schemas.microsoft.com/office/drawing/2014/main" id="{C45F3235-9B26-42B8-A044-228A3F2E438F}"/>
+                <a16:creationId xmlns:a16="http://schemas.microsoft.com/office/drawing/2014/main" id="{A9D573F4-7CF0-4970-BAF6-DF549C56A861}"/>
               </a:ext>
             </a:extLst>
           </p:cNvPr>
@@ -7095,7 +7095,7 @@
           <p:cNvPr id="19" name="">
             <a:extLst xmlns:a="http://schemas.openxmlformats.org/drawingml/2006/main">
               <a:ext uri="{FF2B5EF4-FFF2-40B4-BE49-F238E27FC236}">
-                <a16:creationId xmlns:a16="http://schemas.microsoft.com/office/drawing/2014/main" id="{6FF5395C-F4C8-4E78-8D7E-69ED51B4E8D7}"/>
+                <a16:creationId xmlns:a16="http://schemas.microsoft.com/office/drawing/2014/main" id="{0B9B7632-97A8-4AB8-8110-9391D9ADA70D}"/>
               </a:ext>
             </a:extLst>
           </p:cNvPr>
@@ -7128,7 +7128,7 @@
           <p:cNvPr id="20" name="">
             <a:extLst xmlns:a="http://schemas.openxmlformats.org/drawingml/2006/main">
               <a:ext uri="{FF2B5EF4-FFF2-40B4-BE49-F238E27FC236}">
-                <a16:creationId xmlns:a16="http://schemas.microsoft.com/office/drawing/2014/main" id="{15EAEF1E-32CA-44E4-A7B5-04226ABC5FD1}"/>
+                <a16:creationId xmlns:a16="http://schemas.microsoft.com/office/drawing/2014/main" id="{28EECAFD-D66E-4C86-A5C0-5BD3F99BEEC9}"/>
               </a:ext>
             </a:extLst>
           </p:cNvPr>
@@ -7178,7 +7178,7 @@
           <p:cNvPr id="21" name="">
             <a:extLst xmlns:a="http://schemas.openxmlformats.org/drawingml/2006/main">
               <a:ext uri="{FF2B5EF4-FFF2-40B4-BE49-F238E27FC236}">
-                <a16:creationId xmlns:a16="http://schemas.microsoft.com/office/drawing/2014/main" id="{F9413058-21D9-4419-8630-54529CB84FE3}"/>
+                <a16:creationId xmlns:a16="http://schemas.microsoft.com/office/drawing/2014/main" id="{A51EA395-2260-4598-85E7-C2BAB11F6D03}"/>
               </a:ext>
             </a:extLst>
           </p:cNvPr>
@@ -7211,7 +7211,7 @@
           <p:cNvPr id="22" name="">
             <a:extLst xmlns:a="http://schemas.openxmlformats.org/drawingml/2006/main">
               <a:ext uri="{FF2B5EF4-FFF2-40B4-BE49-F238E27FC236}">
-                <a16:creationId xmlns:a16="http://schemas.microsoft.com/office/drawing/2014/main" id="{E79084B6-CFC5-4138-A6D4-5DD6C9B72C0E}"/>
+                <a16:creationId xmlns:a16="http://schemas.microsoft.com/office/drawing/2014/main" id="{A5A75673-9D78-49E4-9A27-C6FDCCF6DCAE}"/>
               </a:ext>
             </a:extLst>
           </p:cNvPr>
@@ -7261,7 +7261,7 @@
           <p:cNvPr id="23" name="">
             <a:extLst xmlns:a="http://schemas.openxmlformats.org/drawingml/2006/main">
               <a:ext uri="{FF2B5EF4-FFF2-40B4-BE49-F238E27FC236}">
-                <a16:creationId xmlns:a16="http://schemas.microsoft.com/office/drawing/2014/main" id="{0799D25A-F035-4EE9-AC17-78AF115DCFFB}"/>
+                <a16:creationId xmlns:a16="http://schemas.microsoft.com/office/drawing/2014/main" id="{5608944E-F6A6-4BBB-B8A5-27BFAEEF026F}"/>
               </a:ext>
             </a:extLst>
           </p:cNvPr>
@@ -7311,7 +7311,7 @@
           <p:cNvPr id="24" name="">
             <a:extLst xmlns:a="http://schemas.openxmlformats.org/drawingml/2006/main">
               <a:ext uri="{FF2B5EF4-FFF2-40B4-BE49-F238E27FC236}">
-                <a16:creationId xmlns:a16="http://schemas.microsoft.com/office/drawing/2014/main" id="{5BE60B31-6C03-4D23-9A59-994B73429C29}"/>
+                <a16:creationId xmlns:a16="http://schemas.microsoft.com/office/drawing/2014/main" id="{95462C82-BD19-455E-A36E-A1225EB08121}"/>
               </a:ext>
             </a:extLst>
           </p:cNvPr>
@@ -7344,7 +7344,7 @@
           <p:cNvPr id="25" name="">
             <a:extLst xmlns:a="http://schemas.openxmlformats.org/drawingml/2006/main">
               <a:ext uri="{FF2B5EF4-FFF2-40B4-BE49-F238E27FC236}">
-                <a16:creationId xmlns:a16="http://schemas.microsoft.com/office/drawing/2014/main" id="{1DB106F5-5655-4354-A13B-AA7C06BF2DA0}"/>
+                <a16:creationId xmlns:a16="http://schemas.microsoft.com/office/drawing/2014/main" id="{4FF49D44-38AA-4148-A006-5F95ED184CFE}"/>
               </a:ext>
             </a:extLst>
           </p:cNvPr>
@@ -7394,7 +7394,7 @@
           <p:cNvPr id="26" name="">
             <a:extLst xmlns:a="http://schemas.openxmlformats.org/drawingml/2006/main">
               <a:ext uri="{FF2B5EF4-FFF2-40B4-BE49-F238E27FC236}">
-                <a16:creationId xmlns:a16="http://schemas.microsoft.com/office/drawing/2014/main" id="{FDC272A5-C81E-40FD-8ABA-EA34723A0E6D}"/>
+                <a16:creationId xmlns:a16="http://schemas.microsoft.com/office/drawing/2014/main" id="{45BF8A7D-A628-49F7-8E14-88CD201DFDA0}"/>
               </a:ext>
             </a:extLst>
           </p:cNvPr>
@@ -7444,7 +7444,7 @@
           <p:cNvPr id="27" name="">
             <a:extLst xmlns:a="http://schemas.openxmlformats.org/drawingml/2006/main">
               <a:ext uri="{FF2B5EF4-FFF2-40B4-BE49-F238E27FC236}">
-                <a16:creationId xmlns:a16="http://schemas.microsoft.com/office/drawing/2014/main" id="{33FFB7E2-4657-49AE-8475-454907474EB2}"/>
+                <a16:creationId xmlns:a16="http://schemas.microsoft.com/office/drawing/2014/main" id="{517D11A9-919D-4310-9992-2D9AE05D0E32}"/>
               </a:ext>
             </a:extLst>
           </p:cNvPr>
@@ -7477,7 +7477,7 @@
           <p:cNvPr id="28" name="">
             <a:extLst xmlns:a="http://schemas.openxmlformats.org/drawingml/2006/main">
               <a:ext uri="{FF2B5EF4-FFF2-40B4-BE49-F238E27FC236}">
-                <a16:creationId xmlns:a16="http://schemas.microsoft.com/office/drawing/2014/main" id="{5C58D6A4-93EF-412A-A16C-BDBF1C7BF48E}"/>
+                <a16:creationId xmlns:a16="http://schemas.microsoft.com/office/drawing/2014/main" id="{5B05DD31-73FD-4995-9A94-BF38948D9BC6}"/>
               </a:ext>
             </a:extLst>
           </p:cNvPr>
@@ -7527,7 +7527,7 @@
           <p:cNvPr id="29" name="">
             <a:extLst xmlns:a="http://schemas.openxmlformats.org/drawingml/2006/main">
               <a:ext uri="{FF2B5EF4-FFF2-40B4-BE49-F238E27FC236}">
-                <a16:creationId xmlns:a16="http://schemas.microsoft.com/office/drawing/2014/main" id="{CFFD7AFF-C346-4D0A-8AA2-39AF61E31835}"/>
+                <a16:creationId xmlns:a16="http://schemas.microsoft.com/office/drawing/2014/main" id="{C15AA487-BFD8-4709-980B-9609D7A91B80}"/>
               </a:ext>
             </a:extLst>
           </p:cNvPr>
@@ -7575,7 +7575,7 @@
     </p:spTree>
     <p:extLst>
       <p:ext uri="{BB962C8B-B14F-4D97-AF65-F5344CB8AC3E}">
-        <p14:creationId xmlns:p14="http://schemas.microsoft.com/office/powerpoint/2010/main" val="2012564758"/>
+        <p14:creationId xmlns:p14="http://schemas.microsoft.com/office/powerpoint/2010/main" val="699301837"/>
       </p:ext>
     </p:extLst>
   </p:cSld>
@@ -7606,7 +7606,7 @@
           <p:cNvPr id="31" name="">
             <a:extLst xmlns:a="http://schemas.openxmlformats.org/drawingml/2006/main">
               <a:ext uri="{FF2B5EF4-FFF2-40B4-BE49-F238E27FC236}">
-                <a16:creationId xmlns:a16="http://schemas.microsoft.com/office/drawing/2014/main" id="{B9A2AC9E-2691-45FF-AFF9-02275406C25F}"/>
+                <a16:creationId xmlns:a16="http://schemas.microsoft.com/office/drawing/2014/main" id="{020642BB-A597-440F-BEEE-8FBD6C12ABF0}"/>
               </a:ext>
             </a:extLst>
           </p:cNvPr>
@@ -7656,7 +7656,7 @@
           <p:cNvPr id="2" name="">
             <a:extLst xmlns:a="http://schemas.openxmlformats.org/drawingml/2006/main">
               <a:ext uri="{FF2B5EF4-FFF2-40B4-BE49-F238E27FC236}">
-                <a16:creationId xmlns:a16="http://schemas.microsoft.com/office/drawing/2014/main" id="{A47A23D5-23BF-43A3-8E5C-A4CC36C1C845}"/>
+                <a16:creationId xmlns:a16="http://schemas.microsoft.com/office/drawing/2014/main" id="{5E1D7A14-5A28-483D-B490-F2FAF60D788D}"/>
               </a:ext>
             </a:extLst>
           </p:cNvPr>
@@ -7706,7 +7706,7 @@
           <p:cNvPr id="3" name="">
             <a:extLst xmlns:a="http://schemas.openxmlformats.org/drawingml/2006/main">
               <a:ext uri="{FF2B5EF4-FFF2-40B4-BE49-F238E27FC236}">
-                <a16:creationId xmlns:a16="http://schemas.microsoft.com/office/drawing/2014/main" id="{9D897CBE-0DFE-41AD-8787-0B7A757D0E51}"/>
+                <a16:creationId xmlns:a16="http://schemas.microsoft.com/office/drawing/2014/main" id="{7057AF63-BCA7-4458-9EEE-2978B4C070FF}"/>
               </a:ext>
             </a:extLst>
           </p:cNvPr>
@@ -7739,7 +7739,7 @@
           <p:cNvPr id="4" name="">
             <a:extLst xmlns:a="http://schemas.openxmlformats.org/drawingml/2006/main">
               <a:ext uri="{FF2B5EF4-FFF2-40B4-BE49-F238E27FC236}">
-                <a16:creationId xmlns:a16="http://schemas.microsoft.com/office/drawing/2014/main" id="{9D2F3467-A2E9-4C4B-AA93-EA45C5770252}"/>
+                <a16:creationId xmlns:a16="http://schemas.microsoft.com/office/drawing/2014/main" id="{E908A46E-B9AC-4541-963A-443F1121FBA5}"/>
               </a:ext>
             </a:extLst>
           </p:cNvPr>
@@ -7789,7 +7789,7 @@
           <p:cNvPr id="5" name="">
             <a:extLst xmlns:a="http://schemas.openxmlformats.org/drawingml/2006/main">
               <a:ext uri="{FF2B5EF4-FFF2-40B4-BE49-F238E27FC236}">
-                <a16:creationId xmlns:a16="http://schemas.microsoft.com/office/drawing/2014/main" id="{A7C69B91-A475-4D04-A8AF-F6B50C91E4F2}"/>
+                <a16:creationId xmlns:a16="http://schemas.microsoft.com/office/drawing/2014/main" id="{2008AFE4-1F73-47AE-9423-C6CC3F94D040}"/>
               </a:ext>
             </a:extLst>
           </p:cNvPr>
@@ -7822,7 +7822,7 @@
           <p:cNvPr id="6" name="">
             <a:extLst xmlns:a="http://schemas.openxmlformats.org/drawingml/2006/main">
               <a:ext uri="{FF2B5EF4-FFF2-40B4-BE49-F238E27FC236}">
-                <a16:creationId xmlns:a16="http://schemas.microsoft.com/office/drawing/2014/main" id="{91C5116A-D990-4634-B7A9-8F7854DD408B}"/>
+                <a16:creationId xmlns:a16="http://schemas.microsoft.com/office/drawing/2014/main" id="{60B111DD-3502-41AA-80D7-561CB4C95E4F}"/>
               </a:ext>
             </a:extLst>
           </p:cNvPr>
@@ -7872,7 +7872,7 @@
           <p:cNvPr id="7" name="">
             <a:extLst xmlns:a="http://schemas.openxmlformats.org/drawingml/2006/main">
               <a:ext uri="{FF2B5EF4-FFF2-40B4-BE49-F238E27FC236}">
-                <a16:creationId xmlns:a16="http://schemas.microsoft.com/office/drawing/2014/main" id="{B7013433-98DB-4717-A174-5B99287DC87E}"/>
+                <a16:creationId xmlns:a16="http://schemas.microsoft.com/office/drawing/2014/main" id="{CBCFD3CA-17A5-49C7-9EBD-2E409DD61809}"/>
               </a:ext>
             </a:extLst>
           </p:cNvPr>
@@ -8046,7 +8046,7 @@
           <p:cNvPr id="8" name="">
             <a:extLst xmlns:a="http://schemas.openxmlformats.org/drawingml/2006/main">
               <a:ext uri="{FF2B5EF4-FFF2-40B4-BE49-F238E27FC236}">
-                <a16:creationId xmlns:a16="http://schemas.microsoft.com/office/drawing/2014/main" id="{584A48E9-707F-437B-BD74-D801FD115544}"/>
+                <a16:creationId xmlns:a16="http://schemas.microsoft.com/office/drawing/2014/main" id="{A751A598-6D2B-4F4E-9921-C41DACF6A064}"/>
               </a:ext>
             </a:extLst>
           </p:cNvPr>
@@ -8096,7 +8096,7 @@
           <p:cNvPr id="9" name="">
             <a:extLst xmlns:a="http://schemas.openxmlformats.org/drawingml/2006/main">
               <a:ext uri="{FF2B5EF4-FFF2-40B4-BE49-F238E27FC236}">
-                <a16:creationId xmlns:a16="http://schemas.microsoft.com/office/drawing/2014/main" id="{7D7411F6-C8B8-4E0C-A5A4-C4307F4CF0F1}"/>
+                <a16:creationId xmlns:a16="http://schemas.microsoft.com/office/drawing/2014/main" id="{6C7EA2A9-E882-4304-880E-4CA271A3C801}"/>
               </a:ext>
             </a:extLst>
           </p:cNvPr>
@@ -8146,7 +8146,7 @@
           <p:cNvPr id="10" name="">
             <a:extLst xmlns:a="http://schemas.openxmlformats.org/drawingml/2006/main">
               <a:ext uri="{FF2B5EF4-FFF2-40B4-BE49-F238E27FC236}">
-                <a16:creationId xmlns:a16="http://schemas.microsoft.com/office/drawing/2014/main" id="{11FDE3EA-D144-49FE-9549-764A895C432E}"/>
+                <a16:creationId xmlns:a16="http://schemas.microsoft.com/office/drawing/2014/main" id="{FD312DCB-BCCA-4B15-AE1E-FE6BCC31EE38}"/>
               </a:ext>
             </a:extLst>
           </p:cNvPr>
@@ -8196,7 +8196,7 @@
           <p:cNvPr id="11" name="">
             <a:extLst xmlns:a="http://schemas.openxmlformats.org/drawingml/2006/main">
               <a:ext uri="{FF2B5EF4-FFF2-40B4-BE49-F238E27FC236}">
-                <a16:creationId xmlns:a16="http://schemas.microsoft.com/office/drawing/2014/main" id="{B7514483-CFD4-4A1B-83CA-0949E5CD93B8}"/>
+                <a16:creationId xmlns:a16="http://schemas.microsoft.com/office/drawing/2014/main" id="{C6EDB74C-D73E-49DF-844D-A2E594714E07}"/>
               </a:ext>
             </a:extLst>
           </p:cNvPr>
@@ -8246,7 +8246,7 @@
           <p:cNvPr id="12" name="">
             <a:extLst xmlns:a="http://schemas.openxmlformats.org/drawingml/2006/main">
               <a:ext uri="{FF2B5EF4-FFF2-40B4-BE49-F238E27FC236}">
-                <a16:creationId xmlns:a16="http://schemas.microsoft.com/office/drawing/2014/main" id="{CCDF6245-CA40-45EF-B9F3-FF56FAE4C963}"/>
+                <a16:creationId xmlns:a16="http://schemas.microsoft.com/office/drawing/2014/main" id="{B185EF76-B7F9-4226-9BC2-CC5B820A4E1B}"/>
               </a:ext>
             </a:extLst>
           </p:cNvPr>
@@ -8296,7 +8296,7 @@
           <p:cNvPr id="13" name="">
             <a:extLst xmlns:a="http://schemas.openxmlformats.org/drawingml/2006/main">
               <a:ext uri="{FF2B5EF4-FFF2-40B4-BE49-F238E27FC236}">
-                <a16:creationId xmlns:a16="http://schemas.microsoft.com/office/drawing/2014/main" id="{E2C2FD9C-9BFC-43E2-9F2C-DB3274DFD348}"/>
+                <a16:creationId xmlns:a16="http://schemas.microsoft.com/office/drawing/2014/main" id="{972818CC-091B-4D89-9850-43E07EC18E6B}"/>
               </a:ext>
             </a:extLst>
           </p:cNvPr>
@@ -8346,7 +8346,7 @@
           <p:cNvPr id="14" name="">
             <a:extLst xmlns:a="http://schemas.openxmlformats.org/drawingml/2006/main">
               <a:ext uri="{FF2B5EF4-FFF2-40B4-BE49-F238E27FC236}">
-                <a16:creationId xmlns:a16="http://schemas.microsoft.com/office/drawing/2014/main" id="{DBC63397-1EC4-4AC2-ABE5-7AC89F3ACB8D}"/>
+                <a16:creationId xmlns:a16="http://schemas.microsoft.com/office/drawing/2014/main" id="{3546FD59-0593-4350-8621-9C8796FF613A}"/>
               </a:ext>
             </a:extLst>
           </p:cNvPr>
@@ -8396,7 +8396,7 @@
           <p:cNvPr id="15" name="">
             <a:extLst xmlns:a="http://schemas.openxmlformats.org/drawingml/2006/main">
               <a:ext uri="{FF2B5EF4-FFF2-40B4-BE49-F238E27FC236}">
-                <a16:creationId xmlns:a16="http://schemas.microsoft.com/office/drawing/2014/main" id="{36E58C39-A9B0-4A06-98E5-803C4833318A}"/>
+                <a16:creationId xmlns:a16="http://schemas.microsoft.com/office/drawing/2014/main" id="{B779F29A-01FA-48CE-9A40-9AFDE153100F}"/>
               </a:ext>
             </a:extLst>
           </p:cNvPr>
@@ -8446,7 +8446,7 @@
           <p:cNvPr id="16" name="">
             <a:extLst xmlns:a="http://schemas.openxmlformats.org/drawingml/2006/main">
               <a:ext uri="{FF2B5EF4-FFF2-40B4-BE49-F238E27FC236}">
-                <a16:creationId xmlns:a16="http://schemas.microsoft.com/office/drawing/2014/main" id="{8DCE98D4-4AED-4D83-909C-01A9ACF80D36}"/>
+                <a16:creationId xmlns:a16="http://schemas.microsoft.com/office/drawing/2014/main" id="{EC22BA35-CA9E-4B7F-AEDA-6C3042CC384B}"/>
               </a:ext>
             </a:extLst>
           </p:cNvPr>
@@ -8479,7 +8479,7 @@
           <p:cNvPr id="17" name="">
             <a:extLst xmlns:a="http://schemas.openxmlformats.org/drawingml/2006/main">
               <a:ext uri="{FF2B5EF4-FFF2-40B4-BE49-F238E27FC236}">
-                <a16:creationId xmlns:a16="http://schemas.microsoft.com/office/drawing/2014/main" id="{E55619DD-E1A8-4B7B-84B5-C8AA1D9347B4}"/>
+                <a16:creationId xmlns:a16="http://schemas.microsoft.com/office/drawing/2014/main" id="{9958C4F9-2D04-4EA9-B4F6-46150D8E6420}"/>
               </a:ext>
             </a:extLst>
           </p:cNvPr>
@@ -8529,7 +8529,7 @@
           <p:cNvPr id="18" name="">
             <a:extLst xmlns:a="http://schemas.openxmlformats.org/drawingml/2006/main">
               <a:ext uri="{FF2B5EF4-FFF2-40B4-BE49-F238E27FC236}">
-                <a16:creationId xmlns:a16="http://schemas.microsoft.com/office/drawing/2014/main" id="{495BA21D-4558-4DEE-B932-E3D3A23903E4}"/>
+                <a16:creationId xmlns:a16="http://schemas.microsoft.com/office/drawing/2014/main" id="{1F6E303B-4B4D-4397-89A6-AA134CDA709B}"/>
               </a:ext>
             </a:extLst>
           </p:cNvPr>
@@ -8579,7 +8579,7 @@
           <p:cNvPr id="19" name="">
             <a:extLst xmlns:a="http://schemas.openxmlformats.org/drawingml/2006/main">
               <a:ext uri="{FF2B5EF4-FFF2-40B4-BE49-F238E27FC236}">
-                <a16:creationId xmlns:a16="http://schemas.microsoft.com/office/drawing/2014/main" id="{6F20118B-9722-4213-A22E-1977574A4783}"/>
+                <a16:creationId xmlns:a16="http://schemas.microsoft.com/office/drawing/2014/main" id="{B1852AF7-2850-4947-82D8-A8FB9E101A1E}"/>
               </a:ext>
             </a:extLst>
           </p:cNvPr>
@@ -8612,7 +8612,7 @@
           <p:cNvPr id="20" name="">
             <a:extLst xmlns:a="http://schemas.openxmlformats.org/drawingml/2006/main">
               <a:ext uri="{FF2B5EF4-FFF2-40B4-BE49-F238E27FC236}">
-                <a16:creationId xmlns:a16="http://schemas.microsoft.com/office/drawing/2014/main" id="{3A08A8BC-A819-4B04-ADA8-6D7D3589ED35}"/>
+                <a16:creationId xmlns:a16="http://schemas.microsoft.com/office/drawing/2014/main" id="{680CC645-A963-46AD-AB69-3A5115341D6B}"/>
               </a:ext>
             </a:extLst>
           </p:cNvPr>
@@ -8662,7 +8662,7 @@
           <p:cNvPr id="21" name="">
             <a:extLst xmlns:a="http://schemas.openxmlformats.org/drawingml/2006/main">
               <a:ext uri="{FF2B5EF4-FFF2-40B4-BE49-F238E27FC236}">
-                <a16:creationId xmlns:a16="http://schemas.microsoft.com/office/drawing/2014/main" id="{0BB523DA-A255-4060-B9D4-3F8C423C15F0}"/>
+                <a16:creationId xmlns:a16="http://schemas.microsoft.com/office/drawing/2014/main" id="{0D260BA8-F24C-4B93-BD8C-3F982911E317}"/>
               </a:ext>
             </a:extLst>
           </p:cNvPr>
@@ -8712,7 +8712,7 @@
           <p:cNvPr id="22" name="">
             <a:extLst xmlns:a="http://schemas.openxmlformats.org/drawingml/2006/main">
               <a:ext uri="{FF2B5EF4-FFF2-40B4-BE49-F238E27FC236}">
-                <a16:creationId xmlns:a16="http://schemas.microsoft.com/office/drawing/2014/main" id="{D3D66A75-D198-4FDE-9C2F-816970EC20DD}"/>
+                <a16:creationId xmlns:a16="http://schemas.microsoft.com/office/drawing/2014/main" id="{E0E4D56B-96F2-40C7-B333-F2167218C959}"/>
               </a:ext>
             </a:extLst>
           </p:cNvPr>
@@ -8745,7 +8745,7 @@
           <p:cNvPr id="23" name="">
             <a:extLst xmlns:a="http://schemas.openxmlformats.org/drawingml/2006/main">
               <a:ext uri="{FF2B5EF4-FFF2-40B4-BE49-F238E27FC236}">
-                <a16:creationId xmlns:a16="http://schemas.microsoft.com/office/drawing/2014/main" id="{959C4EEF-6EE2-43C6-8444-9E0EA6F33BBC}"/>
+                <a16:creationId xmlns:a16="http://schemas.microsoft.com/office/drawing/2014/main" id="{92BBC386-F3F8-496B-A989-4F59FD3A553B}"/>
               </a:ext>
             </a:extLst>
           </p:cNvPr>
@@ -8795,7 +8795,7 @@
           <p:cNvPr id="24" name="">
             <a:extLst xmlns:a="http://schemas.openxmlformats.org/drawingml/2006/main">
               <a:ext uri="{FF2B5EF4-FFF2-40B4-BE49-F238E27FC236}">
-                <a16:creationId xmlns:a16="http://schemas.microsoft.com/office/drawing/2014/main" id="{FCADF561-82C4-4247-A890-5F02FE8776F6}"/>
+                <a16:creationId xmlns:a16="http://schemas.microsoft.com/office/drawing/2014/main" id="{312E0DB1-EB57-4A02-B69D-4BAAFE3FBB0A}"/>
               </a:ext>
             </a:extLst>
           </p:cNvPr>
@@ -8845,7 +8845,7 @@
           <p:cNvPr id="25" name="">
             <a:extLst xmlns:a="http://schemas.openxmlformats.org/drawingml/2006/main">
               <a:ext uri="{FF2B5EF4-FFF2-40B4-BE49-F238E27FC236}">
-                <a16:creationId xmlns:a16="http://schemas.microsoft.com/office/drawing/2014/main" id="{1062646D-BCA8-4457-87C4-113F48EF6799}"/>
+                <a16:creationId xmlns:a16="http://schemas.microsoft.com/office/drawing/2014/main" id="{58B1499D-D976-40EB-BA04-01E92E7D373F}"/>
               </a:ext>
             </a:extLst>
           </p:cNvPr>
@@ -8878,7 +8878,7 @@
           <p:cNvPr id="26" name="">
             <a:extLst xmlns:a="http://schemas.openxmlformats.org/drawingml/2006/main">
               <a:ext uri="{FF2B5EF4-FFF2-40B4-BE49-F238E27FC236}">
-                <a16:creationId xmlns:a16="http://schemas.microsoft.com/office/drawing/2014/main" id="{30353956-EACF-4B17-8748-EB212F288C94}"/>
+                <a16:creationId xmlns:a16="http://schemas.microsoft.com/office/drawing/2014/main" id="{C623A577-9A5B-41B8-A66F-109C12D48B41}"/>
               </a:ext>
             </a:extLst>
           </p:cNvPr>
@@ -8928,7 +8928,7 @@
           <p:cNvPr id="27" name="">
             <a:extLst xmlns:a="http://schemas.openxmlformats.org/drawingml/2006/main">
               <a:ext uri="{FF2B5EF4-FFF2-40B4-BE49-F238E27FC236}">
-                <a16:creationId xmlns:a16="http://schemas.microsoft.com/office/drawing/2014/main" id="{847E889D-D61B-4F01-82EA-16DF52AC5166}"/>
+                <a16:creationId xmlns:a16="http://schemas.microsoft.com/office/drawing/2014/main" id="{228EFC92-B121-4B36-A4B4-D2173EB96283}"/>
               </a:ext>
             </a:extLst>
           </p:cNvPr>
@@ -8978,7 +8978,7 @@
           <p:cNvPr id="28" name="">
             <a:extLst xmlns:a="http://schemas.openxmlformats.org/drawingml/2006/main">
               <a:ext uri="{FF2B5EF4-FFF2-40B4-BE49-F238E27FC236}">
-                <a16:creationId xmlns:a16="http://schemas.microsoft.com/office/drawing/2014/main" id="{C8AE31A3-F0A3-45AE-B11A-D8E9FE189076}"/>
+                <a16:creationId xmlns:a16="http://schemas.microsoft.com/office/drawing/2014/main" id="{725F75AD-C6AA-48B8-8C76-AC4906AFB513}"/>
               </a:ext>
             </a:extLst>
           </p:cNvPr>
@@ -9011,7 +9011,7 @@
           <p:cNvPr id="29" name="">
             <a:extLst xmlns:a="http://schemas.openxmlformats.org/drawingml/2006/main">
               <a:ext uri="{FF2B5EF4-FFF2-40B4-BE49-F238E27FC236}">
-                <a16:creationId xmlns:a16="http://schemas.microsoft.com/office/drawing/2014/main" id="{A693A464-FDE8-4518-B31F-D77E68A987F3}"/>
+                <a16:creationId xmlns:a16="http://schemas.microsoft.com/office/drawing/2014/main" id="{3DAC8090-C3CD-4DDF-9E99-3401C8071B4B}"/>
               </a:ext>
             </a:extLst>
           </p:cNvPr>
@@ -9061,7 +9061,7 @@
           <p:cNvPr id="30" name="">
             <a:extLst xmlns:a="http://schemas.openxmlformats.org/drawingml/2006/main">
               <a:ext uri="{FF2B5EF4-FFF2-40B4-BE49-F238E27FC236}">
-                <a16:creationId xmlns:a16="http://schemas.microsoft.com/office/drawing/2014/main" id="{12BF917B-7661-4706-BB83-CB4BB849A7A4}"/>
+                <a16:creationId xmlns:a16="http://schemas.microsoft.com/office/drawing/2014/main" id="{7A34D56A-4364-4632-83AF-B34FABFC34B4}"/>
               </a:ext>
             </a:extLst>
           </p:cNvPr>
@@ -9109,7 +9109,7 @@
     </p:spTree>
     <p:extLst>
       <p:ext uri="{BB962C8B-B14F-4D97-AF65-F5344CB8AC3E}">
-        <p14:creationId xmlns:p14="http://schemas.microsoft.com/office/powerpoint/2010/main" val="1264488709"/>
+        <p14:creationId xmlns:p14="http://schemas.microsoft.com/office/powerpoint/2010/main" val="1826663872"/>
       </p:ext>
     </p:extLst>
   </p:cSld>
@@ -9140,7 +9140,7 @@
           <p:cNvPr id="13" name="">
             <a:extLst xmlns:a="http://schemas.openxmlformats.org/drawingml/2006/main">
               <a:ext uri="{FF2B5EF4-FFF2-40B4-BE49-F238E27FC236}">
-                <a16:creationId xmlns:a16="http://schemas.microsoft.com/office/drawing/2014/main" id="{51F89F1F-BAB7-4813-846A-45FC82879832}"/>
+                <a16:creationId xmlns:a16="http://schemas.microsoft.com/office/drawing/2014/main" id="{9CDCAACD-767E-4C1A-9BF2-53A44987C90D}"/>
               </a:ext>
             </a:extLst>
           </p:cNvPr>
@@ -9190,7 +9190,7 @@
           <p:cNvPr id="2" name="">
             <a:extLst xmlns:a="http://schemas.openxmlformats.org/drawingml/2006/main">
               <a:ext uri="{FF2B5EF4-FFF2-40B4-BE49-F238E27FC236}">
-                <a16:creationId xmlns:a16="http://schemas.microsoft.com/office/drawing/2014/main" id="{DD37808A-3C2C-4812-B54C-C8318CA46DC8}"/>
+                <a16:creationId xmlns:a16="http://schemas.microsoft.com/office/drawing/2014/main" id="{4D02D76E-8F18-496A-B6E9-A3133FABD60D}"/>
               </a:ext>
             </a:extLst>
           </p:cNvPr>
@@ -9240,7 +9240,7 @@
           <p:cNvPr id="3" name="">
             <a:extLst xmlns:a="http://schemas.openxmlformats.org/drawingml/2006/main">
               <a:ext uri="{FF2B5EF4-FFF2-40B4-BE49-F238E27FC236}">
-                <a16:creationId xmlns:a16="http://schemas.microsoft.com/office/drawing/2014/main" id="{8707D5D9-5372-48E5-9561-E958CF866F0E}"/>
+                <a16:creationId xmlns:a16="http://schemas.microsoft.com/office/drawing/2014/main" id="{C407ACF0-C904-41DF-B1AE-A4E2E20C19F4}"/>
               </a:ext>
             </a:extLst>
           </p:cNvPr>
@@ -9273,7 +9273,7 @@
           <p:cNvPr id="4" name="">
             <a:extLst xmlns:a="http://schemas.openxmlformats.org/drawingml/2006/main">
               <a:ext uri="{FF2B5EF4-FFF2-40B4-BE49-F238E27FC236}">
-                <a16:creationId xmlns:a16="http://schemas.microsoft.com/office/drawing/2014/main" id="{6DDAD903-E064-48C4-A616-AA8DCA3E3FB6}"/>
+                <a16:creationId xmlns:a16="http://schemas.microsoft.com/office/drawing/2014/main" id="{9D17A686-6AAA-4A3C-8373-EFE583B4D2BB}"/>
               </a:ext>
             </a:extLst>
           </p:cNvPr>
@@ -9323,7 +9323,7 @@
           <p:cNvPr id="5" name="">
             <a:extLst xmlns:a="http://schemas.openxmlformats.org/drawingml/2006/main">
               <a:ext uri="{FF2B5EF4-FFF2-40B4-BE49-F238E27FC236}">
-                <a16:creationId xmlns:a16="http://schemas.microsoft.com/office/drawing/2014/main" id="{CE999DBD-F2D3-4CA6-86E2-4F95B7A6AFC5}"/>
+                <a16:creationId xmlns:a16="http://schemas.microsoft.com/office/drawing/2014/main" id="{F6CD19B6-7561-4EE2-981C-7AC0740F8A0C}"/>
               </a:ext>
             </a:extLst>
           </p:cNvPr>
@@ -9356,7 +9356,7 @@
           <p:cNvPr id="6" name="">
             <a:extLst xmlns:a="http://schemas.openxmlformats.org/drawingml/2006/main">
               <a:ext uri="{FF2B5EF4-FFF2-40B4-BE49-F238E27FC236}">
-                <a16:creationId xmlns:a16="http://schemas.microsoft.com/office/drawing/2014/main" id="{C76D3FA3-5189-4AF7-B36D-33B32FA1C999}"/>
+                <a16:creationId xmlns:a16="http://schemas.microsoft.com/office/drawing/2014/main" id="{BA1A028D-821D-4DE3-96B6-F7EDECA77ECC}"/>
               </a:ext>
             </a:extLst>
           </p:cNvPr>
@@ -9406,7 +9406,7 @@
           <p:cNvPr id="7" name="">
             <a:extLst xmlns:a="http://schemas.openxmlformats.org/drawingml/2006/main">
               <a:ext uri="{FF2B5EF4-FFF2-40B4-BE49-F238E27FC236}">
-                <a16:creationId xmlns:a16="http://schemas.microsoft.com/office/drawing/2014/main" id="{51BA30D9-B239-4C2A-AC7C-06C00AFB5BDA}"/>
+                <a16:creationId xmlns:a16="http://schemas.microsoft.com/office/drawing/2014/main" id="{88498A10-2FB0-44FE-B3F6-2D9C29F88A4A}"/>
               </a:ext>
             </a:extLst>
           </p:cNvPr>
@@ -9607,7 +9607,7 @@
           <p:cNvPr id="8" name="">
             <a:extLst xmlns:a="http://schemas.openxmlformats.org/drawingml/2006/main">
               <a:ext uri="{FF2B5EF4-FFF2-40B4-BE49-F238E27FC236}">
-                <a16:creationId xmlns:a16="http://schemas.microsoft.com/office/drawing/2014/main" id="{6E8F6AD4-CA14-4475-B45A-EA94A627B3DA}"/>
+                <a16:creationId xmlns:a16="http://schemas.microsoft.com/office/drawing/2014/main" id="{80C2FB23-9C04-4710-9DAF-D33636EFF0D1}"/>
               </a:ext>
             </a:extLst>
           </p:cNvPr>
@@ -9640,7 +9640,7 @@
           <p:cNvPr id="9" name="">
             <a:extLst xmlns:a="http://schemas.openxmlformats.org/drawingml/2006/main">
               <a:ext uri="{FF2B5EF4-FFF2-40B4-BE49-F238E27FC236}">
-                <a16:creationId xmlns:a16="http://schemas.microsoft.com/office/drawing/2014/main" id="{76FAAB31-F4CF-40FC-865B-1B305C1FA17D}"/>
+                <a16:creationId xmlns:a16="http://schemas.microsoft.com/office/drawing/2014/main" id="{DBE58F3F-92AB-4E8C-A1E1-72E8D72CD325}"/>
               </a:ext>
             </a:extLst>
           </p:cNvPr>
@@ -9690,7 +9690,7 @@
           <p:cNvPr id="10" name="">
             <a:extLst xmlns:a="http://schemas.openxmlformats.org/drawingml/2006/main">
               <a:ext uri="{FF2B5EF4-FFF2-40B4-BE49-F238E27FC236}">
-                <a16:creationId xmlns:a16="http://schemas.microsoft.com/office/drawing/2014/main" id="{B177750E-1659-477A-A237-5A5298FE9569}"/>
+                <a16:creationId xmlns:a16="http://schemas.microsoft.com/office/drawing/2014/main" id="{97730AEE-C825-409A-A531-5A96D48AFB8C}"/>
               </a:ext>
             </a:extLst>
           </p:cNvPr>
@@ -9949,7 +9949,7 @@
           <p:cNvPr id="11" name="">
             <a:extLst xmlns:a="http://schemas.openxmlformats.org/drawingml/2006/main">
               <a:ext uri="{FF2B5EF4-FFF2-40B4-BE49-F238E27FC236}">
-                <a16:creationId xmlns:a16="http://schemas.microsoft.com/office/drawing/2014/main" id="{CC1E4BF9-3FB5-4ABB-9E5F-3B9CFF1D1242}"/>
+                <a16:creationId xmlns:a16="http://schemas.microsoft.com/office/drawing/2014/main" id="{D2BDA627-7572-48EA-9700-52AB47769814}"/>
               </a:ext>
             </a:extLst>
           </p:cNvPr>
@@ -9999,7 +9999,7 @@
           <p:cNvPr id="12" name="">
             <a:extLst xmlns:a="http://schemas.openxmlformats.org/drawingml/2006/main">
               <a:ext uri="{FF2B5EF4-FFF2-40B4-BE49-F238E27FC236}">
-                <a16:creationId xmlns:a16="http://schemas.microsoft.com/office/drawing/2014/main" id="{D8E0533F-700B-4923-A870-2FE6F9A1D1CB}"/>
+                <a16:creationId xmlns:a16="http://schemas.microsoft.com/office/drawing/2014/main" id="{DDC3F581-1F64-484B-905C-0BE1493AE708}"/>
               </a:ext>
             </a:extLst>
           </p:cNvPr>
@@ -10047,7 +10047,7 @@
     </p:spTree>
     <p:extLst>
       <p:ext uri="{BB962C8B-B14F-4D97-AF65-F5344CB8AC3E}">
-        <p14:creationId xmlns:p14="http://schemas.microsoft.com/office/powerpoint/2010/main" val="512609860"/>
+        <p14:creationId xmlns:p14="http://schemas.microsoft.com/office/powerpoint/2010/main" val="1817260625"/>
       </p:ext>
     </p:extLst>
   </p:cSld>
@@ -10078,7 +10078,7 @@
           <p:cNvPr id="27" name="">
             <a:extLst xmlns:a="http://schemas.openxmlformats.org/drawingml/2006/main">
               <a:ext uri="{FF2B5EF4-FFF2-40B4-BE49-F238E27FC236}">
-                <a16:creationId xmlns:a16="http://schemas.microsoft.com/office/drawing/2014/main" id="{11116B57-1BD4-44CC-B25C-3CE2477F386F}"/>
+                <a16:creationId xmlns:a16="http://schemas.microsoft.com/office/drawing/2014/main" id="{D03107D6-4623-4F64-B3AC-2FEF42F2DCE8}"/>
               </a:ext>
             </a:extLst>
           </p:cNvPr>
@@ -10128,7 +10128,7 @@
           <p:cNvPr id="2" name="">
             <a:extLst xmlns:a="http://schemas.openxmlformats.org/drawingml/2006/main">
               <a:ext uri="{FF2B5EF4-FFF2-40B4-BE49-F238E27FC236}">
-                <a16:creationId xmlns:a16="http://schemas.microsoft.com/office/drawing/2014/main" id="{5625009E-490E-43B5-AA02-6B8EAE89284B}"/>
+                <a16:creationId xmlns:a16="http://schemas.microsoft.com/office/drawing/2014/main" id="{1753D9C5-02DA-4B20-86BD-606E611C1929}"/>
               </a:ext>
             </a:extLst>
           </p:cNvPr>
@@ -10178,7 +10178,7 @@
           <p:cNvPr id="3" name="">
             <a:extLst xmlns:a="http://schemas.openxmlformats.org/drawingml/2006/main">
               <a:ext uri="{FF2B5EF4-FFF2-40B4-BE49-F238E27FC236}">
-                <a16:creationId xmlns:a16="http://schemas.microsoft.com/office/drawing/2014/main" id="{F96D1C84-FEAC-43AC-8F54-CDA5D6DFE5DE}"/>
+                <a16:creationId xmlns:a16="http://schemas.microsoft.com/office/drawing/2014/main" id="{A82565D4-B4B8-44F5-81A9-EC084A25AB3C}"/>
               </a:ext>
             </a:extLst>
           </p:cNvPr>
@@ -10211,7 +10211,7 @@
           <p:cNvPr id="4" name="">
             <a:extLst xmlns:a="http://schemas.openxmlformats.org/drawingml/2006/main">
               <a:ext uri="{FF2B5EF4-FFF2-40B4-BE49-F238E27FC236}">
-                <a16:creationId xmlns:a16="http://schemas.microsoft.com/office/drawing/2014/main" id="{60EB2EA6-C891-44AF-82D4-F03FA4B2465F}"/>
+                <a16:creationId xmlns:a16="http://schemas.microsoft.com/office/drawing/2014/main" id="{D651AD5A-4536-4989-8D11-7B1D32150046}"/>
               </a:ext>
             </a:extLst>
           </p:cNvPr>
@@ -10261,7 +10261,7 @@
           <p:cNvPr id="5" name="">
             <a:extLst xmlns:a="http://schemas.openxmlformats.org/drawingml/2006/main">
               <a:ext uri="{FF2B5EF4-FFF2-40B4-BE49-F238E27FC236}">
-                <a16:creationId xmlns:a16="http://schemas.microsoft.com/office/drawing/2014/main" id="{850AB67D-FB2B-4790-BA0C-922A79665178}"/>
+                <a16:creationId xmlns:a16="http://schemas.microsoft.com/office/drawing/2014/main" id="{D0C479CE-A604-4867-B699-35764723993B}"/>
               </a:ext>
             </a:extLst>
           </p:cNvPr>
@@ -10294,7 +10294,7 @@
           <p:cNvPr id="6" name="">
             <a:extLst xmlns:a="http://schemas.openxmlformats.org/drawingml/2006/main">
               <a:ext uri="{FF2B5EF4-FFF2-40B4-BE49-F238E27FC236}">
-                <a16:creationId xmlns:a16="http://schemas.microsoft.com/office/drawing/2014/main" id="{38D42773-9070-4822-B1CA-AE3FDCBB3B72}"/>
+                <a16:creationId xmlns:a16="http://schemas.microsoft.com/office/drawing/2014/main" id="{7D6A4361-2274-4851-AA30-30549B0D36AC}"/>
               </a:ext>
             </a:extLst>
           </p:cNvPr>
@@ -10327,7 +10327,7 @@
           <p:cNvPr id="7" name="">
             <a:extLst xmlns:a="http://schemas.openxmlformats.org/drawingml/2006/main">
               <a:ext uri="{FF2B5EF4-FFF2-40B4-BE49-F238E27FC236}">
-                <a16:creationId xmlns:a16="http://schemas.microsoft.com/office/drawing/2014/main" id="{9F92C0E8-E4C6-4FBC-AD5E-4E8DD750EA44}"/>
+                <a16:creationId xmlns:a16="http://schemas.microsoft.com/office/drawing/2014/main" id="{CB37DA64-672A-4D36-951B-CA953D5B9F43}"/>
               </a:ext>
             </a:extLst>
           </p:cNvPr>
@@ -10377,7 +10377,7 @@
           <p:cNvPr id="8" name="">
             <a:extLst xmlns:a="http://schemas.openxmlformats.org/drawingml/2006/main">
               <a:ext uri="{FF2B5EF4-FFF2-40B4-BE49-F238E27FC236}">
-                <a16:creationId xmlns:a16="http://schemas.microsoft.com/office/drawing/2014/main" id="{2C2CF4D6-2853-4A25-AD5A-26FE2A2B291D}"/>
+                <a16:creationId xmlns:a16="http://schemas.microsoft.com/office/drawing/2014/main" id="{8781DBC4-3C4F-4B34-8CBD-B47C2A7A44F6}"/>
               </a:ext>
             </a:extLst>
           </p:cNvPr>
@@ -10427,7 +10427,7 @@
           <p:cNvPr id="9" name="">
             <a:extLst xmlns:a="http://schemas.openxmlformats.org/drawingml/2006/main">
               <a:ext uri="{FF2B5EF4-FFF2-40B4-BE49-F238E27FC236}">
-                <a16:creationId xmlns:a16="http://schemas.microsoft.com/office/drawing/2014/main" id="{AB0663D1-F17F-4FF3-BB5E-070919658C31}"/>
+                <a16:creationId xmlns:a16="http://schemas.microsoft.com/office/drawing/2014/main" id="{BFDEA7FC-42CA-4519-B0F3-84D50CFD5737}"/>
               </a:ext>
             </a:extLst>
           </p:cNvPr>
@@ -10460,7 +10460,7 @@
           <p:cNvPr id="10" name="">
             <a:extLst xmlns:a="http://schemas.openxmlformats.org/drawingml/2006/main">
               <a:ext uri="{FF2B5EF4-FFF2-40B4-BE49-F238E27FC236}">
-                <a16:creationId xmlns:a16="http://schemas.microsoft.com/office/drawing/2014/main" id="{466A3545-DF9B-4070-A68D-D4F23DEA6129}"/>
+                <a16:creationId xmlns:a16="http://schemas.microsoft.com/office/drawing/2014/main" id="{378E2E40-C582-4F9D-AD26-4F4D5ECA7864}"/>
               </a:ext>
             </a:extLst>
           </p:cNvPr>
@@ -10493,7 +10493,7 @@
           <p:cNvPr id="11" name="">
             <a:extLst xmlns:a="http://schemas.openxmlformats.org/drawingml/2006/main">
               <a:ext uri="{FF2B5EF4-FFF2-40B4-BE49-F238E27FC236}">
-                <a16:creationId xmlns:a16="http://schemas.microsoft.com/office/drawing/2014/main" id="{4F03DEA2-0B2D-457E-BDF2-297B371A3C99}"/>
+                <a16:creationId xmlns:a16="http://schemas.microsoft.com/office/drawing/2014/main" id="{19D55521-9831-4E76-A71E-02468FE6BFF0}"/>
               </a:ext>
             </a:extLst>
           </p:cNvPr>
@@ -10543,7 +10543,7 @@
           <p:cNvPr id="12" name="">
             <a:extLst xmlns:a="http://schemas.openxmlformats.org/drawingml/2006/main">
               <a:ext uri="{FF2B5EF4-FFF2-40B4-BE49-F238E27FC236}">
-                <a16:creationId xmlns:a16="http://schemas.microsoft.com/office/drawing/2014/main" id="{E4051689-5773-4E44-9A84-CDE02DF710C1}"/>
+                <a16:creationId xmlns:a16="http://schemas.microsoft.com/office/drawing/2014/main" id="{34A2F3C8-CB5A-4F95-A16A-23B058CC8A81}"/>
               </a:ext>
             </a:extLst>
           </p:cNvPr>
@@ -10593,7 +10593,7 @@
           <p:cNvPr id="13" name="">
             <a:extLst xmlns:a="http://schemas.openxmlformats.org/drawingml/2006/main">
               <a:ext uri="{FF2B5EF4-FFF2-40B4-BE49-F238E27FC236}">
-                <a16:creationId xmlns:a16="http://schemas.microsoft.com/office/drawing/2014/main" id="{8761E38E-0B99-4567-B217-DC4EE3D9E1ED}"/>
+                <a16:creationId xmlns:a16="http://schemas.microsoft.com/office/drawing/2014/main" id="{CFE734A9-F4BE-4011-AC2E-CE1BF891B0D2}"/>
               </a:ext>
             </a:extLst>
           </p:cNvPr>
@@ -10626,7 +10626,7 @@
           <p:cNvPr id="14" name="">
             <a:extLst xmlns:a="http://schemas.openxmlformats.org/drawingml/2006/main">
               <a:ext uri="{FF2B5EF4-FFF2-40B4-BE49-F238E27FC236}">
-                <a16:creationId xmlns:a16="http://schemas.microsoft.com/office/drawing/2014/main" id="{56FF62AA-184F-4B05-A438-2D1ACD181500}"/>
+                <a16:creationId xmlns:a16="http://schemas.microsoft.com/office/drawing/2014/main" id="{01D51BCA-0686-4FD2-9420-8DD4310A993A}"/>
               </a:ext>
             </a:extLst>
           </p:cNvPr>
@@ -10659,7 +10659,7 @@
           <p:cNvPr id="15" name="">
             <a:extLst xmlns:a="http://schemas.openxmlformats.org/drawingml/2006/main">
               <a:ext uri="{FF2B5EF4-FFF2-40B4-BE49-F238E27FC236}">
-                <a16:creationId xmlns:a16="http://schemas.microsoft.com/office/drawing/2014/main" id="{F37B46D7-8504-4FB9-B88C-D4CF51ED9765}"/>
+                <a16:creationId xmlns:a16="http://schemas.microsoft.com/office/drawing/2014/main" id="{D60FA894-AB94-402F-842E-CE1708FE85E5}"/>
               </a:ext>
             </a:extLst>
           </p:cNvPr>
@@ -10709,7 +10709,7 @@
           <p:cNvPr id="16" name="">
             <a:extLst xmlns:a="http://schemas.openxmlformats.org/drawingml/2006/main">
               <a:ext uri="{FF2B5EF4-FFF2-40B4-BE49-F238E27FC236}">
-                <a16:creationId xmlns:a16="http://schemas.microsoft.com/office/drawing/2014/main" id="{64FEFA03-5B58-4CB2-82CD-50EFE2734ABC}"/>
+                <a16:creationId xmlns:a16="http://schemas.microsoft.com/office/drawing/2014/main" id="{06C82DB0-9049-48E8-BD5B-C44481C99357}"/>
               </a:ext>
             </a:extLst>
           </p:cNvPr>
@@ -10759,7 +10759,7 @@
           <p:cNvPr id="17" name="">
             <a:extLst xmlns:a="http://schemas.openxmlformats.org/drawingml/2006/main">
               <a:ext uri="{FF2B5EF4-FFF2-40B4-BE49-F238E27FC236}">
-                <a16:creationId xmlns:a16="http://schemas.microsoft.com/office/drawing/2014/main" id="{91BEEE35-9EAA-4927-B6A2-8EA4C0423D36}"/>
+                <a16:creationId xmlns:a16="http://schemas.microsoft.com/office/drawing/2014/main" id="{9AC57409-719B-4599-9D5B-EDE60C829DB9}"/>
               </a:ext>
             </a:extLst>
           </p:cNvPr>
@@ -10792,7 +10792,7 @@
           <p:cNvPr id="18" name="">
             <a:extLst xmlns:a="http://schemas.openxmlformats.org/drawingml/2006/main">
               <a:ext uri="{FF2B5EF4-FFF2-40B4-BE49-F238E27FC236}">
-                <a16:creationId xmlns:a16="http://schemas.microsoft.com/office/drawing/2014/main" id="{C85FE893-9639-40ED-8E17-A459904232AC}"/>
+                <a16:creationId xmlns:a16="http://schemas.microsoft.com/office/drawing/2014/main" id="{E09E8AC4-DAD5-4256-9996-6D6A77FEC980}"/>
               </a:ext>
             </a:extLst>
           </p:cNvPr>
@@ -10825,7 +10825,7 @@
           <p:cNvPr id="19" name="">
             <a:extLst xmlns:a="http://schemas.openxmlformats.org/drawingml/2006/main">
               <a:ext uri="{FF2B5EF4-FFF2-40B4-BE49-F238E27FC236}">
-                <a16:creationId xmlns:a16="http://schemas.microsoft.com/office/drawing/2014/main" id="{4AC2F131-A462-4980-A32B-87F9C1624C6E}"/>
+                <a16:creationId xmlns:a16="http://schemas.microsoft.com/office/drawing/2014/main" id="{B7043C6F-4774-4E01-8D42-F86A1E5937D4}"/>
               </a:ext>
             </a:extLst>
           </p:cNvPr>
@@ -10858,7 +10858,7 @@
           <p:cNvPr id="20" name="">
             <a:extLst xmlns:a="http://schemas.openxmlformats.org/drawingml/2006/main">
               <a:ext uri="{FF2B5EF4-FFF2-40B4-BE49-F238E27FC236}">
-                <a16:creationId xmlns:a16="http://schemas.microsoft.com/office/drawing/2014/main" id="{CA498A7B-CAE5-4920-8644-0C0C659F3EB6}"/>
+                <a16:creationId xmlns:a16="http://schemas.microsoft.com/office/drawing/2014/main" id="{740E78FC-9052-4CBE-8967-D68B3F222D3B}"/>
               </a:ext>
             </a:extLst>
           </p:cNvPr>
@@ -10891,7 +10891,7 @@
           <p:cNvPr id="21" name="">
             <a:extLst xmlns:a="http://schemas.openxmlformats.org/drawingml/2006/main">
               <a:ext uri="{FF2B5EF4-FFF2-40B4-BE49-F238E27FC236}">
-                <a16:creationId xmlns:a16="http://schemas.microsoft.com/office/drawing/2014/main" id="{460DD0AA-CB69-494B-A9E6-439EF777A5ED}"/>
+                <a16:creationId xmlns:a16="http://schemas.microsoft.com/office/drawing/2014/main" id="{6619A9A9-9AD0-4DDB-9A96-7D91BB54552B}"/>
               </a:ext>
             </a:extLst>
           </p:cNvPr>
@@ -10924,7 +10924,7 @@
           <p:cNvPr id="22" name="">
             <a:extLst xmlns:a="http://schemas.openxmlformats.org/drawingml/2006/main">
               <a:ext uri="{FF2B5EF4-FFF2-40B4-BE49-F238E27FC236}">
-                <a16:creationId xmlns:a16="http://schemas.microsoft.com/office/drawing/2014/main" id="{86C2107B-2457-4ED5-9B20-AD0FE560F514}"/>
+                <a16:creationId xmlns:a16="http://schemas.microsoft.com/office/drawing/2014/main" id="{0BA47EDB-B58E-4D47-9AE7-051E7CB55A91}"/>
               </a:ext>
             </a:extLst>
           </p:cNvPr>
@@ -10957,7 +10957,7 @@
           <p:cNvPr id="23" name="">
             <a:extLst xmlns:a="http://schemas.openxmlformats.org/drawingml/2006/main">
               <a:ext uri="{FF2B5EF4-FFF2-40B4-BE49-F238E27FC236}">
-                <a16:creationId xmlns:a16="http://schemas.microsoft.com/office/drawing/2014/main" id="{6EED17F6-0E32-4C54-AD48-D3491E0013EF}"/>
+                <a16:creationId xmlns:a16="http://schemas.microsoft.com/office/drawing/2014/main" id="{DEC99674-D6B3-43F1-8319-A3A6472A17D4}"/>
               </a:ext>
             </a:extLst>
           </p:cNvPr>
@@ -10990,7 +10990,7 @@
           <p:cNvPr id="24" name="">
             <a:extLst xmlns:a="http://schemas.openxmlformats.org/drawingml/2006/main">
               <a:ext uri="{FF2B5EF4-FFF2-40B4-BE49-F238E27FC236}">
-                <a16:creationId xmlns:a16="http://schemas.microsoft.com/office/drawing/2014/main" id="{C9BC3512-ABE9-47EA-9274-83D90FD1DDD3}"/>
+                <a16:creationId xmlns:a16="http://schemas.microsoft.com/office/drawing/2014/main" id="{7BF57338-8313-4000-9FE1-3D6F05F15E2F}"/>
               </a:ext>
             </a:extLst>
           </p:cNvPr>
@@ -11023,7 +11023,7 @@
           <p:cNvPr id="25" name="">
             <a:extLst xmlns:a="http://schemas.openxmlformats.org/drawingml/2006/main">
               <a:ext uri="{FF2B5EF4-FFF2-40B4-BE49-F238E27FC236}">
-                <a16:creationId xmlns:a16="http://schemas.microsoft.com/office/drawing/2014/main" id="{100C264D-C584-4757-B024-364A7D8B05CE}"/>
+                <a16:creationId xmlns:a16="http://schemas.microsoft.com/office/drawing/2014/main" id="{2A5E96DE-D957-430C-817A-471753969F95}"/>
               </a:ext>
             </a:extLst>
           </p:cNvPr>
@@ -11073,7 +11073,7 @@
           <p:cNvPr id="26" name="">
             <a:extLst xmlns:a="http://schemas.openxmlformats.org/drawingml/2006/main">
               <a:ext uri="{FF2B5EF4-FFF2-40B4-BE49-F238E27FC236}">
-                <a16:creationId xmlns:a16="http://schemas.microsoft.com/office/drawing/2014/main" id="{816EDF4F-53E3-42CA-A80F-2A750C9A1B1D}"/>
+                <a16:creationId xmlns:a16="http://schemas.microsoft.com/office/drawing/2014/main" id="{729B8D11-7B72-4E60-9B81-0584ECB806CA}"/>
               </a:ext>
             </a:extLst>
           </p:cNvPr>
@@ -11121,7 +11121,7 @@
     </p:spTree>
     <p:extLst>
       <p:ext uri="{BB962C8B-B14F-4D97-AF65-F5344CB8AC3E}">
-        <p14:creationId xmlns:p14="http://schemas.microsoft.com/office/powerpoint/2010/main" val="1241445175"/>
+        <p14:creationId xmlns:p14="http://schemas.microsoft.com/office/powerpoint/2010/main" val="1307742873"/>
       </p:ext>
     </p:extLst>
   </p:cSld>
@@ -11149,10 +11149,10 @@
       </p:grpSpPr>
       <p:sp>
         <p:nvSpPr>
-          <p:cNvPr id="42" name="">
-            <a:extLst xmlns:a="http://schemas.openxmlformats.org/drawingml/2006/main">
-              <a:ext uri="{FF2B5EF4-FFF2-40B4-BE49-F238E27FC236}">
-                <a16:creationId xmlns:a16="http://schemas.microsoft.com/office/drawing/2014/main" id="{D8B4C329-9DEA-4857-8DDD-8FF259045930}"/>
+          <p:cNvPr id="41" name="">
+            <a:extLst xmlns:a="http://schemas.openxmlformats.org/drawingml/2006/main">
+              <a:ext uri="{FF2B5EF4-FFF2-40B4-BE49-F238E27FC236}">
+                <a16:creationId xmlns:a16="http://schemas.microsoft.com/office/drawing/2014/main" id="{C845FC13-DE40-4D58-8A6B-51C8090DC93D}"/>
               </a:ext>
             </a:extLst>
           </p:cNvPr>
@@ -11202,7 +11202,7 @@
           <p:cNvPr id="2" name="">
             <a:extLst xmlns:a="http://schemas.openxmlformats.org/drawingml/2006/main">
               <a:ext uri="{FF2B5EF4-FFF2-40B4-BE49-F238E27FC236}">
-                <a16:creationId xmlns:a16="http://schemas.microsoft.com/office/drawing/2014/main" id="{4C611F73-1949-43EC-84EF-5F4934B2BAE8}"/>
+                <a16:creationId xmlns:a16="http://schemas.microsoft.com/office/drawing/2014/main" id="{E063D8B7-CCD5-4B0D-BD8F-4681DBBFD0FA}"/>
               </a:ext>
             </a:extLst>
           </p:cNvPr>
@@ -11252,7 +11252,7 @@
           <p:cNvPr id="3" name="">
             <a:extLst xmlns:a="http://schemas.openxmlformats.org/drawingml/2006/main">
               <a:ext uri="{FF2B5EF4-FFF2-40B4-BE49-F238E27FC236}">
-                <a16:creationId xmlns:a16="http://schemas.microsoft.com/office/drawing/2014/main" id="{DCE1F012-80BE-48C7-BE5B-2E5CDAB4B5DB}"/>
+                <a16:creationId xmlns:a16="http://schemas.microsoft.com/office/drawing/2014/main" id="{CCAC0C0B-FA9F-4784-B595-3A6F8D2CEB10}"/>
               </a:ext>
             </a:extLst>
           </p:cNvPr>
@@ -11285,7 +11285,7 @@
           <p:cNvPr id="4" name="">
             <a:extLst xmlns:a="http://schemas.openxmlformats.org/drawingml/2006/main">
               <a:ext uri="{FF2B5EF4-FFF2-40B4-BE49-F238E27FC236}">
-                <a16:creationId xmlns:a16="http://schemas.microsoft.com/office/drawing/2014/main" id="{BFD165C4-7012-4DD6-A843-A4CBFF7CB119}"/>
+                <a16:creationId xmlns:a16="http://schemas.microsoft.com/office/drawing/2014/main" id="{C3B212CD-6611-4C86-B6B6-A008C22BB1D6}"/>
               </a:ext>
             </a:extLst>
           </p:cNvPr>
@@ -11335,7 +11335,7 @@
           <p:cNvPr id="5" name="">
             <a:extLst xmlns:a="http://schemas.openxmlformats.org/drawingml/2006/main">
               <a:ext uri="{FF2B5EF4-FFF2-40B4-BE49-F238E27FC236}">
-                <a16:creationId xmlns:a16="http://schemas.microsoft.com/office/drawing/2014/main" id="{CA5E6D01-C732-4BAB-B7CA-489E9F04D319}"/>
+                <a16:creationId xmlns:a16="http://schemas.microsoft.com/office/drawing/2014/main" id="{55C97D8E-7E37-4129-8538-C92FC56F5DB1}"/>
               </a:ext>
             </a:extLst>
           </p:cNvPr>
@@ -11368,7 +11368,7 @@
           <p:cNvPr id="6" name="">
             <a:extLst xmlns:a="http://schemas.openxmlformats.org/drawingml/2006/main">
               <a:ext uri="{FF2B5EF4-FFF2-40B4-BE49-F238E27FC236}">
-                <a16:creationId xmlns:a16="http://schemas.microsoft.com/office/drawing/2014/main" id="{CA33265A-E4CE-4F4C-A6A7-0694B2D9F40E}"/>
+                <a16:creationId xmlns:a16="http://schemas.microsoft.com/office/drawing/2014/main" id="{B1703EEE-47D4-4A9D-84E3-DF891FF8977E}"/>
               </a:ext>
             </a:extLst>
           </p:cNvPr>
@@ -11418,7 +11418,7 @@
           <p:cNvPr id="7" name="">
             <a:extLst xmlns:a="http://schemas.openxmlformats.org/drawingml/2006/main">
               <a:ext uri="{FF2B5EF4-FFF2-40B4-BE49-F238E27FC236}">
-                <a16:creationId xmlns:a16="http://schemas.microsoft.com/office/drawing/2014/main" id="{6E2D4CFF-FF06-4CCD-AACC-2F99EF335EB1}"/>
+                <a16:creationId xmlns:a16="http://schemas.microsoft.com/office/drawing/2014/main" id="{4524D8DF-F8E8-440F-AAB2-F9BDDEE685F3}"/>
               </a:ext>
             </a:extLst>
           </p:cNvPr>
@@ -11468,7 +11468,7 @@
           <p:cNvPr id="8" name="">
             <a:extLst xmlns:a="http://schemas.openxmlformats.org/drawingml/2006/main">
               <a:ext uri="{FF2B5EF4-FFF2-40B4-BE49-F238E27FC236}">
-                <a16:creationId xmlns:a16="http://schemas.microsoft.com/office/drawing/2014/main" id="{3623F85E-F2CC-46DF-A93B-0BF73C45FD79}"/>
+                <a16:creationId xmlns:a16="http://schemas.microsoft.com/office/drawing/2014/main" id="{ADBB72E9-535B-48E3-A814-77E70D4A4F01}"/>
               </a:ext>
             </a:extLst>
           </p:cNvPr>
@@ -11501,7 +11501,7 @@
           <p:cNvPr id="9" name="">
             <a:extLst xmlns:a="http://schemas.openxmlformats.org/drawingml/2006/main">
               <a:ext uri="{FF2B5EF4-FFF2-40B4-BE49-F238E27FC236}">
-                <a16:creationId xmlns:a16="http://schemas.microsoft.com/office/drawing/2014/main" id="{3735FE69-1F8C-4545-ADCD-64CAEE00C289}"/>
+                <a16:creationId xmlns:a16="http://schemas.microsoft.com/office/drawing/2014/main" id="{A99BEFEA-39BD-4500-AB3A-686B60AFDDF2}"/>
               </a:ext>
             </a:extLst>
           </p:cNvPr>
@@ -11551,7 +11551,7 @@
           <p:cNvPr id="10" name="">
             <a:extLst xmlns:a="http://schemas.openxmlformats.org/drawingml/2006/main">
               <a:ext uri="{FF2B5EF4-FFF2-40B4-BE49-F238E27FC236}">
-                <a16:creationId xmlns:a16="http://schemas.microsoft.com/office/drawing/2014/main" id="{88925C8D-CEA9-4D6E-BC9A-F1D1E4660AA7}"/>
+                <a16:creationId xmlns:a16="http://schemas.microsoft.com/office/drawing/2014/main" id="{9539CB7C-8FD8-4C58-9FB4-9ADA39C485B5}"/>
               </a:ext>
             </a:extLst>
           </p:cNvPr>
@@ -11601,7 +11601,7 @@
           <p:cNvPr id="11" name="">
             <a:extLst xmlns:a="http://schemas.openxmlformats.org/drawingml/2006/main">
               <a:ext uri="{FF2B5EF4-FFF2-40B4-BE49-F238E27FC236}">
-                <a16:creationId xmlns:a16="http://schemas.microsoft.com/office/drawing/2014/main" id="{BB147AC7-F5AA-4326-82B1-23EA5A4DF96D}"/>
+                <a16:creationId xmlns:a16="http://schemas.microsoft.com/office/drawing/2014/main" id="{D9BDB040-D538-4055-A29E-8054829455C0}"/>
               </a:ext>
             </a:extLst>
           </p:cNvPr>
@@ -11634,7 +11634,7 @@
           <p:cNvPr id="12" name="">
             <a:extLst xmlns:a="http://schemas.openxmlformats.org/drawingml/2006/main">
               <a:ext uri="{FF2B5EF4-FFF2-40B4-BE49-F238E27FC236}">
-                <a16:creationId xmlns:a16="http://schemas.microsoft.com/office/drawing/2014/main" id="{AC322022-F2B1-4FCD-BA20-7A02A1150503}"/>
+                <a16:creationId xmlns:a16="http://schemas.microsoft.com/office/drawing/2014/main" id="{EB7DC9C0-945A-4B06-AFCF-B5502933CC22}"/>
               </a:ext>
             </a:extLst>
           </p:cNvPr>
@@ -11684,7 +11684,7 @@
           <p:cNvPr id="13" name="">
             <a:extLst xmlns:a="http://schemas.openxmlformats.org/drawingml/2006/main">
               <a:ext uri="{FF2B5EF4-FFF2-40B4-BE49-F238E27FC236}">
-                <a16:creationId xmlns:a16="http://schemas.microsoft.com/office/drawing/2014/main" id="{E0ED2758-94E7-47B1-9C2B-03CC550F519B}"/>
+                <a16:creationId xmlns:a16="http://schemas.microsoft.com/office/drawing/2014/main" id="{C9D87B3B-0D49-419D-8A7F-B0FE1893CC58}"/>
               </a:ext>
             </a:extLst>
           </p:cNvPr>
@@ -11734,7 +11734,7 @@
           <p:cNvPr id="14" name="">
             <a:extLst xmlns:a="http://schemas.openxmlformats.org/drawingml/2006/main">
               <a:ext uri="{FF2B5EF4-FFF2-40B4-BE49-F238E27FC236}">
-                <a16:creationId xmlns:a16="http://schemas.microsoft.com/office/drawing/2014/main" id="{6175AE28-949F-4BE9-A8A0-1238C53B16B3}"/>
+                <a16:creationId xmlns:a16="http://schemas.microsoft.com/office/drawing/2014/main" id="{73B4D7D3-2D4E-408E-A882-C352CD5CA18F}"/>
               </a:ext>
             </a:extLst>
           </p:cNvPr>
@@ -11767,7 +11767,7 @@
           <p:cNvPr id="15" name="">
             <a:extLst xmlns:a="http://schemas.openxmlformats.org/drawingml/2006/main">
               <a:ext uri="{FF2B5EF4-FFF2-40B4-BE49-F238E27FC236}">
-                <a16:creationId xmlns:a16="http://schemas.microsoft.com/office/drawing/2014/main" id="{26111948-A925-4DF9-BD0C-E55AEBAC3996}"/>
+                <a16:creationId xmlns:a16="http://schemas.microsoft.com/office/drawing/2014/main" id="{B6EA843A-E7B8-49E9-A179-93DBDDE970D5}"/>
               </a:ext>
             </a:extLst>
           </p:cNvPr>
@@ -11817,7 +11817,7 @@
           <p:cNvPr id="16" name="">
             <a:extLst xmlns:a="http://schemas.openxmlformats.org/drawingml/2006/main">
               <a:ext uri="{FF2B5EF4-FFF2-40B4-BE49-F238E27FC236}">
-                <a16:creationId xmlns:a16="http://schemas.microsoft.com/office/drawing/2014/main" id="{ECDCE430-042E-45A5-938E-210D5F292E05}"/>
+                <a16:creationId xmlns:a16="http://schemas.microsoft.com/office/drawing/2014/main" id="{3B693905-EA68-4111-B89C-30907A8C7259}"/>
               </a:ext>
             </a:extLst>
           </p:cNvPr>
@@ -11867,7 +11867,7 @@
           <p:cNvPr id="17" name="">
             <a:extLst xmlns:a="http://schemas.openxmlformats.org/drawingml/2006/main">
               <a:ext uri="{FF2B5EF4-FFF2-40B4-BE49-F238E27FC236}">
-                <a16:creationId xmlns:a16="http://schemas.microsoft.com/office/drawing/2014/main" id="{BA78C0B8-06EF-43EC-8D0A-8A2089B576FA}"/>
+                <a16:creationId xmlns:a16="http://schemas.microsoft.com/office/drawing/2014/main" id="{D43BDC12-248E-4A8D-B933-81DB75B45876}"/>
               </a:ext>
             </a:extLst>
           </p:cNvPr>
@@ -11900,7 +11900,7 @@
           <p:cNvPr id="18" name="">
             <a:extLst xmlns:a="http://schemas.openxmlformats.org/drawingml/2006/main">
               <a:ext uri="{FF2B5EF4-FFF2-40B4-BE49-F238E27FC236}">
-                <a16:creationId xmlns:a16="http://schemas.microsoft.com/office/drawing/2014/main" id="{817566CB-34BF-4E97-AFB2-E0CBAE31CAA1}"/>
+                <a16:creationId xmlns:a16="http://schemas.microsoft.com/office/drawing/2014/main" id="{4AD62334-A804-44BE-9706-92E1D42DCBF7}"/>
               </a:ext>
             </a:extLst>
           </p:cNvPr>
@@ -11950,7 +11950,7 @@
           <p:cNvPr id="19" name="">
             <a:extLst xmlns:a="http://schemas.openxmlformats.org/drawingml/2006/main">
               <a:ext uri="{FF2B5EF4-FFF2-40B4-BE49-F238E27FC236}">
-                <a16:creationId xmlns:a16="http://schemas.microsoft.com/office/drawing/2014/main" id="{CCEDAFD6-44ED-40B2-B136-609838E8CAE4}"/>
+                <a16:creationId xmlns:a16="http://schemas.microsoft.com/office/drawing/2014/main" id="{3C709DC5-A440-4168-B099-256D0DAF7470}"/>
               </a:ext>
             </a:extLst>
           </p:cNvPr>
@@ -12000,7 +12000,7 @@
           <p:cNvPr id="20" name="">
             <a:extLst xmlns:a="http://schemas.openxmlformats.org/drawingml/2006/main">
               <a:ext uri="{FF2B5EF4-FFF2-40B4-BE49-F238E27FC236}">
-                <a16:creationId xmlns:a16="http://schemas.microsoft.com/office/drawing/2014/main" id="{E6E22DAF-576C-44D0-BB71-6160E8791786}"/>
+                <a16:creationId xmlns:a16="http://schemas.microsoft.com/office/drawing/2014/main" id="{A944A366-B84F-48CE-8325-48EE73AE194F}"/>
               </a:ext>
             </a:extLst>
           </p:cNvPr>
@@ -12033,7 +12033,7 @@
           <p:cNvPr id="21" name="">
             <a:extLst xmlns:a="http://schemas.openxmlformats.org/drawingml/2006/main">
               <a:ext uri="{FF2B5EF4-FFF2-40B4-BE49-F238E27FC236}">
-                <a16:creationId xmlns:a16="http://schemas.microsoft.com/office/drawing/2014/main" id="{50FDA4B1-5017-467C-A690-B5E7D38191C3}"/>
+                <a16:creationId xmlns:a16="http://schemas.microsoft.com/office/drawing/2014/main" id="{05CF1CFF-8DA2-45A1-8692-AF05C02BF356}"/>
               </a:ext>
             </a:extLst>
           </p:cNvPr>
@@ -12083,7 +12083,7 @@
           <p:cNvPr id="22" name="">
             <a:extLst xmlns:a="http://schemas.openxmlformats.org/drawingml/2006/main">
               <a:ext uri="{FF2B5EF4-FFF2-40B4-BE49-F238E27FC236}">
-                <a16:creationId xmlns:a16="http://schemas.microsoft.com/office/drawing/2014/main" id="{BC686F45-D5C0-4C4A-9E63-018840F784A7}"/>
+                <a16:creationId xmlns:a16="http://schemas.microsoft.com/office/drawing/2014/main" id="{1FEC068C-BEF4-4870-A422-72B7A62829CF}"/>
               </a:ext>
             </a:extLst>
           </p:cNvPr>
@@ -12133,7 +12133,7 @@
           <p:cNvPr id="23" name="">
             <a:extLst xmlns:a="http://schemas.openxmlformats.org/drawingml/2006/main">
               <a:ext uri="{FF2B5EF4-FFF2-40B4-BE49-F238E27FC236}">
-                <a16:creationId xmlns:a16="http://schemas.microsoft.com/office/drawing/2014/main" id="{3321E975-B4E3-4C87-8882-13F4EE1B554D}"/>
+                <a16:creationId xmlns:a16="http://schemas.microsoft.com/office/drawing/2014/main" id="{E664ACEE-9D32-40AC-A20A-C27AB04464F9}"/>
               </a:ext>
             </a:extLst>
           </p:cNvPr>
@@ -12183,7 +12183,7 @@
           <p:cNvPr id="24" name="">
             <a:extLst xmlns:a="http://schemas.openxmlformats.org/drawingml/2006/main">
               <a:ext uri="{FF2B5EF4-FFF2-40B4-BE49-F238E27FC236}">
-                <a16:creationId xmlns:a16="http://schemas.microsoft.com/office/drawing/2014/main" id="{F2262952-07AF-4723-9C02-86EE87776DAF}"/>
+                <a16:creationId xmlns:a16="http://schemas.microsoft.com/office/drawing/2014/main" id="{06596D56-F39E-4793-BB58-77EA4A7D1DE1}"/>
               </a:ext>
             </a:extLst>
           </p:cNvPr>
@@ -12233,7 +12233,7 @@
           <p:cNvPr id="25" name="">
             <a:extLst xmlns:a="http://schemas.openxmlformats.org/drawingml/2006/main">
               <a:ext uri="{FF2B5EF4-FFF2-40B4-BE49-F238E27FC236}">
-                <a16:creationId xmlns:a16="http://schemas.microsoft.com/office/drawing/2014/main" id="{822A6E4F-36F1-4614-836E-372C55B4D664}"/>
+                <a16:creationId xmlns:a16="http://schemas.microsoft.com/office/drawing/2014/main" id="{2BE19B65-6275-449F-8D4E-3844E65C5A11}"/>
               </a:ext>
             </a:extLst>
           </p:cNvPr>
@@ -12283,7 +12283,7 @@
           <p:cNvPr id="26" name="">
             <a:extLst xmlns:a="http://schemas.openxmlformats.org/drawingml/2006/main">
               <a:ext uri="{FF2B5EF4-FFF2-40B4-BE49-F238E27FC236}">
-                <a16:creationId xmlns:a16="http://schemas.microsoft.com/office/drawing/2014/main" id="{7BB7AB06-FC6A-4AAD-8D77-C56B93345553}"/>
+                <a16:creationId xmlns:a16="http://schemas.microsoft.com/office/drawing/2014/main" id="{8BA3C6AF-2D8D-43C2-BFE0-1B09456E278B}"/>
               </a:ext>
             </a:extLst>
           </p:cNvPr>
@@ -12333,7 +12333,7 @@
           <p:cNvPr id="27" name="">
             <a:extLst xmlns:a="http://schemas.openxmlformats.org/drawingml/2006/main">
               <a:ext uri="{FF2B5EF4-FFF2-40B4-BE49-F238E27FC236}">
-                <a16:creationId xmlns:a16="http://schemas.microsoft.com/office/drawing/2014/main" id="{CC5405B3-7840-4314-A24E-2403A19759DB}"/>
+                <a16:creationId xmlns:a16="http://schemas.microsoft.com/office/drawing/2014/main" id="{FAF96688-4CB6-4C60-A284-7F973EF9B3AE}"/>
               </a:ext>
             </a:extLst>
           </p:cNvPr>
@@ -12383,7 +12383,7 @@
           <p:cNvPr id="28" name="">
             <a:extLst xmlns:a="http://schemas.openxmlformats.org/drawingml/2006/main">
               <a:ext uri="{FF2B5EF4-FFF2-40B4-BE49-F238E27FC236}">
-                <a16:creationId xmlns:a16="http://schemas.microsoft.com/office/drawing/2014/main" id="{ECD4FC06-AC7E-4DF4-98E7-3352B36021F3}"/>
+                <a16:creationId xmlns:a16="http://schemas.microsoft.com/office/drawing/2014/main" id="{42BD486B-942F-4226-915C-E2B5BB56FC84}"/>
               </a:ext>
             </a:extLst>
           </p:cNvPr>
@@ -12433,7 +12433,7 @@
           <p:cNvPr id="29" name="">
             <a:extLst xmlns:a="http://schemas.openxmlformats.org/drawingml/2006/main">
               <a:ext uri="{FF2B5EF4-FFF2-40B4-BE49-F238E27FC236}">
-                <a16:creationId xmlns:a16="http://schemas.microsoft.com/office/drawing/2014/main" id="{D0F66829-70B7-4350-9801-E8BC71654DBB}"/>
+                <a16:creationId xmlns:a16="http://schemas.microsoft.com/office/drawing/2014/main" id="{D1000E9B-F58D-4A2D-AFB0-3BC467491473}"/>
               </a:ext>
             </a:extLst>
           </p:cNvPr>
@@ -12483,7 +12483,7 @@
           <p:cNvPr id="30" name="">
             <a:extLst xmlns:a="http://schemas.openxmlformats.org/drawingml/2006/main">
               <a:ext uri="{FF2B5EF4-FFF2-40B4-BE49-F238E27FC236}">
-                <a16:creationId xmlns:a16="http://schemas.microsoft.com/office/drawing/2014/main" id="{E6D54FBD-7A5D-43EA-B205-F94FE0CB47F0}"/>
+                <a16:creationId xmlns:a16="http://schemas.microsoft.com/office/drawing/2014/main" id="{156C66D9-25D1-4698-A245-8B42AE67889E}"/>
               </a:ext>
             </a:extLst>
           </p:cNvPr>
@@ -12533,7 +12533,7 @@
           <p:cNvPr id="31" name="">
             <a:extLst xmlns:a="http://schemas.openxmlformats.org/drawingml/2006/main">
               <a:ext uri="{FF2B5EF4-FFF2-40B4-BE49-F238E27FC236}">
-                <a16:creationId xmlns:a16="http://schemas.microsoft.com/office/drawing/2014/main" id="{6D8E4D70-58D9-4D88-80C9-CF8E3588EC05}"/>
+                <a16:creationId xmlns:a16="http://schemas.microsoft.com/office/drawing/2014/main" id="{07304436-021A-495D-8F5C-F73DDAC38AB0}"/>
               </a:ext>
             </a:extLst>
           </p:cNvPr>
@@ -12583,7 +12583,7 @@
           <p:cNvPr id="32" name="">
             <a:extLst xmlns:a="http://schemas.openxmlformats.org/drawingml/2006/main">
               <a:ext uri="{FF2B5EF4-FFF2-40B4-BE49-F238E27FC236}">
-                <a16:creationId xmlns:a16="http://schemas.microsoft.com/office/drawing/2014/main" id="{704C78F3-3CB8-4171-91DC-C78C42024CF2}"/>
+                <a16:creationId xmlns:a16="http://schemas.microsoft.com/office/drawing/2014/main" id="{593C5143-9A96-458A-9E80-E7250E503523}"/>
               </a:ext>
             </a:extLst>
           </p:cNvPr>
@@ -12633,7 +12633,7 @@
           <p:cNvPr id="33" name="">
             <a:extLst xmlns:a="http://schemas.openxmlformats.org/drawingml/2006/main">
               <a:ext uri="{FF2B5EF4-FFF2-40B4-BE49-F238E27FC236}">
-                <a16:creationId xmlns:a16="http://schemas.microsoft.com/office/drawing/2014/main" id="{F14D432B-656D-4E94-BA42-16A125BE772F}"/>
+                <a16:creationId xmlns:a16="http://schemas.microsoft.com/office/drawing/2014/main" id="{70EF8D64-C157-4125-987D-A42C21E7E97F}"/>
               </a:ext>
             </a:extLst>
           </p:cNvPr>
@@ -12683,7 +12683,7 @@
           <p:cNvPr id="34" name="">
             <a:extLst xmlns:a="http://schemas.openxmlformats.org/drawingml/2006/main">
               <a:ext uri="{FF2B5EF4-FFF2-40B4-BE49-F238E27FC236}">
-                <a16:creationId xmlns:a16="http://schemas.microsoft.com/office/drawing/2014/main" id="{C4BA3B98-F258-48F5-96B4-4B37F01F3542}"/>
+                <a16:creationId xmlns:a16="http://schemas.microsoft.com/office/drawing/2014/main" id="{47BA3246-4DC9-474A-9FBB-A6D96D9D316B}"/>
               </a:ext>
             </a:extLst>
           </p:cNvPr>
@@ -12733,7 +12733,7 @@
           <p:cNvPr id="35" name="">
             <a:extLst xmlns:a="http://schemas.openxmlformats.org/drawingml/2006/main">
               <a:ext uri="{FF2B5EF4-FFF2-40B4-BE49-F238E27FC236}">
-                <a16:creationId xmlns:a16="http://schemas.microsoft.com/office/drawing/2014/main" id="{CB7314F3-ABA1-4D38-B8F5-12464999E6E3}"/>
+                <a16:creationId xmlns:a16="http://schemas.microsoft.com/office/drawing/2014/main" id="{E5C77565-B466-4B03-8DC2-3ED0A82D9B7E}"/>
               </a:ext>
             </a:extLst>
           </p:cNvPr>
@@ -12783,7 +12783,7 @@
           <p:cNvPr id="36" name="">
             <a:extLst xmlns:a="http://schemas.openxmlformats.org/drawingml/2006/main">
               <a:ext uri="{FF2B5EF4-FFF2-40B4-BE49-F238E27FC236}">
-                <a16:creationId xmlns:a16="http://schemas.microsoft.com/office/drawing/2014/main" id="{D5545C5E-88E6-4CFA-8409-4EF92B15F64E}"/>
+                <a16:creationId xmlns:a16="http://schemas.microsoft.com/office/drawing/2014/main" id="{0CDC8482-C96E-43F7-B1BA-C8A5503C0706}"/>
               </a:ext>
             </a:extLst>
           </p:cNvPr>
@@ -12816,7 +12816,7 @@
           <p:cNvPr id="37" name="">
             <a:extLst xmlns:a="http://schemas.openxmlformats.org/drawingml/2006/main">
               <a:ext uri="{FF2B5EF4-FFF2-40B4-BE49-F238E27FC236}">
-                <a16:creationId xmlns:a16="http://schemas.microsoft.com/office/drawing/2014/main" id="{428EB3DD-C383-40CB-B243-756D4C93E5E2}"/>
+                <a16:creationId xmlns:a16="http://schemas.microsoft.com/office/drawing/2014/main" id="{A5E98F1D-F954-4C32-9470-424E14ED1251}"/>
               </a:ext>
             </a:extLst>
           </p:cNvPr>
@@ -12866,7 +12866,7 @@
           <p:cNvPr id="38" name="">
             <a:extLst xmlns:a="http://schemas.openxmlformats.org/drawingml/2006/main">
               <a:ext uri="{FF2B5EF4-FFF2-40B4-BE49-F238E27FC236}">
-                <a16:creationId xmlns:a16="http://schemas.microsoft.com/office/drawing/2014/main" id="{77EDAED1-5AF1-48C5-A9AC-D5A21A5296EA}"/>
+                <a16:creationId xmlns:a16="http://schemas.microsoft.com/office/drawing/2014/main" id="{42354E64-6F25-48DF-A877-AEB09EE177C2}"/>
               </a:ext>
             </a:extLst>
           </p:cNvPr>
@@ -12916,57 +12916,7 @@
           <p:cNvPr id="39" name="">
             <a:extLst xmlns:a="http://schemas.openxmlformats.org/drawingml/2006/main">
               <a:ext uri="{FF2B5EF4-FFF2-40B4-BE49-F238E27FC236}">
-                <a16:creationId xmlns:a16="http://schemas.microsoft.com/office/drawing/2014/main" id="{65AF55F8-D7A8-40B3-9C9C-3AF74A0C111E}"/>
-              </a:ext>
-            </a:extLst>
-          </p:cNvPr>
-          <p:cNvSpPr>
-            <a:spLocks xmlns:a="http://schemas.openxmlformats.org/drawingml/2006/main" noGrp="1"/>
-          </p:cNvSpPr>
-          <p:nvPr/>
-        </p:nvSpPr>
-        <p:spPr>
-          <a:xfrm xmlns:a="http://schemas.openxmlformats.org/drawingml/2006/main">
-            <a:off x="1009650" y="5467350"/>
-            <a:ext cx="6572250" cy="171450"/>
-          </a:xfrm>
-          <a:prstGeom xmlns:a="http://schemas.openxmlformats.org/drawingml/2006/main" prst="rect">
-            <a:avLst/>
-          </a:prstGeom>
-          <a:noFill xmlns:a="http://schemas.openxmlformats.org/drawingml/2006/main"/>
-          <a:ln xmlns:a="http://schemas.openxmlformats.org/drawingml/2006/main" w="0">
-            <a:noFill/>
-            <a:prstDash val="solid"/>
-          </a:ln>
-        </p:spPr>
-        <p:txBody>
-          <a:bodyPr xmlns:a="http://schemas.openxmlformats.org/drawingml/2006/main"/>
-          <a:lstStyle xmlns:a="http://schemas.openxmlformats.org/drawingml/2006/main"/>
-          <a:p xmlns:a="http://schemas.openxmlformats.org/drawingml/2006/main">
-            <a:pPr algn="l">
-              <a:defRPr sz="1050" b="0">
-                <a:solidFill>
-                  <a:srgbClr val="4B5563"/>
-                </a:solidFill>
-              </a:defRPr>
-            </a:pPr>
-            <a:r>
-              <a:rPr sz="1050" b="0">
-                <a:solidFill>
-                  <a:srgbClr val="4B5563"/>
-                </a:solidFill>
-              </a:rPr>
-              <a:t>影片建議內容：START 畫面、按鍵操作、分數增加、GAME OVER 結果。</a:t>
-            </a:r>
-          </a:p>
-        </p:txBody>
-      </p:sp>
-      <p:sp>
-        <p:nvSpPr>
-          <p:cNvPr id="40" name="">
-            <a:extLst xmlns:a="http://schemas.openxmlformats.org/drawingml/2006/main">
-              <a:ext uri="{FF2B5EF4-FFF2-40B4-BE49-F238E27FC236}">
-                <a16:creationId xmlns:a16="http://schemas.microsoft.com/office/drawing/2014/main" id="{35341266-0FCB-476C-A231-F813EE3AC252}"/>
+                <a16:creationId xmlns:a16="http://schemas.microsoft.com/office/drawing/2014/main" id="{868DDF53-D03A-40E4-AD07-0B2CCA32B391}"/>
               </a:ext>
             </a:extLst>
           </p:cNvPr>
@@ -12996,10 +12946,10 @@
       </p:sp>
       <p:sp>
         <p:nvSpPr>
-          <p:cNvPr id="41" name="">
-            <a:extLst xmlns:a="http://schemas.openxmlformats.org/drawingml/2006/main">
-              <a:ext uri="{FF2B5EF4-FFF2-40B4-BE49-F238E27FC236}">
-                <a16:creationId xmlns:a16="http://schemas.microsoft.com/office/drawing/2014/main" id="{7F661FEE-002C-4A73-83E6-E676FBCD760F}"/>
+          <p:cNvPr id="40" name="">
+            <a:extLst xmlns:a="http://schemas.openxmlformats.org/drawingml/2006/main">
+              <a:ext uri="{FF2B5EF4-FFF2-40B4-BE49-F238E27FC236}">
+                <a16:creationId xmlns:a16="http://schemas.microsoft.com/office/drawing/2014/main" id="{1B62F586-4A48-428E-8656-48DF8F426D19}"/>
               </a:ext>
             </a:extLst>
           </p:cNvPr>
@@ -13081,7 +13031,7 @@
     </p:spTree>
     <p:extLst>
       <p:ext uri="{BB962C8B-B14F-4D97-AF65-F5344CB8AC3E}">
-        <p14:creationId xmlns:p14="http://schemas.microsoft.com/office/powerpoint/2010/main" val="807516110"/>
+        <p14:creationId xmlns:p14="http://schemas.microsoft.com/office/powerpoint/2010/main" val="444714870"/>
       </p:ext>
     </p:extLst>
   </p:cSld>

</xml_diff>

<commit_message>
docs: polish VGA report wording
</commit_message>
<xml_diff>
--- a/outputs/EGO1_Flappy_Bird_FPGA_8頁書面型PPT報告.pptx
+++ b/outputs/EGO1_Flappy_Bird_FPGA_8頁書面型PPT報告.pptx
@@ -2,20 +2,20 @@
 <file path=ppt/presentation.xml><?xml version="1.0" encoding="utf-8"?>
 <p:presentation xmlns:p="http://schemas.openxmlformats.org/presentationml/2006/main">
   <p:sldMasterIdLst>
-    <p:sldMasterId xmlns:r="http://schemas.openxmlformats.org/officeDocument/2006/relationships" id="2147483648" r:id="Rd3a2e73c0dbb4ba1"/>
+    <p:sldMasterId xmlns:r="http://schemas.openxmlformats.org/officeDocument/2006/relationships" id="2147483648" r:id="Rd286bfea39a748ac"/>
   </p:sldMasterIdLst>
   <p:notesMasterIdLst>
-    <p:notesMasterId xmlns:r="http://schemas.openxmlformats.org/officeDocument/2006/relationships" r:id="R1daa58ef58e34be4"/>
+    <p:notesMasterId xmlns:r="http://schemas.openxmlformats.org/officeDocument/2006/relationships" r:id="Rbb51c2d26b6e4c99"/>
   </p:notesMasterIdLst>
   <p:sldIdLst>
-    <p:sldId xmlns:r="http://schemas.openxmlformats.org/officeDocument/2006/relationships" id="256" r:id="R80a2884de4e74103"/>
-    <p:sldId xmlns:r="http://schemas.openxmlformats.org/officeDocument/2006/relationships" id="257" r:id="R89c6cf09f30d4d39"/>
-    <p:sldId xmlns:r="http://schemas.openxmlformats.org/officeDocument/2006/relationships" id="258" r:id="Ra25e4857ca834849"/>
-    <p:sldId xmlns:r="http://schemas.openxmlformats.org/officeDocument/2006/relationships" id="259" r:id="R7bd3b9c7293f409c"/>
-    <p:sldId xmlns:r="http://schemas.openxmlformats.org/officeDocument/2006/relationships" id="260" r:id="R4cf2b7e14d6d4e64"/>
-    <p:sldId xmlns:r="http://schemas.openxmlformats.org/officeDocument/2006/relationships" id="261" r:id="R9688f6d5a66f4a58"/>
-    <p:sldId xmlns:r="http://schemas.openxmlformats.org/officeDocument/2006/relationships" id="262" r:id="Rfc5d4758c7b541c8"/>
-    <p:sldId xmlns:r="http://schemas.openxmlformats.org/officeDocument/2006/relationships" id="263" r:id="Rb744c0a4b1214c19"/>
+    <p:sldId xmlns:r="http://schemas.openxmlformats.org/officeDocument/2006/relationships" id="256" r:id="R369adaf007e24c62"/>
+    <p:sldId xmlns:r="http://schemas.openxmlformats.org/officeDocument/2006/relationships" id="257" r:id="Rc589261598354f35"/>
+    <p:sldId xmlns:r="http://schemas.openxmlformats.org/officeDocument/2006/relationships" id="258" r:id="R63a94e11944c4423"/>
+    <p:sldId xmlns:r="http://schemas.openxmlformats.org/officeDocument/2006/relationships" id="259" r:id="Rc636348bf28d44a7"/>
+    <p:sldId xmlns:r="http://schemas.openxmlformats.org/officeDocument/2006/relationships" id="260" r:id="R6db266921e3f46b2"/>
+    <p:sldId xmlns:r="http://schemas.openxmlformats.org/officeDocument/2006/relationships" id="261" r:id="R28e3e798d071456a"/>
+    <p:sldId xmlns:r="http://schemas.openxmlformats.org/officeDocument/2006/relationships" id="262" r:id="R9a5a9f10904948e6"/>
+    <p:sldId xmlns:r="http://schemas.openxmlformats.org/officeDocument/2006/relationships" id="263" r:id="R8b15b70aac4b4f68"/>
   </p:sldIdLst>
   <p:sldSz cx="12192000" cy="6858000"/>
   <p:notesSz cx="6858000" cy="9144000"/>
@@ -1070,7 +1070,7 @@
   </p:cSld>
   <p:clrMap bg1="lt1" tx1="dk1" bg2="lt2" tx2="dk2" accent1="accent1" accent2="accent2" accent3="accent3" accent4="accent4" accent5="accent5" accent6="accent6" hlink="hlink" folHlink="folHlink"/>
   <p:sldLayoutIdLst>
-    <p:sldLayoutId xmlns:r="http://schemas.openxmlformats.org/officeDocument/2006/relationships" id="2147483649" r:id="R02bfb9dd273a48e9"/>
+    <p:sldLayoutId xmlns:r="http://schemas.openxmlformats.org/officeDocument/2006/relationships" id="2147483649" r:id="R81fc67e1a46e40fd"/>
   </p:sldLayoutIdLst>
   <p:txStyles>
     <p:titleStyle>
@@ -1621,7 +1621,7 @@
           <p:cNvPr id="17" name="">
             <a:extLst xmlns:a="http://schemas.openxmlformats.org/drawingml/2006/main">
               <a:ext uri="{FF2B5EF4-FFF2-40B4-BE49-F238E27FC236}">
-                <a16:creationId xmlns:a16="http://schemas.microsoft.com/office/drawing/2014/main" id="{F0AAC191-B0CD-4DB6-97F3-A029F5C4144A}"/>
+                <a16:creationId xmlns:a16="http://schemas.microsoft.com/office/drawing/2014/main" id="{D89AA233-1298-465C-B4DD-9E100AE5EB4F}"/>
               </a:ext>
             </a:extLst>
           </p:cNvPr>
@@ -1688,7 +1688,7 @@
           <p:cNvPr id="2" name="">
             <a:extLst xmlns:a="http://schemas.openxmlformats.org/drawingml/2006/main">
               <a:ext uri="{FF2B5EF4-FFF2-40B4-BE49-F238E27FC236}">
-                <a16:creationId xmlns:a16="http://schemas.microsoft.com/office/drawing/2014/main" id="{472BE39A-3A52-4146-8F29-F6BD26C69740}"/>
+                <a16:creationId xmlns:a16="http://schemas.microsoft.com/office/drawing/2014/main" id="{0D777F2A-8BD5-4D3F-A451-0D1E4C1E43C1}"/>
               </a:ext>
             </a:extLst>
           </p:cNvPr>
@@ -1738,7 +1738,7 @@
           <p:cNvPr id="3" name="">
             <a:extLst xmlns:a="http://schemas.openxmlformats.org/drawingml/2006/main">
               <a:ext uri="{FF2B5EF4-FFF2-40B4-BE49-F238E27FC236}">
-                <a16:creationId xmlns:a16="http://schemas.microsoft.com/office/drawing/2014/main" id="{E59BCC3D-4AE4-4991-BFE6-A3A378CB076B}"/>
+                <a16:creationId xmlns:a16="http://schemas.microsoft.com/office/drawing/2014/main" id="{5C9E0E99-E9BF-4987-9330-D0698088799D}"/>
               </a:ext>
             </a:extLst>
           </p:cNvPr>
@@ -1788,7 +1788,7 @@
           <p:cNvPr id="4" name="">
             <a:extLst xmlns:a="http://schemas.openxmlformats.org/drawingml/2006/main">
               <a:ext uri="{FF2B5EF4-FFF2-40B4-BE49-F238E27FC236}">
-                <a16:creationId xmlns:a16="http://schemas.microsoft.com/office/drawing/2014/main" id="{D39A265A-AEFB-49D6-A18C-EB0B975C2517}"/>
+                <a16:creationId xmlns:a16="http://schemas.microsoft.com/office/drawing/2014/main" id="{C8152007-3224-4509-B492-79AF60548CE9}"/>
               </a:ext>
             </a:extLst>
           </p:cNvPr>
@@ -1838,7 +1838,7 @@
           <p:cNvPr id="5" name="">
             <a:extLst xmlns:a="http://schemas.openxmlformats.org/drawingml/2006/main">
               <a:ext uri="{FF2B5EF4-FFF2-40B4-BE49-F238E27FC236}">
-                <a16:creationId xmlns:a16="http://schemas.microsoft.com/office/drawing/2014/main" id="{D25FBBD8-0DF7-4D8C-A74B-995C40C9ABE7}"/>
+                <a16:creationId xmlns:a16="http://schemas.microsoft.com/office/drawing/2014/main" id="{B791F91F-6D67-4137-BD04-307B44191803}"/>
               </a:ext>
             </a:extLst>
           </p:cNvPr>
@@ -1888,7 +1888,7 @@
           <p:cNvPr id="6" name="">
             <a:extLst xmlns:a="http://schemas.openxmlformats.org/drawingml/2006/main">
               <a:ext uri="{FF2B5EF4-FFF2-40B4-BE49-F238E27FC236}">
-                <a16:creationId xmlns:a16="http://schemas.microsoft.com/office/drawing/2014/main" id="{EFE74758-2D0E-4AB7-8F3D-89346309014C}"/>
+                <a16:creationId xmlns:a16="http://schemas.microsoft.com/office/drawing/2014/main" id="{46AD8B77-171D-4D50-9319-61241C1834F8}"/>
               </a:ext>
             </a:extLst>
           </p:cNvPr>
@@ -1938,7 +1938,7 @@
           <p:cNvPr id="7" name="">
             <a:extLst xmlns:a="http://schemas.openxmlformats.org/drawingml/2006/main">
               <a:ext uri="{FF2B5EF4-FFF2-40B4-BE49-F238E27FC236}">
-                <a16:creationId xmlns:a16="http://schemas.microsoft.com/office/drawing/2014/main" id="{C0C3B11A-BB70-4F78-94CF-D0A928BF575B}"/>
+                <a16:creationId xmlns:a16="http://schemas.microsoft.com/office/drawing/2014/main" id="{984C200A-CBC2-4A9E-9815-38C9A448FE1F}"/>
               </a:ext>
             </a:extLst>
           </p:cNvPr>
@@ -1988,7 +1988,7 @@
           <p:cNvPr id="8" name="">
             <a:extLst xmlns:a="http://schemas.openxmlformats.org/drawingml/2006/main">
               <a:ext uri="{FF2B5EF4-FFF2-40B4-BE49-F238E27FC236}">
-                <a16:creationId xmlns:a16="http://schemas.microsoft.com/office/drawing/2014/main" id="{A2882B7E-0161-4A4B-91E7-1BE5C897E0E8}"/>
+                <a16:creationId xmlns:a16="http://schemas.microsoft.com/office/drawing/2014/main" id="{DC5F3AB3-83AE-4561-9653-15E25910F240}"/>
               </a:ext>
             </a:extLst>
           </p:cNvPr>
@@ -2021,7 +2021,7 @@
           <p:cNvPr id="9" name="">
             <a:extLst xmlns:a="http://schemas.openxmlformats.org/drawingml/2006/main">
               <a:ext uri="{FF2B5EF4-FFF2-40B4-BE49-F238E27FC236}">
-                <a16:creationId xmlns:a16="http://schemas.microsoft.com/office/drawing/2014/main" id="{2F8C7BA0-AA7C-4DAD-8BC0-AD3945E556CF}"/>
+                <a16:creationId xmlns:a16="http://schemas.microsoft.com/office/drawing/2014/main" id="{59ED1488-4CC5-48A2-95E9-EDF41E861998}"/>
               </a:ext>
             </a:extLst>
           </p:cNvPr>
@@ -2088,7 +2088,7 @@
           <p:cNvPr id="10" name="">
             <a:extLst xmlns:a="http://schemas.openxmlformats.org/drawingml/2006/main">
               <a:ext uri="{FF2B5EF4-FFF2-40B4-BE49-F238E27FC236}">
-                <a16:creationId xmlns:a16="http://schemas.microsoft.com/office/drawing/2014/main" id="{64EEB4BB-6414-4486-BC6F-89E48861FE0C}"/>
+                <a16:creationId xmlns:a16="http://schemas.microsoft.com/office/drawing/2014/main" id="{4716BC6D-1DE9-4E24-B646-F5B04E0CB676}"/>
               </a:ext>
             </a:extLst>
           </p:cNvPr>
@@ -2121,7 +2121,7 @@
           <p:cNvPr id="11" name="">
             <a:extLst xmlns:a="http://schemas.openxmlformats.org/drawingml/2006/main">
               <a:ext uri="{FF2B5EF4-FFF2-40B4-BE49-F238E27FC236}">
-                <a16:creationId xmlns:a16="http://schemas.microsoft.com/office/drawing/2014/main" id="{94BF5384-1C4C-4647-B67C-485FF310A441}"/>
+                <a16:creationId xmlns:a16="http://schemas.microsoft.com/office/drawing/2014/main" id="{4054A982-8FB4-4BD8-8688-8E372FF28B88}"/>
               </a:ext>
             </a:extLst>
           </p:cNvPr>
@@ -2188,7 +2188,7 @@
           <p:cNvPr id="12" name="">
             <a:extLst xmlns:a="http://schemas.openxmlformats.org/drawingml/2006/main">
               <a:ext uri="{FF2B5EF4-FFF2-40B4-BE49-F238E27FC236}">
-                <a16:creationId xmlns:a16="http://schemas.microsoft.com/office/drawing/2014/main" id="{715125B1-5C35-4B37-A10F-EF14F18A8654}"/>
+                <a16:creationId xmlns:a16="http://schemas.microsoft.com/office/drawing/2014/main" id="{8DD6A19B-D270-4DA5-AC17-27EA54B58D69}"/>
               </a:ext>
             </a:extLst>
           </p:cNvPr>
@@ -2221,7 +2221,7 @@
           <p:cNvPr id="13" name="">
             <a:extLst xmlns:a="http://schemas.openxmlformats.org/drawingml/2006/main">
               <a:ext uri="{FF2B5EF4-FFF2-40B4-BE49-F238E27FC236}">
-                <a16:creationId xmlns:a16="http://schemas.microsoft.com/office/drawing/2014/main" id="{8FFC6CF8-EE8F-48D6-B1D3-7C8A59CD03A0}"/>
+                <a16:creationId xmlns:a16="http://schemas.microsoft.com/office/drawing/2014/main" id="{3BACCD1D-2A37-453D-BA60-B04A3E11CE24}"/>
               </a:ext>
             </a:extLst>
           </p:cNvPr>
@@ -2288,7 +2288,7 @@
           <p:cNvPr id="14" name="">
             <a:extLst xmlns:a="http://schemas.openxmlformats.org/drawingml/2006/main">
               <a:ext uri="{FF2B5EF4-FFF2-40B4-BE49-F238E27FC236}">
-                <a16:creationId xmlns:a16="http://schemas.microsoft.com/office/drawing/2014/main" id="{F6A93361-3A8E-4D70-888D-EBF37F0D2792}"/>
+                <a16:creationId xmlns:a16="http://schemas.microsoft.com/office/drawing/2014/main" id="{F65C2C0A-6521-4006-941A-6538B6419ADC}"/>
               </a:ext>
             </a:extLst>
           </p:cNvPr>
@@ -2321,7 +2321,7 @@
           <p:cNvPr id="15" name="">
             <a:extLst xmlns:a="http://schemas.openxmlformats.org/drawingml/2006/main">
               <a:ext uri="{FF2B5EF4-FFF2-40B4-BE49-F238E27FC236}">
-                <a16:creationId xmlns:a16="http://schemas.microsoft.com/office/drawing/2014/main" id="{541ADA5A-4B5C-40A6-A512-8D40C0EEB543}"/>
+                <a16:creationId xmlns:a16="http://schemas.microsoft.com/office/drawing/2014/main" id="{14F88AE0-1F9C-47E3-B671-4919352644BB}"/>
               </a:ext>
             </a:extLst>
           </p:cNvPr>
@@ -2388,7 +2388,7 @@
           <p:cNvPr id="16" name="">
             <a:extLst xmlns:a="http://schemas.openxmlformats.org/drawingml/2006/main">
               <a:ext uri="{FF2B5EF4-FFF2-40B4-BE49-F238E27FC236}">
-                <a16:creationId xmlns:a16="http://schemas.microsoft.com/office/drawing/2014/main" id="{FC678925-03D1-4C94-981C-E9AB22F601CF}"/>
+                <a16:creationId xmlns:a16="http://schemas.microsoft.com/office/drawing/2014/main" id="{EA7C04C5-332E-44B9-BDF4-1F5AF0F5E17E}"/>
               </a:ext>
             </a:extLst>
           </p:cNvPr>
@@ -2436,7 +2436,7 @@
     </p:spTree>
     <p:extLst>
       <p:ext uri="{BB962C8B-B14F-4D97-AF65-F5344CB8AC3E}">
-        <p14:creationId xmlns:p14="http://schemas.microsoft.com/office/powerpoint/2010/main" val="966549572"/>
+        <p14:creationId xmlns:p14="http://schemas.microsoft.com/office/powerpoint/2010/main" val="1978631214"/>
       </p:ext>
     </p:extLst>
   </p:cSld>
@@ -2467,7 +2467,7 @@
           <p:cNvPr id="43" name="">
             <a:extLst xmlns:a="http://schemas.openxmlformats.org/drawingml/2006/main">
               <a:ext uri="{FF2B5EF4-FFF2-40B4-BE49-F238E27FC236}">
-                <a16:creationId xmlns:a16="http://schemas.microsoft.com/office/drawing/2014/main" id="{B9614843-55F3-4A21-A652-379F1A2C18AD}"/>
+                <a16:creationId xmlns:a16="http://schemas.microsoft.com/office/drawing/2014/main" id="{EB35BCFC-C5E0-4E39-B211-2926771E38A7}"/>
               </a:ext>
             </a:extLst>
           </p:cNvPr>
@@ -2517,7 +2517,7 @@
           <p:cNvPr id="2" name="">
             <a:extLst xmlns:a="http://schemas.openxmlformats.org/drawingml/2006/main">
               <a:ext uri="{FF2B5EF4-FFF2-40B4-BE49-F238E27FC236}">
-                <a16:creationId xmlns:a16="http://schemas.microsoft.com/office/drawing/2014/main" id="{6AD85A9F-E638-4E58-B6F3-96B42D018560}"/>
+                <a16:creationId xmlns:a16="http://schemas.microsoft.com/office/drawing/2014/main" id="{38394E48-D1AF-4173-83EA-9B0F4FF08589}"/>
               </a:ext>
             </a:extLst>
           </p:cNvPr>
@@ -2567,7 +2567,7 @@
           <p:cNvPr id="3" name="">
             <a:extLst xmlns:a="http://schemas.openxmlformats.org/drawingml/2006/main">
               <a:ext uri="{FF2B5EF4-FFF2-40B4-BE49-F238E27FC236}">
-                <a16:creationId xmlns:a16="http://schemas.microsoft.com/office/drawing/2014/main" id="{9A0293EE-9FC1-4402-ACDD-5066D9F3C77F}"/>
+                <a16:creationId xmlns:a16="http://schemas.microsoft.com/office/drawing/2014/main" id="{CA520ADF-E852-4BF9-A88D-AEB829AD2DD5}"/>
               </a:ext>
             </a:extLst>
           </p:cNvPr>
@@ -2600,7 +2600,7 @@
           <p:cNvPr id="4" name="">
             <a:extLst xmlns:a="http://schemas.openxmlformats.org/drawingml/2006/main">
               <a:ext uri="{FF2B5EF4-FFF2-40B4-BE49-F238E27FC236}">
-                <a16:creationId xmlns:a16="http://schemas.microsoft.com/office/drawing/2014/main" id="{BCC610BF-4C63-42E4-B029-753135F91D50}"/>
+                <a16:creationId xmlns:a16="http://schemas.microsoft.com/office/drawing/2014/main" id="{FA1D7847-3210-43B5-AAF0-9E3170876B20}"/>
               </a:ext>
             </a:extLst>
           </p:cNvPr>
@@ -2650,7 +2650,7 @@
           <p:cNvPr id="5" name="">
             <a:extLst xmlns:a="http://schemas.openxmlformats.org/drawingml/2006/main">
               <a:ext uri="{FF2B5EF4-FFF2-40B4-BE49-F238E27FC236}">
-                <a16:creationId xmlns:a16="http://schemas.microsoft.com/office/drawing/2014/main" id="{9C3F1417-9425-4DBC-862C-526FB45AC4B1}"/>
+                <a16:creationId xmlns:a16="http://schemas.microsoft.com/office/drawing/2014/main" id="{4A69A30A-B7BF-447E-AB0A-E6BB1429DC31}"/>
               </a:ext>
             </a:extLst>
           </p:cNvPr>
@@ -2683,7 +2683,7 @@
           <p:cNvPr id="6" name="">
             <a:extLst xmlns:a="http://schemas.openxmlformats.org/drawingml/2006/main">
               <a:ext uri="{FF2B5EF4-FFF2-40B4-BE49-F238E27FC236}">
-                <a16:creationId xmlns:a16="http://schemas.microsoft.com/office/drawing/2014/main" id="{40F0B8BD-4C3A-44A8-94CA-D3095D07A389}"/>
+                <a16:creationId xmlns:a16="http://schemas.microsoft.com/office/drawing/2014/main" id="{F370DEFF-2537-4B31-ADCA-64826D0A9D49}"/>
               </a:ext>
             </a:extLst>
           </p:cNvPr>
@@ -2716,7 +2716,7 @@
           <p:cNvPr id="7" name="">
             <a:extLst xmlns:a="http://schemas.openxmlformats.org/drawingml/2006/main">
               <a:ext uri="{FF2B5EF4-FFF2-40B4-BE49-F238E27FC236}">
-                <a16:creationId xmlns:a16="http://schemas.microsoft.com/office/drawing/2014/main" id="{A4FB9A1B-3661-447B-A2F5-80A268B79ED0}"/>
+                <a16:creationId xmlns:a16="http://schemas.microsoft.com/office/drawing/2014/main" id="{4A03DCCD-C751-411B-818E-9022E7BBF58E}"/>
               </a:ext>
             </a:extLst>
           </p:cNvPr>
@@ -2766,7 +2766,7 @@
           <p:cNvPr id="8" name="">
             <a:extLst xmlns:a="http://schemas.openxmlformats.org/drawingml/2006/main">
               <a:ext uri="{FF2B5EF4-FFF2-40B4-BE49-F238E27FC236}">
-                <a16:creationId xmlns:a16="http://schemas.microsoft.com/office/drawing/2014/main" id="{000A061E-DDDD-457D-AF57-84D4AB2BE68A}"/>
+                <a16:creationId xmlns:a16="http://schemas.microsoft.com/office/drawing/2014/main" id="{65A8F722-E748-4BDA-A524-EABB19C1AD15}"/>
               </a:ext>
             </a:extLst>
           </p:cNvPr>
@@ -2816,7 +2816,7 @@
           <p:cNvPr id="9" name="">
             <a:extLst xmlns:a="http://schemas.openxmlformats.org/drawingml/2006/main">
               <a:ext uri="{FF2B5EF4-FFF2-40B4-BE49-F238E27FC236}">
-                <a16:creationId xmlns:a16="http://schemas.microsoft.com/office/drawing/2014/main" id="{BC04D39B-C73F-4730-9708-F6B267E69A3B}"/>
+                <a16:creationId xmlns:a16="http://schemas.microsoft.com/office/drawing/2014/main" id="{EE3F336C-E6F7-4D85-9733-DBADC283821B}"/>
               </a:ext>
             </a:extLst>
           </p:cNvPr>
@@ -2849,7 +2849,7 @@
           <p:cNvPr id="10" name="">
             <a:extLst xmlns:a="http://schemas.openxmlformats.org/drawingml/2006/main">
               <a:ext uri="{FF2B5EF4-FFF2-40B4-BE49-F238E27FC236}">
-                <a16:creationId xmlns:a16="http://schemas.microsoft.com/office/drawing/2014/main" id="{80F51162-71B5-4539-AEBA-F1B34E8517CD}"/>
+                <a16:creationId xmlns:a16="http://schemas.microsoft.com/office/drawing/2014/main" id="{8E2EEFE3-23EB-4C24-A198-FC446D13835B}"/>
               </a:ext>
             </a:extLst>
           </p:cNvPr>
@@ -2882,7 +2882,7 @@
           <p:cNvPr id="11" name="">
             <a:extLst xmlns:a="http://schemas.openxmlformats.org/drawingml/2006/main">
               <a:ext uri="{FF2B5EF4-FFF2-40B4-BE49-F238E27FC236}">
-                <a16:creationId xmlns:a16="http://schemas.microsoft.com/office/drawing/2014/main" id="{38E4CBBB-6814-4771-9326-C009A959E3AC}"/>
+                <a16:creationId xmlns:a16="http://schemas.microsoft.com/office/drawing/2014/main" id="{05FE4A07-D874-4DD3-BC44-F72B97F2F0E5}"/>
               </a:ext>
             </a:extLst>
           </p:cNvPr>
@@ -2932,7 +2932,7 @@
           <p:cNvPr id="12" name="">
             <a:extLst xmlns:a="http://schemas.openxmlformats.org/drawingml/2006/main">
               <a:ext uri="{FF2B5EF4-FFF2-40B4-BE49-F238E27FC236}">
-                <a16:creationId xmlns:a16="http://schemas.microsoft.com/office/drawing/2014/main" id="{FE811084-0E51-4984-83A6-6EA54458B0CF}"/>
+                <a16:creationId xmlns:a16="http://schemas.microsoft.com/office/drawing/2014/main" id="{AF6A6EFA-316B-405D-AA83-1FC75C50C8A6}"/>
               </a:ext>
             </a:extLst>
           </p:cNvPr>
@@ -2982,7 +2982,7 @@
           <p:cNvPr id="13" name="">
             <a:extLst xmlns:a="http://schemas.openxmlformats.org/drawingml/2006/main">
               <a:ext uri="{FF2B5EF4-FFF2-40B4-BE49-F238E27FC236}">
-                <a16:creationId xmlns:a16="http://schemas.microsoft.com/office/drawing/2014/main" id="{2CD570F4-BD85-4D81-B6DE-E0AE8C868A99}"/>
+                <a16:creationId xmlns:a16="http://schemas.microsoft.com/office/drawing/2014/main" id="{B26BDA53-0501-4347-A09D-5F877B49741D}"/>
               </a:ext>
             </a:extLst>
           </p:cNvPr>
@@ -3015,7 +3015,7 @@
           <p:cNvPr id="14" name="">
             <a:extLst xmlns:a="http://schemas.openxmlformats.org/drawingml/2006/main">
               <a:ext uri="{FF2B5EF4-FFF2-40B4-BE49-F238E27FC236}">
-                <a16:creationId xmlns:a16="http://schemas.microsoft.com/office/drawing/2014/main" id="{8ABA2F84-ACA5-4C21-AF30-C84D286C9E35}"/>
+                <a16:creationId xmlns:a16="http://schemas.microsoft.com/office/drawing/2014/main" id="{0B9C157B-CD4D-4771-9BA7-066BBE9ED87C}"/>
               </a:ext>
             </a:extLst>
           </p:cNvPr>
@@ -3048,7 +3048,7 @@
           <p:cNvPr id="15" name="">
             <a:extLst xmlns:a="http://schemas.openxmlformats.org/drawingml/2006/main">
               <a:ext uri="{FF2B5EF4-FFF2-40B4-BE49-F238E27FC236}">
-                <a16:creationId xmlns:a16="http://schemas.microsoft.com/office/drawing/2014/main" id="{B870A52C-2660-455C-958B-2179363C036D}"/>
+                <a16:creationId xmlns:a16="http://schemas.microsoft.com/office/drawing/2014/main" id="{410EB1D1-8898-4C4B-8C44-8C7C11924BC7}"/>
               </a:ext>
             </a:extLst>
           </p:cNvPr>
@@ -3098,7 +3098,7 @@
           <p:cNvPr id="16" name="">
             <a:extLst xmlns:a="http://schemas.openxmlformats.org/drawingml/2006/main">
               <a:ext uri="{FF2B5EF4-FFF2-40B4-BE49-F238E27FC236}">
-                <a16:creationId xmlns:a16="http://schemas.microsoft.com/office/drawing/2014/main" id="{CAF9F507-676B-4BD5-ADC7-3F7A93F78D2B}"/>
+                <a16:creationId xmlns:a16="http://schemas.microsoft.com/office/drawing/2014/main" id="{738F2AA5-E267-479E-8EA3-773F3A6CDCAA}"/>
               </a:ext>
             </a:extLst>
           </p:cNvPr>
@@ -3148,7 +3148,7 @@
           <p:cNvPr id="17" name="">
             <a:extLst xmlns:a="http://schemas.openxmlformats.org/drawingml/2006/main">
               <a:ext uri="{FF2B5EF4-FFF2-40B4-BE49-F238E27FC236}">
-                <a16:creationId xmlns:a16="http://schemas.microsoft.com/office/drawing/2014/main" id="{F3247BA3-3CA8-444F-9EEE-643B5317AE70}"/>
+                <a16:creationId xmlns:a16="http://schemas.microsoft.com/office/drawing/2014/main" id="{F66A0D7C-D635-42AE-ADF3-24B816387573}"/>
               </a:ext>
             </a:extLst>
           </p:cNvPr>
@@ -3181,7 +3181,7 @@
           <p:cNvPr id="18" name="">
             <a:extLst xmlns:a="http://schemas.openxmlformats.org/drawingml/2006/main">
               <a:ext uri="{FF2B5EF4-FFF2-40B4-BE49-F238E27FC236}">
-                <a16:creationId xmlns:a16="http://schemas.microsoft.com/office/drawing/2014/main" id="{21B7F551-FDF6-41E2-B893-5D377BE2D188}"/>
+                <a16:creationId xmlns:a16="http://schemas.microsoft.com/office/drawing/2014/main" id="{34F8A573-47E8-4AFD-A062-B04C0E33B919}"/>
               </a:ext>
             </a:extLst>
           </p:cNvPr>
@@ -3231,7 +3231,7 @@
           <p:cNvPr id="19" name="">
             <a:extLst xmlns:a="http://schemas.openxmlformats.org/drawingml/2006/main">
               <a:ext uri="{FF2B5EF4-FFF2-40B4-BE49-F238E27FC236}">
-                <a16:creationId xmlns:a16="http://schemas.microsoft.com/office/drawing/2014/main" id="{02A9CDF1-900D-4960-913B-55DA9A960136}"/>
+                <a16:creationId xmlns:a16="http://schemas.microsoft.com/office/drawing/2014/main" id="{AA25000F-C888-461F-B566-BD46C76DCECD}"/>
               </a:ext>
             </a:extLst>
           </p:cNvPr>
@@ -3281,7 +3281,7 @@
           <p:cNvPr id="20" name="">
             <a:extLst xmlns:a="http://schemas.openxmlformats.org/drawingml/2006/main">
               <a:ext uri="{FF2B5EF4-FFF2-40B4-BE49-F238E27FC236}">
-                <a16:creationId xmlns:a16="http://schemas.microsoft.com/office/drawing/2014/main" id="{14728700-E567-4F18-B1C1-C69D0BBC5E28}"/>
+                <a16:creationId xmlns:a16="http://schemas.microsoft.com/office/drawing/2014/main" id="{FBBE0579-EE18-4C23-9C7C-8370D7EA00F3}"/>
               </a:ext>
             </a:extLst>
           </p:cNvPr>
@@ -3314,7 +3314,7 @@
           <p:cNvPr id="21" name="">
             <a:extLst xmlns:a="http://schemas.openxmlformats.org/drawingml/2006/main">
               <a:ext uri="{FF2B5EF4-FFF2-40B4-BE49-F238E27FC236}">
-                <a16:creationId xmlns:a16="http://schemas.microsoft.com/office/drawing/2014/main" id="{F6E92D76-A42A-4C36-BEB0-307A3487A146}"/>
+                <a16:creationId xmlns:a16="http://schemas.microsoft.com/office/drawing/2014/main" id="{90B92372-299C-4FAA-B074-4A2F420174E4}"/>
               </a:ext>
             </a:extLst>
           </p:cNvPr>
@@ -3364,7 +3364,7 @@
           <p:cNvPr id="22" name="">
             <a:extLst xmlns:a="http://schemas.openxmlformats.org/drawingml/2006/main">
               <a:ext uri="{FF2B5EF4-FFF2-40B4-BE49-F238E27FC236}">
-                <a16:creationId xmlns:a16="http://schemas.microsoft.com/office/drawing/2014/main" id="{F068FD22-3AB6-4FBF-B169-1017177C7AC2}"/>
+                <a16:creationId xmlns:a16="http://schemas.microsoft.com/office/drawing/2014/main" id="{589F4367-7357-4E0C-AC22-07C09DD9E761}"/>
               </a:ext>
             </a:extLst>
           </p:cNvPr>
@@ -3414,7 +3414,7 @@
           <p:cNvPr id="23" name="">
             <a:extLst xmlns:a="http://schemas.openxmlformats.org/drawingml/2006/main">
               <a:ext uri="{FF2B5EF4-FFF2-40B4-BE49-F238E27FC236}">
-                <a16:creationId xmlns:a16="http://schemas.microsoft.com/office/drawing/2014/main" id="{FA33BE45-836E-4A14-AFEC-1BC11660F7FA}"/>
+                <a16:creationId xmlns:a16="http://schemas.microsoft.com/office/drawing/2014/main" id="{96C15CF0-9C4F-4C76-B6D9-CD89283ACEE1}"/>
               </a:ext>
             </a:extLst>
           </p:cNvPr>
@@ -3447,7 +3447,7 @@
           <p:cNvPr id="24" name="">
             <a:extLst xmlns:a="http://schemas.openxmlformats.org/drawingml/2006/main">
               <a:ext uri="{FF2B5EF4-FFF2-40B4-BE49-F238E27FC236}">
-                <a16:creationId xmlns:a16="http://schemas.microsoft.com/office/drawing/2014/main" id="{3A16CF70-9553-46CD-BF67-5FA4724ED917}"/>
+                <a16:creationId xmlns:a16="http://schemas.microsoft.com/office/drawing/2014/main" id="{F353E2D7-1E51-468B-9963-2D0762779345}"/>
               </a:ext>
             </a:extLst>
           </p:cNvPr>
@@ -3497,7 +3497,7 @@
           <p:cNvPr id="25" name="">
             <a:extLst xmlns:a="http://schemas.openxmlformats.org/drawingml/2006/main">
               <a:ext uri="{FF2B5EF4-FFF2-40B4-BE49-F238E27FC236}">
-                <a16:creationId xmlns:a16="http://schemas.microsoft.com/office/drawing/2014/main" id="{CCA074E5-8912-4F4C-8799-840E4E46689A}"/>
+                <a16:creationId xmlns:a16="http://schemas.microsoft.com/office/drawing/2014/main" id="{1EC482D3-EFC8-42AC-99AA-5DB1C7E6DDFE}"/>
               </a:ext>
             </a:extLst>
           </p:cNvPr>
@@ -3547,7 +3547,7 @@
           <p:cNvPr id="26" name="">
             <a:extLst xmlns:a="http://schemas.openxmlformats.org/drawingml/2006/main">
               <a:ext uri="{FF2B5EF4-FFF2-40B4-BE49-F238E27FC236}">
-                <a16:creationId xmlns:a16="http://schemas.microsoft.com/office/drawing/2014/main" id="{9484793A-0498-40C8-BD4F-36F0501B981E}"/>
+                <a16:creationId xmlns:a16="http://schemas.microsoft.com/office/drawing/2014/main" id="{CE6214DF-CAF8-407D-B882-FD7AB1B4329E}"/>
               </a:ext>
             </a:extLst>
           </p:cNvPr>
@@ -3580,7 +3580,7 @@
           <p:cNvPr id="27" name="">
             <a:extLst xmlns:a="http://schemas.openxmlformats.org/drawingml/2006/main">
               <a:ext uri="{FF2B5EF4-FFF2-40B4-BE49-F238E27FC236}">
-                <a16:creationId xmlns:a16="http://schemas.microsoft.com/office/drawing/2014/main" id="{C5E1AE86-BC7D-4B4F-8D32-77253AF955C7}"/>
+                <a16:creationId xmlns:a16="http://schemas.microsoft.com/office/drawing/2014/main" id="{765BFE61-96F6-4029-AEC1-9F8812832ACF}"/>
               </a:ext>
             </a:extLst>
           </p:cNvPr>
@@ -3630,7 +3630,7 @@
           <p:cNvPr id="28" name="">
             <a:extLst xmlns:a="http://schemas.openxmlformats.org/drawingml/2006/main">
               <a:ext uri="{FF2B5EF4-FFF2-40B4-BE49-F238E27FC236}">
-                <a16:creationId xmlns:a16="http://schemas.microsoft.com/office/drawing/2014/main" id="{6FFBAD72-A615-46F0-A748-C3AF2ECDF3F4}"/>
+                <a16:creationId xmlns:a16="http://schemas.microsoft.com/office/drawing/2014/main" id="{067D7286-BD18-4C29-AF82-1F60BD5D2A45}"/>
               </a:ext>
             </a:extLst>
           </p:cNvPr>
@@ -3680,7 +3680,7 @@
           <p:cNvPr id="29" name="">
             <a:extLst xmlns:a="http://schemas.openxmlformats.org/drawingml/2006/main">
               <a:ext uri="{FF2B5EF4-FFF2-40B4-BE49-F238E27FC236}">
-                <a16:creationId xmlns:a16="http://schemas.microsoft.com/office/drawing/2014/main" id="{A6983050-3581-49C7-A08C-5DF9835D8178}"/>
+                <a16:creationId xmlns:a16="http://schemas.microsoft.com/office/drawing/2014/main" id="{FD242475-3EBB-4343-96AD-696A3DB0DE39}"/>
               </a:ext>
             </a:extLst>
           </p:cNvPr>
@@ -3713,7 +3713,7 @@
           <p:cNvPr id="30" name="">
             <a:extLst xmlns:a="http://schemas.openxmlformats.org/drawingml/2006/main">
               <a:ext uri="{FF2B5EF4-FFF2-40B4-BE49-F238E27FC236}">
-                <a16:creationId xmlns:a16="http://schemas.microsoft.com/office/drawing/2014/main" id="{18DFAC31-1CDC-4050-BE0E-261D6D35D932}"/>
+                <a16:creationId xmlns:a16="http://schemas.microsoft.com/office/drawing/2014/main" id="{E3BA9277-8CE0-427C-8571-FF923A76AA74}"/>
               </a:ext>
             </a:extLst>
           </p:cNvPr>
@@ -3763,7 +3763,7 @@
           <p:cNvPr id="31" name="">
             <a:extLst xmlns:a="http://schemas.openxmlformats.org/drawingml/2006/main">
               <a:ext uri="{FF2B5EF4-FFF2-40B4-BE49-F238E27FC236}">
-                <a16:creationId xmlns:a16="http://schemas.microsoft.com/office/drawing/2014/main" id="{45A86C34-67B7-43D8-B3C0-6022F01CD58E}"/>
+                <a16:creationId xmlns:a16="http://schemas.microsoft.com/office/drawing/2014/main" id="{3C4A650A-5149-449A-BA85-302BC8ED019C}"/>
               </a:ext>
             </a:extLst>
           </p:cNvPr>
@@ -3813,7 +3813,7 @@
           <p:cNvPr id="32" name="">
             <a:extLst xmlns:a="http://schemas.openxmlformats.org/drawingml/2006/main">
               <a:ext uri="{FF2B5EF4-FFF2-40B4-BE49-F238E27FC236}">
-                <a16:creationId xmlns:a16="http://schemas.microsoft.com/office/drawing/2014/main" id="{32595F1B-72B3-4145-8461-D778362D8C0D}"/>
+                <a16:creationId xmlns:a16="http://schemas.microsoft.com/office/drawing/2014/main" id="{9642AF23-1FBB-46D9-AD52-950F6102727A}"/>
               </a:ext>
             </a:extLst>
           </p:cNvPr>
@@ -3846,7 +3846,7 @@
           <p:cNvPr id="33" name="">
             <a:extLst xmlns:a="http://schemas.openxmlformats.org/drawingml/2006/main">
               <a:ext uri="{FF2B5EF4-FFF2-40B4-BE49-F238E27FC236}">
-                <a16:creationId xmlns:a16="http://schemas.microsoft.com/office/drawing/2014/main" id="{66063E7C-FB59-4493-8237-838DE95D44FC}"/>
+                <a16:creationId xmlns:a16="http://schemas.microsoft.com/office/drawing/2014/main" id="{4075CF12-7FC6-43C3-90E1-3601E46C5471}"/>
               </a:ext>
             </a:extLst>
           </p:cNvPr>
@@ -3896,7 +3896,7 @@
           <p:cNvPr id="34" name="">
             <a:extLst xmlns:a="http://schemas.openxmlformats.org/drawingml/2006/main">
               <a:ext uri="{FF2B5EF4-FFF2-40B4-BE49-F238E27FC236}">
-                <a16:creationId xmlns:a16="http://schemas.microsoft.com/office/drawing/2014/main" id="{761218D4-1237-46F5-936F-DE7EE183ADF0}"/>
+                <a16:creationId xmlns:a16="http://schemas.microsoft.com/office/drawing/2014/main" id="{32F35F80-FD02-43CB-9495-A5333A125DF6}"/>
               </a:ext>
             </a:extLst>
           </p:cNvPr>
@@ -3946,7 +3946,7 @@
           <p:cNvPr id="35" name="">
             <a:extLst xmlns:a="http://schemas.openxmlformats.org/drawingml/2006/main">
               <a:ext uri="{FF2B5EF4-FFF2-40B4-BE49-F238E27FC236}">
-                <a16:creationId xmlns:a16="http://schemas.microsoft.com/office/drawing/2014/main" id="{A2C01093-D5B8-4F8E-8B1C-833A386A1B1B}"/>
+                <a16:creationId xmlns:a16="http://schemas.microsoft.com/office/drawing/2014/main" id="{2A2AB9A7-BC9C-4257-A560-132F76574B06}"/>
               </a:ext>
             </a:extLst>
           </p:cNvPr>
@@ -3979,7 +3979,7 @@
           <p:cNvPr id="36" name="">
             <a:extLst xmlns:a="http://schemas.openxmlformats.org/drawingml/2006/main">
               <a:ext uri="{FF2B5EF4-FFF2-40B4-BE49-F238E27FC236}">
-                <a16:creationId xmlns:a16="http://schemas.microsoft.com/office/drawing/2014/main" id="{98736C79-C2AB-4A6C-A37F-C5CD59683557}"/>
+                <a16:creationId xmlns:a16="http://schemas.microsoft.com/office/drawing/2014/main" id="{EDDFA91F-0FD2-4B3E-A9D0-D0B7DC374A85}"/>
               </a:ext>
             </a:extLst>
           </p:cNvPr>
@@ -4029,7 +4029,7 @@
           <p:cNvPr id="37" name="">
             <a:extLst xmlns:a="http://schemas.openxmlformats.org/drawingml/2006/main">
               <a:ext uri="{FF2B5EF4-FFF2-40B4-BE49-F238E27FC236}">
-                <a16:creationId xmlns:a16="http://schemas.microsoft.com/office/drawing/2014/main" id="{C7016A89-3442-498B-85DC-E9674AE3C786}"/>
+                <a16:creationId xmlns:a16="http://schemas.microsoft.com/office/drawing/2014/main" id="{C7A1B97F-0DF1-4455-AF03-BF4E79455655}"/>
               </a:ext>
             </a:extLst>
           </p:cNvPr>
@@ -4079,7 +4079,7 @@
           <p:cNvPr id="38" name="">
             <a:extLst xmlns:a="http://schemas.openxmlformats.org/drawingml/2006/main">
               <a:ext uri="{FF2B5EF4-FFF2-40B4-BE49-F238E27FC236}">
-                <a16:creationId xmlns:a16="http://schemas.microsoft.com/office/drawing/2014/main" id="{F9EBC3E3-6F67-4E57-8C9F-CA325D8BE520}"/>
+                <a16:creationId xmlns:a16="http://schemas.microsoft.com/office/drawing/2014/main" id="{08827B3A-8671-462D-AA73-A6323D3EA822}"/>
               </a:ext>
             </a:extLst>
           </p:cNvPr>
@@ -4129,7 +4129,7 @@
           <p:cNvPr id="39" name="">
             <a:extLst xmlns:a="http://schemas.openxmlformats.org/drawingml/2006/main">
               <a:ext uri="{FF2B5EF4-FFF2-40B4-BE49-F238E27FC236}">
-                <a16:creationId xmlns:a16="http://schemas.microsoft.com/office/drawing/2014/main" id="{8B23BB2E-0895-4228-94AA-3A69B6CB38E4}"/>
+                <a16:creationId xmlns:a16="http://schemas.microsoft.com/office/drawing/2014/main" id="{2E243702-A0EB-437F-91F6-B5793F58EABB}"/>
               </a:ext>
             </a:extLst>
           </p:cNvPr>
@@ -4179,7 +4179,7 @@
           <p:cNvPr id="40" name="">
             <a:extLst xmlns:a="http://schemas.openxmlformats.org/drawingml/2006/main">
               <a:ext uri="{FF2B5EF4-FFF2-40B4-BE49-F238E27FC236}">
-                <a16:creationId xmlns:a16="http://schemas.microsoft.com/office/drawing/2014/main" id="{BC47FA9D-E759-426A-9049-2CA33FED89B2}"/>
+                <a16:creationId xmlns:a16="http://schemas.microsoft.com/office/drawing/2014/main" id="{1470863A-1EC5-4E51-8592-251DD1A1A938}"/>
               </a:ext>
             </a:extLst>
           </p:cNvPr>
@@ -4229,7 +4229,7 @@
           <p:cNvPr id="41" name="">
             <a:extLst xmlns:a="http://schemas.openxmlformats.org/drawingml/2006/main">
               <a:ext uri="{FF2B5EF4-FFF2-40B4-BE49-F238E27FC236}">
-                <a16:creationId xmlns:a16="http://schemas.microsoft.com/office/drawing/2014/main" id="{6CFCE3F4-0D3C-4982-8E28-ACB0EA49DB27}"/>
+                <a16:creationId xmlns:a16="http://schemas.microsoft.com/office/drawing/2014/main" id="{FA3EE0A2-CAF3-4328-9A3F-055C15E1130B}"/>
               </a:ext>
             </a:extLst>
           </p:cNvPr>
@@ -4279,7 +4279,7 @@
           <p:cNvPr id="42" name="">
             <a:extLst xmlns:a="http://schemas.openxmlformats.org/drawingml/2006/main">
               <a:ext uri="{FF2B5EF4-FFF2-40B4-BE49-F238E27FC236}">
-                <a16:creationId xmlns:a16="http://schemas.microsoft.com/office/drawing/2014/main" id="{F2889DFC-8059-47E5-9E57-521496916289}"/>
+                <a16:creationId xmlns:a16="http://schemas.microsoft.com/office/drawing/2014/main" id="{03A65E93-AED3-4667-AC3B-8AE1EBB60478}"/>
               </a:ext>
             </a:extLst>
           </p:cNvPr>
@@ -4327,7 +4327,7 @@
     </p:spTree>
     <p:extLst>
       <p:ext uri="{BB962C8B-B14F-4D97-AF65-F5344CB8AC3E}">
-        <p14:creationId xmlns:p14="http://schemas.microsoft.com/office/powerpoint/2010/main" val="1793398574"/>
+        <p14:creationId xmlns:p14="http://schemas.microsoft.com/office/powerpoint/2010/main" val="1261150830"/>
       </p:ext>
     </p:extLst>
   </p:cSld>
@@ -4358,7 +4358,7 @@
           <p:cNvPr id="34" name="">
             <a:extLst xmlns:a="http://schemas.openxmlformats.org/drawingml/2006/main">
               <a:ext uri="{FF2B5EF4-FFF2-40B4-BE49-F238E27FC236}">
-                <a16:creationId xmlns:a16="http://schemas.microsoft.com/office/drawing/2014/main" id="{BB0F9580-9285-4A76-93C8-2BF977712AE9}"/>
+                <a16:creationId xmlns:a16="http://schemas.microsoft.com/office/drawing/2014/main" id="{100420D4-FECE-4653-BF67-0454A847FF2A}"/>
               </a:ext>
             </a:extLst>
           </p:cNvPr>
@@ -4408,7 +4408,7 @@
           <p:cNvPr id="2" name="">
             <a:extLst xmlns:a="http://schemas.openxmlformats.org/drawingml/2006/main">
               <a:ext uri="{FF2B5EF4-FFF2-40B4-BE49-F238E27FC236}">
-                <a16:creationId xmlns:a16="http://schemas.microsoft.com/office/drawing/2014/main" id="{EBDEC5E8-7D64-4539-9B73-3A456DC82E9B}"/>
+                <a16:creationId xmlns:a16="http://schemas.microsoft.com/office/drawing/2014/main" id="{5DB65765-3D01-457B-8169-57840826EE55}"/>
               </a:ext>
             </a:extLst>
           </p:cNvPr>
@@ -4458,7 +4458,7 @@
           <p:cNvPr id="3" name="">
             <a:extLst xmlns:a="http://schemas.openxmlformats.org/drawingml/2006/main">
               <a:ext uri="{FF2B5EF4-FFF2-40B4-BE49-F238E27FC236}">
-                <a16:creationId xmlns:a16="http://schemas.microsoft.com/office/drawing/2014/main" id="{3A5BE9FC-92FE-4875-9A63-B757DC3AD280}"/>
+                <a16:creationId xmlns:a16="http://schemas.microsoft.com/office/drawing/2014/main" id="{51683600-120C-4C04-96A5-ADACF0A6BDF2}"/>
               </a:ext>
             </a:extLst>
           </p:cNvPr>
@@ -4491,7 +4491,7 @@
           <p:cNvPr id="4" name="">
             <a:extLst xmlns:a="http://schemas.openxmlformats.org/drawingml/2006/main">
               <a:ext uri="{FF2B5EF4-FFF2-40B4-BE49-F238E27FC236}">
-                <a16:creationId xmlns:a16="http://schemas.microsoft.com/office/drawing/2014/main" id="{8641E0F6-0016-48F5-93F5-E5DB10E2757C}"/>
+                <a16:creationId xmlns:a16="http://schemas.microsoft.com/office/drawing/2014/main" id="{B186CA95-A3AC-451E-9E75-6EEADCC38804}"/>
               </a:ext>
             </a:extLst>
           </p:cNvPr>
@@ -4541,7 +4541,7 @@
           <p:cNvPr id="5" name="">
             <a:extLst xmlns:a="http://schemas.openxmlformats.org/drawingml/2006/main">
               <a:ext uri="{FF2B5EF4-FFF2-40B4-BE49-F238E27FC236}">
-                <a16:creationId xmlns:a16="http://schemas.microsoft.com/office/drawing/2014/main" id="{E1C79AD0-61E4-4743-9AB4-0617B93E0EAE}"/>
+                <a16:creationId xmlns:a16="http://schemas.microsoft.com/office/drawing/2014/main" id="{FC66B1A9-4513-4D71-ADD0-936668702D31}"/>
               </a:ext>
             </a:extLst>
           </p:cNvPr>
@@ -4574,7 +4574,7 @@
           <p:cNvPr id="6" name="">
             <a:extLst xmlns:a="http://schemas.openxmlformats.org/drawingml/2006/main">
               <a:ext uri="{FF2B5EF4-FFF2-40B4-BE49-F238E27FC236}">
-                <a16:creationId xmlns:a16="http://schemas.microsoft.com/office/drawing/2014/main" id="{1F40C20A-F149-49EB-89DE-C1B0A17ED888}"/>
+                <a16:creationId xmlns:a16="http://schemas.microsoft.com/office/drawing/2014/main" id="{AF668222-2900-404B-8003-890CA5A55EFD}"/>
               </a:ext>
             </a:extLst>
           </p:cNvPr>
@@ -4641,7 +4641,7 @@
           <p:cNvPr id="7" name="">
             <a:extLst xmlns:a="http://schemas.openxmlformats.org/drawingml/2006/main">
               <a:ext uri="{FF2B5EF4-FFF2-40B4-BE49-F238E27FC236}">
-                <a16:creationId xmlns:a16="http://schemas.microsoft.com/office/drawing/2014/main" id="{4151BCEB-1B36-4975-B55F-6C7D56D87981}"/>
+                <a16:creationId xmlns:a16="http://schemas.microsoft.com/office/drawing/2014/main" id="{43350D95-EEAA-4AB7-9E47-016761D08435}"/>
               </a:ext>
             </a:extLst>
           </p:cNvPr>
@@ -4691,7 +4691,7 @@
           <p:cNvPr id="8" name="">
             <a:extLst xmlns:a="http://schemas.openxmlformats.org/drawingml/2006/main">
               <a:ext uri="{FF2B5EF4-FFF2-40B4-BE49-F238E27FC236}">
-                <a16:creationId xmlns:a16="http://schemas.microsoft.com/office/drawing/2014/main" id="{A42E98BD-FEED-4987-9EA1-536E938C0E2E}"/>
+                <a16:creationId xmlns:a16="http://schemas.microsoft.com/office/drawing/2014/main" id="{7322BE4A-81DE-4B8F-A2FD-5C5037A62391}"/>
               </a:ext>
             </a:extLst>
           </p:cNvPr>
@@ -4724,7 +4724,7 @@
           <p:cNvPr id="9" name="">
             <a:extLst xmlns:a="http://schemas.openxmlformats.org/drawingml/2006/main">
               <a:ext uri="{FF2B5EF4-FFF2-40B4-BE49-F238E27FC236}">
-                <a16:creationId xmlns:a16="http://schemas.microsoft.com/office/drawing/2014/main" id="{AC599502-8DA7-477F-90F3-92094AFC2639}"/>
+                <a16:creationId xmlns:a16="http://schemas.microsoft.com/office/drawing/2014/main" id="{F5972B69-3371-4B1F-92FF-153E38760E41}"/>
               </a:ext>
             </a:extLst>
           </p:cNvPr>
@@ -4791,7 +4791,7 @@
           <p:cNvPr id="10" name="">
             <a:extLst xmlns:a="http://schemas.openxmlformats.org/drawingml/2006/main">
               <a:ext uri="{FF2B5EF4-FFF2-40B4-BE49-F238E27FC236}">
-                <a16:creationId xmlns:a16="http://schemas.microsoft.com/office/drawing/2014/main" id="{228B5EEC-80F7-4EBA-9DB4-EABCF2A1A522}"/>
+                <a16:creationId xmlns:a16="http://schemas.microsoft.com/office/drawing/2014/main" id="{7877FC4D-9C91-4DB9-8EA6-8C4A0DD63B33}"/>
               </a:ext>
             </a:extLst>
           </p:cNvPr>
@@ -4841,7 +4841,7 @@
           <p:cNvPr id="11" name="">
             <a:extLst xmlns:a="http://schemas.openxmlformats.org/drawingml/2006/main">
               <a:ext uri="{FF2B5EF4-FFF2-40B4-BE49-F238E27FC236}">
-                <a16:creationId xmlns:a16="http://schemas.microsoft.com/office/drawing/2014/main" id="{D40E4BEC-5164-4154-9936-1EC46D69FE39}"/>
+                <a16:creationId xmlns:a16="http://schemas.microsoft.com/office/drawing/2014/main" id="{CAEEDA32-7F44-43C2-B905-B468891A9358}"/>
               </a:ext>
             </a:extLst>
           </p:cNvPr>
@@ -4874,7 +4874,7 @@
           <p:cNvPr id="12" name="">
             <a:extLst xmlns:a="http://schemas.openxmlformats.org/drawingml/2006/main">
               <a:ext uri="{FF2B5EF4-FFF2-40B4-BE49-F238E27FC236}">
-                <a16:creationId xmlns:a16="http://schemas.microsoft.com/office/drawing/2014/main" id="{7E1245A2-9E43-4AB3-99AE-FE9BF558CBF4}"/>
+                <a16:creationId xmlns:a16="http://schemas.microsoft.com/office/drawing/2014/main" id="{7F6EB060-F72F-4962-9A9F-B990E8E4A1E5}"/>
               </a:ext>
             </a:extLst>
           </p:cNvPr>
@@ -4941,7 +4941,7 @@
           <p:cNvPr id="13" name="">
             <a:extLst xmlns:a="http://schemas.openxmlformats.org/drawingml/2006/main">
               <a:ext uri="{FF2B5EF4-FFF2-40B4-BE49-F238E27FC236}">
-                <a16:creationId xmlns:a16="http://schemas.microsoft.com/office/drawing/2014/main" id="{D59B6754-97BF-445B-B8BF-C332EE6C425D}"/>
+                <a16:creationId xmlns:a16="http://schemas.microsoft.com/office/drawing/2014/main" id="{FCCBB054-B1B8-4608-994B-147205526955}"/>
               </a:ext>
             </a:extLst>
           </p:cNvPr>
@@ -4991,7 +4991,7 @@
           <p:cNvPr id="14" name="">
             <a:extLst xmlns:a="http://schemas.openxmlformats.org/drawingml/2006/main">
               <a:ext uri="{FF2B5EF4-FFF2-40B4-BE49-F238E27FC236}">
-                <a16:creationId xmlns:a16="http://schemas.microsoft.com/office/drawing/2014/main" id="{2139AA70-D20D-4B70-8EC2-C5034E1D12E9}"/>
+                <a16:creationId xmlns:a16="http://schemas.microsoft.com/office/drawing/2014/main" id="{F75FE8D8-4662-4D0B-B928-ECF488CA1D91}"/>
               </a:ext>
             </a:extLst>
           </p:cNvPr>
@@ -5024,7 +5024,7 @@
           <p:cNvPr id="15" name="">
             <a:extLst xmlns:a="http://schemas.openxmlformats.org/drawingml/2006/main">
               <a:ext uri="{FF2B5EF4-FFF2-40B4-BE49-F238E27FC236}">
-                <a16:creationId xmlns:a16="http://schemas.microsoft.com/office/drawing/2014/main" id="{C00D276A-0BC6-4A90-B792-1FFA1755160F}"/>
+                <a16:creationId xmlns:a16="http://schemas.microsoft.com/office/drawing/2014/main" id="{286E7572-881E-4218-9CB9-4285C9B21B2B}"/>
               </a:ext>
             </a:extLst>
           </p:cNvPr>
@@ -5091,7 +5091,7 @@
           <p:cNvPr id="16" name="">
             <a:extLst xmlns:a="http://schemas.openxmlformats.org/drawingml/2006/main">
               <a:ext uri="{FF2B5EF4-FFF2-40B4-BE49-F238E27FC236}">
-                <a16:creationId xmlns:a16="http://schemas.microsoft.com/office/drawing/2014/main" id="{F17B7DC6-D0C4-48E5-8002-2060D45C474F}"/>
+                <a16:creationId xmlns:a16="http://schemas.microsoft.com/office/drawing/2014/main" id="{3A9F14A7-A49A-4CBB-9D52-2AA11D500510}"/>
               </a:ext>
             </a:extLst>
           </p:cNvPr>
@@ -5141,7 +5141,7 @@
           <p:cNvPr id="17" name="">
             <a:extLst xmlns:a="http://schemas.openxmlformats.org/drawingml/2006/main">
               <a:ext uri="{FF2B5EF4-FFF2-40B4-BE49-F238E27FC236}">
-                <a16:creationId xmlns:a16="http://schemas.microsoft.com/office/drawing/2014/main" id="{FCA58C49-BBF7-4292-8D23-FEBDB2304C3E}"/>
+                <a16:creationId xmlns:a16="http://schemas.microsoft.com/office/drawing/2014/main" id="{226A30FC-EE7A-4E17-8062-2F594AE32AB9}"/>
               </a:ext>
             </a:extLst>
           </p:cNvPr>
@@ -5174,7 +5174,7 @@
           <p:cNvPr id="18" name="">
             <a:extLst xmlns:a="http://schemas.openxmlformats.org/drawingml/2006/main">
               <a:ext uri="{FF2B5EF4-FFF2-40B4-BE49-F238E27FC236}">
-                <a16:creationId xmlns:a16="http://schemas.microsoft.com/office/drawing/2014/main" id="{89F30888-CB8D-40B0-85AA-51DFBFDB7BA8}"/>
+                <a16:creationId xmlns:a16="http://schemas.microsoft.com/office/drawing/2014/main" id="{801C498D-653C-4C14-8563-5CA1DF00EF99}"/>
               </a:ext>
             </a:extLst>
           </p:cNvPr>
@@ -5241,7 +5241,7 @@
           <p:cNvPr id="19" name="">
             <a:extLst xmlns:a="http://schemas.openxmlformats.org/drawingml/2006/main">
               <a:ext uri="{FF2B5EF4-FFF2-40B4-BE49-F238E27FC236}">
-                <a16:creationId xmlns:a16="http://schemas.microsoft.com/office/drawing/2014/main" id="{A78EEAC0-A935-41E0-BE37-488ACF9DB452}"/>
+                <a16:creationId xmlns:a16="http://schemas.microsoft.com/office/drawing/2014/main" id="{2D90505C-98E4-4A21-9653-B09C835D4C6A}"/>
               </a:ext>
             </a:extLst>
           </p:cNvPr>
@@ -5291,7 +5291,7 @@
           <p:cNvPr id="20" name="">
             <a:extLst xmlns:a="http://schemas.openxmlformats.org/drawingml/2006/main">
               <a:ext uri="{FF2B5EF4-FFF2-40B4-BE49-F238E27FC236}">
-                <a16:creationId xmlns:a16="http://schemas.microsoft.com/office/drawing/2014/main" id="{8756D28C-88F1-4631-BD47-1AED28D98790}"/>
+                <a16:creationId xmlns:a16="http://schemas.microsoft.com/office/drawing/2014/main" id="{F9D7122A-CA4D-42C6-AFA4-AE3D9BD6765A}"/>
               </a:ext>
             </a:extLst>
           </p:cNvPr>
@@ -5324,7 +5324,7 @@
           <p:cNvPr id="21" name="">
             <a:extLst xmlns:a="http://schemas.openxmlformats.org/drawingml/2006/main">
               <a:ext uri="{FF2B5EF4-FFF2-40B4-BE49-F238E27FC236}">
-                <a16:creationId xmlns:a16="http://schemas.microsoft.com/office/drawing/2014/main" id="{D66A7E7E-4FDA-464B-B355-99267730DCDC}"/>
+                <a16:creationId xmlns:a16="http://schemas.microsoft.com/office/drawing/2014/main" id="{86D36ED1-4F77-42A5-BCA5-E379F4851418}"/>
               </a:ext>
             </a:extLst>
           </p:cNvPr>
@@ -5391,7 +5391,7 @@
           <p:cNvPr id="22" name="">
             <a:extLst xmlns:a="http://schemas.openxmlformats.org/drawingml/2006/main">
               <a:ext uri="{FF2B5EF4-FFF2-40B4-BE49-F238E27FC236}">
-                <a16:creationId xmlns:a16="http://schemas.microsoft.com/office/drawing/2014/main" id="{AF927F76-D97E-450D-B3D5-57A09670B450}"/>
+                <a16:creationId xmlns:a16="http://schemas.microsoft.com/office/drawing/2014/main" id="{4CABD30A-C62F-4D82-8BDE-859EF357B2A1}"/>
               </a:ext>
             </a:extLst>
           </p:cNvPr>
@@ -5441,7 +5441,7 @@
           <p:cNvPr id="23" name="">
             <a:extLst xmlns:a="http://schemas.openxmlformats.org/drawingml/2006/main">
               <a:ext uri="{FF2B5EF4-FFF2-40B4-BE49-F238E27FC236}">
-                <a16:creationId xmlns:a16="http://schemas.microsoft.com/office/drawing/2014/main" id="{42E1D216-D3A4-458C-B885-97FC10807B65}"/>
+                <a16:creationId xmlns:a16="http://schemas.microsoft.com/office/drawing/2014/main" id="{B5A54EB6-3B5D-4BF9-839F-DDE90EB08683}"/>
               </a:ext>
             </a:extLst>
           </p:cNvPr>
@@ -5491,7 +5491,7 @@
           <p:cNvPr id="24" name="">
             <a:extLst xmlns:a="http://schemas.openxmlformats.org/drawingml/2006/main">
               <a:ext uri="{FF2B5EF4-FFF2-40B4-BE49-F238E27FC236}">
-                <a16:creationId xmlns:a16="http://schemas.microsoft.com/office/drawing/2014/main" id="{165A8E2E-9D68-4B5D-8FDE-346CFD4D6FDF}"/>
+                <a16:creationId xmlns:a16="http://schemas.microsoft.com/office/drawing/2014/main" id="{AED92646-E522-4869-A669-A5B65144492C}"/>
               </a:ext>
             </a:extLst>
           </p:cNvPr>
@@ -5541,7 +5541,7 @@
           <p:cNvPr id="25" name="">
             <a:extLst xmlns:a="http://schemas.openxmlformats.org/drawingml/2006/main">
               <a:ext uri="{FF2B5EF4-FFF2-40B4-BE49-F238E27FC236}">
-                <a16:creationId xmlns:a16="http://schemas.microsoft.com/office/drawing/2014/main" id="{B295C8D9-8A61-4B32-A540-3F75C6E5499D}"/>
+                <a16:creationId xmlns:a16="http://schemas.microsoft.com/office/drawing/2014/main" id="{F7BD0930-B777-4941-BA32-E8C0DD37F430}"/>
               </a:ext>
             </a:extLst>
           </p:cNvPr>
@@ -5591,7 +5591,7 @@
           <p:cNvPr id="26" name="">
             <a:extLst xmlns:a="http://schemas.openxmlformats.org/drawingml/2006/main">
               <a:ext uri="{FF2B5EF4-FFF2-40B4-BE49-F238E27FC236}">
-                <a16:creationId xmlns:a16="http://schemas.microsoft.com/office/drawing/2014/main" id="{49EDEE01-B482-4FE6-A2B3-0BD534019AB3}"/>
+                <a16:creationId xmlns:a16="http://schemas.microsoft.com/office/drawing/2014/main" id="{56157AA3-D575-49B7-B177-626D43F7C535}"/>
               </a:ext>
             </a:extLst>
           </p:cNvPr>
@@ -5641,7 +5641,7 @@
           <p:cNvPr id="27" name="">
             <a:extLst xmlns:a="http://schemas.openxmlformats.org/drawingml/2006/main">
               <a:ext uri="{FF2B5EF4-FFF2-40B4-BE49-F238E27FC236}">
-                <a16:creationId xmlns:a16="http://schemas.microsoft.com/office/drawing/2014/main" id="{B82218DF-6B7B-4D19-9850-0C632F27B956}"/>
+                <a16:creationId xmlns:a16="http://schemas.microsoft.com/office/drawing/2014/main" id="{4FC5217C-0D7C-4C8B-B775-6D7C2CE1BE0B}"/>
               </a:ext>
             </a:extLst>
           </p:cNvPr>
@@ -5691,7 +5691,7 @@
           <p:cNvPr id="28" name="">
             <a:extLst xmlns:a="http://schemas.openxmlformats.org/drawingml/2006/main">
               <a:ext uri="{FF2B5EF4-FFF2-40B4-BE49-F238E27FC236}">
-                <a16:creationId xmlns:a16="http://schemas.microsoft.com/office/drawing/2014/main" id="{E6ADDA74-1C07-487E-87CF-7B0E1B7DBC65}"/>
+                <a16:creationId xmlns:a16="http://schemas.microsoft.com/office/drawing/2014/main" id="{171A7229-2C47-46FE-86C3-47EE39746F73}"/>
               </a:ext>
             </a:extLst>
           </p:cNvPr>
@@ -5741,7 +5741,7 @@
           <p:cNvPr id="29" name="">
             <a:extLst xmlns:a="http://schemas.openxmlformats.org/drawingml/2006/main">
               <a:ext uri="{FF2B5EF4-FFF2-40B4-BE49-F238E27FC236}">
-                <a16:creationId xmlns:a16="http://schemas.microsoft.com/office/drawing/2014/main" id="{78B69794-CE37-43E2-876C-BB56E69A6871}"/>
+                <a16:creationId xmlns:a16="http://schemas.microsoft.com/office/drawing/2014/main" id="{967F7497-3DF7-4766-BB87-DD526452C254}"/>
               </a:ext>
             </a:extLst>
           </p:cNvPr>
@@ -5791,7 +5791,7 @@
           <p:cNvPr id="30" name="">
             <a:extLst xmlns:a="http://schemas.openxmlformats.org/drawingml/2006/main">
               <a:ext uri="{FF2B5EF4-FFF2-40B4-BE49-F238E27FC236}">
-                <a16:creationId xmlns:a16="http://schemas.microsoft.com/office/drawing/2014/main" id="{892AA204-1BDA-456B-BCF6-751A8ADD30BE}"/>
+                <a16:creationId xmlns:a16="http://schemas.microsoft.com/office/drawing/2014/main" id="{B0590023-6502-4CF0-B772-645609D5676D}"/>
               </a:ext>
             </a:extLst>
           </p:cNvPr>
@@ -5841,7 +5841,7 @@
           <p:cNvPr id="31" name="">
             <a:extLst xmlns:a="http://schemas.openxmlformats.org/drawingml/2006/main">
               <a:ext uri="{FF2B5EF4-FFF2-40B4-BE49-F238E27FC236}">
-                <a16:creationId xmlns:a16="http://schemas.microsoft.com/office/drawing/2014/main" id="{A8FE5FBE-E373-4E58-886E-B5B8A2405094}"/>
+                <a16:creationId xmlns:a16="http://schemas.microsoft.com/office/drawing/2014/main" id="{79E703E0-A601-4B54-AD24-8BC1CE9051CA}"/>
               </a:ext>
             </a:extLst>
           </p:cNvPr>
@@ -5874,7 +5874,7 @@
           <p:cNvPr id="32" name="">
             <a:extLst xmlns:a="http://schemas.openxmlformats.org/drawingml/2006/main">
               <a:ext uri="{FF2B5EF4-FFF2-40B4-BE49-F238E27FC236}">
-                <a16:creationId xmlns:a16="http://schemas.microsoft.com/office/drawing/2014/main" id="{362A6D03-551C-4827-A3B8-D4DB360927CE}"/>
+                <a16:creationId xmlns:a16="http://schemas.microsoft.com/office/drawing/2014/main" id="{34E4BCCD-D455-4D78-9120-4E9B476D838D}"/>
               </a:ext>
             </a:extLst>
           </p:cNvPr>
@@ -5924,7 +5924,7 @@
           <p:cNvPr id="33" name="">
             <a:extLst xmlns:a="http://schemas.openxmlformats.org/drawingml/2006/main">
               <a:ext uri="{FF2B5EF4-FFF2-40B4-BE49-F238E27FC236}">
-                <a16:creationId xmlns:a16="http://schemas.microsoft.com/office/drawing/2014/main" id="{A2D30A73-38F2-459E-9A21-A4D9D0533216}"/>
+                <a16:creationId xmlns:a16="http://schemas.microsoft.com/office/drawing/2014/main" id="{9A56FF80-B7EE-4432-982C-D6A41AB7612B}"/>
               </a:ext>
             </a:extLst>
           </p:cNvPr>
@@ -6091,7 +6091,7 @@
     </p:spTree>
     <p:extLst>
       <p:ext uri="{BB962C8B-B14F-4D97-AF65-F5344CB8AC3E}">
-        <p14:creationId xmlns:p14="http://schemas.microsoft.com/office/powerpoint/2010/main" val="635890156"/>
+        <p14:creationId xmlns:p14="http://schemas.microsoft.com/office/powerpoint/2010/main" val="1169554678"/>
       </p:ext>
     </p:extLst>
   </p:cSld>
@@ -6122,7 +6122,7 @@
           <p:cNvPr id="30" name="">
             <a:extLst xmlns:a="http://schemas.openxmlformats.org/drawingml/2006/main">
               <a:ext uri="{FF2B5EF4-FFF2-40B4-BE49-F238E27FC236}">
-                <a16:creationId xmlns:a16="http://schemas.microsoft.com/office/drawing/2014/main" id="{60BFE707-8921-4780-9FD5-1DE51A966DAE}"/>
+                <a16:creationId xmlns:a16="http://schemas.microsoft.com/office/drawing/2014/main" id="{1E948813-06BF-42AA-BB56-3F3E890EDB52}"/>
               </a:ext>
             </a:extLst>
           </p:cNvPr>
@@ -6172,7 +6172,7 @@
           <p:cNvPr id="2" name="">
             <a:extLst xmlns:a="http://schemas.openxmlformats.org/drawingml/2006/main">
               <a:ext uri="{FF2B5EF4-FFF2-40B4-BE49-F238E27FC236}">
-                <a16:creationId xmlns:a16="http://schemas.microsoft.com/office/drawing/2014/main" id="{C03A9D0A-9132-4AD7-8F86-2E280BFC39B0}"/>
+                <a16:creationId xmlns:a16="http://schemas.microsoft.com/office/drawing/2014/main" id="{D1FE3925-E9E7-4801-A00D-D49F1DD9B76A}"/>
               </a:ext>
             </a:extLst>
           </p:cNvPr>
@@ -6222,7 +6222,7 @@
           <p:cNvPr id="3" name="">
             <a:extLst xmlns:a="http://schemas.openxmlformats.org/drawingml/2006/main">
               <a:ext uri="{FF2B5EF4-FFF2-40B4-BE49-F238E27FC236}">
-                <a16:creationId xmlns:a16="http://schemas.microsoft.com/office/drawing/2014/main" id="{7B5EC6C0-EE4F-4E7A-925C-0CB16945D39A}"/>
+                <a16:creationId xmlns:a16="http://schemas.microsoft.com/office/drawing/2014/main" id="{83D98C6D-A95D-4DC4-9185-F06AC170D9CB}"/>
               </a:ext>
             </a:extLst>
           </p:cNvPr>
@@ -6255,7 +6255,7 @@
           <p:cNvPr id="4" name="">
             <a:extLst xmlns:a="http://schemas.openxmlformats.org/drawingml/2006/main">
               <a:ext uri="{FF2B5EF4-FFF2-40B4-BE49-F238E27FC236}">
-                <a16:creationId xmlns:a16="http://schemas.microsoft.com/office/drawing/2014/main" id="{09DAC40B-62F8-4CF0-956D-24F628931636}"/>
+                <a16:creationId xmlns:a16="http://schemas.microsoft.com/office/drawing/2014/main" id="{C74819FE-A62D-4C34-9A05-93921D285D04}"/>
               </a:ext>
             </a:extLst>
           </p:cNvPr>
@@ -6305,7 +6305,7 @@
           <p:cNvPr id="5" name="">
             <a:extLst xmlns:a="http://schemas.openxmlformats.org/drawingml/2006/main">
               <a:ext uri="{FF2B5EF4-FFF2-40B4-BE49-F238E27FC236}">
-                <a16:creationId xmlns:a16="http://schemas.microsoft.com/office/drawing/2014/main" id="{82544621-4DF9-43E2-A110-A047CB132ABA}"/>
+                <a16:creationId xmlns:a16="http://schemas.microsoft.com/office/drawing/2014/main" id="{AE30D201-CF6A-4CF0-9ACE-8410718F10C2}"/>
               </a:ext>
             </a:extLst>
           </p:cNvPr>
@@ -6338,7 +6338,7 @@
           <p:cNvPr id="6" name="">
             <a:extLst xmlns:a="http://schemas.openxmlformats.org/drawingml/2006/main">
               <a:ext uri="{FF2B5EF4-FFF2-40B4-BE49-F238E27FC236}">
-                <a16:creationId xmlns:a16="http://schemas.microsoft.com/office/drawing/2014/main" id="{10B04D11-DBA9-452E-B43B-95FA15F0F67B}"/>
+                <a16:creationId xmlns:a16="http://schemas.microsoft.com/office/drawing/2014/main" id="{44EBF667-30D7-4145-9CCA-1FB900195159}"/>
               </a:ext>
             </a:extLst>
           </p:cNvPr>
@@ -6405,7 +6405,7 @@
           <p:cNvPr id="7" name="">
             <a:extLst xmlns:a="http://schemas.openxmlformats.org/drawingml/2006/main">
               <a:ext uri="{FF2B5EF4-FFF2-40B4-BE49-F238E27FC236}">
-                <a16:creationId xmlns:a16="http://schemas.microsoft.com/office/drawing/2014/main" id="{8CC0F0D3-660A-4C53-8C8D-F2807540A2A2}"/>
+                <a16:creationId xmlns:a16="http://schemas.microsoft.com/office/drawing/2014/main" id="{9B169399-E941-471E-93C5-0AC979DFAD06}"/>
               </a:ext>
             </a:extLst>
           </p:cNvPr>
@@ -6455,7 +6455,7 @@
           <p:cNvPr id="8" name="">
             <a:extLst xmlns:a="http://schemas.openxmlformats.org/drawingml/2006/main">
               <a:ext uri="{FF2B5EF4-FFF2-40B4-BE49-F238E27FC236}">
-                <a16:creationId xmlns:a16="http://schemas.microsoft.com/office/drawing/2014/main" id="{FD6B73E2-8EF0-4D5D-98C5-DD2A66444CC5}"/>
+                <a16:creationId xmlns:a16="http://schemas.microsoft.com/office/drawing/2014/main" id="{B3495E2A-9B79-4FB4-82DD-25B2CD17ED35}"/>
               </a:ext>
             </a:extLst>
           </p:cNvPr>
@@ -6488,7 +6488,7 @@
           <p:cNvPr id="9" name="">
             <a:extLst xmlns:a="http://schemas.openxmlformats.org/drawingml/2006/main">
               <a:ext uri="{FF2B5EF4-FFF2-40B4-BE49-F238E27FC236}">
-                <a16:creationId xmlns:a16="http://schemas.microsoft.com/office/drawing/2014/main" id="{98ED4C2F-C44C-4E21-ABA4-7BDE19A3738C}"/>
+                <a16:creationId xmlns:a16="http://schemas.microsoft.com/office/drawing/2014/main" id="{542C14C6-6945-41C9-A26B-60C222F6D0AA}"/>
               </a:ext>
             </a:extLst>
           </p:cNvPr>
@@ -6555,7 +6555,7 @@
           <p:cNvPr id="10" name="">
             <a:extLst xmlns:a="http://schemas.openxmlformats.org/drawingml/2006/main">
               <a:ext uri="{FF2B5EF4-FFF2-40B4-BE49-F238E27FC236}">
-                <a16:creationId xmlns:a16="http://schemas.microsoft.com/office/drawing/2014/main" id="{F2365720-F552-424B-9177-0C0FCDB4665B}"/>
+                <a16:creationId xmlns:a16="http://schemas.microsoft.com/office/drawing/2014/main" id="{47AE765A-BAFA-4875-B77F-00FD8B8735B9}"/>
               </a:ext>
             </a:extLst>
           </p:cNvPr>
@@ -6605,7 +6605,7 @@
           <p:cNvPr id="11" name="">
             <a:extLst xmlns:a="http://schemas.openxmlformats.org/drawingml/2006/main">
               <a:ext uri="{FF2B5EF4-FFF2-40B4-BE49-F238E27FC236}">
-                <a16:creationId xmlns:a16="http://schemas.microsoft.com/office/drawing/2014/main" id="{A41FA7A8-CF08-4A32-92D7-BD36F57DC711}"/>
+                <a16:creationId xmlns:a16="http://schemas.microsoft.com/office/drawing/2014/main" id="{1DE23AA8-F084-4963-95B5-99C7294F11C6}"/>
               </a:ext>
             </a:extLst>
           </p:cNvPr>
@@ -6638,7 +6638,7 @@
           <p:cNvPr id="12" name="">
             <a:extLst xmlns:a="http://schemas.openxmlformats.org/drawingml/2006/main">
               <a:ext uri="{FF2B5EF4-FFF2-40B4-BE49-F238E27FC236}">
-                <a16:creationId xmlns:a16="http://schemas.microsoft.com/office/drawing/2014/main" id="{BABA82F9-AF53-49B5-8CA6-B58480714DCC}"/>
+                <a16:creationId xmlns:a16="http://schemas.microsoft.com/office/drawing/2014/main" id="{939D1C0C-AB19-416E-A2BF-6AF508246A94}"/>
               </a:ext>
             </a:extLst>
           </p:cNvPr>
@@ -6705,7 +6705,7 @@
           <p:cNvPr id="13" name="">
             <a:extLst xmlns:a="http://schemas.openxmlformats.org/drawingml/2006/main">
               <a:ext uri="{FF2B5EF4-FFF2-40B4-BE49-F238E27FC236}">
-                <a16:creationId xmlns:a16="http://schemas.microsoft.com/office/drawing/2014/main" id="{69DC2914-BF28-4543-BA5D-B2D617E8487B}"/>
+                <a16:creationId xmlns:a16="http://schemas.microsoft.com/office/drawing/2014/main" id="{F9CCBDC8-8219-47AE-9926-154F389AF6B7}"/>
               </a:ext>
             </a:extLst>
           </p:cNvPr>
@@ -6755,7 +6755,7 @@
           <p:cNvPr id="14" name="">
             <a:extLst xmlns:a="http://schemas.openxmlformats.org/drawingml/2006/main">
               <a:ext uri="{FF2B5EF4-FFF2-40B4-BE49-F238E27FC236}">
-                <a16:creationId xmlns:a16="http://schemas.microsoft.com/office/drawing/2014/main" id="{7D27B08B-342F-40C0-AB62-791A278DDBAA}"/>
+                <a16:creationId xmlns:a16="http://schemas.microsoft.com/office/drawing/2014/main" id="{29FBF2E5-547F-4AA5-BC1E-AA1B39F8FA8C}"/>
               </a:ext>
             </a:extLst>
           </p:cNvPr>
@@ -6805,7 +6805,7 @@
           <p:cNvPr id="15" name="">
             <a:extLst xmlns:a="http://schemas.openxmlformats.org/drawingml/2006/main">
               <a:ext uri="{FF2B5EF4-FFF2-40B4-BE49-F238E27FC236}">
-                <a16:creationId xmlns:a16="http://schemas.microsoft.com/office/drawing/2014/main" id="{300442A1-0B80-4D98-BB33-0C6751032BCE}"/>
+                <a16:creationId xmlns:a16="http://schemas.microsoft.com/office/drawing/2014/main" id="{B8EAA27D-3129-4B1E-B3EA-981D82782DF1}"/>
               </a:ext>
             </a:extLst>
           </p:cNvPr>
@@ -6855,7 +6855,7 @@
           <p:cNvPr id="16" name="">
             <a:extLst xmlns:a="http://schemas.openxmlformats.org/drawingml/2006/main">
               <a:ext uri="{FF2B5EF4-FFF2-40B4-BE49-F238E27FC236}">
-                <a16:creationId xmlns:a16="http://schemas.microsoft.com/office/drawing/2014/main" id="{2693AF63-2076-4584-A025-216164145C23}"/>
+                <a16:creationId xmlns:a16="http://schemas.microsoft.com/office/drawing/2014/main" id="{98AF2036-5197-42B8-8405-419526E075BA}"/>
               </a:ext>
             </a:extLst>
           </p:cNvPr>
@@ -6888,7 +6888,7 @@
           <p:cNvPr id="17" name="">
             <a:extLst xmlns:a="http://schemas.openxmlformats.org/drawingml/2006/main">
               <a:ext uri="{FF2B5EF4-FFF2-40B4-BE49-F238E27FC236}">
-                <a16:creationId xmlns:a16="http://schemas.microsoft.com/office/drawing/2014/main" id="{284F30C9-074A-46F8-BA79-7E182AB450F9}"/>
+                <a16:creationId xmlns:a16="http://schemas.microsoft.com/office/drawing/2014/main" id="{2DEF691D-FB52-48A2-B24D-9DAC32C927F9}"/>
               </a:ext>
             </a:extLst>
           </p:cNvPr>
@@ -6938,7 +6938,7 @@
           <p:cNvPr id="18" name="">
             <a:extLst xmlns:a="http://schemas.openxmlformats.org/drawingml/2006/main">
               <a:ext uri="{FF2B5EF4-FFF2-40B4-BE49-F238E27FC236}">
-                <a16:creationId xmlns:a16="http://schemas.microsoft.com/office/drawing/2014/main" id="{A9D573F4-7CF0-4970-BAF6-DF549C56A861}"/>
+                <a16:creationId xmlns:a16="http://schemas.microsoft.com/office/drawing/2014/main" id="{5A7786D2-7354-4989-B88C-AB7DEFE61ACA}"/>
               </a:ext>
             </a:extLst>
           </p:cNvPr>
@@ -7095,7 +7095,7 @@
           <p:cNvPr id="19" name="">
             <a:extLst xmlns:a="http://schemas.openxmlformats.org/drawingml/2006/main">
               <a:ext uri="{FF2B5EF4-FFF2-40B4-BE49-F238E27FC236}">
-                <a16:creationId xmlns:a16="http://schemas.microsoft.com/office/drawing/2014/main" id="{0B9B7632-97A8-4AB8-8110-9391D9ADA70D}"/>
+                <a16:creationId xmlns:a16="http://schemas.microsoft.com/office/drawing/2014/main" id="{02CA06F8-2C9F-4DD2-9E3A-A4FBBDFF1AAB}"/>
               </a:ext>
             </a:extLst>
           </p:cNvPr>
@@ -7128,7 +7128,7 @@
           <p:cNvPr id="20" name="">
             <a:extLst xmlns:a="http://schemas.openxmlformats.org/drawingml/2006/main">
               <a:ext uri="{FF2B5EF4-FFF2-40B4-BE49-F238E27FC236}">
-                <a16:creationId xmlns:a16="http://schemas.microsoft.com/office/drawing/2014/main" id="{28EECAFD-D66E-4C86-A5C0-5BD3F99BEEC9}"/>
+                <a16:creationId xmlns:a16="http://schemas.microsoft.com/office/drawing/2014/main" id="{74EF41B7-F90D-4788-AD5D-D5E05E9B02F4}"/>
               </a:ext>
             </a:extLst>
           </p:cNvPr>
@@ -7178,7 +7178,7 @@
           <p:cNvPr id="21" name="">
             <a:extLst xmlns:a="http://schemas.openxmlformats.org/drawingml/2006/main">
               <a:ext uri="{FF2B5EF4-FFF2-40B4-BE49-F238E27FC236}">
-                <a16:creationId xmlns:a16="http://schemas.microsoft.com/office/drawing/2014/main" id="{A51EA395-2260-4598-85E7-C2BAB11F6D03}"/>
+                <a16:creationId xmlns:a16="http://schemas.microsoft.com/office/drawing/2014/main" id="{C7959552-C2C8-4784-94CA-A76CEB5D0F62}"/>
               </a:ext>
             </a:extLst>
           </p:cNvPr>
@@ -7211,7 +7211,7 @@
           <p:cNvPr id="22" name="">
             <a:extLst xmlns:a="http://schemas.openxmlformats.org/drawingml/2006/main">
               <a:ext uri="{FF2B5EF4-FFF2-40B4-BE49-F238E27FC236}">
-                <a16:creationId xmlns:a16="http://schemas.microsoft.com/office/drawing/2014/main" id="{A5A75673-9D78-49E4-9A27-C6FDCCF6DCAE}"/>
+                <a16:creationId xmlns:a16="http://schemas.microsoft.com/office/drawing/2014/main" id="{B76AF372-DD12-49CB-B4CC-249CD3BB3AF5}"/>
               </a:ext>
             </a:extLst>
           </p:cNvPr>
@@ -7261,7 +7261,7 @@
           <p:cNvPr id="23" name="">
             <a:extLst xmlns:a="http://schemas.openxmlformats.org/drawingml/2006/main">
               <a:ext uri="{FF2B5EF4-FFF2-40B4-BE49-F238E27FC236}">
-                <a16:creationId xmlns:a16="http://schemas.microsoft.com/office/drawing/2014/main" id="{5608944E-F6A6-4BBB-B8A5-27BFAEEF026F}"/>
+                <a16:creationId xmlns:a16="http://schemas.microsoft.com/office/drawing/2014/main" id="{43A27172-EB13-480C-9C1E-1EFC413A632A}"/>
               </a:ext>
             </a:extLst>
           </p:cNvPr>
@@ -7311,7 +7311,7 @@
           <p:cNvPr id="24" name="">
             <a:extLst xmlns:a="http://schemas.openxmlformats.org/drawingml/2006/main">
               <a:ext uri="{FF2B5EF4-FFF2-40B4-BE49-F238E27FC236}">
-                <a16:creationId xmlns:a16="http://schemas.microsoft.com/office/drawing/2014/main" id="{95462C82-BD19-455E-A36E-A1225EB08121}"/>
+                <a16:creationId xmlns:a16="http://schemas.microsoft.com/office/drawing/2014/main" id="{BD358400-AADA-4997-9CC8-41624D57FC9E}"/>
               </a:ext>
             </a:extLst>
           </p:cNvPr>
@@ -7344,7 +7344,7 @@
           <p:cNvPr id="25" name="">
             <a:extLst xmlns:a="http://schemas.openxmlformats.org/drawingml/2006/main">
               <a:ext uri="{FF2B5EF4-FFF2-40B4-BE49-F238E27FC236}">
-                <a16:creationId xmlns:a16="http://schemas.microsoft.com/office/drawing/2014/main" id="{4FF49D44-38AA-4148-A006-5F95ED184CFE}"/>
+                <a16:creationId xmlns:a16="http://schemas.microsoft.com/office/drawing/2014/main" id="{6A9B51F2-5EF6-4055-88B7-B30A6D53A547}"/>
               </a:ext>
             </a:extLst>
           </p:cNvPr>
@@ -7394,7 +7394,7 @@
           <p:cNvPr id="26" name="">
             <a:extLst xmlns:a="http://schemas.openxmlformats.org/drawingml/2006/main">
               <a:ext uri="{FF2B5EF4-FFF2-40B4-BE49-F238E27FC236}">
-                <a16:creationId xmlns:a16="http://schemas.microsoft.com/office/drawing/2014/main" id="{45BF8A7D-A628-49F7-8E14-88CD201DFDA0}"/>
+                <a16:creationId xmlns:a16="http://schemas.microsoft.com/office/drawing/2014/main" id="{8D6683AB-C901-42EF-80BD-19671F984B15}"/>
               </a:ext>
             </a:extLst>
           </p:cNvPr>
@@ -7444,7 +7444,7 @@
           <p:cNvPr id="27" name="">
             <a:extLst xmlns:a="http://schemas.openxmlformats.org/drawingml/2006/main">
               <a:ext uri="{FF2B5EF4-FFF2-40B4-BE49-F238E27FC236}">
-                <a16:creationId xmlns:a16="http://schemas.microsoft.com/office/drawing/2014/main" id="{517D11A9-919D-4310-9992-2D9AE05D0E32}"/>
+                <a16:creationId xmlns:a16="http://schemas.microsoft.com/office/drawing/2014/main" id="{7784F3D4-EB73-4DF9-8099-1C267D9115B1}"/>
               </a:ext>
             </a:extLst>
           </p:cNvPr>
@@ -7477,7 +7477,7 @@
           <p:cNvPr id="28" name="">
             <a:extLst xmlns:a="http://schemas.openxmlformats.org/drawingml/2006/main">
               <a:ext uri="{FF2B5EF4-FFF2-40B4-BE49-F238E27FC236}">
-                <a16:creationId xmlns:a16="http://schemas.microsoft.com/office/drawing/2014/main" id="{5B05DD31-73FD-4995-9A94-BF38948D9BC6}"/>
+                <a16:creationId xmlns:a16="http://schemas.microsoft.com/office/drawing/2014/main" id="{1AE55F41-CEE5-4AFF-BC42-211330048673}"/>
               </a:ext>
             </a:extLst>
           </p:cNvPr>
@@ -7527,7 +7527,7 @@
           <p:cNvPr id="29" name="">
             <a:extLst xmlns:a="http://schemas.openxmlformats.org/drawingml/2006/main">
               <a:ext uri="{FF2B5EF4-FFF2-40B4-BE49-F238E27FC236}">
-                <a16:creationId xmlns:a16="http://schemas.microsoft.com/office/drawing/2014/main" id="{C15AA487-BFD8-4709-980B-9609D7A91B80}"/>
+                <a16:creationId xmlns:a16="http://schemas.microsoft.com/office/drawing/2014/main" id="{DFE388A6-6FE5-4DEA-9796-ABA2965557DF}"/>
               </a:ext>
             </a:extLst>
           </p:cNvPr>
@@ -7575,7 +7575,7 @@
     </p:spTree>
     <p:extLst>
       <p:ext uri="{BB962C8B-B14F-4D97-AF65-F5344CB8AC3E}">
-        <p14:creationId xmlns:p14="http://schemas.microsoft.com/office/powerpoint/2010/main" val="699301837"/>
+        <p14:creationId xmlns:p14="http://schemas.microsoft.com/office/powerpoint/2010/main" val="1351782843"/>
       </p:ext>
     </p:extLst>
   </p:cSld>
@@ -7606,7 +7606,7 @@
           <p:cNvPr id="31" name="">
             <a:extLst xmlns:a="http://schemas.openxmlformats.org/drawingml/2006/main">
               <a:ext uri="{FF2B5EF4-FFF2-40B4-BE49-F238E27FC236}">
-                <a16:creationId xmlns:a16="http://schemas.microsoft.com/office/drawing/2014/main" id="{020642BB-A597-440F-BEEE-8FBD6C12ABF0}"/>
+                <a16:creationId xmlns:a16="http://schemas.microsoft.com/office/drawing/2014/main" id="{4C8A0A76-F8EA-4A70-A391-AD6937679882}"/>
               </a:ext>
             </a:extLst>
           </p:cNvPr>
@@ -7656,7 +7656,7 @@
           <p:cNvPr id="2" name="">
             <a:extLst xmlns:a="http://schemas.openxmlformats.org/drawingml/2006/main">
               <a:ext uri="{FF2B5EF4-FFF2-40B4-BE49-F238E27FC236}">
-                <a16:creationId xmlns:a16="http://schemas.microsoft.com/office/drawing/2014/main" id="{5E1D7A14-5A28-483D-B490-F2FAF60D788D}"/>
+                <a16:creationId xmlns:a16="http://schemas.microsoft.com/office/drawing/2014/main" id="{A24191F3-63BA-404D-84B3-63F7102DD02E}"/>
               </a:ext>
             </a:extLst>
           </p:cNvPr>
@@ -7706,7 +7706,7 @@
           <p:cNvPr id="3" name="">
             <a:extLst xmlns:a="http://schemas.openxmlformats.org/drawingml/2006/main">
               <a:ext uri="{FF2B5EF4-FFF2-40B4-BE49-F238E27FC236}">
-                <a16:creationId xmlns:a16="http://schemas.microsoft.com/office/drawing/2014/main" id="{7057AF63-BCA7-4458-9EEE-2978B4C070FF}"/>
+                <a16:creationId xmlns:a16="http://schemas.microsoft.com/office/drawing/2014/main" id="{58A1D50D-9F65-4C35-8274-C2D12F72D195}"/>
               </a:ext>
             </a:extLst>
           </p:cNvPr>
@@ -7739,7 +7739,7 @@
           <p:cNvPr id="4" name="">
             <a:extLst xmlns:a="http://schemas.openxmlformats.org/drawingml/2006/main">
               <a:ext uri="{FF2B5EF4-FFF2-40B4-BE49-F238E27FC236}">
-                <a16:creationId xmlns:a16="http://schemas.microsoft.com/office/drawing/2014/main" id="{E908A46E-B9AC-4541-963A-443F1121FBA5}"/>
+                <a16:creationId xmlns:a16="http://schemas.microsoft.com/office/drawing/2014/main" id="{F69DEFBD-FBCF-48DB-B80C-2F96204E50A1}"/>
               </a:ext>
             </a:extLst>
           </p:cNvPr>
@@ -7789,7 +7789,7 @@
           <p:cNvPr id="5" name="">
             <a:extLst xmlns:a="http://schemas.openxmlformats.org/drawingml/2006/main">
               <a:ext uri="{FF2B5EF4-FFF2-40B4-BE49-F238E27FC236}">
-                <a16:creationId xmlns:a16="http://schemas.microsoft.com/office/drawing/2014/main" id="{2008AFE4-1F73-47AE-9423-C6CC3F94D040}"/>
+                <a16:creationId xmlns:a16="http://schemas.microsoft.com/office/drawing/2014/main" id="{F5E8D959-5496-4668-87BA-2D758DA0A615}"/>
               </a:ext>
             </a:extLst>
           </p:cNvPr>
@@ -7822,7 +7822,7 @@
           <p:cNvPr id="6" name="">
             <a:extLst xmlns:a="http://schemas.openxmlformats.org/drawingml/2006/main">
               <a:ext uri="{FF2B5EF4-FFF2-40B4-BE49-F238E27FC236}">
-                <a16:creationId xmlns:a16="http://schemas.microsoft.com/office/drawing/2014/main" id="{60B111DD-3502-41AA-80D7-561CB4C95E4F}"/>
+                <a16:creationId xmlns:a16="http://schemas.microsoft.com/office/drawing/2014/main" id="{11376895-431B-4A03-B3B7-E1E51774B1C1}"/>
               </a:ext>
             </a:extLst>
           </p:cNvPr>
@@ -7872,7 +7872,7 @@
           <p:cNvPr id="7" name="">
             <a:extLst xmlns:a="http://schemas.openxmlformats.org/drawingml/2006/main">
               <a:ext uri="{FF2B5EF4-FFF2-40B4-BE49-F238E27FC236}">
-                <a16:creationId xmlns:a16="http://schemas.microsoft.com/office/drawing/2014/main" id="{CBCFD3CA-17A5-49C7-9EBD-2E409DD61809}"/>
+                <a16:creationId xmlns:a16="http://schemas.microsoft.com/office/drawing/2014/main" id="{A5DF84B3-9234-46CD-B1EE-DF52706AEB28}"/>
               </a:ext>
             </a:extLst>
           </p:cNvPr>
@@ -8046,7 +8046,7 @@
           <p:cNvPr id="8" name="">
             <a:extLst xmlns:a="http://schemas.openxmlformats.org/drawingml/2006/main">
               <a:ext uri="{FF2B5EF4-FFF2-40B4-BE49-F238E27FC236}">
-                <a16:creationId xmlns:a16="http://schemas.microsoft.com/office/drawing/2014/main" id="{A751A598-6D2B-4F4E-9921-C41DACF6A064}"/>
+                <a16:creationId xmlns:a16="http://schemas.microsoft.com/office/drawing/2014/main" id="{F7E91A0A-6B4E-495B-8EB6-F3478EE9D42E}"/>
               </a:ext>
             </a:extLst>
           </p:cNvPr>
@@ -8096,7 +8096,7 @@
           <p:cNvPr id="9" name="">
             <a:extLst xmlns:a="http://schemas.openxmlformats.org/drawingml/2006/main">
               <a:ext uri="{FF2B5EF4-FFF2-40B4-BE49-F238E27FC236}">
-                <a16:creationId xmlns:a16="http://schemas.microsoft.com/office/drawing/2014/main" id="{6C7EA2A9-E882-4304-880E-4CA271A3C801}"/>
+                <a16:creationId xmlns:a16="http://schemas.microsoft.com/office/drawing/2014/main" id="{8908248B-5188-4125-80CE-A62A25D690D1}"/>
               </a:ext>
             </a:extLst>
           </p:cNvPr>
@@ -8146,7 +8146,7 @@
           <p:cNvPr id="10" name="">
             <a:extLst xmlns:a="http://schemas.openxmlformats.org/drawingml/2006/main">
               <a:ext uri="{FF2B5EF4-FFF2-40B4-BE49-F238E27FC236}">
-                <a16:creationId xmlns:a16="http://schemas.microsoft.com/office/drawing/2014/main" id="{FD312DCB-BCCA-4B15-AE1E-FE6BCC31EE38}"/>
+                <a16:creationId xmlns:a16="http://schemas.microsoft.com/office/drawing/2014/main" id="{6676C83E-F255-4C24-B530-331337EC4BE3}"/>
               </a:ext>
             </a:extLst>
           </p:cNvPr>
@@ -8196,7 +8196,7 @@
           <p:cNvPr id="11" name="">
             <a:extLst xmlns:a="http://schemas.openxmlformats.org/drawingml/2006/main">
               <a:ext uri="{FF2B5EF4-FFF2-40B4-BE49-F238E27FC236}">
-                <a16:creationId xmlns:a16="http://schemas.microsoft.com/office/drawing/2014/main" id="{C6EDB74C-D73E-49DF-844D-A2E594714E07}"/>
+                <a16:creationId xmlns:a16="http://schemas.microsoft.com/office/drawing/2014/main" id="{F26B235F-46D2-462C-86B7-D2097874C491}"/>
               </a:ext>
             </a:extLst>
           </p:cNvPr>
@@ -8246,7 +8246,7 @@
           <p:cNvPr id="12" name="">
             <a:extLst xmlns:a="http://schemas.openxmlformats.org/drawingml/2006/main">
               <a:ext uri="{FF2B5EF4-FFF2-40B4-BE49-F238E27FC236}">
-                <a16:creationId xmlns:a16="http://schemas.microsoft.com/office/drawing/2014/main" id="{B185EF76-B7F9-4226-9BC2-CC5B820A4E1B}"/>
+                <a16:creationId xmlns:a16="http://schemas.microsoft.com/office/drawing/2014/main" id="{90FE1D92-B162-4847-983C-190C56E56C39}"/>
               </a:ext>
             </a:extLst>
           </p:cNvPr>
@@ -8296,7 +8296,7 @@
           <p:cNvPr id="13" name="">
             <a:extLst xmlns:a="http://schemas.openxmlformats.org/drawingml/2006/main">
               <a:ext uri="{FF2B5EF4-FFF2-40B4-BE49-F238E27FC236}">
-                <a16:creationId xmlns:a16="http://schemas.microsoft.com/office/drawing/2014/main" id="{972818CC-091B-4D89-9850-43E07EC18E6B}"/>
+                <a16:creationId xmlns:a16="http://schemas.microsoft.com/office/drawing/2014/main" id="{EF90495C-6B08-43A7-A81E-9FCDEC6B9950}"/>
               </a:ext>
             </a:extLst>
           </p:cNvPr>
@@ -8346,7 +8346,7 @@
           <p:cNvPr id="14" name="">
             <a:extLst xmlns:a="http://schemas.openxmlformats.org/drawingml/2006/main">
               <a:ext uri="{FF2B5EF4-FFF2-40B4-BE49-F238E27FC236}">
-                <a16:creationId xmlns:a16="http://schemas.microsoft.com/office/drawing/2014/main" id="{3546FD59-0593-4350-8621-9C8796FF613A}"/>
+                <a16:creationId xmlns:a16="http://schemas.microsoft.com/office/drawing/2014/main" id="{C947520D-0E0C-48F0-BEE6-372E931C136D}"/>
               </a:ext>
             </a:extLst>
           </p:cNvPr>
@@ -8396,7 +8396,7 @@
           <p:cNvPr id="15" name="">
             <a:extLst xmlns:a="http://schemas.openxmlformats.org/drawingml/2006/main">
               <a:ext uri="{FF2B5EF4-FFF2-40B4-BE49-F238E27FC236}">
-                <a16:creationId xmlns:a16="http://schemas.microsoft.com/office/drawing/2014/main" id="{B779F29A-01FA-48CE-9A40-9AFDE153100F}"/>
+                <a16:creationId xmlns:a16="http://schemas.microsoft.com/office/drawing/2014/main" id="{086D1A86-BA67-47AE-8CF8-2AFA25235BCE}"/>
               </a:ext>
             </a:extLst>
           </p:cNvPr>
@@ -8446,7 +8446,7 @@
           <p:cNvPr id="16" name="">
             <a:extLst xmlns:a="http://schemas.openxmlformats.org/drawingml/2006/main">
               <a:ext uri="{FF2B5EF4-FFF2-40B4-BE49-F238E27FC236}">
-                <a16:creationId xmlns:a16="http://schemas.microsoft.com/office/drawing/2014/main" id="{EC22BA35-CA9E-4B7F-AEDA-6C3042CC384B}"/>
+                <a16:creationId xmlns:a16="http://schemas.microsoft.com/office/drawing/2014/main" id="{C9DBCB0A-E34F-4BDE-9738-2329B1620E37}"/>
               </a:ext>
             </a:extLst>
           </p:cNvPr>
@@ -8479,7 +8479,7 @@
           <p:cNvPr id="17" name="">
             <a:extLst xmlns:a="http://schemas.openxmlformats.org/drawingml/2006/main">
               <a:ext uri="{FF2B5EF4-FFF2-40B4-BE49-F238E27FC236}">
-                <a16:creationId xmlns:a16="http://schemas.microsoft.com/office/drawing/2014/main" id="{9958C4F9-2D04-4EA9-B4F6-46150D8E6420}"/>
+                <a16:creationId xmlns:a16="http://schemas.microsoft.com/office/drawing/2014/main" id="{82A2EDDC-4BFF-40B4-A1CC-C5A81EB188FB}"/>
               </a:ext>
             </a:extLst>
           </p:cNvPr>
@@ -8529,7 +8529,7 @@
           <p:cNvPr id="18" name="">
             <a:extLst xmlns:a="http://schemas.openxmlformats.org/drawingml/2006/main">
               <a:ext uri="{FF2B5EF4-FFF2-40B4-BE49-F238E27FC236}">
-                <a16:creationId xmlns:a16="http://schemas.microsoft.com/office/drawing/2014/main" id="{1F6E303B-4B4D-4397-89A6-AA134CDA709B}"/>
+                <a16:creationId xmlns:a16="http://schemas.microsoft.com/office/drawing/2014/main" id="{7A94B314-A91B-4802-8412-88D273F792EE}"/>
               </a:ext>
             </a:extLst>
           </p:cNvPr>
@@ -8579,7 +8579,7 @@
           <p:cNvPr id="19" name="">
             <a:extLst xmlns:a="http://schemas.openxmlformats.org/drawingml/2006/main">
               <a:ext uri="{FF2B5EF4-FFF2-40B4-BE49-F238E27FC236}">
-                <a16:creationId xmlns:a16="http://schemas.microsoft.com/office/drawing/2014/main" id="{B1852AF7-2850-4947-82D8-A8FB9E101A1E}"/>
+                <a16:creationId xmlns:a16="http://schemas.microsoft.com/office/drawing/2014/main" id="{3DD7ED1A-B32A-471D-9455-FCD0C7398873}"/>
               </a:ext>
             </a:extLst>
           </p:cNvPr>
@@ -8612,7 +8612,7 @@
           <p:cNvPr id="20" name="">
             <a:extLst xmlns:a="http://schemas.openxmlformats.org/drawingml/2006/main">
               <a:ext uri="{FF2B5EF4-FFF2-40B4-BE49-F238E27FC236}">
-                <a16:creationId xmlns:a16="http://schemas.microsoft.com/office/drawing/2014/main" id="{680CC645-A963-46AD-AB69-3A5115341D6B}"/>
+                <a16:creationId xmlns:a16="http://schemas.microsoft.com/office/drawing/2014/main" id="{AAF231A6-C30A-4617-84FB-CB783CCD90D4}"/>
               </a:ext>
             </a:extLst>
           </p:cNvPr>
@@ -8662,7 +8662,7 @@
           <p:cNvPr id="21" name="">
             <a:extLst xmlns:a="http://schemas.openxmlformats.org/drawingml/2006/main">
               <a:ext uri="{FF2B5EF4-FFF2-40B4-BE49-F238E27FC236}">
-                <a16:creationId xmlns:a16="http://schemas.microsoft.com/office/drawing/2014/main" id="{0D260BA8-F24C-4B93-BD8C-3F982911E317}"/>
+                <a16:creationId xmlns:a16="http://schemas.microsoft.com/office/drawing/2014/main" id="{AB13D523-543E-4353-A56F-D1EA7A80AF10}"/>
               </a:ext>
             </a:extLst>
           </p:cNvPr>
@@ -8712,7 +8712,7 @@
           <p:cNvPr id="22" name="">
             <a:extLst xmlns:a="http://schemas.openxmlformats.org/drawingml/2006/main">
               <a:ext uri="{FF2B5EF4-FFF2-40B4-BE49-F238E27FC236}">
-                <a16:creationId xmlns:a16="http://schemas.microsoft.com/office/drawing/2014/main" id="{E0E4D56B-96F2-40C7-B333-F2167218C959}"/>
+                <a16:creationId xmlns:a16="http://schemas.microsoft.com/office/drawing/2014/main" id="{E7973ED8-15A5-417D-8EB7-A537961CE63E}"/>
               </a:ext>
             </a:extLst>
           </p:cNvPr>
@@ -8745,7 +8745,7 @@
           <p:cNvPr id="23" name="">
             <a:extLst xmlns:a="http://schemas.openxmlformats.org/drawingml/2006/main">
               <a:ext uri="{FF2B5EF4-FFF2-40B4-BE49-F238E27FC236}">
-                <a16:creationId xmlns:a16="http://schemas.microsoft.com/office/drawing/2014/main" id="{92BBC386-F3F8-496B-A989-4F59FD3A553B}"/>
+                <a16:creationId xmlns:a16="http://schemas.microsoft.com/office/drawing/2014/main" id="{C22148F6-7488-445F-A5F8-77AF534F3FB0}"/>
               </a:ext>
             </a:extLst>
           </p:cNvPr>
@@ -8795,7 +8795,7 @@
           <p:cNvPr id="24" name="">
             <a:extLst xmlns:a="http://schemas.openxmlformats.org/drawingml/2006/main">
               <a:ext uri="{FF2B5EF4-FFF2-40B4-BE49-F238E27FC236}">
-                <a16:creationId xmlns:a16="http://schemas.microsoft.com/office/drawing/2014/main" id="{312E0DB1-EB57-4A02-B69D-4BAAFE3FBB0A}"/>
+                <a16:creationId xmlns:a16="http://schemas.microsoft.com/office/drawing/2014/main" id="{14E2AACE-0446-45E1-A78F-B4C7208763E1}"/>
               </a:ext>
             </a:extLst>
           </p:cNvPr>
@@ -8845,7 +8845,7 @@
           <p:cNvPr id="25" name="">
             <a:extLst xmlns:a="http://schemas.openxmlformats.org/drawingml/2006/main">
               <a:ext uri="{FF2B5EF4-FFF2-40B4-BE49-F238E27FC236}">
-                <a16:creationId xmlns:a16="http://schemas.microsoft.com/office/drawing/2014/main" id="{58B1499D-D976-40EB-BA04-01E92E7D373F}"/>
+                <a16:creationId xmlns:a16="http://schemas.microsoft.com/office/drawing/2014/main" id="{EC8D9F97-6570-44B6-9A08-4E890835FAC6}"/>
               </a:ext>
             </a:extLst>
           </p:cNvPr>
@@ -8878,7 +8878,7 @@
           <p:cNvPr id="26" name="">
             <a:extLst xmlns:a="http://schemas.openxmlformats.org/drawingml/2006/main">
               <a:ext uri="{FF2B5EF4-FFF2-40B4-BE49-F238E27FC236}">
-                <a16:creationId xmlns:a16="http://schemas.microsoft.com/office/drawing/2014/main" id="{C623A577-9A5B-41B8-A66F-109C12D48B41}"/>
+                <a16:creationId xmlns:a16="http://schemas.microsoft.com/office/drawing/2014/main" id="{B1FAFF51-1CFF-4980-A4BB-87C5B854F175}"/>
               </a:ext>
             </a:extLst>
           </p:cNvPr>
@@ -8928,7 +8928,7 @@
           <p:cNvPr id="27" name="">
             <a:extLst xmlns:a="http://schemas.openxmlformats.org/drawingml/2006/main">
               <a:ext uri="{FF2B5EF4-FFF2-40B4-BE49-F238E27FC236}">
-                <a16:creationId xmlns:a16="http://schemas.microsoft.com/office/drawing/2014/main" id="{228EFC92-B121-4B36-A4B4-D2173EB96283}"/>
+                <a16:creationId xmlns:a16="http://schemas.microsoft.com/office/drawing/2014/main" id="{EE47158E-3557-426C-938D-B8F03E85D7AC}"/>
               </a:ext>
             </a:extLst>
           </p:cNvPr>
@@ -8978,7 +8978,7 @@
           <p:cNvPr id="28" name="">
             <a:extLst xmlns:a="http://schemas.openxmlformats.org/drawingml/2006/main">
               <a:ext uri="{FF2B5EF4-FFF2-40B4-BE49-F238E27FC236}">
-                <a16:creationId xmlns:a16="http://schemas.microsoft.com/office/drawing/2014/main" id="{725F75AD-C6AA-48B8-8C76-AC4906AFB513}"/>
+                <a16:creationId xmlns:a16="http://schemas.microsoft.com/office/drawing/2014/main" id="{8DC3ECBB-0E7E-4BCA-AF8A-75A26BA524CB}"/>
               </a:ext>
             </a:extLst>
           </p:cNvPr>
@@ -9011,7 +9011,7 @@
           <p:cNvPr id="29" name="">
             <a:extLst xmlns:a="http://schemas.openxmlformats.org/drawingml/2006/main">
               <a:ext uri="{FF2B5EF4-FFF2-40B4-BE49-F238E27FC236}">
-                <a16:creationId xmlns:a16="http://schemas.microsoft.com/office/drawing/2014/main" id="{3DAC8090-C3CD-4DDF-9E99-3401C8071B4B}"/>
+                <a16:creationId xmlns:a16="http://schemas.microsoft.com/office/drawing/2014/main" id="{A2B69390-86CB-41F8-808D-F8358A009513}"/>
               </a:ext>
             </a:extLst>
           </p:cNvPr>
@@ -9061,7 +9061,7 @@
           <p:cNvPr id="30" name="">
             <a:extLst xmlns:a="http://schemas.openxmlformats.org/drawingml/2006/main">
               <a:ext uri="{FF2B5EF4-FFF2-40B4-BE49-F238E27FC236}">
-                <a16:creationId xmlns:a16="http://schemas.microsoft.com/office/drawing/2014/main" id="{7A34D56A-4364-4632-83AF-B34FABFC34B4}"/>
+                <a16:creationId xmlns:a16="http://schemas.microsoft.com/office/drawing/2014/main" id="{E4470727-DB03-4997-A98C-F12C91B49972}"/>
               </a:ext>
             </a:extLst>
           </p:cNvPr>
@@ -9109,7 +9109,7 @@
     </p:spTree>
     <p:extLst>
       <p:ext uri="{BB962C8B-B14F-4D97-AF65-F5344CB8AC3E}">
-        <p14:creationId xmlns:p14="http://schemas.microsoft.com/office/powerpoint/2010/main" val="1826663872"/>
+        <p14:creationId xmlns:p14="http://schemas.microsoft.com/office/powerpoint/2010/main" val="460966684"/>
       </p:ext>
     </p:extLst>
   </p:cSld>
@@ -9140,7 +9140,7 @@
           <p:cNvPr id="13" name="">
             <a:extLst xmlns:a="http://schemas.openxmlformats.org/drawingml/2006/main">
               <a:ext uri="{FF2B5EF4-FFF2-40B4-BE49-F238E27FC236}">
-                <a16:creationId xmlns:a16="http://schemas.microsoft.com/office/drawing/2014/main" id="{9CDCAACD-767E-4C1A-9BF2-53A44987C90D}"/>
+                <a16:creationId xmlns:a16="http://schemas.microsoft.com/office/drawing/2014/main" id="{663A95CB-27C1-4A75-A800-41A35CF31B82}"/>
               </a:ext>
             </a:extLst>
           </p:cNvPr>
@@ -9190,7 +9190,7 @@
           <p:cNvPr id="2" name="">
             <a:extLst xmlns:a="http://schemas.openxmlformats.org/drawingml/2006/main">
               <a:ext uri="{FF2B5EF4-FFF2-40B4-BE49-F238E27FC236}">
-                <a16:creationId xmlns:a16="http://schemas.microsoft.com/office/drawing/2014/main" id="{4D02D76E-8F18-496A-B6E9-A3133FABD60D}"/>
+                <a16:creationId xmlns:a16="http://schemas.microsoft.com/office/drawing/2014/main" id="{F21FB83D-6B78-4E61-91DF-E5DFC77C7030}"/>
               </a:ext>
             </a:extLst>
           </p:cNvPr>
@@ -9240,7 +9240,7 @@
           <p:cNvPr id="3" name="">
             <a:extLst xmlns:a="http://schemas.openxmlformats.org/drawingml/2006/main">
               <a:ext uri="{FF2B5EF4-FFF2-40B4-BE49-F238E27FC236}">
-                <a16:creationId xmlns:a16="http://schemas.microsoft.com/office/drawing/2014/main" id="{C407ACF0-C904-41DF-B1AE-A4E2E20C19F4}"/>
+                <a16:creationId xmlns:a16="http://schemas.microsoft.com/office/drawing/2014/main" id="{AA1BAE1A-2B57-4397-9086-C51A55461737}"/>
               </a:ext>
             </a:extLst>
           </p:cNvPr>
@@ -9273,7 +9273,7 @@
           <p:cNvPr id="4" name="">
             <a:extLst xmlns:a="http://schemas.openxmlformats.org/drawingml/2006/main">
               <a:ext uri="{FF2B5EF4-FFF2-40B4-BE49-F238E27FC236}">
-                <a16:creationId xmlns:a16="http://schemas.microsoft.com/office/drawing/2014/main" id="{9D17A686-6AAA-4A3C-8373-EFE583B4D2BB}"/>
+                <a16:creationId xmlns:a16="http://schemas.microsoft.com/office/drawing/2014/main" id="{EB838340-BEDC-4C7C-978D-069498103DA1}"/>
               </a:ext>
             </a:extLst>
           </p:cNvPr>
@@ -9323,7 +9323,7 @@
           <p:cNvPr id="5" name="">
             <a:extLst xmlns:a="http://schemas.openxmlformats.org/drawingml/2006/main">
               <a:ext uri="{FF2B5EF4-FFF2-40B4-BE49-F238E27FC236}">
-                <a16:creationId xmlns:a16="http://schemas.microsoft.com/office/drawing/2014/main" id="{F6CD19B6-7561-4EE2-981C-7AC0740F8A0C}"/>
+                <a16:creationId xmlns:a16="http://schemas.microsoft.com/office/drawing/2014/main" id="{B757A888-FAA1-492F-B2F4-F35BB95683B3}"/>
               </a:ext>
             </a:extLst>
           </p:cNvPr>
@@ -9356,7 +9356,7 @@
           <p:cNvPr id="6" name="">
             <a:extLst xmlns:a="http://schemas.openxmlformats.org/drawingml/2006/main">
               <a:ext uri="{FF2B5EF4-FFF2-40B4-BE49-F238E27FC236}">
-                <a16:creationId xmlns:a16="http://schemas.microsoft.com/office/drawing/2014/main" id="{BA1A028D-821D-4DE3-96B6-F7EDECA77ECC}"/>
+                <a16:creationId xmlns:a16="http://schemas.microsoft.com/office/drawing/2014/main" id="{E3B9D8A8-5AF9-4528-BA37-AF9AFEC9916E}"/>
               </a:ext>
             </a:extLst>
           </p:cNvPr>
@@ -9406,7 +9406,7 @@
           <p:cNvPr id="7" name="">
             <a:extLst xmlns:a="http://schemas.openxmlformats.org/drawingml/2006/main">
               <a:ext uri="{FF2B5EF4-FFF2-40B4-BE49-F238E27FC236}">
-                <a16:creationId xmlns:a16="http://schemas.microsoft.com/office/drawing/2014/main" id="{88498A10-2FB0-44FE-B3F6-2D9C29F88A4A}"/>
+                <a16:creationId xmlns:a16="http://schemas.microsoft.com/office/drawing/2014/main" id="{C56B5DA3-C112-41E3-BD00-26004DE7626D}"/>
               </a:ext>
             </a:extLst>
           </p:cNvPr>
@@ -9607,7 +9607,7 @@
           <p:cNvPr id="8" name="">
             <a:extLst xmlns:a="http://schemas.openxmlformats.org/drawingml/2006/main">
               <a:ext uri="{FF2B5EF4-FFF2-40B4-BE49-F238E27FC236}">
-                <a16:creationId xmlns:a16="http://schemas.microsoft.com/office/drawing/2014/main" id="{80C2FB23-9C04-4710-9DAF-D33636EFF0D1}"/>
+                <a16:creationId xmlns:a16="http://schemas.microsoft.com/office/drawing/2014/main" id="{43A878F7-93A8-48AC-B07E-AF40B4CC9300}"/>
               </a:ext>
             </a:extLst>
           </p:cNvPr>
@@ -9640,7 +9640,7 @@
           <p:cNvPr id="9" name="">
             <a:extLst xmlns:a="http://schemas.openxmlformats.org/drawingml/2006/main">
               <a:ext uri="{FF2B5EF4-FFF2-40B4-BE49-F238E27FC236}">
-                <a16:creationId xmlns:a16="http://schemas.microsoft.com/office/drawing/2014/main" id="{DBE58F3F-92AB-4E8C-A1E1-72E8D72CD325}"/>
+                <a16:creationId xmlns:a16="http://schemas.microsoft.com/office/drawing/2014/main" id="{2AD26A8F-7733-4C03-89C4-AC7FAC400FDD}"/>
               </a:ext>
             </a:extLst>
           </p:cNvPr>
@@ -9690,7 +9690,7 @@
           <p:cNvPr id="10" name="">
             <a:extLst xmlns:a="http://schemas.openxmlformats.org/drawingml/2006/main">
               <a:ext uri="{FF2B5EF4-FFF2-40B4-BE49-F238E27FC236}">
-                <a16:creationId xmlns:a16="http://schemas.microsoft.com/office/drawing/2014/main" id="{97730AEE-C825-409A-A531-5A96D48AFB8C}"/>
+                <a16:creationId xmlns:a16="http://schemas.microsoft.com/office/drawing/2014/main" id="{9A709584-EB33-4893-8A5B-B3C057EB0919}"/>
               </a:ext>
             </a:extLst>
           </p:cNvPr>
@@ -9949,7 +9949,7 @@
           <p:cNvPr id="11" name="">
             <a:extLst xmlns:a="http://schemas.openxmlformats.org/drawingml/2006/main">
               <a:ext uri="{FF2B5EF4-FFF2-40B4-BE49-F238E27FC236}">
-                <a16:creationId xmlns:a16="http://schemas.microsoft.com/office/drawing/2014/main" id="{D2BDA627-7572-48EA-9700-52AB47769814}"/>
+                <a16:creationId xmlns:a16="http://schemas.microsoft.com/office/drawing/2014/main" id="{F0C009B0-E749-4564-AA51-2B9164CA5AA4}"/>
               </a:ext>
             </a:extLst>
           </p:cNvPr>
@@ -9999,7 +9999,7 @@
           <p:cNvPr id="12" name="">
             <a:extLst xmlns:a="http://schemas.openxmlformats.org/drawingml/2006/main">
               <a:ext uri="{FF2B5EF4-FFF2-40B4-BE49-F238E27FC236}">
-                <a16:creationId xmlns:a16="http://schemas.microsoft.com/office/drawing/2014/main" id="{DDC3F581-1F64-484B-905C-0BE1493AE708}"/>
+                <a16:creationId xmlns:a16="http://schemas.microsoft.com/office/drawing/2014/main" id="{3C45766C-9CDE-487E-8A53-CCFF0F5976CD}"/>
               </a:ext>
             </a:extLst>
           </p:cNvPr>
@@ -10047,7 +10047,7 @@
     </p:spTree>
     <p:extLst>
       <p:ext uri="{BB962C8B-B14F-4D97-AF65-F5344CB8AC3E}">
-        <p14:creationId xmlns:p14="http://schemas.microsoft.com/office/powerpoint/2010/main" val="1817260625"/>
+        <p14:creationId xmlns:p14="http://schemas.microsoft.com/office/powerpoint/2010/main" val="2121332330"/>
       </p:ext>
     </p:extLst>
   </p:cSld>
@@ -10078,7 +10078,7 @@
           <p:cNvPr id="27" name="">
             <a:extLst xmlns:a="http://schemas.openxmlformats.org/drawingml/2006/main">
               <a:ext uri="{FF2B5EF4-FFF2-40B4-BE49-F238E27FC236}">
-                <a16:creationId xmlns:a16="http://schemas.microsoft.com/office/drawing/2014/main" id="{D03107D6-4623-4F64-B3AC-2FEF42F2DCE8}"/>
+                <a16:creationId xmlns:a16="http://schemas.microsoft.com/office/drawing/2014/main" id="{FDB50C52-06AB-4DA1-814D-F429C534E612}"/>
               </a:ext>
             </a:extLst>
           </p:cNvPr>
@@ -10128,7 +10128,7 @@
           <p:cNvPr id="2" name="">
             <a:extLst xmlns:a="http://schemas.openxmlformats.org/drawingml/2006/main">
               <a:ext uri="{FF2B5EF4-FFF2-40B4-BE49-F238E27FC236}">
-                <a16:creationId xmlns:a16="http://schemas.microsoft.com/office/drawing/2014/main" id="{1753D9C5-02DA-4B20-86BD-606E611C1929}"/>
+                <a16:creationId xmlns:a16="http://schemas.microsoft.com/office/drawing/2014/main" id="{250DAAB1-78CE-46F7-9FA7-46F6FA959098}"/>
               </a:ext>
             </a:extLst>
           </p:cNvPr>
@@ -10178,7 +10178,7 @@
           <p:cNvPr id="3" name="">
             <a:extLst xmlns:a="http://schemas.openxmlformats.org/drawingml/2006/main">
               <a:ext uri="{FF2B5EF4-FFF2-40B4-BE49-F238E27FC236}">
-                <a16:creationId xmlns:a16="http://schemas.microsoft.com/office/drawing/2014/main" id="{A82565D4-B4B8-44F5-81A9-EC084A25AB3C}"/>
+                <a16:creationId xmlns:a16="http://schemas.microsoft.com/office/drawing/2014/main" id="{5FB29DE2-9BD5-42DC-9E2A-4D3B2BEAFF90}"/>
               </a:ext>
             </a:extLst>
           </p:cNvPr>
@@ -10211,7 +10211,7 @@
           <p:cNvPr id="4" name="">
             <a:extLst xmlns:a="http://schemas.openxmlformats.org/drawingml/2006/main">
               <a:ext uri="{FF2B5EF4-FFF2-40B4-BE49-F238E27FC236}">
-                <a16:creationId xmlns:a16="http://schemas.microsoft.com/office/drawing/2014/main" id="{D651AD5A-4536-4989-8D11-7B1D32150046}"/>
+                <a16:creationId xmlns:a16="http://schemas.microsoft.com/office/drawing/2014/main" id="{DDE77656-3617-4732-911B-33921899584B}"/>
               </a:ext>
             </a:extLst>
           </p:cNvPr>
@@ -10261,7 +10261,7 @@
           <p:cNvPr id="5" name="">
             <a:extLst xmlns:a="http://schemas.openxmlformats.org/drawingml/2006/main">
               <a:ext uri="{FF2B5EF4-FFF2-40B4-BE49-F238E27FC236}">
-                <a16:creationId xmlns:a16="http://schemas.microsoft.com/office/drawing/2014/main" id="{D0C479CE-A604-4867-B699-35764723993B}"/>
+                <a16:creationId xmlns:a16="http://schemas.microsoft.com/office/drawing/2014/main" id="{A6524EBC-FFF0-452B-A9ED-36E9A24FF997}"/>
               </a:ext>
             </a:extLst>
           </p:cNvPr>
@@ -10294,7 +10294,7 @@
           <p:cNvPr id="6" name="">
             <a:extLst xmlns:a="http://schemas.openxmlformats.org/drawingml/2006/main">
               <a:ext uri="{FF2B5EF4-FFF2-40B4-BE49-F238E27FC236}">
-                <a16:creationId xmlns:a16="http://schemas.microsoft.com/office/drawing/2014/main" id="{7D6A4361-2274-4851-AA30-30549B0D36AC}"/>
+                <a16:creationId xmlns:a16="http://schemas.microsoft.com/office/drawing/2014/main" id="{19AB693F-6133-4821-84E2-ED8A8026DD51}"/>
               </a:ext>
             </a:extLst>
           </p:cNvPr>
@@ -10327,7 +10327,7 @@
           <p:cNvPr id="7" name="">
             <a:extLst xmlns:a="http://schemas.openxmlformats.org/drawingml/2006/main">
               <a:ext uri="{FF2B5EF4-FFF2-40B4-BE49-F238E27FC236}">
-                <a16:creationId xmlns:a16="http://schemas.microsoft.com/office/drawing/2014/main" id="{CB37DA64-672A-4D36-951B-CA953D5B9F43}"/>
+                <a16:creationId xmlns:a16="http://schemas.microsoft.com/office/drawing/2014/main" id="{C81EF1A8-3D03-47CA-9D30-3C4F398D1DBA}"/>
               </a:ext>
             </a:extLst>
           </p:cNvPr>
@@ -10377,7 +10377,7 @@
           <p:cNvPr id="8" name="">
             <a:extLst xmlns:a="http://schemas.openxmlformats.org/drawingml/2006/main">
               <a:ext uri="{FF2B5EF4-FFF2-40B4-BE49-F238E27FC236}">
-                <a16:creationId xmlns:a16="http://schemas.microsoft.com/office/drawing/2014/main" id="{8781DBC4-3C4F-4B34-8CBD-B47C2A7A44F6}"/>
+                <a16:creationId xmlns:a16="http://schemas.microsoft.com/office/drawing/2014/main" id="{8941994D-500C-4D57-A425-8EA20F5EF06C}"/>
               </a:ext>
             </a:extLst>
           </p:cNvPr>
@@ -10427,7 +10427,7 @@
           <p:cNvPr id="9" name="">
             <a:extLst xmlns:a="http://schemas.openxmlformats.org/drawingml/2006/main">
               <a:ext uri="{FF2B5EF4-FFF2-40B4-BE49-F238E27FC236}">
-                <a16:creationId xmlns:a16="http://schemas.microsoft.com/office/drawing/2014/main" id="{BFDEA7FC-42CA-4519-B0F3-84D50CFD5737}"/>
+                <a16:creationId xmlns:a16="http://schemas.microsoft.com/office/drawing/2014/main" id="{22A643EB-FCBF-4D99-A7E3-D8748BD4B0AF}"/>
               </a:ext>
             </a:extLst>
           </p:cNvPr>
@@ -10460,7 +10460,7 @@
           <p:cNvPr id="10" name="">
             <a:extLst xmlns:a="http://schemas.openxmlformats.org/drawingml/2006/main">
               <a:ext uri="{FF2B5EF4-FFF2-40B4-BE49-F238E27FC236}">
-                <a16:creationId xmlns:a16="http://schemas.microsoft.com/office/drawing/2014/main" id="{378E2E40-C582-4F9D-AD26-4F4D5ECA7864}"/>
+                <a16:creationId xmlns:a16="http://schemas.microsoft.com/office/drawing/2014/main" id="{E8921D11-A595-40F1-BC53-3FFE4E1D0437}"/>
               </a:ext>
             </a:extLst>
           </p:cNvPr>
@@ -10493,7 +10493,7 @@
           <p:cNvPr id="11" name="">
             <a:extLst xmlns:a="http://schemas.openxmlformats.org/drawingml/2006/main">
               <a:ext uri="{FF2B5EF4-FFF2-40B4-BE49-F238E27FC236}">
-                <a16:creationId xmlns:a16="http://schemas.microsoft.com/office/drawing/2014/main" id="{19D55521-9831-4E76-A71E-02468FE6BFF0}"/>
+                <a16:creationId xmlns:a16="http://schemas.microsoft.com/office/drawing/2014/main" id="{273703AA-8EFA-484E-ADEC-273672CF2FC7}"/>
               </a:ext>
             </a:extLst>
           </p:cNvPr>
@@ -10543,7 +10543,7 @@
           <p:cNvPr id="12" name="">
             <a:extLst xmlns:a="http://schemas.openxmlformats.org/drawingml/2006/main">
               <a:ext uri="{FF2B5EF4-FFF2-40B4-BE49-F238E27FC236}">
-                <a16:creationId xmlns:a16="http://schemas.microsoft.com/office/drawing/2014/main" id="{34A2F3C8-CB5A-4F95-A16A-23B058CC8A81}"/>
+                <a16:creationId xmlns:a16="http://schemas.microsoft.com/office/drawing/2014/main" id="{CA1D0B08-A23C-4732-8830-B5F541EC7933}"/>
               </a:ext>
             </a:extLst>
           </p:cNvPr>
@@ -10593,7 +10593,7 @@
           <p:cNvPr id="13" name="">
             <a:extLst xmlns:a="http://schemas.openxmlformats.org/drawingml/2006/main">
               <a:ext uri="{FF2B5EF4-FFF2-40B4-BE49-F238E27FC236}">
-                <a16:creationId xmlns:a16="http://schemas.microsoft.com/office/drawing/2014/main" id="{CFE734A9-F4BE-4011-AC2E-CE1BF891B0D2}"/>
+                <a16:creationId xmlns:a16="http://schemas.microsoft.com/office/drawing/2014/main" id="{511ACB8A-147C-4350-AE74-6FFEF2B686BA}"/>
               </a:ext>
             </a:extLst>
           </p:cNvPr>
@@ -10626,7 +10626,7 @@
           <p:cNvPr id="14" name="">
             <a:extLst xmlns:a="http://schemas.openxmlformats.org/drawingml/2006/main">
               <a:ext uri="{FF2B5EF4-FFF2-40B4-BE49-F238E27FC236}">
-                <a16:creationId xmlns:a16="http://schemas.microsoft.com/office/drawing/2014/main" id="{01D51BCA-0686-4FD2-9420-8DD4310A993A}"/>
+                <a16:creationId xmlns:a16="http://schemas.microsoft.com/office/drawing/2014/main" id="{D14E833D-CC8A-4989-B3B3-26602F90949B}"/>
               </a:ext>
             </a:extLst>
           </p:cNvPr>
@@ -10659,7 +10659,7 @@
           <p:cNvPr id="15" name="">
             <a:extLst xmlns:a="http://schemas.openxmlformats.org/drawingml/2006/main">
               <a:ext uri="{FF2B5EF4-FFF2-40B4-BE49-F238E27FC236}">
-                <a16:creationId xmlns:a16="http://schemas.microsoft.com/office/drawing/2014/main" id="{D60FA894-AB94-402F-842E-CE1708FE85E5}"/>
+                <a16:creationId xmlns:a16="http://schemas.microsoft.com/office/drawing/2014/main" id="{B9BB0164-668D-4D7E-A417-D66E924536F1}"/>
               </a:ext>
             </a:extLst>
           </p:cNvPr>
@@ -10709,7 +10709,7 @@
           <p:cNvPr id="16" name="">
             <a:extLst xmlns:a="http://schemas.openxmlformats.org/drawingml/2006/main">
               <a:ext uri="{FF2B5EF4-FFF2-40B4-BE49-F238E27FC236}">
-                <a16:creationId xmlns:a16="http://schemas.microsoft.com/office/drawing/2014/main" id="{06C82DB0-9049-48E8-BD5B-C44481C99357}"/>
+                <a16:creationId xmlns:a16="http://schemas.microsoft.com/office/drawing/2014/main" id="{3808E3C4-4699-4828-844C-EE9A1B44774F}"/>
               </a:ext>
             </a:extLst>
           </p:cNvPr>
@@ -10759,7 +10759,7 @@
           <p:cNvPr id="17" name="">
             <a:extLst xmlns:a="http://schemas.openxmlformats.org/drawingml/2006/main">
               <a:ext uri="{FF2B5EF4-FFF2-40B4-BE49-F238E27FC236}">
-                <a16:creationId xmlns:a16="http://schemas.microsoft.com/office/drawing/2014/main" id="{9AC57409-719B-4599-9D5B-EDE60C829DB9}"/>
+                <a16:creationId xmlns:a16="http://schemas.microsoft.com/office/drawing/2014/main" id="{E7A810E9-42F9-4A9B-8C5A-C708F78E6484}"/>
               </a:ext>
             </a:extLst>
           </p:cNvPr>
@@ -10792,7 +10792,7 @@
           <p:cNvPr id="18" name="">
             <a:extLst xmlns:a="http://schemas.openxmlformats.org/drawingml/2006/main">
               <a:ext uri="{FF2B5EF4-FFF2-40B4-BE49-F238E27FC236}">
-                <a16:creationId xmlns:a16="http://schemas.microsoft.com/office/drawing/2014/main" id="{E09E8AC4-DAD5-4256-9996-6D6A77FEC980}"/>
+                <a16:creationId xmlns:a16="http://schemas.microsoft.com/office/drawing/2014/main" id="{174DC14F-FE33-4647-9F18-EDAE38A3A7FF}"/>
               </a:ext>
             </a:extLst>
           </p:cNvPr>
@@ -10825,7 +10825,7 @@
           <p:cNvPr id="19" name="">
             <a:extLst xmlns:a="http://schemas.openxmlformats.org/drawingml/2006/main">
               <a:ext uri="{FF2B5EF4-FFF2-40B4-BE49-F238E27FC236}">
-                <a16:creationId xmlns:a16="http://schemas.microsoft.com/office/drawing/2014/main" id="{B7043C6F-4774-4E01-8D42-F86A1E5937D4}"/>
+                <a16:creationId xmlns:a16="http://schemas.microsoft.com/office/drawing/2014/main" id="{B8E011D9-BCB8-4821-94E4-988F7E6C8FC8}"/>
               </a:ext>
             </a:extLst>
           </p:cNvPr>
@@ -10858,7 +10858,7 @@
           <p:cNvPr id="20" name="">
             <a:extLst xmlns:a="http://schemas.openxmlformats.org/drawingml/2006/main">
               <a:ext uri="{FF2B5EF4-FFF2-40B4-BE49-F238E27FC236}">
-                <a16:creationId xmlns:a16="http://schemas.microsoft.com/office/drawing/2014/main" id="{740E78FC-9052-4CBE-8967-D68B3F222D3B}"/>
+                <a16:creationId xmlns:a16="http://schemas.microsoft.com/office/drawing/2014/main" id="{08289159-A876-4AFD-8826-BAA00D66E0EF}"/>
               </a:ext>
             </a:extLst>
           </p:cNvPr>
@@ -10891,7 +10891,7 @@
           <p:cNvPr id="21" name="">
             <a:extLst xmlns:a="http://schemas.openxmlformats.org/drawingml/2006/main">
               <a:ext uri="{FF2B5EF4-FFF2-40B4-BE49-F238E27FC236}">
-                <a16:creationId xmlns:a16="http://schemas.microsoft.com/office/drawing/2014/main" id="{6619A9A9-9AD0-4DDB-9A96-7D91BB54552B}"/>
+                <a16:creationId xmlns:a16="http://schemas.microsoft.com/office/drawing/2014/main" id="{D3270DB3-054E-40A3-853E-9C1C172303D0}"/>
               </a:ext>
             </a:extLst>
           </p:cNvPr>
@@ -10924,7 +10924,7 @@
           <p:cNvPr id="22" name="">
             <a:extLst xmlns:a="http://schemas.openxmlformats.org/drawingml/2006/main">
               <a:ext uri="{FF2B5EF4-FFF2-40B4-BE49-F238E27FC236}">
-                <a16:creationId xmlns:a16="http://schemas.microsoft.com/office/drawing/2014/main" id="{0BA47EDB-B58E-4D47-9AE7-051E7CB55A91}"/>
+                <a16:creationId xmlns:a16="http://schemas.microsoft.com/office/drawing/2014/main" id="{E71AE296-918F-4714-AC08-E604ACF846A6}"/>
               </a:ext>
             </a:extLst>
           </p:cNvPr>
@@ -10957,7 +10957,7 @@
           <p:cNvPr id="23" name="">
             <a:extLst xmlns:a="http://schemas.openxmlformats.org/drawingml/2006/main">
               <a:ext uri="{FF2B5EF4-FFF2-40B4-BE49-F238E27FC236}">
-                <a16:creationId xmlns:a16="http://schemas.microsoft.com/office/drawing/2014/main" id="{DEC99674-D6B3-43F1-8319-A3A6472A17D4}"/>
+                <a16:creationId xmlns:a16="http://schemas.microsoft.com/office/drawing/2014/main" id="{6C10F986-3579-4333-8E4E-D580B902FED0}"/>
               </a:ext>
             </a:extLst>
           </p:cNvPr>
@@ -10990,7 +10990,7 @@
           <p:cNvPr id="24" name="">
             <a:extLst xmlns:a="http://schemas.openxmlformats.org/drawingml/2006/main">
               <a:ext uri="{FF2B5EF4-FFF2-40B4-BE49-F238E27FC236}">
-                <a16:creationId xmlns:a16="http://schemas.microsoft.com/office/drawing/2014/main" id="{7BF57338-8313-4000-9FE1-3D6F05F15E2F}"/>
+                <a16:creationId xmlns:a16="http://schemas.microsoft.com/office/drawing/2014/main" id="{CACF2F90-4DCC-41AF-A541-476B883F0BA4}"/>
               </a:ext>
             </a:extLst>
           </p:cNvPr>
@@ -11023,7 +11023,7 @@
           <p:cNvPr id="25" name="">
             <a:extLst xmlns:a="http://schemas.openxmlformats.org/drawingml/2006/main">
               <a:ext uri="{FF2B5EF4-FFF2-40B4-BE49-F238E27FC236}">
-                <a16:creationId xmlns:a16="http://schemas.microsoft.com/office/drawing/2014/main" id="{2A5E96DE-D957-430C-817A-471753969F95}"/>
+                <a16:creationId xmlns:a16="http://schemas.microsoft.com/office/drawing/2014/main" id="{FCA42D3D-B2A4-4E96-AB60-55295620B5CC}"/>
               </a:ext>
             </a:extLst>
           </p:cNvPr>
@@ -11063,7 +11063,7 @@
                   <a:srgbClr val="EA580C"/>
                 </a:solidFill>
               </a:rPr>
-              <a:t>這頁重點</a:t>
+              <a:t>畫面整合</a:t>
             </a:r>
           </a:p>
         </p:txBody>
@@ -11073,7 +11073,7 @@
           <p:cNvPr id="26" name="">
             <a:extLst xmlns:a="http://schemas.openxmlformats.org/drawingml/2006/main">
               <a:ext uri="{FF2B5EF4-FFF2-40B4-BE49-F238E27FC236}">
-                <a16:creationId xmlns:a16="http://schemas.microsoft.com/office/drawing/2014/main" id="{729B8D11-7B72-4E60-9B81-0584ECB806CA}"/>
+                <a16:creationId xmlns:a16="http://schemas.microsoft.com/office/drawing/2014/main" id="{231FD020-DA69-4726-8EAD-54876AC222F8}"/>
               </a:ext>
             </a:extLst>
           </p:cNvPr>
@@ -11113,7 +11113,7 @@
                   <a:srgbClr val="111827"/>
                 </a:solidFill>
               </a:rPr>
-              <a:t>VGA 只負責顯示，遊戲規則已在前面模組完成。</a:t>
+              <a:t>renderer 依據遊戲狀態與座標輸出對應 RGB 畫面。</a:t>
             </a:r>
           </a:p>
         </p:txBody>
@@ -11121,7 +11121,7 @@
     </p:spTree>
     <p:extLst>
       <p:ext uri="{BB962C8B-B14F-4D97-AF65-F5344CB8AC3E}">
-        <p14:creationId xmlns:p14="http://schemas.microsoft.com/office/powerpoint/2010/main" val="1307742873"/>
+        <p14:creationId xmlns:p14="http://schemas.microsoft.com/office/powerpoint/2010/main" val="324251628"/>
       </p:ext>
     </p:extLst>
   </p:cSld>
@@ -11152,7 +11152,7 @@
           <p:cNvPr id="41" name="">
             <a:extLst xmlns:a="http://schemas.openxmlformats.org/drawingml/2006/main">
               <a:ext uri="{FF2B5EF4-FFF2-40B4-BE49-F238E27FC236}">
-                <a16:creationId xmlns:a16="http://schemas.microsoft.com/office/drawing/2014/main" id="{C845FC13-DE40-4D58-8A6B-51C8090DC93D}"/>
+                <a16:creationId xmlns:a16="http://schemas.microsoft.com/office/drawing/2014/main" id="{A97F7C7F-6A70-409D-B318-4DEC957BA611}"/>
               </a:ext>
             </a:extLst>
           </p:cNvPr>
@@ -11202,7 +11202,7 @@
           <p:cNvPr id="2" name="">
             <a:extLst xmlns:a="http://schemas.openxmlformats.org/drawingml/2006/main">
               <a:ext uri="{FF2B5EF4-FFF2-40B4-BE49-F238E27FC236}">
-                <a16:creationId xmlns:a16="http://schemas.microsoft.com/office/drawing/2014/main" id="{E063D8B7-CCD5-4B0D-BD8F-4681DBBFD0FA}"/>
+                <a16:creationId xmlns:a16="http://schemas.microsoft.com/office/drawing/2014/main" id="{76AC60EB-087D-492F-BD4C-CE6ED6266C8E}"/>
               </a:ext>
             </a:extLst>
           </p:cNvPr>
@@ -11252,7 +11252,7 @@
           <p:cNvPr id="3" name="">
             <a:extLst xmlns:a="http://schemas.openxmlformats.org/drawingml/2006/main">
               <a:ext uri="{FF2B5EF4-FFF2-40B4-BE49-F238E27FC236}">
-                <a16:creationId xmlns:a16="http://schemas.microsoft.com/office/drawing/2014/main" id="{CCAC0C0B-FA9F-4784-B595-3A6F8D2CEB10}"/>
+                <a16:creationId xmlns:a16="http://schemas.microsoft.com/office/drawing/2014/main" id="{A35FFAB3-F49C-4136-B6AA-CAF9CFAD54FA}"/>
               </a:ext>
             </a:extLst>
           </p:cNvPr>
@@ -11285,7 +11285,7 @@
           <p:cNvPr id="4" name="">
             <a:extLst xmlns:a="http://schemas.openxmlformats.org/drawingml/2006/main">
               <a:ext uri="{FF2B5EF4-FFF2-40B4-BE49-F238E27FC236}">
-                <a16:creationId xmlns:a16="http://schemas.microsoft.com/office/drawing/2014/main" id="{C3B212CD-6611-4C86-B6B6-A008C22BB1D6}"/>
+                <a16:creationId xmlns:a16="http://schemas.microsoft.com/office/drawing/2014/main" id="{737133C3-1F1C-4D78-9E53-82A3CB659A79}"/>
               </a:ext>
             </a:extLst>
           </p:cNvPr>
@@ -11335,7 +11335,7 @@
           <p:cNvPr id="5" name="">
             <a:extLst xmlns:a="http://schemas.openxmlformats.org/drawingml/2006/main">
               <a:ext uri="{FF2B5EF4-FFF2-40B4-BE49-F238E27FC236}">
-                <a16:creationId xmlns:a16="http://schemas.microsoft.com/office/drawing/2014/main" id="{55C97D8E-7E37-4129-8538-C92FC56F5DB1}"/>
+                <a16:creationId xmlns:a16="http://schemas.microsoft.com/office/drawing/2014/main" id="{9B112CA3-F49F-4E22-9C4E-CFACD3BE8908}"/>
               </a:ext>
             </a:extLst>
           </p:cNvPr>
@@ -11368,7 +11368,7 @@
           <p:cNvPr id="6" name="">
             <a:extLst xmlns:a="http://schemas.openxmlformats.org/drawingml/2006/main">
               <a:ext uri="{FF2B5EF4-FFF2-40B4-BE49-F238E27FC236}">
-                <a16:creationId xmlns:a16="http://schemas.microsoft.com/office/drawing/2014/main" id="{B1703EEE-47D4-4A9D-84E3-DF891FF8977E}"/>
+                <a16:creationId xmlns:a16="http://schemas.microsoft.com/office/drawing/2014/main" id="{501ABFF7-1D66-48EB-86D2-3C12FEA07EC6}"/>
               </a:ext>
             </a:extLst>
           </p:cNvPr>
@@ -11418,7 +11418,7 @@
           <p:cNvPr id="7" name="">
             <a:extLst xmlns:a="http://schemas.openxmlformats.org/drawingml/2006/main">
               <a:ext uri="{FF2B5EF4-FFF2-40B4-BE49-F238E27FC236}">
-                <a16:creationId xmlns:a16="http://schemas.microsoft.com/office/drawing/2014/main" id="{4524D8DF-F8E8-440F-AAB2-F9BDDEE685F3}"/>
+                <a16:creationId xmlns:a16="http://schemas.microsoft.com/office/drawing/2014/main" id="{20ABF5D6-5CF8-43D3-8CED-39265AD74192}"/>
               </a:ext>
             </a:extLst>
           </p:cNvPr>
@@ -11468,7 +11468,7 @@
           <p:cNvPr id="8" name="">
             <a:extLst xmlns:a="http://schemas.openxmlformats.org/drawingml/2006/main">
               <a:ext uri="{FF2B5EF4-FFF2-40B4-BE49-F238E27FC236}">
-                <a16:creationId xmlns:a16="http://schemas.microsoft.com/office/drawing/2014/main" id="{ADBB72E9-535B-48E3-A814-77E70D4A4F01}"/>
+                <a16:creationId xmlns:a16="http://schemas.microsoft.com/office/drawing/2014/main" id="{4B741160-06F5-4EBB-8196-367018DE14C6}"/>
               </a:ext>
             </a:extLst>
           </p:cNvPr>
@@ -11501,7 +11501,7 @@
           <p:cNvPr id="9" name="">
             <a:extLst xmlns:a="http://schemas.openxmlformats.org/drawingml/2006/main">
               <a:ext uri="{FF2B5EF4-FFF2-40B4-BE49-F238E27FC236}">
-                <a16:creationId xmlns:a16="http://schemas.microsoft.com/office/drawing/2014/main" id="{A99BEFEA-39BD-4500-AB3A-686B60AFDDF2}"/>
+                <a16:creationId xmlns:a16="http://schemas.microsoft.com/office/drawing/2014/main" id="{A418FB42-F557-4A49-83B4-A68A3C9D56E6}"/>
               </a:ext>
             </a:extLst>
           </p:cNvPr>
@@ -11551,7 +11551,7 @@
           <p:cNvPr id="10" name="">
             <a:extLst xmlns:a="http://schemas.openxmlformats.org/drawingml/2006/main">
               <a:ext uri="{FF2B5EF4-FFF2-40B4-BE49-F238E27FC236}">
-                <a16:creationId xmlns:a16="http://schemas.microsoft.com/office/drawing/2014/main" id="{9539CB7C-8FD8-4C58-9FB4-9ADA39C485B5}"/>
+                <a16:creationId xmlns:a16="http://schemas.microsoft.com/office/drawing/2014/main" id="{01E26FE1-64F2-4665-A286-372640B42BCD}"/>
               </a:ext>
             </a:extLst>
           </p:cNvPr>
@@ -11601,7 +11601,7 @@
           <p:cNvPr id="11" name="">
             <a:extLst xmlns:a="http://schemas.openxmlformats.org/drawingml/2006/main">
               <a:ext uri="{FF2B5EF4-FFF2-40B4-BE49-F238E27FC236}">
-                <a16:creationId xmlns:a16="http://schemas.microsoft.com/office/drawing/2014/main" id="{D9BDB040-D538-4055-A29E-8054829455C0}"/>
+                <a16:creationId xmlns:a16="http://schemas.microsoft.com/office/drawing/2014/main" id="{65336C92-C9B8-48BD-A817-F574CB1CAD35}"/>
               </a:ext>
             </a:extLst>
           </p:cNvPr>
@@ -11634,7 +11634,7 @@
           <p:cNvPr id="12" name="">
             <a:extLst xmlns:a="http://schemas.openxmlformats.org/drawingml/2006/main">
               <a:ext uri="{FF2B5EF4-FFF2-40B4-BE49-F238E27FC236}">
-                <a16:creationId xmlns:a16="http://schemas.microsoft.com/office/drawing/2014/main" id="{EB7DC9C0-945A-4B06-AFCF-B5502933CC22}"/>
+                <a16:creationId xmlns:a16="http://schemas.microsoft.com/office/drawing/2014/main" id="{ABB32A47-5002-4F25-97B2-52E3A29AFBE5}"/>
               </a:ext>
             </a:extLst>
           </p:cNvPr>
@@ -11684,7 +11684,7 @@
           <p:cNvPr id="13" name="">
             <a:extLst xmlns:a="http://schemas.openxmlformats.org/drawingml/2006/main">
               <a:ext uri="{FF2B5EF4-FFF2-40B4-BE49-F238E27FC236}">
-                <a16:creationId xmlns:a16="http://schemas.microsoft.com/office/drawing/2014/main" id="{C9D87B3B-0D49-419D-8A7F-B0FE1893CC58}"/>
+                <a16:creationId xmlns:a16="http://schemas.microsoft.com/office/drawing/2014/main" id="{26C03B51-A713-438F-8203-C60664A763B9}"/>
               </a:ext>
             </a:extLst>
           </p:cNvPr>
@@ -11734,7 +11734,7 @@
           <p:cNvPr id="14" name="">
             <a:extLst xmlns:a="http://schemas.openxmlformats.org/drawingml/2006/main">
               <a:ext uri="{FF2B5EF4-FFF2-40B4-BE49-F238E27FC236}">
-                <a16:creationId xmlns:a16="http://schemas.microsoft.com/office/drawing/2014/main" id="{73B4D7D3-2D4E-408E-A882-C352CD5CA18F}"/>
+                <a16:creationId xmlns:a16="http://schemas.microsoft.com/office/drawing/2014/main" id="{299B4D1F-B5D9-4F4D-AFF8-61854114A964}"/>
               </a:ext>
             </a:extLst>
           </p:cNvPr>
@@ -11767,7 +11767,7 @@
           <p:cNvPr id="15" name="">
             <a:extLst xmlns:a="http://schemas.openxmlformats.org/drawingml/2006/main">
               <a:ext uri="{FF2B5EF4-FFF2-40B4-BE49-F238E27FC236}">
-                <a16:creationId xmlns:a16="http://schemas.microsoft.com/office/drawing/2014/main" id="{B6EA843A-E7B8-49E9-A179-93DBDDE970D5}"/>
+                <a16:creationId xmlns:a16="http://schemas.microsoft.com/office/drawing/2014/main" id="{7EDE6BD0-041A-4D17-9B2A-E3B8DB90BFEA}"/>
               </a:ext>
             </a:extLst>
           </p:cNvPr>
@@ -11817,7 +11817,7 @@
           <p:cNvPr id="16" name="">
             <a:extLst xmlns:a="http://schemas.openxmlformats.org/drawingml/2006/main">
               <a:ext uri="{FF2B5EF4-FFF2-40B4-BE49-F238E27FC236}">
-                <a16:creationId xmlns:a16="http://schemas.microsoft.com/office/drawing/2014/main" id="{3B693905-EA68-4111-B89C-30907A8C7259}"/>
+                <a16:creationId xmlns:a16="http://schemas.microsoft.com/office/drawing/2014/main" id="{30DFE01F-E6F4-4D8B-9F1F-26B7D5C5A0CD}"/>
               </a:ext>
             </a:extLst>
           </p:cNvPr>
@@ -11867,7 +11867,7 @@
           <p:cNvPr id="17" name="">
             <a:extLst xmlns:a="http://schemas.openxmlformats.org/drawingml/2006/main">
               <a:ext uri="{FF2B5EF4-FFF2-40B4-BE49-F238E27FC236}">
-                <a16:creationId xmlns:a16="http://schemas.microsoft.com/office/drawing/2014/main" id="{D43BDC12-248E-4A8D-B933-81DB75B45876}"/>
+                <a16:creationId xmlns:a16="http://schemas.microsoft.com/office/drawing/2014/main" id="{147ADC1D-A000-4486-B5A4-57A38CD34383}"/>
               </a:ext>
             </a:extLst>
           </p:cNvPr>
@@ -11900,7 +11900,7 @@
           <p:cNvPr id="18" name="">
             <a:extLst xmlns:a="http://schemas.openxmlformats.org/drawingml/2006/main">
               <a:ext uri="{FF2B5EF4-FFF2-40B4-BE49-F238E27FC236}">
-                <a16:creationId xmlns:a16="http://schemas.microsoft.com/office/drawing/2014/main" id="{4AD62334-A804-44BE-9706-92E1D42DCBF7}"/>
+                <a16:creationId xmlns:a16="http://schemas.microsoft.com/office/drawing/2014/main" id="{B66FB210-13A2-4303-8BF6-F452FB9E025A}"/>
               </a:ext>
             </a:extLst>
           </p:cNvPr>
@@ -11950,7 +11950,7 @@
           <p:cNvPr id="19" name="">
             <a:extLst xmlns:a="http://schemas.openxmlformats.org/drawingml/2006/main">
               <a:ext uri="{FF2B5EF4-FFF2-40B4-BE49-F238E27FC236}">
-                <a16:creationId xmlns:a16="http://schemas.microsoft.com/office/drawing/2014/main" id="{3C709DC5-A440-4168-B099-256D0DAF7470}"/>
+                <a16:creationId xmlns:a16="http://schemas.microsoft.com/office/drawing/2014/main" id="{73817053-C37D-4435-932B-69230E23C730}"/>
               </a:ext>
             </a:extLst>
           </p:cNvPr>
@@ -12000,7 +12000,7 @@
           <p:cNvPr id="20" name="">
             <a:extLst xmlns:a="http://schemas.openxmlformats.org/drawingml/2006/main">
               <a:ext uri="{FF2B5EF4-FFF2-40B4-BE49-F238E27FC236}">
-                <a16:creationId xmlns:a16="http://schemas.microsoft.com/office/drawing/2014/main" id="{A944A366-B84F-48CE-8325-48EE73AE194F}"/>
+                <a16:creationId xmlns:a16="http://schemas.microsoft.com/office/drawing/2014/main" id="{0C7EB84D-7740-4DEF-8461-0183CD359915}"/>
               </a:ext>
             </a:extLst>
           </p:cNvPr>
@@ -12033,7 +12033,7 @@
           <p:cNvPr id="21" name="">
             <a:extLst xmlns:a="http://schemas.openxmlformats.org/drawingml/2006/main">
               <a:ext uri="{FF2B5EF4-FFF2-40B4-BE49-F238E27FC236}">
-                <a16:creationId xmlns:a16="http://schemas.microsoft.com/office/drawing/2014/main" id="{05CF1CFF-8DA2-45A1-8692-AF05C02BF356}"/>
+                <a16:creationId xmlns:a16="http://schemas.microsoft.com/office/drawing/2014/main" id="{F149EBCE-44FA-4B8C-A840-173CDE0ACE75}"/>
               </a:ext>
             </a:extLst>
           </p:cNvPr>
@@ -12083,7 +12083,7 @@
           <p:cNvPr id="22" name="">
             <a:extLst xmlns:a="http://schemas.openxmlformats.org/drawingml/2006/main">
               <a:ext uri="{FF2B5EF4-FFF2-40B4-BE49-F238E27FC236}">
-                <a16:creationId xmlns:a16="http://schemas.microsoft.com/office/drawing/2014/main" id="{1FEC068C-BEF4-4870-A422-72B7A62829CF}"/>
+                <a16:creationId xmlns:a16="http://schemas.microsoft.com/office/drawing/2014/main" id="{8A9907EA-8244-4600-8FDC-649337AE9459}"/>
               </a:ext>
             </a:extLst>
           </p:cNvPr>
@@ -12133,7 +12133,7 @@
           <p:cNvPr id="23" name="">
             <a:extLst xmlns:a="http://schemas.openxmlformats.org/drawingml/2006/main">
               <a:ext uri="{FF2B5EF4-FFF2-40B4-BE49-F238E27FC236}">
-                <a16:creationId xmlns:a16="http://schemas.microsoft.com/office/drawing/2014/main" id="{E664ACEE-9D32-40AC-A20A-C27AB04464F9}"/>
+                <a16:creationId xmlns:a16="http://schemas.microsoft.com/office/drawing/2014/main" id="{6663F801-2E18-4B90-992B-BD91E6412986}"/>
               </a:ext>
             </a:extLst>
           </p:cNvPr>
@@ -12183,7 +12183,7 @@
           <p:cNvPr id="24" name="">
             <a:extLst xmlns:a="http://schemas.openxmlformats.org/drawingml/2006/main">
               <a:ext uri="{FF2B5EF4-FFF2-40B4-BE49-F238E27FC236}">
-                <a16:creationId xmlns:a16="http://schemas.microsoft.com/office/drawing/2014/main" id="{06596D56-F39E-4793-BB58-77EA4A7D1DE1}"/>
+                <a16:creationId xmlns:a16="http://schemas.microsoft.com/office/drawing/2014/main" id="{F6D97049-C8D6-475A-A841-DC78270DEFDD}"/>
               </a:ext>
             </a:extLst>
           </p:cNvPr>
@@ -12233,7 +12233,7 @@
           <p:cNvPr id="25" name="">
             <a:extLst xmlns:a="http://schemas.openxmlformats.org/drawingml/2006/main">
               <a:ext uri="{FF2B5EF4-FFF2-40B4-BE49-F238E27FC236}">
-                <a16:creationId xmlns:a16="http://schemas.microsoft.com/office/drawing/2014/main" id="{2BE19B65-6275-449F-8D4E-3844E65C5A11}"/>
+                <a16:creationId xmlns:a16="http://schemas.microsoft.com/office/drawing/2014/main" id="{214C4CE5-F8ED-4BAA-B230-1DC5C760F1E4}"/>
               </a:ext>
             </a:extLst>
           </p:cNvPr>
@@ -12283,7 +12283,7 @@
           <p:cNvPr id="26" name="">
             <a:extLst xmlns:a="http://schemas.openxmlformats.org/drawingml/2006/main">
               <a:ext uri="{FF2B5EF4-FFF2-40B4-BE49-F238E27FC236}">
-                <a16:creationId xmlns:a16="http://schemas.microsoft.com/office/drawing/2014/main" id="{8BA3C6AF-2D8D-43C2-BFE0-1B09456E278B}"/>
+                <a16:creationId xmlns:a16="http://schemas.microsoft.com/office/drawing/2014/main" id="{B2B14A2A-0740-4749-80D5-F1338BF65113}"/>
               </a:ext>
             </a:extLst>
           </p:cNvPr>
@@ -12333,7 +12333,7 @@
           <p:cNvPr id="27" name="">
             <a:extLst xmlns:a="http://schemas.openxmlformats.org/drawingml/2006/main">
               <a:ext uri="{FF2B5EF4-FFF2-40B4-BE49-F238E27FC236}">
-                <a16:creationId xmlns:a16="http://schemas.microsoft.com/office/drawing/2014/main" id="{FAF96688-4CB6-4C60-A284-7F973EF9B3AE}"/>
+                <a16:creationId xmlns:a16="http://schemas.microsoft.com/office/drawing/2014/main" id="{DCF6415E-3464-4B64-9A32-2D090B79C0E4}"/>
               </a:ext>
             </a:extLst>
           </p:cNvPr>
@@ -12383,7 +12383,7 @@
           <p:cNvPr id="28" name="">
             <a:extLst xmlns:a="http://schemas.openxmlformats.org/drawingml/2006/main">
               <a:ext uri="{FF2B5EF4-FFF2-40B4-BE49-F238E27FC236}">
-                <a16:creationId xmlns:a16="http://schemas.microsoft.com/office/drawing/2014/main" id="{42BD486B-942F-4226-915C-E2B5BB56FC84}"/>
+                <a16:creationId xmlns:a16="http://schemas.microsoft.com/office/drawing/2014/main" id="{D5F3F9D4-B53C-4098-AB46-4D8B2DF9BBCF}"/>
               </a:ext>
             </a:extLst>
           </p:cNvPr>
@@ -12433,7 +12433,7 @@
           <p:cNvPr id="29" name="">
             <a:extLst xmlns:a="http://schemas.openxmlformats.org/drawingml/2006/main">
               <a:ext uri="{FF2B5EF4-FFF2-40B4-BE49-F238E27FC236}">
-                <a16:creationId xmlns:a16="http://schemas.microsoft.com/office/drawing/2014/main" id="{D1000E9B-F58D-4A2D-AFB0-3BC467491473}"/>
+                <a16:creationId xmlns:a16="http://schemas.microsoft.com/office/drawing/2014/main" id="{00EB0F05-0D84-47EA-9807-458C16F1B345}"/>
               </a:ext>
             </a:extLst>
           </p:cNvPr>
@@ -12483,7 +12483,7 @@
           <p:cNvPr id="30" name="">
             <a:extLst xmlns:a="http://schemas.openxmlformats.org/drawingml/2006/main">
               <a:ext uri="{FF2B5EF4-FFF2-40B4-BE49-F238E27FC236}">
-                <a16:creationId xmlns:a16="http://schemas.microsoft.com/office/drawing/2014/main" id="{156C66D9-25D1-4698-A245-8B42AE67889E}"/>
+                <a16:creationId xmlns:a16="http://schemas.microsoft.com/office/drawing/2014/main" id="{56290523-A2A5-47CA-B7E7-E589EADF3D1B}"/>
               </a:ext>
             </a:extLst>
           </p:cNvPr>
@@ -12533,7 +12533,7 @@
           <p:cNvPr id="31" name="">
             <a:extLst xmlns:a="http://schemas.openxmlformats.org/drawingml/2006/main">
               <a:ext uri="{FF2B5EF4-FFF2-40B4-BE49-F238E27FC236}">
-                <a16:creationId xmlns:a16="http://schemas.microsoft.com/office/drawing/2014/main" id="{07304436-021A-495D-8F5C-F73DDAC38AB0}"/>
+                <a16:creationId xmlns:a16="http://schemas.microsoft.com/office/drawing/2014/main" id="{67772625-06F7-4286-9CEB-7F6C29FA283B}"/>
               </a:ext>
             </a:extLst>
           </p:cNvPr>
@@ -12583,7 +12583,7 @@
           <p:cNvPr id="32" name="">
             <a:extLst xmlns:a="http://schemas.openxmlformats.org/drawingml/2006/main">
               <a:ext uri="{FF2B5EF4-FFF2-40B4-BE49-F238E27FC236}">
-                <a16:creationId xmlns:a16="http://schemas.microsoft.com/office/drawing/2014/main" id="{593C5143-9A96-458A-9E80-E7250E503523}"/>
+                <a16:creationId xmlns:a16="http://schemas.microsoft.com/office/drawing/2014/main" id="{B5859CF6-3C75-43C8-BE92-C322BD15622C}"/>
               </a:ext>
             </a:extLst>
           </p:cNvPr>
@@ -12633,7 +12633,7 @@
           <p:cNvPr id="33" name="">
             <a:extLst xmlns:a="http://schemas.openxmlformats.org/drawingml/2006/main">
               <a:ext uri="{FF2B5EF4-FFF2-40B4-BE49-F238E27FC236}">
-                <a16:creationId xmlns:a16="http://schemas.microsoft.com/office/drawing/2014/main" id="{70EF8D64-C157-4125-987D-A42C21E7E97F}"/>
+                <a16:creationId xmlns:a16="http://schemas.microsoft.com/office/drawing/2014/main" id="{5E0F832D-3BF8-4CA4-AF8F-88CBAB4AF884}"/>
               </a:ext>
             </a:extLst>
           </p:cNvPr>
@@ -12683,7 +12683,7 @@
           <p:cNvPr id="34" name="">
             <a:extLst xmlns:a="http://schemas.openxmlformats.org/drawingml/2006/main">
               <a:ext uri="{FF2B5EF4-FFF2-40B4-BE49-F238E27FC236}">
-                <a16:creationId xmlns:a16="http://schemas.microsoft.com/office/drawing/2014/main" id="{47BA3246-4DC9-474A-9FBB-A6D96D9D316B}"/>
+                <a16:creationId xmlns:a16="http://schemas.microsoft.com/office/drawing/2014/main" id="{CEC6C14B-8F74-425C-AECE-3156D474AE1C}"/>
               </a:ext>
             </a:extLst>
           </p:cNvPr>
@@ -12733,7 +12733,7 @@
           <p:cNvPr id="35" name="">
             <a:extLst xmlns:a="http://schemas.openxmlformats.org/drawingml/2006/main">
               <a:ext uri="{FF2B5EF4-FFF2-40B4-BE49-F238E27FC236}">
-                <a16:creationId xmlns:a16="http://schemas.microsoft.com/office/drawing/2014/main" id="{E5C77565-B466-4B03-8DC2-3ED0A82D9B7E}"/>
+                <a16:creationId xmlns:a16="http://schemas.microsoft.com/office/drawing/2014/main" id="{01F60380-FA2C-4725-935D-64D872B5F36D}"/>
               </a:ext>
             </a:extLst>
           </p:cNvPr>
@@ -12783,7 +12783,7 @@
           <p:cNvPr id="36" name="">
             <a:extLst xmlns:a="http://schemas.openxmlformats.org/drawingml/2006/main">
               <a:ext uri="{FF2B5EF4-FFF2-40B4-BE49-F238E27FC236}">
-                <a16:creationId xmlns:a16="http://schemas.microsoft.com/office/drawing/2014/main" id="{0CDC8482-C96E-43F7-B1BA-C8A5503C0706}"/>
+                <a16:creationId xmlns:a16="http://schemas.microsoft.com/office/drawing/2014/main" id="{2F2AA273-3886-4F4C-AC22-658C613F4CF0}"/>
               </a:ext>
             </a:extLst>
           </p:cNvPr>
@@ -12816,7 +12816,7 @@
           <p:cNvPr id="37" name="">
             <a:extLst xmlns:a="http://schemas.openxmlformats.org/drawingml/2006/main">
               <a:ext uri="{FF2B5EF4-FFF2-40B4-BE49-F238E27FC236}">
-                <a16:creationId xmlns:a16="http://schemas.microsoft.com/office/drawing/2014/main" id="{A5E98F1D-F954-4C32-9470-424E14ED1251}"/>
+                <a16:creationId xmlns:a16="http://schemas.microsoft.com/office/drawing/2014/main" id="{9F12F8DE-5E49-4CFD-A461-2A4E27B5AAFD}"/>
               </a:ext>
             </a:extLst>
           </p:cNvPr>
@@ -12866,7 +12866,7 @@
           <p:cNvPr id="38" name="">
             <a:extLst xmlns:a="http://schemas.openxmlformats.org/drawingml/2006/main">
               <a:ext uri="{FF2B5EF4-FFF2-40B4-BE49-F238E27FC236}">
-                <a16:creationId xmlns:a16="http://schemas.microsoft.com/office/drawing/2014/main" id="{42354E64-6F25-48DF-A877-AEB09EE177C2}"/>
+                <a16:creationId xmlns:a16="http://schemas.microsoft.com/office/drawing/2014/main" id="{8F3B512A-0C9A-46E9-BFFD-E64E7AC5079F}"/>
               </a:ext>
             </a:extLst>
           </p:cNvPr>
@@ -12916,7 +12916,7 @@
           <p:cNvPr id="39" name="">
             <a:extLst xmlns:a="http://schemas.openxmlformats.org/drawingml/2006/main">
               <a:ext uri="{FF2B5EF4-FFF2-40B4-BE49-F238E27FC236}">
-                <a16:creationId xmlns:a16="http://schemas.microsoft.com/office/drawing/2014/main" id="{868DDF53-D03A-40E4-AD07-0B2CCA32B391}"/>
+                <a16:creationId xmlns:a16="http://schemas.microsoft.com/office/drawing/2014/main" id="{1BD53DA3-D287-451F-A35F-AAD1C8E0B15C}"/>
               </a:ext>
             </a:extLst>
           </p:cNvPr>
@@ -12949,7 +12949,7 @@
           <p:cNvPr id="40" name="">
             <a:extLst xmlns:a="http://schemas.openxmlformats.org/drawingml/2006/main">
               <a:ext uri="{FF2B5EF4-FFF2-40B4-BE49-F238E27FC236}">
-                <a16:creationId xmlns:a16="http://schemas.microsoft.com/office/drawing/2014/main" id="{1B62F586-4A48-428E-8656-48DF8F426D19}"/>
+                <a16:creationId xmlns:a16="http://schemas.microsoft.com/office/drawing/2014/main" id="{3C1346A8-2ACC-4C2B-970F-EB9F1FCBDCF2}"/>
               </a:ext>
             </a:extLst>
           </p:cNvPr>
@@ -13031,7 +13031,7 @@
     </p:spTree>
     <p:extLst>
       <p:ext uri="{BB962C8B-B14F-4D97-AF65-F5344CB8AC3E}">
-        <p14:creationId xmlns:p14="http://schemas.microsoft.com/office/powerpoint/2010/main" val="444714870"/>
+        <p14:creationId xmlns:p14="http://schemas.microsoft.com/office/powerpoint/2010/main" val="1523963759"/>
       </p:ext>
     </p:extLst>
   </p:cSld>

</xml_diff>

<commit_message>
docs: simplify video link field
</commit_message>
<xml_diff>
--- a/outputs/EGO1_Flappy_Bird_FPGA_8頁書面型PPT報告.pptx
+++ b/outputs/EGO1_Flappy_Bird_FPGA_8頁書面型PPT報告.pptx
@@ -2,20 +2,20 @@
 <file path=ppt/presentation.xml><?xml version="1.0" encoding="utf-8"?>
 <p:presentation xmlns:p="http://schemas.openxmlformats.org/presentationml/2006/main">
   <p:sldMasterIdLst>
-    <p:sldMasterId xmlns:r="http://schemas.openxmlformats.org/officeDocument/2006/relationships" id="2147483648" r:id="Rd286bfea39a748ac"/>
+    <p:sldMasterId xmlns:r="http://schemas.openxmlformats.org/officeDocument/2006/relationships" id="2147483648" r:id="R85ebbdc84f3c4e0d"/>
   </p:sldMasterIdLst>
   <p:notesMasterIdLst>
-    <p:notesMasterId xmlns:r="http://schemas.openxmlformats.org/officeDocument/2006/relationships" r:id="Rbb51c2d26b6e4c99"/>
+    <p:notesMasterId xmlns:r="http://schemas.openxmlformats.org/officeDocument/2006/relationships" r:id="Rc8f5f22c0faa493f"/>
   </p:notesMasterIdLst>
   <p:sldIdLst>
-    <p:sldId xmlns:r="http://schemas.openxmlformats.org/officeDocument/2006/relationships" id="256" r:id="R369adaf007e24c62"/>
-    <p:sldId xmlns:r="http://schemas.openxmlformats.org/officeDocument/2006/relationships" id="257" r:id="Rc589261598354f35"/>
-    <p:sldId xmlns:r="http://schemas.openxmlformats.org/officeDocument/2006/relationships" id="258" r:id="R63a94e11944c4423"/>
-    <p:sldId xmlns:r="http://schemas.openxmlformats.org/officeDocument/2006/relationships" id="259" r:id="Rc636348bf28d44a7"/>
-    <p:sldId xmlns:r="http://schemas.openxmlformats.org/officeDocument/2006/relationships" id="260" r:id="R6db266921e3f46b2"/>
-    <p:sldId xmlns:r="http://schemas.openxmlformats.org/officeDocument/2006/relationships" id="261" r:id="R28e3e798d071456a"/>
-    <p:sldId xmlns:r="http://schemas.openxmlformats.org/officeDocument/2006/relationships" id="262" r:id="R9a5a9f10904948e6"/>
-    <p:sldId xmlns:r="http://schemas.openxmlformats.org/officeDocument/2006/relationships" id="263" r:id="R8b15b70aac4b4f68"/>
+    <p:sldId xmlns:r="http://schemas.openxmlformats.org/officeDocument/2006/relationships" id="256" r:id="R05b213a607574e0f"/>
+    <p:sldId xmlns:r="http://schemas.openxmlformats.org/officeDocument/2006/relationships" id="257" r:id="Rbbb0e83c15dd4cce"/>
+    <p:sldId xmlns:r="http://schemas.openxmlformats.org/officeDocument/2006/relationships" id="258" r:id="R9820f7fade56408b"/>
+    <p:sldId xmlns:r="http://schemas.openxmlformats.org/officeDocument/2006/relationships" id="259" r:id="Rf9387d3b1b004bcd"/>
+    <p:sldId xmlns:r="http://schemas.openxmlformats.org/officeDocument/2006/relationships" id="260" r:id="R075fbfefa9c340d7"/>
+    <p:sldId xmlns:r="http://schemas.openxmlformats.org/officeDocument/2006/relationships" id="261" r:id="R84f95f499af64ace"/>
+    <p:sldId xmlns:r="http://schemas.openxmlformats.org/officeDocument/2006/relationships" id="262" r:id="R42c4fe5e0c76448e"/>
+    <p:sldId xmlns:r="http://schemas.openxmlformats.org/officeDocument/2006/relationships" id="263" r:id="Rdab3ddeab09a4f5d"/>
   </p:sldIdLst>
   <p:sldSz cx="12192000" cy="6858000"/>
   <p:notesSz cx="6858000" cy="9144000"/>
@@ -1070,7 +1070,7 @@
   </p:cSld>
   <p:clrMap bg1="lt1" tx1="dk1" bg2="lt2" tx2="dk2" accent1="accent1" accent2="accent2" accent3="accent3" accent4="accent4" accent5="accent5" accent6="accent6" hlink="hlink" folHlink="folHlink"/>
   <p:sldLayoutIdLst>
-    <p:sldLayoutId xmlns:r="http://schemas.openxmlformats.org/officeDocument/2006/relationships" id="2147483649" r:id="R81fc67e1a46e40fd"/>
+    <p:sldLayoutId xmlns:r="http://schemas.openxmlformats.org/officeDocument/2006/relationships" id="2147483649" r:id="Rba41b5d1dcef4358"/>
   </p:sldLayoutIdLst>
   <p:txStyles>
     <p:titleStyle>
@@ -1621,7 +1621,7 @@
           <p:cNvPr id="17" name="">
             <a:extLst xmlns:a="http://schemas.openxmlformats.org/drawingml/2006/main">
               <a:ext uri="{FF2B5EF4-FFF2-40B4-BE49-F238E27FC236}">
-                <a16:creationId xmlns:a16="http://schemas.microsoft.com/office/drawing/2014/main" id="{D89AA233-1298-465C-B4DD-9E100AE5EB4F}"/>
+                <a16:creationId xmlns:a16="http://schemas.microsoft.com/office/drawing/2014/main" id="{F46EF24D-0269-4F44-A8DD-FD1D4D718B19}"/>
               </a:ext>
             </a:extLst>
           </p:cNvPr>
@@ -1688,7 +1688,7 @@
           <p:cNvPr id="2" name="">
             <a:extLst xmlns:a="http://schemas.openxmlformats.org/drawingml/2006/main">
               <a:ext uri="{FF2B5EF4-FFF2-40B4-BE49-F238E27FC236}">
-                <a16:creationId xmlns:a16="http://schemas.microsoft.com/office/drawing/2014/main" id="{0D777F2A-8BD5-4D3F-A451-0D1E4C1E43C1}"/>
+                <a16:creationId xmlns:a16="http://schemas.microsoft.com/office/drawing/2014/main" id="{C035E261-E5D1-42CC-BA88-BC4D62D00773}"/>
               </a:ext>
             </a:extLst>
           </p:cNvPr>
@@ -1738,7 +1738,7 @@
           <p:cNvPr id="3" name="">
             <a:extLst xmlns:a="http://schemas.openxmlformats.org/drawingml/2006/main">
               <a:ext uri="{FF2B5EF4-FFF2-40B4-BE49-F238E27FC236}">
-                <a16:creationId xmlns:a16="http://schemas.microsoft.com/office/drawing/2014/main" id="{5C9E0E99-E9BF-4987-9330-D0698088799D}"/>
+                <a16:creationId xmlns:a16="http://schemas.microsoft.com/office/drawing/2014/main" id="{D86ECC40-E641-4E3B-90EC-96C049A53E0E}"/>
               </a:ext>
             </a:extLst>
           </p:cNvPr>
@@ -1788,7 +1788,7 @@
           <p:cNvPr id="4" name="">
             <a:extLst xmlns:a="http://schemas.openxmlformats.org/drawingml/2006/main">
               <a:ext uri="{FF2B5EF4-FFF2-40B4-BE49-F238E27FC236}">
-                <a16:creationId xmlns:a16="http://schemas.microsoft.com/office/drawing/2014/main" id="{C8152007-3224-4509-B492-79AF60548CE9}"/>
+                <a16:creationId xmlns:a16="http://schemas.microsoft.com/office/drawing/2014/main" id="{E72CF39D-5FF7-422C-8660-8FA5486AC9D0}"/>
               </a:ext>
             </a:extLst>
           </p:cNvPr>
@@ -1838,7 +1838,7 @@
           <p:cNvPr id="5" name="">
             <a:extLst xmlns:a="http://schemas.openxmlformats.org/drawingml/2006/main">
               <a:ext uri="{FF2B5EF4-FFF2-40B4-BE49-F238E27FC236}">
-                <a16:creationId xmlns:a16="http://schemas.microsoft.com/office/drawing/2014/main" id="{B791F91F-6D67-4137-BD04-307B44191803}"/>
+                <a16:creationId xmlns:a16="http://schemas.microsoft.com/office/drawing/2014/main" id="{9EC1511A-AE85-4DC2-8078-81A12BC238C1}"/>
               </a:ext>
             </a:extLst>
           </p:cNvPr>
@@ -1888,7 +1888,7 @@
           <p:cNvPr id="6" name="">
             <a:extLst xmlns:a="http://schemas.openxmlformats.org/drawingml/2006/main">
               <a:ext uri="{FF2B5EF4-FFF2-40B4-BE49-F238E27FC236}">
-                <a16:creationId xmlns:a16="http://schemas.microsoft.com/office/drawing/2014/main" id="{46AD8B77-171D-4D50-9319-61241C1834F8}"/>
+                <a16:creationId xmlns:a16="http://schemas.microsoft.com/office/drawing/2014/main" id="{56D01323-D867-4DF8-8658-F32CCC873597}"/>
               </a:ext>
             </a:extLst>
           </p:cNvPr>
@@ -1938,7 +1938,7 @@
           <p:cNvPr id="7" name="">
             <a:extLst xmlns:a="http://schemas.openxmlformats.org/drawingml/2006/main">
               <a:ext uri="{FF2B5EF4-FFF2-40B4-BE49-F238E27FC236}">
-                <a16:creationId xmlns:a16="http://schemas.microsoft.com/office/drawing/2014/main" id="{984C200A-CBC2-4A9E-9815-38C9A448FE1F}"/>
+                <a16:creationId xmlns:a16="http://schemas.microsoft.com/office/drawing/2014/main" id="{85E34D44-5130-4DE6-9DAE-F0C024CB7AEB}"/>
               </a:ext>
             </a:extLst>
           </p:cNvPr>
@@ -1988,7 +1988,7 @@
           <p:cNvPr id="8" name="">
             <a:extLst xmlns:a="http://schemas.openxmlformats.org/drawingml/2006/main">
               <a:ext uri="{FF2B5EF4-FFF2-40B4-BE49-F238E27FC236}">
-                <a16:creationId xmlns:a16="http://schemas.microsoft.com/office/drawing/2014/main" id="{DC5F3AB3-83AE-4561-9653-15E25910F240}"/>
+                <a16:creationId xmlns:a16="http://schemas.microsoft.com/office/drawing/2014/main" id="{C0D7CB71-68DC-4BFE-873B-FBBD943C9E0F}"/>
               </a:ext>
             </a:extLst>
           </p:cNvPr>
@@ -2021,7 +2021,7 @@
           <p:cNvPr id="9" name="">
             <a:extLst xmlns:a="http://schemas.openxmlformats.org/drawingml/2006/main">
               <a:ext uri="{FF2B5EF4-FFF2-40B4-BE49-F238E27FC236}">
-                <a16:creationId xmlns:a16="http://schemas.microsoft.com/office/drawing/2014/main" id="{59ED1488-4CC5-48A2-95E9-EDF41E861998}"/>
+                <a16:creationId xmlns:a16="http://schemas.microsoft.com/office/drawing/2014/main" id="{21C08C6F-D6E6-432C-8D7D-CD587E68D5B9}"/>
               </a:ext>
             </a:extLst>
           </p:cNvPr>
@@ -2088,7 +2088,7 @@
           <p:cNvPr id="10" name="">
             <a:extLst xmlns:a="http://schemas.openxmlformats.org/drawingml/2006/main">
               <a:ext uri="{FF2B5EF4-FFF2-40B4-BE49-F238E27FC236}">
-                <a16:creationId xmlns:a16="http://schemas.microsoft.com/office/drawing/2014/main" id="{4716BC6D-1DE9-4E24-B646-F5B04E0CB676}"/>
+                <a16:creationId xmlns:a16="http://schemas.microsoft.com/office/drawing/2014/main" id="{490A18A5-3309-425E-A117-E5CCD9B759F0}"/>
               </a:ext>
             </a:extLst>
           </p:cNvPr>
@@ -2121,7 +2121,7 @@
           <p:cNvPr id="11" name="">
             <a:extLst xmlns:a="http://schemas.openxmlformats.org/drawingml/2006/main">
               <a:ext uri="{FF2B5EF4-FFF2-40B4-BE49-F238E27FC236}">
-                <a16:creationId xmlns:a16="http://schemas.microsoft.com/office/drawing/2014/main" id="{4054A982-8FB4-4BD8-8688-8E372FF28B88}"/>
+                <a16:creationId xmlns:a16="http://schemas.microsoft.com/office/drawing/2014/main" id="{58CE4695-7313-457F-A6FA-8F17FAC10B21}"/>
               </a:ext>
             </a:extLst>
           </p:cNvPr>
@@ -2188,7 +2188,7 @@
           <p:cNvPr id="12" name="">
             <a:extLst xmlns:a="http://schemas.openxmlformats.org/drawingml/2006/main">
               <a:ext uri="{FF2B5EF4-FFF2-40B4-BE49-F238E27FC236}">
-                <a16:creationId xmlns:a16="http://schemas.microsoft.com/office/drawing/2014/main" id="{8DD6A19B-D270-4DA5-AC17-27EA54B58D69}"/>
+                <a16:creationId xmlns:a16="http://schemas.microsoft.com/office/drawing/2014/main" id="{4B57ED62-CAED-4E3A-97F9-3A5EAA4EF1B5}"/>
               </a:ext>
             </a:extLst>
           </p:cNvPr>
@@ -2221,7 +2221,7 @@
           <p:cNvPr id="13" name="">
             <a:extLst xmlns:a="http://schemas.openxmlformats.org/drawingml/2006/main">
               <a:ext uri="{FF2B5EF4-FFF2-40B4-BE49-F238E27FC236}">
-                <a16:creationId xmlns:a16="http://schemas.microsoft.com/office/drawing/2014/main" id="{3BACCD1D-2A37-453D-BA60-B04A3E11CE24}"/>
+                <a16:creationId xmlns:a16="http://schemas.microsoft.com/office/drawing/2014/main" id="{73D5C423-20DB-4730-BB4A-2A5FB46A980E}"/>
               </a:ext>
             </a:extLst>
           </p:cNvPr>
@@ -2288,7 +2288,7 @@
           <p:cNvPr id="14" name="">
             <a:extLst xmlns:a="http://schemas.openxmlformats.org/drawingml/2006/main">
               <a:ext uri="{FF2B5EF4-FFF2-40B4-BE49-F238E27FC236}">
-                <a16:creationId xmlns:a16="http://schemas.microsoft.com/office/drawing/2014/main" id="{F65C2C0A-6521-4006-941A-6538B6419ADC}"/>
+                <a16:creationId xmlns:a16="http://schemas.microsoft.com/office/drawing/2014/main" id="{9788711F-0E70-45BF-9D6F-AE3D7A42B638}"/>
               </a:ext>
             </a:extLst>
           </p:cNvPr>
@@ -2321,7 +2321,7 @@
           <p:cNvPr id="15" name="">
             <a:extLst xmlns:a="http://schemas.openxmlformats.org/drawingml/2006/main">
               <a:ext uri="{FF2B5EF4-FFF2-40B4-BE49-F238E27FC236}">
-                <a16:creationId xmlns:a16="http://schemas.microsoft.com/office/drawing/2014/main" id="{14F88AE0-1F9C-47E3-B671-4919352644BB}"/>
+                <a16:creationId xmlns:a16="http://schemas.microsoft.com/office/drawing/2014/main" id="{032D8EAD-B9B2-4350-9DE2-117B58CD3FBA}"/>
               </a:ext>
             </a:extLst>
           </p:cNvPr>
@@ -2388,7 +2388,7 @@
           <p:cNvPr id="16" name="">
             <a:extLst xmlns:a="http://schemas.openxmlformats.org/drawingml/2006/main">
               <a:ext uri="{FF2B5EF4-FFF2-40B4-BE49-F238E27FC236}">
-                <a16:creationId xmlns:a16="http://schemas.microsoft.com/office/drawing/2014/main" id="{EA7C04C5-332E-44B9-BDF4-1F5AF0F5E17E}"/>
+                <a16:creationId xmlns:a16="http://schemas.microsoft.com/office/drawing/2014/main" id="{D225635C-7CD5-4AC9-A82F-38B49D5028DF}"/>
               </a:ext>
             </a:extLst>
           </p:cNvPr>
@@ -2436,7 +2436,7 @@
     </p:spTree>
     <p:extLst>
       <p:ext uri="{BB962C8B-B14F-4D97-AF65-F5344CB8AC3E}">
-        <p14:creationId xmlns:p14="http://schemas.microsoft.com/office/powerpoint/2010/main" val="1978631214"/>
+        <p14:creationId xmlns:p14="http://schemas.microsoft.com/office/powerpoint/2010/main" val="1439702434"/>
       </p:ext>
     </p:extLst>
   </p:cSld>
@@ -2467,7 +2467,7 @@
           <p:cNvPr id="43" name="">
             <a:extLst xmlns:a="http://schemas.openxmlformats.org/drawingml/2006/main">
               <a:ext uri="{FF2B5EF4-FFF2-40B4-BE49-F238E27FC236}">
-                <a16:creationId xmlns:a16="http://schemas.microsoft.com/office/drawing/2014/main" id="{EB35BCFC-C5E0-4E39-B211-2926771E38A7}"/>
+                <a16:creationId xmlns:a16="http://schemas.microsoft.com/office/drawing/2014/main" id="{3FA64805-9634-4CF4-A1EF-A2BEF8B8F0FB}"/>
               </a:ext>
             </a:extLst>
           </p:cNvPr>
@@ -2517,7 +2517,7 @@
           <p:cNvPr id="2" name="">
             <a:extLst xmlns:a="http://schemas.openxmlformats.org/drawingml/2006/main">
               <a:ext uri="{FF2B5EF4-FFF2-40B4-BE49-F238E27FC236}">
-                <a16:creationId xmlns:a16="http://schemas.microsoft.com/office/drawing/2014/main" id="{38394E48-D1AF-4173-83EA-9B0F4FF08589}"/>
+                <a16:creationId xmlns:a16="http://schemas.microsoft.com/office/drawing/2014/main" id="{4D1A95EE-7B0B-457B-891F-9F394C60E26E}"/>
               </a:ext>
             </a:extLst>
           </p:cNvPr>
@@ -2567,7 +2567,7 @@
           <p:cNvPr id="3" name="">
             <a:extLst xmlns:a="http://schemas.openxmlformats.org/drawingml/2006/main">
               <a:ext uri="{FF2B5EF4-FFF2-40B4-BE49-F238E27FC236}">
-                <a16:creationId xmlns:a16="http://schemas.microsoft.com/office/drawing/2014/main" id="{CA520ADF-E852-4BF9-A88D-AEB829AD2DD5}"/>
+                <a16:creationId xmlns:a16="http://schemas.microsoft.com/office/drawing/2014/main" id="{68CE0315-0D90-4B60-AF8A-A3219BD811B8}"/>
               </a:ext>
             </a:extLst>
           </p:cNvPr>
@@ -2600,7 +2600,7 @@
           <p:cNvPr id="4" name="">
             <a:extLst xmlns:a="http://schemas.openxmlformats.org/drawingml/2006/main">
               <a:ext uri="{FF2B5EF4-FFF2-40B4-BE49-F238E27FC236}">
-                <a16:creationId xmlns:a16="http://schemas.microsoft.com/office/drawing/2014/main" id="{FA1D7847-3210-43B5-AAF0-9E3170876B20}"/>
+                <a16:creationId xmlns:a16="http://schemas.microsoft.com/office/drawing/2014/main" id="{D8114CA4-EA93-4A5C-84DB-5F6179283372}"/>
               </a:ext>
             </a:extLst>
           </p:cNvPr>
@@ -2650,7 +2650,7 @@
           <p:cNvPr id="5" name="">
             <a:extLst xmlns:a="http://schemas.openxmlformats.org/drawingml/2006/main">
               <a:ext uri="{FF2B5EF4-FFF2-40B4-BE49-F238E27FC236}">
-                <a16:creationId xmlns:a16="http://schemas.microsoft.com/office/drawing/2014/main" id="{4A69A30A-B7BF-447E-AB0A-E6BB1429DC31}"/>
+                <a16:creationId xmlns:a16="http://schemas.microsoft.com/office/drawing/2014/main" id="{A738ADCD-760B-460B-9A74-4720E48ED507}"/>
               </a:ext>
             </a:extLst>
           </p:cNvPr>
@@ -2683,7 +2683,7 @@
           <p:cNvPr id="6" name="">
             <a:extLst xmlns:a="http://schemas.openxmlformats.org/drawingml/2006/main">
               <a:ext uri="{FF2B5EF4-FFF2-40B4-BE49-F238E27FC236}">
-                <a16:creationId xmlns:a16="http://schemas.microsoft.com/office/drawing/2014/main" id="{F370DEFF-2537-4B31-ADCA-64826D0A9D49}"/>
+                <a16:creationId xmlns:a16="http://schemas.microsoft.com/office/drawing/2014/main" id="{5251623B-C2E7-41BF-8D26-1AFDBAD3FCF4}"/>
               </a:ext>
             </a:extLst>
           </p:cNvPr>
@@ -2716,7 +2716,7 @@
           <p:cNvPr id="7" name="">
             <a:extLst xmlns:a="http://schemas.openxmlformats.org/drawingml/2006/main">
               <a:ext uri="{FF2B5EF4-FFF2-40B4-BE49-F238E27FC236}">
-                <a16:creationId xmlns:a16="http://schemas.microsoft.com/office/drawing/2014/main" id="{4A03DCCD-C751-411B-818E-9022E7BBF58E}"/>
+                <a16:creationId xmlns:a16="http://schemas.microsoft.com/office/drawing/2014/main" id="{48AFAF1F-84AE-4C0D-BF8F-E5E861C7020F}"/>
               </a:ext>
             </a:extLst>
           </p:cNvPr>
@@ -2766,7 +2766,7 @@
           <p:cNvPr id="8" name="">
             <a:extLst xmlns:a="http://schemas.openxmlformats.org/drawingml/2006/main">
               <a:ext uri="{FF2B5EF4-FFF2-40B4-BE49-F238E27FC236}">
-                <a16:creationId xmlns:a16="http://schemas.microsoft.com/office/drawing/2014/main" id="{65A8F722-E748-4BDA-A524-EABB19C1AD15}"/>
+                <a16:creationId xmlns:a16="http://schemas.microsoft.com/office/drawing/2014/main" id="{070F560B-9267-4720-BC4D-C33C3C04372B}"/>
               </a:ext>
             </a:extLst>
           </p:cNvPr>
@@ -2816,7 +2816,7 @@
           <p:cNvPr id="9" name="">
             <a:extLst xmlns:a="http://schemas.openxmlformats.org/drawingml/2006/main">
               <a:ext uri="{FF2B5EF4-FFF2-40B4-BE49-F238E27FC236}">
-                <a16:creationId xmlns:a16="http://schemas.microsoft.com/office/drawing/2014/main" id="{EE3F336C-E6F7-4D85-9733-DBADC283821B}"/>
+                <a16:creationId xmlns:a16="http://schemas.microsoft.com/office/drawing/2014/main" id="{BAC346DC-47B7-4439-8057-3FFD2C02C42C}"/>
               </a:ext>
             </a:extLst>
           </p:cNvPr>
@@ -2849,7 +2849,7 @@
           <p:cNvPr id="10" name="">
             <a:extLst xmlns:a="http://schemas.openxmlformats.org/drawingml/2006/main">
               <a:ext uri="{FF2B5EF4-FFF2-40B4-BE49-F238E27FC236}">
-                <a16:creationId xmlns:a16="http://schemas.microsoft.com/office/drawing/2014/main" id="{8E2EEFE3-23EB-4C24-A198-FC446D13835B}"/>
+                <a16:creationId xmlns:a16="http://schemas.microsoft.com/office/drawing/2014/main" id="{F848FBA1-FA06-4E91-A6E1-1C88051CE647}"/>
               </a:ext>
             </a:extLst>
           </p:cNvPr>
@@ -2882,7 +2882,7 @@
           <p:cNvPr id="11" name="">
             <a:extLst xmlns:a="http://schemas.openxmlformats.org/drawingml/2006/main">
               <a:ext uri="{FF2B5EF4-FFF2-40B4-BE49-F238E27FC236}">
-                <a16:creationId xmlns:a16="http://schemas.microsoft.com/office/drawing/2014/main" id="{05FE4A07-D874-4DD3-BC44-F72B97F2F0E5}"/>
+                <a16:creationId xmlns:a16="http://schemas.microsoft.com/office/drawing/2014/main" id="{ACF99C94-4575-4839-B452-3E0AC7520F1B}"/>
               </a:ext>
             </a:extLst>
           </p:cNvPr>
@@ -2932,7 +2932,7 @@
           <p:cNvPr id="12" name="">
             <a:extLst xmlns:a="http://schemas.openxmlformats.org/drawingml/2006/main">
               <a:ext uri="{FF2B5EF4-FFF2-40B4-BE49-F238E27FC236}">
-                <a16:creationId xmlns:a16="http://schemas.microsoft.com/office/drawing/2014/main" id="{AF6A6EFA-316B-405D-AA83-1FC75C50C8A6}"/>
+                <a16:creationId xmlns:a16="http://schemas.microsoft.com/office/drawing/2014/main" id="{3FDF74B4-E2B9-428C-86DF-7B55C55B28E5}"/>
               </a:ext>
             </a:extLst>
           </p:cNvPr>
@@ -2982,7 +2982,7 @@
           <p:cNvPr id="13" name="">
             <a:extLst xmlns:a="http://schemas.openxmlformats.org/drawingml/2006/main">
               <a:ext uri="{FF2B5EF4-FFF2-40B4-BE49-F238E27FC236}">
-                <a16:creationId xmlns:a16="http://schemas.microsoft.com/office/drawing/2014/main" id="{B26BDA53-0501-4347-A09D-5F877B49741D}"/>
+                <a16:creationId xmlns:a16="http://schemas.microsoft.com/office/drawing/2014/main" id="{A0127278-E905-48CC-8159-C1923AD834C3}"/>
               </a:ext>
             </a:extLst>
           </p:cNvPr>
@@ -3015,7 +3015,7 @@
           <p:cNvPr id="14" name="">
             <a:extLst xmlns:a="http://schemas.openxmlformats.org/drawingml/2006/main">
               <a:ext uri="{FF2B5EF4-FFF2-40B4-BE49-F238E27FC236}">
-                <a16:creationId xmlns:a16="http://schemas.microsoft.com/office/drawing/2014/main" id="{0B9C157B-CD4D-4771-9BA7-066BBE9ED87C}"/>
+                <a16:creationId xmlns:a16="http://schemas.microsoft.com/office/drawing/2014/main" id="{8B9888EE-EEDB-4F07-9574-226C6017666A}"/>
               </a:ext>
             </a:extLst>
           </p:cNvPr>
@@ -3048,7 +3048,7 @@
           <p:cNvPr id="15" name="">
             <a:extLst xmlns:a="http://schemas.openxmlformats.org/drawingml/2006/main">
               <a:ext uri="{FF2B5EF4-FFF2-40B4-BE49-F238E27FC236}">
-                <a16:creationId xmlns:a16="http://schemas.microsoft.com/office/drawing/2014/main" id="{410EB1D1-8898-4C4B-8C44-8C7C11924BC7}"/>
+                <a16:creationId xmlns:a16="http://schemas.microsoft.com/office/drawing/2014/main" id="{5650DA96-C8DD-4975-8FB1-DE1649A38EFD}"/>
               </a:ext>
             </a:extLst>
           </p:cNvPr>
@@ -3098,7 +3098,7 @@
           <p:cNvPr id="16" name="">
             <a:extLst xmlns:a="http://schemas.openxmlformats.org/drawingml/2006/main">
               <a:ext uri="{FF2B5EF4-FFF2-40B4-BE49-F238E27FC236}">
-                <a16:creationId xmlns:a16="http://schemas.microsoft.com/office/drawing/2014/main" id="{738F2AA5-E267-479E-8EA3-773F3A6CDCAA}"/>
+                <a16:creationId xmlns:a16="http://schemas.microsoft.com/office/drawing/2014/main" id="{5E9E0316-1F22-421B-9E16-F0E73E3EDF28}"/>
               </a:ext>
             </a:extLst>
           </p:cNvPr>
@@ -3148,7 +3148,7 @@
           <p:cNvPr id="17" name="">
             <a:extLst xmlns:a="http://schemas.openxmlformats.org/drawingml/2006/main">
               <a:ext uri="{FF2B5EF4-FFF2-40B4-BE49-F238E27FC236}">
-                <a16:creationId xmlns:a16="http://schemas.microsoft.com/office/drawing/2014/main" id="{F66A0D7C-D635-42AE-ADF3-24B816387573}"/>
+                <a16:creationId xmlns:a16="http://schemas.microsoft.com/office/drawing/2014/main" id="{A4DA9179-F1C5-4D68-8179-38E99BDD0BED}"/>
               </a:ext>
             </a:extLst>
           </p:cNvPr>
@@ -3181,7 +3181,7 @@
           <p:cNvPr id="18" name="">
             <a:extLst xmlns:a="http://schemas.openxmlformats.org/drawingml/2006/main">
               <a:ext uri="{FF2B5EF4-FFF2-40B4-BE49-F238E27FC236}">
-                <a16:creationId xmlns:a16="http://schemas.microsoft.com/office/drawing/2014/main" id="{34F8A573-47E8-4AFD-A062-B04C0E33B919}"/>
+                <a16:creationId xmlns:a16="http://schemas.microsoft.com/office/drawing/2014/main" id="{8F8004E6-8441-4FAB-BE5C-1445EAC4D7DE}"/>
               </a:ext>
             </a:extLst>
           </p:cNvPr>
@@ -3231,7 +3231,7 @@
           <p:cNvPr id="19" name="">
             <a:extLst xmlns:a="http://schemas.openxmlformats.org/drawingml/2006/main">
               <a:ext uri="{FF2B5EF4-FFF2-40B4-BE49-F238E27FC236}">
-                <a16:creationId xmlns:a16="http://schemas.microsoft.com/office/drawing/2014/main" id="{AA25000F-C888-461F-B566-BD46C76DCECD}"/>
+                <a16:creationId xmlns:a16="http://schemas.microsoft.com/office/drawing/2014/main" id="{686D064D-2E94-4D18-A612-D4FB4F427D47}"/>
               </a:ext>
             </a:extLst>
           </p:cNvPr>
@@ -3281,7 +3281,7 @@
           <p:cNvPr id="20" name="">
             <a:extLst xmlns:a="http://schemas.openxmlformats.org/drawingml/2006/main">
               <a:ext uri="{FF2B5EF4-FFF2-40B4-BE49-F238E27FC236}">
-                <a16:creationId xmlns:a16="http://schemas.microsoft.com/office/drawing/2014/main" id="{FBBE0579-EE18-4C23-9C7C-8370D7EA00F3}"/>
+                <a16:creationId xmlns:a16="http://schemas.microsoft.com/office/drawing/2014/main" id="{45B2D16D-D459-4A74-B610-C2C1BC38E783}"/>
               </a:ext>
             </a:extLst>
           </p:cNvPr>
@@ -3314,7 +3314,7 @@
           <p:cNvPr id="21" name="">
             <a:extLst xmlns:a="http://schemas.openxmlformats.org/drawingml/2006/main">
               <a:ext uri="{FF2B5EF4-FFF2-40B4-BE49-F238E27FC236}">
-                <a16:creationId xmlns:a16="http://schemas.microsoft.com/office/drawing/2014/main" id="{90B92372-299C-4FAA-B074-4A2F420174E4}"/>
+                <a16:creationId xmlns:a16="http://schemas.microsoft.com/office/drawing/2014/main" id="{65BAA40E-BF01-4F75-8859-B664E3C839AB}"/>
               </a:ext>
             </a:extLst>
           </p:cNvPr>
@@ -3364,7 +3364,7 @@
           <p:cNvPr id="22" name="">
             <a:extLst xmlns:a="http://schemas.openxmlformats.org/drawingml/2006/main">
               <a:ext uri="{FF2B5EF4-FFF2-40B4-BE49-F238E27FC236}">
-                <a16:creationId xmlns:a16="http://schemas.microsoft.com/office/drawing/2014/main" id="{589F4367-7357-4E0C-AC22-07C09DD9E761}"/>
+                <a16:creationId xmlns:a16="http://schemas.microsoft.com/office/drawing/2014/main" id="{A50176C6-6679-4ED7-BF38-2574CA31C9B6}"/>
               </a:ext>
             </a:extLst>
           </p:cNvPr>
@@ -3414,7 +3414,7 @@
           <p:cNvPr id="23" name="">
             <a:extLst xmlns:a="http://schemas.openxmlformats.org/drawingml/2006/main">
               <a:ext uri="{FF2B5EF4-FFF2-40B4-BE49-F238E27FC236}">
-                <a16:creationId xmlns:a16="http://schemas.microsoft.com/office/drawing/2014/main" id="{96C15CF0-9C4F-4C76-B6D9-CD89283ACEE1}"/>
+                <a16:creationId xmlns:a16="http://schemas.microsoft.com/office/drawing/2014/main" id="{D181EADF-F56E-4F80-BD3E-0DEF2BA8B506}"/>
               </a:ext>
             </a:extLst>
           </p:cNvPr>
@@ -3447,7 +3447,7 @@
           <p:cNvPr id="24" name="">
             <a:extLst xmlns:a="http://schemas.openxmlformats.org/drawingml/2006/main">
               <a:ext uri="{FF2B5EF4-FFF2-40B4-BE49-F238E27FC236}">
-                <a16:creationId xmlns:a16="http://schemas.microsoft.com/office/drawing/2014/main" id="{F353E2D7-1E51-468B-9963-2D0762779345}"/>
+                <a16:creationId xmlns:a16="http://schemas.microsoft.com/office/drawing/2014/main" id="{E51DC7AF-3954-47CB-8A77-E2E5A25BAB5B}"/>
               </a:ext>
             </a:extLst>
           </p:cNvPr>
@@ -3497,7 +3497,7 @@
           <p:cNvPr id="25" name="">
             <a:extLst xmlns:a="http://schemas.openxmlformats.org/drawingml/2006/main">
               <a:ext uri="{FF2B5EF4-FFF2-40B4-BE49-F238E27FC236}">
-                <a16:creationId xmlns:a16="http://schemas.microsoft.com/office/drawing/2014/main" id="{1EC482D3-EFC8-42AC-99AA-5DB1C7E6DDFE}"/>
+                <a16:creationId xmlns:a16="http://schemas.microsoft.com/office/drawing/2014/main" id="{FF846FE4-6FF8-4347-A161-93914DCDCFF6}"/>
               </a:ext>
             </a:extLst>
           </p:cNvPr>
@@ -3547,7 +3547,7 @@
           <p:cNvPr id="26" name="">
             <a:extLst xmlns:a="http://schemas.openxmlformats.org/drawingml/2006/main">
               <a:ext uri="{FF2B5EF4-FFF2-40B4-BE49-F238E27FC236}">
-                <a16:creationId xmlns:a16="http://schemas.microsoft.com/office/drawing/2014/main" id="{CE6214DF-CAF8-407D-B882-FD7AB1B4329E}"/>
+                <a16:creationId xmlns:a16="http://schemas.microsoft.com/office/drawing/2014/main" id="{CC2B35E6-F1CB-4D90-BCF4-E4BF217D5418}"/>
               </a:ext>
             </a:extLst>
           </p:cNvPr>
@@ -3580,7 +3580,7 @@
           <p:cNvPr id="27" name="">
             <a:extLst xmlns:a="http://schemas.openxmlformats.org/drawingml/2006/main">
               <a:ext uri="{FF2B5EF4-FFF2-40B4-BE49-F238E27FC236}">
-                <a16:creationId xmlns:a16="http://schemas.microsoft.com/office/drawing/2014/main" id="{765BFE61-96F6-4029-AEC1-9F8812832ACF}"/>
+                <a16:creationId xmlns:a16="http://schemas.microsoft.com/office/drawing/2014/main" id="{0FC156BF-2313-45CC-99E2-310F76B573B3}"/>
               </a:ext>
             </a:extLst>
           </p:cNvPr>
@@ -3630,7 +3630,7 @@
           <p:cNvPr id="28" name="">
             <a:extLst xmlns:a="http://schemas.openxmlformats.org/drawingml/2006/main">
               <a:ext uri="{FF2B5EF4-FFF2-40B4-BE49-F238E27FC236}">
-                <a16:creationId xmlns:a16="http://schemas.microsoft.com/office/drawing/2014/main" id="{067D7286-BD18-4C29-AF82-1F60BD5D2A45}"/>
+                <a16:creationId xmlns:a16="http://schemas.microsoft.com/office/drawing/2014/main" id="{970AE9A1-7725-4F5A-93ED-077294D4586B}"/>
               </a:ext>
             </a:extLst>
           </p:cNvPr>
@@ -3680,7 +3680,7 @@
           <p:cNvPr id="29" name="">
             <a:extLst xmlns:a="http://schemas.openxmlformats.org/drawingml/2006/main">
               <a:ext uri="{FF2B5EF4-FFF2-40B4-BE49-F238E27FC236}">
-                <a16:creationId xmlns:a16="http://schemas.microsoft.com/office/drawing/2014/main" id="{FD242475-3EBB-4343-96AD-696A3DB0DE39}"/>
+                <a16:creationId xmlns:a16="http://schemas.microsoft.com/office/drawing/2014/main" id="{C5F43AD4-5376-49F5-9970-3D09C5216805}"/>
               </a:ext>
             </a:extLst>
           </p:cNvPr>
@@ -3713,7 +3713,7 @@
           <p:cNvPr id="30" name="">
             <a:extLst xmlns:a="http://schemas.openxmlformats.org/drawingml/2006/main">
               <a:ext uri="{FF2B5EF4-FFF2-40B4-BE49-F238E27FC236}">
-                <a16:creationId xmlns:a16="http://schemas.microsoft.com/office/drawing/2014/main" id="{E3BA9277-8CE0-427C-8571-FF923A76AA74}"/>
+                <a16:creationId xmlns:a16="http://schemas.microsoft.com/office/drawing/2014/main" id="{7EB800D6-5803-49C0-8E84-44E21F3C8383}"/>
               </a:ext>
             </a:extLst>
           </p:cNvPr>
@@ -3763,7 +3763,7 @@
           <p:cNvPr id="31" name="">
             <a:extLst xmlns:a="http://schemas.openxmlformats.org/drawingml/2006/main">
               <a:ext uri="{FF2B5EF4-FFF2-40B4-BE49-F238E27FC236}">
-                <a16:creationId xmlns:a16="http://schemas.microsoft.com/office/drawing/2014/main" id="{3C4A650A-5149-449A-BA85-302BC8ED019C}"/>
+                <a16:creationId xmlns:a16="http://schemas.microsoft.com/office/drawing/2014/main" id="{F0B67EEE-D756-4602-932F-8C104D3A6D50}"/>
               </a:ext>
             </a:extLst>
           </p:cNvPr>
@@ -3813,7 +3813,7 @@
           <p:cNvPr id="32" name="">
             <a:extLst xmlns:a="http://schemas.openxmlformats.org/drawingml/2006/main">
               <a:ext uri="{FF2B5EF4-FFF2-40B4-BE49-F238E27FC236}">
-                <a16:creationId xmlns:a16="http://schemas.microsoft.com/office/drawing/2014/main" id="{9642AF23-1FBB-46D9-AD52-950F6102727A}"/>
+                <a16:creationId xmlns:a16="http://schemas.microsoft.com/office/drawing/2014/main" id="{8BED0AA9-4D95-4B03-A8FC-D0515D6D4361}"/>
               </a:ext>
             </a:extLst>
           </p:cNvPr>
@@ -3846,7 +3846,7 @@
           <p:cNvPr id="33" name="">
             <a:extLst xmlns:a="http://schemas.openxmlformats.org/drawingml/2006/main">
               <a:ext uri="{FF2B5EF4-FFF2-40B4-BE49-F238E27FC236}">
-                <a16:creationId xmlns:a16="http://schemas.microsoft.com/office/drawing/2014/main" id="{4075CF12-7FC6-43C3-90E1-3601E46C5471}"/>
+                <a16:creationId xmlns:a16="http://schemas.microsoft.com/office/drawing/2014/main" id="{3036320B-01B5-40EB-8EFB-21805610D2AA}"/>
               </a:ext>
             </a:extLst>
           </p:cNvPr>
@@ -3896,7 +3896,7 @@
           <p:cNvPr id="34" name="">
             <a:extLst xmlns:a="http://schemas.openxmlformats.org/drawingml/2006/main">
               <a:ext uri="{FF2B5EF4-FFF2-40B4-BE49-F238E27FC236}">
-                <a16:creationId xmlns:a16="http://schemas.microsoft.com/office/drawing/2014/main" id="{32F35F80-FD02-43CB-9495-A5333A125DF6}"/>
+                <a16:creationId xmlns:a16="http://schemas.microsoft.com/office/drawing/2014/main" id="{93B378A2-245F-48C5-8AA5-A5EA8928E21B}"/>
               </a:ext>
             </a:extLst>
           </p:cNvPr>
@@ -3946,7 +3946,7 @@
           <p:cNvPr id="35" name="">
             <a:extLst xmlns:a="http://schemas.openxmlformats.org/drawingml/2006/main">
               <a:ext uri="{FF2B5EF4-FFF2-40B4-BE49-F238E27FC236}">
-                <a16:creationId xmlns:a16="http://schemas.microsoft.com/office/drawing/2014/main" id="{2A2AB9A7-BC9C-4257-A560-132F76574B06}"/>
+                <a16:creationId xmlns:a16="http://schemas.microsoft.com/office/drawing/2014/main" id="{CBCE89CD-58F3-4D19-B0D7-8E4414A308F6}"/>
               </a:ext>
             </a:extLst>
           </p:cNvPr>
@@ -3979,7 +3979,7 @@
           <p:cNvPr id="36" name="">
             <a:extLst xmlns:a="http://schemas.openxmlformats.org/drawingml/2006/main">
               <a:ext uri="{FF2B5EF4-FFF2-40B4-BE49-F238E27FC236}">
-                <a16:creationId xmlns:a16="http://schemas.microsoft.com/office/drawing/2014/main" id="{EDDFA91F-0FD2-4B3E-A9D0-D0B7DC374A85}"/>
+                <a16:creationId xmlns:a16="http://schemas.microsoft.com/office/drawing/2014/main" id="{CBF17FF2-A5AC-431A-9F4F-1E074B605AA4}"/>
               </a:ext>
             </a:extLst>
           </p:cNvPr>
@@ -4029,7 +4029,7 @@
           <p:cNvPr id="37" name="">
             <a:extLst xmlns:a="http://schemas.openxmlformats.org/drawingml/2006/main">
               <a:ext uri="{FF2B5EF4-FFF2-40B4-BE49-F238E27FC236}">
-                <a16:creationId xmlns:a16="http://schemas.microsoft.com/office/drawing/2014/main" id="{C7A1B97F-0DF1-4455-AF03-BF4E79455655}"/>
+                <a16:creationId xmlns:a16="http://schemas.microsoft.com/office/drawing/2014/main" id="{117789B2-2CD1-4B69-8F90-DA686212A102}"/>
               </a:ext>
             </a:extLst>
           </p:cNvPr>
@@ -4079,7 +4079,7 @@
           <p:cNvPr id="38" name="">
             <a:extLst xmlns:a="http://schemas.openxmlformats.org/drawingml/2006/main">
               <a:ext uri="{FF2B5EF4-FFF2-40B4-BE49-F238E27FC236}">
-                <a16:creationId xmlns:a16="http://schemas.microsoft.com/office/drawing/2014/main" id="{08827B3A-8671-462D-AA73-A6323D3EA822}"/>
+                <a16:creationId xmlns:a16="http://schemas.microsoft.com/office/drawing/2014/main" id="{C9DE70F8-EA18-4D69-8972-675AF313C054}"/>
               </a:ext>
             </a:extLst>
           </p:cNvPr>
@@ -4129,7 +4129,7 @@
           <p:cNvPr id="39" name="">
             <a:extLst xmlns:a="http://schemas.openxmlformats.org/drawingml/2006/main">
               <a:ext uri="{FF2B5EF4-FFF2-40B4-BE49-F238E27FC236}">
-                <a16:creationId xmlns:a16="http://schemas.microsoft.com/office/drawing/2014/main" id="{2E243702-A0EB-437F-91F6-B5793F58EABB}"/>
+                <a16:creationId xmlns:a16="http://schemas.microsoft.com/office/drawing/2014/main" id="{F6B580E1-8656-44AA-9036-0C7EC24959E5}"/>
               </a:ext>
             </a:extLst>
           </p:cNvPr>
@@ -4179,7 +4179,7 @@
           <p:cNvPr id="40" name="">
             <a:extLst xmlns:a="http://schemas.openxmlformats.org/drawingml/2006/main">
               <a:ext uri="{FF2B5EF4-FFF2-40B4-BE49-F238E27FC236}">
-                <a16:creationId xmlns:a16="http://schemas.microsoft.com/office/drawing/2014/main" id="{1470863A-1EC5-4E51-8592-251DD1A1A938}"/>
+                <a16:creationId xmlns:a16="http://schemas.microsoft.com/office/drawing/2014/main" id="{4829AD66-92C9-4CE7-8729-C0B83F97A0BE}"/>
               </a:ext>
             </a:extLst>
           </p:cNvPr>
@@ -4229,7 +4229,7 @@
           <p:cNvPr id="41" name="">
             <a:extLst xmlns:a="http://schemas.openxmlformats.org/drawingml/2006/main">
               <a:ext uri="{FF2B5EF4-FFF2-40B4-BE49-F238E27FC236}">
-                <a16:creationId xmlns:a16="http://schemas.microsoft.com/office/drawing/2014/main" id="{FA3EE0A2-CAF3-4328-9A3F-055C15E1130B}"/>
+                <a16:creationId xmlns:a16="http://schemas.microsoft.com/office/drawing/2014/main" id="{97A5F7E3-B8B3-4F0D-A134-7237A0F76079}"/>
               </a:ext>
             </a:extLst>
           </p:cNvPr>
@@ -4279,7 +4279,7 @@
           <p:cNvPr id="42" name="">
             <a:extLst xmlns:a="http://schemas.openxmlformats.org/drawingml/2006/main">
               <a:ext uri="{FF2B5EF4-FFF2-40B4-BE49-F238E27FC236}">
-                <a16:creationId xmlns:a16="http://schemas.microsoft.com/office/drawing/2014/main" id="{03A65E93-AED3-4667-AC3B-8AE1EBB60478}"/>
+                <a16:creationId xmlns:a16="http://schemas.microsoft.com/office/drawing/2014/main" id="{26FDDF74-EFA5-4243-8C4A-F4ADF0A7E034}"/>
               </a:ext>
             </a:extLst>
           </p:cNvPr>
@@ -4327,7 +4327,7 @@
     </p:spTree>
     <p:extLst>
       <p:ext uri="{BB962C8B-B14F-4D97-AF65-F5344CB8AC3E}">
-        <p14:creationId xmlns:p14="http://schemas.microsoft.com/office/powerpoint/2010/main" val="1261150830"/>
+        <p14:creationId xmlns:p14="http://schemas.microsoft.com/office/powerpoint/2010/main" val="1550715453"/>
       </p:ext>
     </p:extLst>
   </p:cSld>
@@ -4358,7 +4358,7 @@
           <p:cNvPr id="34" name="">
             <a:extLst xmlns:a="http://schemas.openxmlformats.org/drawingml/2006/main">
               <a:ext uri="{FF2B5EF4-FFF2-40B4-BE49-F238E27FC236}">
-                <a16:creationId xmlns:a16="http://schemas.microsoft.com/office/drawing/2014/main" id="{100420D4-FECE-4653-BF67-0454A847FF2A}"/>
+                <a16:creationId xmlns:a16="http://schemas.microsoft.com/office/drawing/2014/main" id="{2754FACE-C555-4347-B8C7-5B69806214F4}"/>
               </a:ext>
             </a:extLst>
           </p:cNvPr>
@@ -4408,7 +4408,7 @@
           <p:cNvPr id="2" name="">
             <a:extLst xmlns:a="http://schemas.openxmlformats.org/drawingml/2006/main">
               <a:ext uri="{FF2B5EF4-FFF2-40B4-BE49-F238E27FC236}">
-                <a16:creationId xmlns:a16="http://schemas.microsoft.com/office/drawing/2014/main" id="{5DB65765-3D01-457B-8169-57840826EE55}"/>
+                <a16:creationId xmlns:a16="http://schemas.microsoft.com/office/drawing/2014/main" id="{2F304DB5-C92B-4594-93E4-724BEC9710D9}"/>
               </a:ext>
             </a:extLst>
           </p:cNvPr>
@@ -4458,7 +4458,7 @@
           <p:cNvPr id="3" name="">
             <a:extLst xmlns:a="http://schemas.openxmlformats.org/drawingml/2006/main">
               <a:ext uri="{FF2B5EF4-FFF2-40B4-BE49-F238E27FC236}">
-                <a16:creationId xmlns:a16="http://schemas.microsoft.com/office/drawing/2014/main" id="{51683600-120C-4C04-96A5-ADACF0A6BDF2}"/>
+                <a16:creationId xmlns:a16="http://schemas.microsoft.com/office/drawing/2014/main" id="{01098B61-5DCA-4BD3-8565-AAAD461C8723}"/>
               </a:ext>
             </a:extLst>
           </p:cNvPr>
@@ -4491,7 +4491,7 @@
           <p:cNvPr id="4" name="">
             <a:extLst xmlns:a="http://schemas.openxmlformats.org/drawingml/2006/main">
               <a:ext uri="{FF2B5EF4-FFF2-40B4-BE49-F238E27FC236}">
-                <a16:creationId xmlns:a16="http://schemas.microsoft.com/office/drawing/2014/main" id="{B186CA95-A3AC-451E-9E75-6EEADCC38804}"/>
+                <a16:creationId xmlns:a16="http://schemas.microsoft.com/office/drawing/2014/main" id="{0D9A6EA6-FC37-405A-90BE-4506246F672C}"/>
               </a:ext>
             </a:extLst>
           </p:cNvPr>
@@ -4541,7 +4541,7 @@
           <p:cNvPr id="5" name="">
             <a:extLst xmlns:a="http://schemas.openxmlformats.org/drawingml/2006/main">
               <a:ext uri="{FF2B5EF4-FFF2-40B4-BE49-F238E27FC236}">
-                <a16:creationId xmlns:a16="http://schemas.microsoft.com/office/drawing/2014/main" id="{FC66B1A9-4513-4D71-ADD0-936668702D31}"/>
+                <a16:creationId xmlns:a16="http://schemas.microsoft.com/office/drawing/2014/main" id="{60C9F1BB-433D-4500-89C1-C316B238933F}"/>
               </a:ext>
             </a:extLst>
           </p:cNvPr>
@@ -4574,7 +4574,7 @@
           <p:cNvPr id="6" name="">
             <a:extLst xmlns:a="http://schemas.openxmlformats.org/drawingml/2006/main">
               <a:ext uri="{FF2B5EF4-FFF2-40B4-BE49-F238E27FC236}">
-                <a16:creationId xmlns:a16="http://schemas.microsoft.com/office/drawing/2014/main" id="{AF668222-2900-404B-8003-890CA5A55EFD}"/>
+                <a16:creationId xmlns:a16="http://schemas.microsoft.com/office/drawing/2014/main" id="{40F767D4-6245-4065-955E-C73D69E1A179}"/>
               </a:ext>
             </a:extLst>
           </p:cNvPr>
@@ -4641,7 +4641,7 @@
           <p:cNvPr id="7" name="">
             <a:extLst xmlns:a="http://schemas.openxmlformats.org/drawingml/2006/main">
               <a:ext uri="{FF2B5EF4-FFF2-40B4-BE49-F238E27FC236}">
-                <a16:creationId xmlns:a16="http://schemas.microsoft.com/office/drawing/2014/main" id="{43350D95-EEAA-4AB7-9E47-016761D08435}"/>
+                <a16:creationId xmlns:a16="http://schemas.microsoft.com/office/drawing/2014/main" id="{4C677573-5743-463D-A63B-F00F4F4B8D65}"/>
               </a:ext>
             </a:extLst>
           </p:cNvPr>
@@ -4691,7 +4691,7 @@
           <p:cNvPr id="8" name="">
             <a:extLst xmlns:a="http://schemas.openxmlformats.org/drawingml/2006/main">
               <a:ext uri="{FF2B5EF4-FFF2-40B4-BE49-F238E27FC236}">
-                <a16:creationId xmlns:a16="http://schemas.microsoft.com/office/drawing/2014/main" id="{7322BE4A-81DE-4B8F-A2FD-5C5037A62391}"/>
+                <a16:creationId xmlns:a16="http://schemas.microsoft.com/office/drawing/2014/main" id="{FB6F61CF-BDE1-4BA0-BCE6-FEF7D2109DE1}"/>
               </a:ext>
             </a:extLst>
           </p:cNvPr>
@@ -4724,7 +4724,7 @@
           <p:cNvPr id="9" name="">
             <a:extLst xmlns:a="http://schemas.openxmlformats.org/drawingml/2006/main">
               <a:ext uri="{FF2B5EF4-FFF2-40B4-BE49-F238E27FC236}">
-                <a16:creationId xmlns:a16="http://schemas.microsoft.com/office/drawing/2014/main" id="{F5972B69-3371-4B1F-92FF-153E38760E41}"/>
+                <a16:creationId xmlns:a16="http://schemas.microsoft.com/office/drawing/2014/main" id="{58B59E91-EECC-4B10-8107-E1E65659365D}"/>
               </a:ext>
             </a:extLst>
           </p:cNvPr>
@@ -4791,7 +4791,7 @@
           <p:cNvPr id="10" name="">
             <a:extLst xmlns:a="http://schemas.openxmlformats.org/drawingml/2006/main">
               <a:ext uri="{FF2B5EF4-FFF2-40B4-BE49-F238E27FC236}">
-                <a16:creationId xmlns:a16="http://schemas.microsoft.com/office/drawing/2014/main" id="{7877FC4D-9C91-4DB9-8EA6-8C4A0DD63B33}"/>
+                <a16:creationId xmlns:a16="http://schemas.microsoft.com/office/drawing/2014/main" id="{695F1A2C-79D7-484F-867D-2FF7DDA0E2FE}"/>
               </a:ext>
             </a:extLst>
           </p:cNvPr>
@@ -4841,7 +4841,7 @@
           <p:cNvPr id="11" name="">
             <a:extLst xmlns:a="http://schemas.openxmlformats.org/drawingml/2006/main">
               <a:ext uri="{FF2B5EF4-FFF2-40B4-BE49-F238E27FC236}">
-                <a16:creationId xmlns:a16="http://schemas.microsoft.com/office/drawing/2014/main" id="{CAEEDA32-7F44-43C2-B905-B468891A9358}"/>
+                <a16:creationId xmlns:a16="http://schemas.microsoft.com/office/drawing/2014/main" id="{9D940973-4280-47C0-8EFB-A5E013C876D7}"/>
               </a:ext>
             </a:extLst>
           </p:cNvPr>
@@ -4874,7 +4874,7 @@
           <p:cNvPr id="12" name="">
             <a:extLst xmlns:a="http://schemas.openxmlformats.org/drawingml/2006/main">
               <a:ext uri="{FF2B5EF4-FFF2-40B4-BE49-F238E27FC236}">
-                <a16:creationId xmlns:a16="http://schemas.microsoft.com/office/drawing/2014/main" id="{7F6EB060-F72F-4962-9A9F-B990E8E4A1E5}"/>
+                <a16:creationId xmlns:a16="http://schemas.microsoft.com/office/drawing/2014/main" id="{DBBC487D-FBCD-4DE9-BA3E-96D38CFC837E}"/>
               </a:ext>
             </a:extLst>
           </p:cNvPr>
@@ -4941,7 +4941,7 @@
           <p:cNvPr id="13" name="">
             <a:extLst xmlns:a="http://schemas.openxmlformats.org/drawingml/2006/main">
               <a:ext uri="{FF2B5EF4-FFF2-40B4-BE49-F238E27FC236}">
-                <a16:creationId xmlns:a16="http://schemas.microsoft.com/office/drawing/2014/main" id="{FCCBB054-B1B8-4608-994B-147205526955}"/>
+                <a16:creationId xmlns:a16="http://schemas.microsoft.com/office/drawing/2014/main" id="{4B333BAB-5257-4BD4-A702-07729FFF35E9}"/>
               </a:ext>
             </a:extLst>
           </p:cNvPr>
@@ -4991,7 +4991,7 @@
           <p:cNvPr id="14" name="">
             <a:extLst xmlns:a="http://schemas.openxmlformats.org/drawingml/2006/main">
               <a:ext uri="{FF2B5EF4-FFF2-40B4-BE49-F238E27FC236}">
-                <a16:creationId xmlns:a16="http://schemas.microsoft.com/office/drawing/2014/main" id="{F75FE8D8-4662-4D0B-B928-ECF488CA1D91}"/>
+                <a16:creationId xmlns:a16="http://schemas.microsoft.com/office/drawing/2014/main" id="{FDC47989-5BD1-477E-AFEB-441D47297594}"/>
               </a:ext>
             </a:extLst>
           </p:cNvPr>
@@ -5024,7 +5024,7 @@
           <p:cNvPr id="15" name="">
             <a:extLst xmlns:a="http://schemas.openxmlformats.org/drawingml/2006/main">
               <a:ext uri="{FF2B5EF4-FFF2-40B4-BE49-F238E27FC236}">
-                <a16:creationId xmlns:a16="http://schemas.microsoft.com/office/drawing/2014/main" id="{286E7572-881E-4218-9CB9-4285C9B21B2B}"/>
+                <a16:creationId xmlns:a16="http://schemas.microsoft.com/office/drawing/2014/main" id="{69DC04A9-73AF-4898-92C4-259B3BE5A98F}"/>
               </a:ext>
             </a:extLst>
           </p:cNvPr>
@@ -5091,7 +5091,7 @@
           <p:cNvPr id="16" name="">
             <a:extLst xmlns:a="http://schemas.openxmlformats.org/drawingml/2006/main">
               <a:ext uri="{FF2B5EF4-FFF2-40B4-BE49-F238E27FC236}">
-                <a16:creationId xmlns:a16="http://schemas.microsoft.com/office/drawing/2014/main" id="{3A9F14A7-A49A-4CBB-9D52-2AA11D500510}"/>
+                <a16:creationId xmlns:a16="http://schemas.microsoft.com/office/drawing/2014/main" id="{96B9C3E9-ABF7-4D28-98F4-384DB606C078}"/>
               </a:ext>
             </a:extLst>
           </p:cNvPr>
@@ -5141,7 +5141,7 @@
           <p:cNvPr id="17" name="">
             <a:extLst xmlns:a="http://schemas.openxmlformats.org/drawingml/2006/main">
               <a:ext uri="{FF2B5EF4-FFF2-40B4-BE49-F238E27FC236}">
-                <a16:creationId xmlns:a16="http://schemas.microsoft.com/office/drawing/2014/main" id="{226A30FC-EE7A-4E17-8062-2F594AE32AB9}"/>
+                <a16:creationId xmlns:a16="http://schemas.microsoft.com/office/drawing/2014/main" id="{79840B87-412F-465F-B894-8DFB1CBE928B}"/>
               </a:ext>
             </a:extLst>
           </p:cNvPr>
@@ -5174,7 +5174,7 @@
           <p:cNvPr id="18" name="">
             <a:extLst xmlns:a="http://schemas.openxmlformats.org/drawingml/2006/main">
               <a:ext uri="{FF2B5EF4-FFF2-40B4-BE49-F238E27FC236}">
-                <a16:creationId xmlns:a16="http://schemas.microsoft.com/office/drawing/2014/main" id="{801C498D-653C-4C14-8563-5CA1DF00EF99}"/>
+                <a16:creationId xmlns:a16="http://schemas.microsoft.com/office/drawing/2014/main" id="{BAFB6731-60A6-4287-AEA8-EEA8D6B5D996}"/>
               </a:ext>
             </a:extLst>
           </p:cNvPr>
@@ -5241,7 +5241,7 @@
           <p:cNvPr id="19" name="">
             <a:extLst xmlns:a="http://schemas.openxmlformats.org/drawingml/2006/main">
               <a:ext uri="{FF2B5EF4-FFF2-40B4-BE49-F238E27FC236}">
-                <a16:creationId xmlns:a16="http://schemas.microsoft.com/office/drawing/2014/main" id="{2D90505C-98E4-4A21-9653-B09C835D4C6A}"/>
+                <a16:creationId xmlns:a16="http://schemas.microsoft.com/office/drawing/2014/main" id="{0F9C092F-3B8A-4956-AAA0-BE22BA07ED0D}"/>
               </a:ext>
             </a:extLst>
           </p:cNvPr>
@@ -5291,7 +5291,7 @@
           <p:cNvPr id="20" name="">
             <a:extLst xmlns:a="http://schemas.openxmlformats.org/drawingml/2006/main">
               <a:ext uri="{FF2B5EF4-FFF2-40B4-BE49-F238E27FC236}">
-                <a16:creationId xmlns:a16="http://schemas.microsoft.com/office/drawing/2014/main" id="{F9D7122A-CA4D-42C6-AFA4-AE3D9BD6765A}"/>
+                <a16:creationId xmlns:a16="http://schemas.microsoft.com/office/drawing/2014/main" id="{CF9E9C75-CDBF-41A6-8010-6056A4B23B18}"/>
               </a:ext>
             </a:extLst>
           </p:cNvPr>
@@ -5324,7 +5324,7 @@
           <p:cNvPr id="21" name="">
             <a:extLst xmlns:a="http://schemas.openxmlformats.org/drawingml/2006/main">
               <a:ext uri="{FF2B5EF4-FFF2-40B4-BE49-F238E27FC236}">
-                <a16:creationId xmlns:a16="http://schemas.microsoft.com/office/drawing/2014/main" id="{86D36ED1-4F77-42A5-BCA5-E379F4851418}"/>
+                <a16:creationId xmlns:a16="http://schemas.microsoft.com/office/drawing/2014/main" id="{D08BC867-63AC-49D2-9477-6E807AAD2F85}"/>
               </a:ext>
             </a:extLst>
           </p:cNvPr>
@@ -5391,7 +5391,7 @@
           <p:cNvPr id="22" name="">
             <a:extLst xmlns:a="http://schemas.openxmlformats.org/drawingml/2006/main">
               <a:ext uri="{FF2B5EF4-FFF2-40B4-BE49-F238E27FC236}">
-                <a16:creationId xmlns:a16="http://schemas.microsoft.com/office/drawing/2014/main" id="{4CABD30A-C62F-4D82-8BDE-859EF357B2A1}"/>
+                <a16:creationId xmlns:a16="http://schemas.microsoft.com/office/drawing/2014/main" id="{39F38D68-3F1A-4C45-8AE0-4A51F486C806}"/>
               </a:ext>
             </a:extLst>
           </p:cNvPr>
@@ -5441,7 +5441,7 @@
           <p:cNvPr id="23" name="">
             <a:extLst xmlns:a="http://schemas.openxmlformats.org/drawingml/2006/main">
               <a:ext uri="{FF2B5EF4-FFF2-40B4-BE49-F238E27FC236}">
-                <a16:creationId xmlns:a16="http://schemas.microsoft.com/office/drawing/2014/main" id="{B5A54EB6-3B5D-4BF9-839F-DDE90EB08683}"/>
+                <a16:creationId xmlns:a16="http://schemas.microsoft.com/office/drawing/2014/main" id="{0FD369E1-3A6F-4328-A330-1CF9345F70DB}"/>
               </a:ext>
             </a:extLst>
           </p:cNvPr>
@@ -5491,7 +5491,7 @@
           <p:cNvPr id="24" name="">
             <a:extLst xmlns:a="http://schemas.openxmlformats.org/drawingml/2006/main">
               <a:ext uri="{FF2B5EF4-FFF2-40B4-BE49-F238E27FC236}">
-                <a16:creationId xmlns:a16="http://schemas.microsoft.com/office/drawing/2014/main" id="{AED92646-E522-4869-A669-A5B65144492C}"/>
+                <a16:creationId xmlns:a16="http://schemas.microsoft.com/office/drawing/2014/main" id="{6898F5D4-5079-40BE-987F-626F538716D8}"/>
               </a:ext>
             </a:extLst>
           </p:cNvPr>
@@ -5541,7 +5541,7 @@
           <p:cNvPr id="25" name="">
             <a:extLst xmlns:a="http://schemas.openxmlformats.org/drawingml/2006/main">
               <a:ext uri="{FF2B5EF4-FFF2-40B4-BE49-F238E27FC236}">
-                <a16:creationId xmlns:a16="http://schemas.microsoft.com/office/drawing/2014/main" id="{F7BD0930-B777-4941-BA32-E8C0DD37F430}"/>
+                <a16:creationId xmlns:a16="http://schemas.microsoft.com/office/drawing/2014/main" id="{DAA5FEB9-6D3E-42CA-85C3-191D67B9C5DA}"/>
               </a:ext>
             </a:extLst>
           </p:cNvPr>
@@ -5591,7 +5591,7 @@
           <p:cNvPr id="26" name="">
             <a:extLst xmlns:a="http://schemas.openxmlformats.org/drawingml/2006/main">
               <a:ext uri="{FF2B5EF4-FFF2-40B4-BE49-F238E27FC236}">
-                <a16:creationId xmlns:a16="http://schemas.microsoft.com/office/drawing/2014/main" id="{56157AA3-D575-49B7-B177-626D43F7C535}"/>
+                <a16:creationId xmlns:a16="http://schemas.microsoft.com/office/drawing/2014/main" id="{6F37F575-5EEA-4466-A3DF-F26AF3E91813}"/>
               </a:ext>
             </a:extLst>
           </p:cNvPr>
@@ -5641,7 +5641,7 @@
           <p:cNvPr id="27" name="">
             <a:extLst xmlns:a="http://schemas.openxmlformats.org/drawingml/2006/main">
               <a:ext uri="{FF2B5EF4-FFF2-40B4-BE49-F238E27FC236}">
-                <a16:creationId xmlns:a16="http://schemas.microsoft.com/office/drawing/2014/main" id="{4FC5217C-0D7C-4C8B-B775-6D7C2CE1BE0B}"/>
+                <a16:creationId xmlns:a16="http://schemas.microsoft.com/office/drawing/2014/main" id="{7984DDE3-04E3-4FC9-B333-1D7B52D14FBB}"/>
               </a:ext>
             </a:extLst>
           </p:cNvPr>
@@ -5691,7 +5691,7 @@
           <p:cNvPr id="28" name="">
             <a:extLst xmlns:a="http://schemas.openxmlformats.org/drawingml/2006/main">
               <a:ext uri="{FF2B5EF4-FFF2-40B4-BE49-F238E27FC236}">
-                <a16:creationId xmlns:a16="http://schemas.microsoft.com/office/drawing/2014/main" id="{171A7229-2C47-46FE-86C3-47EE39746F73}"/>
+                <a16:creationId xmlns:a16="http://schemas.microsoft.com/office/drawing/2014/main" id="{318EC3D4-43B0-4E70-8464-6FC95131ABE5}"/>
               </a:ext>
             </a:extLst>
           </p:cNvPr>
@@ -5741,7 +5741,7 @@
           <p:cNvPr id="29" name="">
             <a:extLst xmlns:a="http://schemas.openxmlformats.org/drawingml/2006/main">
               <a:ext uri="{FF2B5EF4-FFF2-40B4-BE49-F238E27FC236}">
-                <a16:creationId xmlns:a16="http://schemas.microsoft.com/office/drawing/2014/main" id="{967F7497-3DF7-4766-BB87-DD526452C254}"/>
+                <a16:creationId xmlns:a16="http://schemas.microsoft.com/office/drawing/2014/main" id="{9A5FCA80-86EE-4D30-B1E3-A6BB2593933B}"/>
               </a:ext>
             </a:extLst>
           </p:cNvPr>
@@ -5791,7 +5791,7 @@
           <p:cNvPr id="30" name="">
             <a:extLst xmlns:a="http://schemas.openxmlformats.org/drawingml/2006/main">
               <a:ext uri="{FF2B5EF4-FFF2-40B4-BE49-F238E27FC236}">
-                <a16:creationId xmlns:a16="http://schemas.microsoft.com/office/drawing/2014/main" id="{B0590023-6502-4CF0-B772-645609D5676D}"/>
+                <a16:creationId xmlns:a16="http://schemas.microsoft.com/office/drawing/2014/main" id="{E0F2D2E9-96D8-4F4D-83DF-3ADC83786EA1}"/>
               </a:ext>
             </a:extLst>
           </p:cNvPr>
@@ -5841,7 +5841,7 @@
           <p:cNvPr id="31" name="">
             <a:extLst xmlns:a="http://schemas.openxmlformats.org/drawingml/2006/main">
               <a:ext uri="{FF2B5EF4-FFF2-40B4-BE49-F238E27FC236}">
-                <a16:creationId xmlns:a16="http://schemas.microsoft.com/office/drawing/2014/main" id="{79E703E0-A601-4B54-AD24-8BC1CE9051CA}"/>
+                <a16:creationId xmlns:a16="http://schemas.microsoft.com/office/drawing/2014/main" id="{66F2E610-E891-4D43-A361-01F769BA7CAF}"/>
               </a:ext>
             </a:extLst>
           </p:cNvPr>
@@ -5874,7 +5874,7 @@
           <p:cNvPr id="32" name="">
             <a:extLst xmlns:a="http://schemas.openxmlformats.org/drawingml/2006/main">
               <a:ext uri="{FF2B5EF4-FFF2-40B4-BE49-F238E27FC236}">
-                <a16:creationId xmlns:a16="http://schemas.microsoft.com/office/drawing/2014/main" id="{34E4BCCD-D455-4D78-9120-4E9B476D838D}"/>
+                <a16:creationId xmlns:a16="http://schemas.microsoft.com/office/drawing/2014/main" id="{4F720E52-155A-4FCC-9FBC-A1DBAFD84824}"/>
               </a:ext>
             </a:extLst>
           </p:cNvPr>
@@ -5924,7 +5924,7 @@
           <p:cNvPr id="33" name="">
             <a:extLst xmlns:a="http://schemas.openxmlformats.org/drawingml/2006/main">
               <a:ext uri="{FF2B5EF4-FFF2-40B4-BE49-F238E27FC236}">
-                <a16:creationId xmlns:a16="http://schemas.microsoft.com/office/drawing/2014/main" id="{9A56FF80-B7EE-4432-982C-D6A41AB7612B}"/>
+                <a16:creationId xmlns:a16="http://schemas.microsoft.com/office/drawing/2014/main" id="{85149C0C-878F-461F-B14A-D4AA01AD8682}"/>
               </a:ext>
             </a:extLst>
           </p:cNvPr>
@@ -6091,7 +6091,7 @@
     </p:spTree>
     <p:extLst>
       <p:ext uri="{BB962C8B-B14F-4D97-AF65-F5344CB8AC3E}">
-        <p14:creationId xmlns:p14="http://schemas.microsoft.com/office/powerpoint/2010/main" val="1169554678"/>
+        <p14:creationId xmlns:p14="http://schemas.microsoft.com/office/powerpoint/2010/main" val="2126419949"/>
       </p:ext>
     </p:extLst>
   </p:cSld>
@@ -6122,7 +6122,7 @@
           <p:cNvPr id="30" name="">
             <a:extLst xmlns:a="http://schemas.openxmlformats.org/drawingml/2006/main">
               <a:ext uri="{FF2B5EF4-FFF2-40B4-BE49-F238E27FC236}">
-                <a16:creationId xmlns:a16="http://schemas.microsoft.com/office/drawing/2014/main" id="{1E948813-06BF-42AA-BB56-3F3E890EDB52}"/>
+                <a16:creationId xmlns:a16="http://schemas.microsoft.com/office/drawing/2014/main" id="{990F244A-FC76-4030-8F19-E9984749AB0A}"/>
               </a:ext>
             </a:extLst>
           </p:cNvPr>
@@ -6172,7 +6172,7 @@
           <p:cNvPr id="2" name="">
             <a:extLst xmlns:a="http://schemas.openxmlformats.org/drawingml/2006/main">
               <a:ext uri="{FF2B5EF4-FFF2-40B4-BE49-F238E27FC236}">
-                <a16:creationId xmlns:a16="http://schemas.microsoft.com/office/drawing/2014/main" id="{D1FE3925-E9E7-4801-A00D-D49F1DD9B76A}"/>
+                <a16:creationId xmlns:a16="http://schemas.microsoft.com/office/drawing/2014/main" id="{FEC91A94-E0B6-4119-80F2-75838631D9A4}"/>
               </a:ext>
             </a:extLst>
           </p:cNvPr>
@@ -6222,7 +6222,7 @@
           <p:cNvPr id="3" name="">
             <a:extLst xmlns:a="http://schemas.openxmlformats.org/drawingml/2006/main">
               <a:ext uri="{FF2B5EF4-FFF2-40B4-BE49-F238E27FC236}">
-                <a16:creationId xmlns:a16="http://schemas.microsoft.com/office/drawing/2014/main" id="{83D98C6D-A95D-4DC4-9185-F06AC170D9CB}"/>
+                <a16:creationId xmlns:a16="http://schemas.microsoft.com/office/drawing/2014/main" id="{A975CEE1-1B70-4CCC-A70E-E58D47FBB921}"/>
               </a:ext>
             </a:extLst>
           </p:cNvPr>
@@ -6255,7 +6255,7 @@
           <p:cNvPr id="4" name="">
             <a:extLst xmlns:a="http://schemas.openxmlformats.org/drawingml/2006/main">
               <a:ext uri="{FF2B5EF4-FFF2-40B4-BE49-F238E27FC236}">
-                <a16:creationId xmlns:a16="http://schemas.microsoft.com/office/drawing/2014/main" id="{C74819FE-A62D-4C34-9A05-93921D285D04}"/>
+                <a16:creationId xmlns:a16="http://schemas.microsoft.com/office/drawing/2014/main" id="{D373F6D9-F455-45D1-B5EB-8EA5C3AC4213}"/>
               </a:ext>
             </a:extLst>
           </p:cNvPr>
@@ -6305,7 +6305,7 @@
           <p:cNvPr id="5" name="">
             <a:extLst xmlns:a="http://schemas.openxmlformats.org/drawingml/2006/main">
               <a:ext uri="{FF2B5EF4-FFF2-40B4-BE49-F238E27FC236}">
-                <a16:creationId xmlns:a16="http://schemas.microsoft.com/office/drawing/2014/main" id="{AE30D201-CF6A-4CF0-9ACE-8410718F10C2}"/>
+                <a16:creationId xmlns:a16="http://schemas.microsoft.com/office/drawing/2014/main" id="{982C86F9-A41F-458B-BC92-F17FD5D1BABF}"/>
               </a:ext>
             </a:extLst>
           </p:cNvPr>
@@ -6338,7 +6338,7 @@
           <p:cNvPr id="6" name="">
             <a:extLst xmlns:a="http://schemas.openxmlformats.org/drawingml/2006/main">
               <a:ext uri="{FF2B5EF4-FFF2-40B4-BE49-F238E27FC236}">
-                <a16:creationId xmlns:a16="http://schemas.microsoft.com/office/drawing/2014/main" id="{44EBF667-30D7-4145-9CCA-1FB900195159}"/>
+                <a16:creationId xmlns:a16="http://schemas.microsoft.com/office/drawing/2014/main" id="{25AAA023-F847-4BC7-90BC-E3CEC48A0695}"/>
               </a:ext>
             </a:extLst>
           </p:cNvPr>
@@ -6405,7 +6405,7 @@
           <p:cNvPr id="7" name="">
             <a:extLst xmlns:a="http://schemas.openxmlformats.org/drawingml/2006/main">
               <a:ext uri="{FF2B5EF4-FFF2-40B4-BE49-F238E27FC236}">
-                <a16:creationId xmlns:a16="http://schemas.microsoft.com/office/drawing/2014/main" id="{9B169399-E941-471E-93C5-0AC979DFAD06}"/>
+                <a16:creationId xmlns:a16="http://schemas.microsoft.com/office/drawing/2014/main" id="{E5F554F9-F3BB-4453-97CD-86416A744DE9}"/>
               </a:ext>
             </a:extLst>
           </p:cNvPr>
@@ -6455,7 +6455,7 @@
           <p:cNvPr id="8" name="">
             <a:extLst xmlns:a="http://schemas.openxmlformats.org/drawingml/2006/main">
               <a:ext uri="{FF2B5EF4-FFF2-40B4-BE49-F238E27FC236}">
-                <a16:creationId xmlns:a16="http://schemas.microsoft.com/office/drawing/2014/main" id="{B3495E2A-9B79-4FB4-82DD-25B2CD17ED35}"/>
+                <a16:creationId xmlns:a16="http://schemas.microsoft.com/office/drawing/2014/main" id="{080475C5-6417-4D79-824B-128B0111B830}"/>
               </a:ext>
             </a:extLst>
           </p:cNvPr>
@@ -6488,7 +6488,7 @@
           <p:cNvPr id="9" name="">
             <a:extLst xmlns:a="http://schemas.openxmlformats.org/drawingml/2006/main">
               <a:ext uri="{FF2B5EF4-FFF2-40B4-BE49-F238E27FC236}">
-                <a16:creationId xmlns:a16="http://schemas.microsoft.com/office/drawing/2014/main" id="{542C14C6-6945-41C9-A26B-60C222F6D0AA}"/>
+                <a16:creationId xmlns:a16="http://schemas.microsoft.com/office/drawing/2014/main" id="{BC4D328F-3AD4-46E9-B1EE-F94DA79B3ECF}"/>
               </a:ext>
             </a:extLst>
           </p:cNvPr>
@@ -6555,7 +6555,7 @@
           <p:cNvPr id="10" name="">
             <a:extLst xmlns:a="http://schemas.openxmlformats.org/drawingml/2006/main">
               <a:ext uri="{FF2B5EF4-FFF2-40B4-BE49-F238E27FC236}">
-                <a16:creationId xmlns:a16="http://schemas.microsoft.com/office/drawing/2014/main" id="{47AE765A-BAFA-4875-B77F-00FD8B8735B9}"/>
+                <a16:creationId xmlns:a16="http://schemas.microsoft.com/office/drawing/2014/main" id="{034C565A-9E88-45C8-9D53-4CD9BBD5B154}"/>
               </a:ext>
             </a:extLst>
           </p:cNvPr>
@@ -6605,7 +6605,7 @@
           <p:cNvPr id="11" name="">
             <a:extLst xmlns:a="http://schemas.openxmlformats.org/drawingml/2006/main">
               <a:ext uri="{FF2B5EF4-FFF2-40B4-BE49-F238E27FC236}">
-                <a16:creationId xmlns:a16="http://schemas.microsoft.com/office/drawing/2014/main" id="{1DE23AA8-F084-4963-95B5-99C7294F11C6}"/>
+                <a16:creationId xmlns:a16="http://schemas.microsoft.com/office/drawing/2014/main" id="{0568D7E7-B823-4523-957A-47DAF3A9AD19}"/>
               </a:ext>
             </a:extLst>
           </p:cNvPr>
@@ -6638,7 +6638,7 @@
           <p:cNvPr id="12" name="">
             <a:extLst xmlns:a="http://schemas.openxmlformats.org/drawingml/2006/main">
               <a:ext uri="{FF2B5EF4-FFF2-40B4-BE49-F238E27FC236}">
-                <a16:creationId xmlns:a16="http://schemas.microsoft.com/office/drawing/2014/main" id="{939D1C0C-AB19-416E-A2BF-6AF508246A94}"/>
+                <a16:creationId xmlns:a16="http://schemas.microsoft.com/office/drawing/2014/main" id="{D77C0706-C9E8-4886-875E-14431A961AA8}"/>
               </a:ext>
             </a:extLst>
           </p:cNvPr>
@@ -6705,7 +6705,7 @@
           <p:cNvPr id="13" name="">
             <a:extLst xmlns:a="http://schemas.openxmlformats.org/drawingml/2006/main">
               <a:ext uri="{FF2B5EF4-FFF2-40B4-BE49-F238E27FC236}">
-                <a16:creationId xmlns:a16="http://schemas.microsoft.com/office/drawing/2014/main" id="{F9CCBDC8-8219-47AE-9926-154F389AF6B7}"/>
+                <a16:creationId xmlns:a16="http://schemas.microsoft.com/office/drawing/2014/main" id="{04D1C0F7-6D95-4F4F-B456-5A26A58E08DF}"/>
               </a:ext>
             </a:extLst>
           </p:cNvPr>
@@ -6755,7 +6755,7 @@
           <p:cNvPr id="14" name="">
             <a:extLst xmlns:a="http://schemas.openxmlformats.org/drawingml/2006/main">
               <a:ext uri="{FF2B5EF4-FFF2-40B4-BE49-F238E27FC236}">
-                <a16:creationId xmlns:a16="http://schemas.microsoft.com/office/drawing/2014/main" id="{29FBF2E5-547F-4AA5-BC1E-AA1B39F8FA8C}"/>
+                <a16:creationId xmlns:a16="http://schemas.microsoft.com/office/drawing/2014/main" id="{E436E097-4C4E-4C7F-92FE-AC8E13812B64}"/>
               </a:ext>
             </a:extLst>
           </p:cNvPr>
@@ -6805,7 +6805,7 @@
           <p:cNvPr id="15" name="">
             <a:extLst xmlns:a="http://schemas.openxmlformats.org/drawingml/2006/main">
               <a:ext uri="{FF2B5EF4-FFF2-40B4-BE49-F238E27FC236}">
-                <a16:creationId xmlns:a16="http://schemas.microsoft.com/office/drawing/2014/main" id="{B8EAA27D-3129-4B1E-B3EA-981D82782DF1}"/>
+                <a16:creationId xmlns:a16="http://schemas.microsoft.com/office/drawing/2014/main" id="{A9D8928B-BA18-4C9D-AA7A-2C4D4CD45F27}"/>
               </a:ext>
             </a:extLst>
           </p:cNvPr>
@@ -6855,7 +6855,7 @@
           <p:cNvPr id="16" name="">
             <a:extLst xmlns:a="http://schemas.openxmlformats.org/drawingml/2006/main">
               <a:ext uri="{FF2B5EF4-FFF2-40B4-BE49-F238E27FC236}">
-                <a16:creationId xmlns:a16="http://schemas.microsoft.com/office/drawing/2014/main" id="{98AF2036-5197-42B8-8405-419526E075BA}"/>
+                <a16:creationId xmlns:a16="http://schemas.microsoft.com/office/drawing/2014/main" id="{7D4D56DF-DD8A-488A-BC0B-948691C254F2}"/>
               </a:ext>
             </a:extLst>
           </p:cNvPr>
@@ -6888,7 +6888,7 @@
           <p:cNvPr id="17" name="">
             <a:extLst xmlns:a="http://schemas.openxmlformats.org/drawingml/2006/main">
               <a:ext uri="{FF2B5EF4-FFF2-40B4-BE49-F238E27FC236}">
-                <a16:creationId xmlns:a16="http://schemas.microsoft.com/office/drawing/2014/main" id="{2DEF691D-FB52-48A2-B24D-9DAC32C927F9}"/>
+                <a16:creationId xmlns:a16="http://schemas.microsoft.com/office/drawing/2014/main" id="{760FFE4E-FE64-40DC-B710-38EE5FBA2B73}"/>
               </a:ext>
             </a:extLst>
           </p:cNvPr>
@@ -6938,7 +6938,7 @@
           <p:cNvPr id="18" name="">
             <a:extLst xmlns:a="http://schemas.openxmlformats.org/drawingml/2006/main">
               <a:ext uri="{FF2B5EF4-FFF2-40B4-BE49-F238E27FC236}">
-                <a16:creationId xmlns:a16="http://schemas.microsoft.com/office/drawing/2014/main" id="{5A7786D2-7354-4989-B88C-AB7DEFE61ACA}"/>
+                <a16:creationId xmlns:a16="http://schemas.microsoft.com/office/drawing/2014/main" id="{3A262A4D-9878-453D-85C5-50F606BC9C54}"/>
               </a:ext>
             </a:extLst>
           </p:cNvPr>
@@ -7095,7 +7095,7 @@
           <p:cNvPr id="19" name="">
             <a:extLst xmlns:a="http://schemas.openxmlformats.org/drawingml/2006/main">
               <a:ext uri="{FF2B5EF4-FFF2-40B4-BE49-F238E27FC236}">
-                <a16:creationId xmlns:a16="http://schemas.microsoft.com/office/drawing/2014/main" id="{02CA06F8-2C9F-4DD2-9E3A-A4FBBDFF1AAB}"/>
+                <a16:creationId xmlns:a16="http://schemas.microsoft.com/office/drawing/2014/main" id="{0C54AB50-FAE1-4733-8982-237FEFA04257}"/>
               </a:ext>
             </a:extLst>
           </p:cNvPr>
@@ -7128,7 +7128,7 @@
           <p:cNvPr id="20" name="">
             <a:extLst xmlns:a="http://schemas.openxmlformats.org/drawingml/2006/main">
               <a:ext uri="{FF2B5EF4-FFF2-40B4-BE49-F238E27FC236}">
-                <a16:creationId xmlns:a16="http://schemas.microsoft.com/office/drawing/2014/main" id="{74EF41B7-F90D-4788-AD5D-D5E05E9B02F4}"/>
+                <a16:creationId xmlns:a16="http://schemas.microsoft.com/office/drawing/2014/main" id="{165ED311-4EAC-4EC1-AEDC-84F4D26DF764}"/>
               </a:ext>
             </a:extLst>
           </p:cNvPr>
@@ -7178,7 +7178,7 @@
           <p:cNvPr id="21" name="">
             <a:extLst xmlns:a="http://schemas.openxmlformats.org/drawingml/2006/main">
               <a:ext uri="{FF2B5EF4-FFF2-40B4-BE49-F238E27FC236}">
-                <a16:creationId xmlns:a16="http://schemas.microsoft.com/office/drawing/2014/main" id="{C7959552-C2C8-4784-94CA-A76CEB5D0F62}"/>
+                <a16:creationId xmlns:a16="http://schemas.microsoft.com/office/drawing/2014/main" id="{D535E00C-A74C-45B0-ADD5-12D9566C403F}"/>
               </a:ext>
             </a:extLst>
           </p:cNvPr>
@@ -7211,7 +7211,7 @@
           <p:cNvPr id="22" name="">
             <a:extLst xmlns:a="http://schemas.openxmlformats.org/drawingml/2006/main">
               <a:ext uri="{FF2B5EF4-FFF2-40B4-BE49-F238E27FC236}">
-                <a16:creationId xmlns:a16="http://schemas.microsoft.com/office/drawing/2014/main" id="{B76AF372-DD12-49CB-B4CC-249CD3BB3AF5}"/>
+                <a16:creationId xmlns:a16="http://schemas.microsoft.com/office/drawing/2014/main" id="{9DA23D28-4A45-4D5E-94C9-6B33E6FBBA2B}"/>
               </a:ext>
             </a:extLst>
           </p:cNvPr>
@@ -7261,7 +7261,7 @@
           <p:cNvPr id="23" name="">
             <a:extLst xmlns:a="http://schemas.openxmlformats.org/drawingml/2006/main">
               <a:ext uri="{FF2B5EF4-FFF2-40B4-BE49-F238E27FC236}">
-                <a16:creationId xmlns:a16="http://schemas.microsoft.com/office/drawing/2014/main" id="{43A27172-EB13-480C-9C1E-1EFC413A632A}"/>
+                <a16:creationId xmlns:a16="http://schemas.microsoft.com/office/drawing/2014/main" id="{56DA8AD5-1EE2-4FA0-A82F-3CEA89476291}"/>
               </a:ext>
             </a:extLst>
           </p:cNvPr>
@@ -7311,7 +7311,7 @@
           <p:cNvPr id="24" name="">
             <a:extLst xmlns:a="http://schemas.openxmlformats.org/drawingml/2006/main">
               <a:ext uri="{FF2B5EF4-FFF2-40B4-BE49-F238E27FC236}">
-                <a16:creationId xmlns:a16="http://schemas.microsoft.com/office/drawing/2014/main" id="{BD358400-AADA-4997-9CC8-41624D57FC9E}"/>
+                <a16:creationId xmlns:a16="http://schemas.microsoft.com/office/drawing/2014/main" id="{59C5792B-B87A-446E-9CCD-8C6642D54B47}"/>
               </a:ext>
             </a:extLst>
           </p:cNvPr>
@@ -7344,7 +7344,7 @@
           <p:cNvPr id="25" name="">
             <a:extLst xmlns:a="http://schemas.openxmlformats.org/drawingml/2006/main">
               <a:ext uri="{FF2B5EF4-FFF2-40B4-BE49-F238E27FC236}">
-                <a16:creationId xmlns:a16="http://schemas.microsoft.com/office/drawing/2014/main" id="{6A9B51F2-5EF6-4055-88B7-B30A6D53A547}"/>
+                <a16:creationId xmlns:a16="http://schemas.microsoft.com/office/drawing/2014/main" id="{C1DAD70A-3DAE-44E6-8645-7E012EBEAEB6}"/>
               </a:ext>
             </a:extLst>
           </p:cNvPr>
@@ -7394,7 +7394,7 @@
           <p:cNvPr id="26" name="">
             <a:extLst xmlns:a="http://schemas.openxmlformats.org/drawingml/2006/main">
               <a:ext uri="{FF2B5EF4-FFF2-40B4-BE49-F238E27FC236}">
-                <a16:creationId xmlns:a16="http://schemas.microsoft.com/office/drawing/2014/main" id="{8D6683AB-C901-42EF-80BD-19671F984B15}"/>
+                <a16:creationId xmlns:a16="http://schemas.microsoft.com/office/drawing/2014/main" id="{95DEA273-A012-4618-BF6F-17CEB4C64B26}"/>
               </a:ext>
             </a:extLst>
           </p:cNvPr>
@@ -7444,7 +7444,7 @@
           <p:cNvPr id="27" name="">
             <a:extLst xmlns:a="http://schemas.openxmlformats.org/drawingml/2006/main">
               <a:ext uri="{FF2B5EF4-FFF2-40B4-BE49-F238E27FC236}">
-                <a16:creationId xmlns:a16="http://schemas.microsoft.com/office/drawing/2014/main" id="{7784F3D4-EB73-4DF9-8099-1C267D9115B1}"/>
+                <a16:creationId xmlns:a16="http://schemas.microsoft.com/office/drawing/2014/main" id="{CC69BC08-0497-4FFD-95A4-92432058BE6B}"/>
               </a:ext>
             </a:extLst>
           </p:cNvPr>
@@ -7477,7 +7477,7 @@
           <p:cNvPr id="28" name="">
             <a:extLst xmlns:a="http://schemas.openxmlformats.org/drawingml/2006/main">
               <a:ext uri="{FF2B5EF4-FFF2-40B4-BE49-F238E27FC236}">
-                <a16:creationId xmlns:a16="http://schemas.microsoft.com/office/drawing/2014/main" id="{1AE55F41-CEE5-4AFF-BC42-211330048673}"/>
+                <a16:creationId xmlns:a16="http://schemas.microsoft.com/office/drawing/2014/main" id="{036575B7-FED9-4359-B27E-0FC9B30FF3F9}"/>
               </a:ext>
             </a:extLst>
           </p:cNvPr>
@@ -7527,7 +7527,7 @@
           <p:cNvPr id="29" name="">
             <a:extLst xmlns:a="http://schemas.openxmlformats.org/drawingml/2006/main">
               <a:ext uri="{FF2B5EF4-FFF2-40B4-BE49-F238E27FC236}">
-                <a16:creationId xmlns:a16="http://schemas.microsoft.com/office/drawing/2014/main" id="{DFE388A6-6FE5-4DEA-9796-ABA2965557DF}"/>
+                <a16:creationId xmlns:a16="http://schemas.microsoft.com/office/drawing/2014/main" id="{F8454301-F40F-4296-ABA1-856B4D6D5430}"/>
               </a:ext>
             </a:extLst>
           </p:cNvPr>
@@ -7575,7 +7575,7 @@
     </p:spTree>
     <p:extLst>
       <p:ext uri="{BB962C8B-B14F-4D97-AF65-F5344CB8AC3E}">
-        <p14:creationId xmlns:p14="http://schemas.microsoft.com/office/powerpoint/2010/main" val="1351782843"/>
+        <p14:creationId xmlns:p14="http://schemas.microsoft.com/office/powerpoint/2010/main" val="1025461567"/>
       </p:ext>
     </p:extLst>
   </p:cSld>
@@ -7606,7 +7606,7 @@
           <p:cNvPr id="31" name="">
             <a:extLst xmlns:a="http://schemas.openxmlformats.org/drawingml/2006/main">
               <a:ext uri="{FF2B5EF4-FFF2-40B4-BE49-F238E27FC236}">
-                <a16:creationId xmlns:a16="http://schemas.microsoft.com/office/drawing/2014/main" id="{4C8A0A76-F8EA-4A70-A391-AD6937679882}"/>
+                <a16:creationId xmlns:a16="http://schemas.microsoft.com/office/drawing/2014/main" id="{18E7F13F-0682-4C18-911B-08B76DEDEDEF}"/>
               </a:ext>
             </a:extLst>
           </p:cNvPr>
@@ -7656,7 +7656,7 @@
           <p:cNvPr id="2" name="">
             <a:extLst xmlns:a="http://schemas.openxmlformats.org/drawingml/2006/main">
               <a:ext uri="{FF2B5EF4-FFF2-40B4-BE49-F238E27FC236}">
-                <a16:creationId xmlns:a16="http://schemas.microsoft.com/office/drawing/2014/main" id="{A24191F3-63BA-404D-84B3-63F7102DD02E}"/>
+                <a16:creationId xmlns:a16="http://schemas.microsoft.com/office/drawing/2014/main" id="{F2C75958-FB72-4EBB-91EA-EAF7AF7C55AF}"/>
               </a:ext>
             </a:extLst>
           </p:cNvPr>
@@ -7706,7 +7706,7 @@
           <p:cNvPr id="3" name="">
             <a:extLst xmlns:a="http://schemas.openxmlformats.org/drawingml/2006/main">
               <a:ext uri="{FF2B5EF4-FFF2-40B4-BE49-F238E27FC236}">
-                <a16:creationId xmlns:a16="http://schemas.microsoft.com/office/drawing/2014/main" id="{58A1D50D-9F65-4C35-8274-C2D12F72D195}"/>
+                <a16:creationId xmlns:a16="http://schemas.microsoft.com/office/drawing/2014/main" id="{281000BE-CE84-4A8A-9954-CBDE1215505C}"/>
               </a:ext>
             </a:extLst>
           </p:cNvPr>
@@ -7739,7 +7739,7 @@
           <p:cNvPr id="4" name="">
             <a:extLst xmlns:a="http://schemas.openxmlformats.org/drawingml/2006/main">
               <a:ext uri="{FF2B5EF4-FFF2-40B4-BE49-F238E27FC236}">
-                <a16:creationId xmlns:a16="http://schemas.microsoft.com/office/drawing/2014/main" id="{F69DEFBD-FBCF-48DB-B80C-2F96204E50A1}"/>
+                <a16:creationId xmlns:a16="http://schemas.microsoft.com/office/drawing/2014/main" id="{92AF17DC-1878-44AC-8BDD-09DD22D57FCE}"/>
               </a:ext>
             </a:extLst>
           </p:cNvPr>
@@ -7789,7 +7789,7 @@
           <p:cNvPr id="5" name="">
             <a:extLst xmlns:a="http://schemas.openxmlformats.org/drawingml/2006/main">
               <a:ext uri="{FF2B5EF4-FFF2-40B4-BE49-F238E27FC236}">
-                <a16:creationId xmlns:a16="http://schemas.microsoft.com/office/drawing/2014/main" id="{F5E8D959-5496-4668-87BA-2D758DA0A615}"/>
+                <a16:creationId xmlns:a16="http://schemas.microsoft.com/office/drawing/2014/main" id="{107EFD28-DCAA-425F-9913-64BE60BB1A7E}"/>
               </a:ext>
             </a:extLst>
           </p:cNvPr>
@@ -7822,7 +7822,7 @@
           <p:cNvPr id="6" name="">
             <a:extLst xmlns:a="http://schemas.openxmlformats.org/drawingml/2006/main">
               <a:ext uri="{FF2B5EF4-FFF2-40B4-BE49-F238E27FC236}">
-                <a16:creationId xmlns:a16="http://schemas.microsoft.com/office/drawing/2014/main" id="{11376895-431B-4A03-B3B7-E1E51774B1C1}"/>
+                <a16:creationId xmlns:a16="http://schemas.microsoft.com/office/drawing/2014/main" id="{8E3BCFBB-C47D-4BAA-B0F7-20328D72CCA0}"/>
               </a:ext>
             </a:extLst>
           </p:cNvPr>
@@ -7872,7 +7872,7 @@
           <p:cNvPr id="7" name="">
             <a:extLst xmlns:a="http://schemas.openxmlformats.org/drawingml/2006/main">
               <a:ext uri="{FF2B5EF4-FFF2-40B4-BE49-F238E27FC236}">
-                <a16:creationId xmlns:a16="http://schemas.microsoft.com/office/drawing/2014/main" id="{A5DF84B3-9234-46CD-B1EE-DF52706AEB28}"/>
+                <a16:creationId xmlns:a16="http://schemas.microsoft.com/office/drawing/2014/main" id="{590A4930-C07D-4A2A-BEA9-33863AE76DED}"/>
               </a:ext>
             </a:extLst>
           </p:cNvPr>
@@ -8046,7 +8046,7 @@
           <p:cNvPr id="8" name="">
             <a:extLst xmlns:a="http://schemas.openxmlformats.org/drawingml/2006/main">
               <a:ext uri="{FF2B5EF4-FFF2-40B4-BE49-F238E27FC236}">
-                <a16:creationId xmlns:a16="http://schemas.microsoft.com/office/drawing/2014/main" id="{F7E91A0A-6B4E-495B-8EB6-F3478EE9D42E}"/>
+                <a16:creationId xmlns:a16="http://schemas.microsoft.com/office/drawing/2014/main" id="{8C2F393B-C12B-4036-BBF2-9C1FC980B416}"/>
               </a:ext>
             </a:extLst>
           </p:cNvPr>
@@ -8096,7 +8096,7 @@
           <p:cNvPr id="9" name="">
             <a:extLst xmlns:a="http://schemas.openxmlformats.org/drawingml/2006/main">
               <a:ext uri="{FF2B5EF4-FFF2-40B4-BE49-F238E27FC236}">
-                <a16:creationId xmlns:a16="http://schemas.microsoft.com/office/drawing/2014/main" id="{8908248B-5188-4125-80CE-A62A25D690D1}"/>
+                <a16:creationId xmlns:a16="http://schemas.microsoft.com/office/drawing/2014/main" id="{573F64A0-8B4C-40E8-A2E8-7D15BDFDAAD8}"/>
               </a:ext>
             </a:extLst>
           </p:cNvPr>
@@ -8146,7 +8146,7 @@
           <p:cNvPr id="10" name="">
             <a:extLst xmlns:a="http://schemas.openxmlformats.org/drawingml/2006/main">
               <a:ext uri="{FF2B5EF4-FFF2-40B4-BE49-F238E27FC236}">
-                <a16:creationId xmlns:a16="http://schemas.microsoft.com/office/drawing/2014/main" id="{6676C83E-F255-4C24-B530-331337EC4BE3}"/>
+                <a16:creationId xmlns:a16="http://schemas.microsoft.com/office/drawing/2014/main" id="{02148D8A-203C-46AD-A3FF-1E2DD97404B4}"/>
               </a:ext>
             </a:extLst>
           </p:cNvPr>
@@ -8196,7 +8196,7 @@
           <p:cNvPr id="11" name="">
             <a:extLst xmlns:a="http://schemas.openxmlformats.org/drawingml/2006/main">
               <a:ext uri="{FF2B5EF4-FFF2-40B4-BE49-F238E27FC236}">
-                <a16:creationId xmlns:a16="http://schemas.microsoft.com/office/drawing/2014/main" id="{F26B235F-46D2-462C-86B7-D2097874C491}"/>
+                <a16:creationId xmlns:a16="http://schemas.microsoft.com/office/drawing/2014/main" id="{0D21905C-7E6F-4964-84C1-670A8B5C2DF4}"/>
               </a:ext>
             </a:extLst>
           </p:cNvPr>
@@ -8246,7 +8246,7 @@
           <p:cNvPr id="12" name="">
             <a:extLst xmlns:a="http://schemas.openxmlformats.org/drawingml/2006/main">
               <a:ext uri="{FF2B5EF4-FFF2-40B4-BE49-F238E27FC236}">
-                <a16:creationId xmlns:a16="http://schemas.microsoft.com/office/drawing/2014/main" id="{90FE1D92-B162-4847-983C-190C56E56C39}"/>
+                <a16:creationId xmlns:a16="http://schemas.microsoft.com/office/drawing/2014/main" id="{02C447E9-48DD-48A6-8884-C85032E0D0B0}"/>
               </a:ext>
             </a:extLst>
           </p:cNvPr>
@@ -8296,7 +8296,7 @@
           <p:cNvPr id="13" name="">
             <a:extLst xmlns:a="http://schemas.openxmlformats.org/drawingml/2006/main">
               <a:ext uri="{FF2B5EF4-FFF2-40B4-BE49-F238E27FC236}">
-                <a16:creationId xmlns:a16="http://schemas.microsoft.com/office/drawing/2014/main" id="{EF90495C-6B08-43A7-A81E-9FCDEC6B9950}"/>
+                <a16:creationId xmlns:a16="http://schemas.microsoft.com/office/drawing/2014/main" id="{346650B3-3D5D-4157-B3E1-3C5667C0E61A}"/>
               </a:ext>
             </a:extLst>
           </p:cNvPr>
@@ -8346,7 +8346,7 @@
           <p:cNvPr id="14" name="">
             <a:extLst xmlns:a="http://schemas.openxmlformats.org/drawingml/2006/main">
               <a:ext uri="{FF2B5EF4-FFF2-40B4-BE49-F238E27FC236}">
-                <a16:creationId xmlns:a16="http://schemas.microsoft.com/office/drawing/2014/main" id="{C947520D-0E0C-48F0-BEE6-372E931C136D}"/>
+                <a16:creationId xmlns:a16="http://schemas.microsoft.com/office/drawing/2014/main" id="{F50B81B6-7FE9-498A-A8A9-8A085401F363}"/>
               </a:ext>
             </a:extLst>
           </p:cNvPr>
@@ -8396,7 +8396,7 @@
           <p:cNvPr id="15" name="">
             <a:extLst xmlns:a="http://schemas.openxmlformats.org/drawingml/2006/main">
               <a:ext uri="{FF2B5EF4-FFF2-40B4-BE49-F238E27FC236}">
-                <a16:creationId xmlns:a16="http://schemas.microsoft.com/office/drawing/2014/main" id="{086D1A86-BA67-47AE-8CF8-2AFA25235BCE}"/>
+                <a16:creationId xmlns:a16="http://schemas.microsoft.com/office/drawing/2014/main" id="{9C1DB864-2252-495A-86DC-3D6DBB6C1DC5}"/>
               </a:ext>
             </a:extLst>
           </p:cNvPr>
@@ -8446,7 +8446,7 @@
           <p:cNvPr id="16" name="">
             <a:extLst xmlns:a="http://schemas.openxmlformats.org/drawingml/2006/main">
               <a:ext uri="{FF2B5EF4-FFF2-40B4-BE49-F238E27FC236}">
-                <a16:creationId xmlns:a16="http://schemas.microsoft.com/office/drawing/2014/main" id="{C9DBCB0A-E34F-4BDE-9738-2329B1620E37}"/>
+                <a16:creationId xmlns:a16="http://schemas.microsoft.com/office/drawing/2014/main" id="{3D210D0B-E1E7-4993-8F10-7DE668DA5A5E}"/>
               </a:ext>
             </a:extLst>
           </p:cNvPr>
@@ -8479,7 +8479,7 @@
           <p:cNvPr id="17" name="">
             <a:extLst xmlns:a="http://schemas.openxmlformats.org/drawingml/2006/main">
               <a:ext uri="{FF2B5EF4-FFF2-40B4-BE49-F238E27FC236}">
-                <a16:creationId xmlns:a16="http://schemas.microsoft.com/office/drawing/2014/main" id="{82A2EDDC-4BFF-40B4-A1CC-C5A81EB188FB}"/>
+                <a16:creationId xmlns:a16="http://schemas.microsoft.com/office/drawing/2014/main" id="{045EC39B-0C13-42BD-AD09-E1C5849C2C29}"/>
               </a:ext>
             </a:extLst>
           </p:cNvPr>
@@ -8529,7 +8529,7 @@
           <p:cNvPr id="18" name="">
             <a:extLst xmlns:a="http://schemas.openxmlformats.org/drawingml/2006/main">
               <a:ext uri="{FF2B5EF4-FFF2-40B4-BE49-F238E27FC236}">
-                <a16:creationId xmlns:a16="http://schemas.microsoft.com/office/drawing/2014/main" id="{7A94B314-A91B-4802-8412-88D273F792EE}"/>
+                <a16:creationId xmlns:a16="http://schemas.microsoft.com/office/drawing/2014/main" id="{F333FCCD-47F6-40AF-AFBC-8E6F11D30134}"/>
               </a:ext>
             </a:extLst>
           </p:cNvPr>
@@ -8579,7 +8579,7 @@
           <p:cNvPr id="19" name="">
             <a:extLst xmlns:a="http://schemas.openxmlformats.org/drawingml/2006/main">
               <a:ext uri="{FF2B5EF4-FFF2-40B4-BE49-F238E27FC236}">
-                <a16:creationId xmlns:a16="http://schemas.microsoft.com/office/drawing/2014/main" id="{3DD7ED1A-B32A-471D-9455-FCD0C7398873}"/>
+                <a16:creationId xmlns:a16="http://schemas.microsoft.com/office/drawing/2014/main" id="{A2C7B5FD-3FD0-4050-9B03-FD0E0FCA3896}"/>
               </a:ext>
             </a:extLst>
           </p:cNvPr>
@@ -8612,7 +8612,7 @@
           <p:cNvPr id="20" name="">
             <a:extLst xmlns:a="http://schemas.openxmlformats.org/drawingml/2006/main">
               <a:ext uri="{FF2B5EF4-FFF2-40B4-BE49-F238E27FC236}">
-                <a16:creationId xmlns:a16="http://schemas.microsoft.com/office/drawing/2014/main" id="{AAF231A6-C30A-4617-84FB-CB783CCD90D4}"/>
+                <a16:creationId xmlns:a16="http://schemas.microsoft.com/office/drawing/2014/main" id="{B0D420FD-B125-4D46-818A-1B44E419ECFE}"/>
               </a:ext>
             </a:extLst>
           </p:cNvPr>
@@ -8662,7 +8662,7 @@
           <p:cNvPr id="21" name="">
             <a:extLst xmlns:a="http://schemas.openxmlformats.org/drawingml/2006/main">
               <a:ext uri="{FF2B5EF4-FFF2-40B4-BE49-F238E27FC236}">
-                <a16:creationId xmlns:a16="http://schemas.microsoft.com/office/drawing/2014/main" id="{AB13D523-543E-4353-A56F-D1EA7A80AF10}"/>
+                <a16:creationId xmlns:a16="http://schemas.microsoft.com/office/drawing/2014/main" id="{D4F28CF3-FB3A-4154-A88A-D29D17E3A02A}"/>
               </a:ext>
             </a:extLst>
           </p:cNvPr>
@@ -8712,7 +8712,7 @@
           <p:cNvPr id="22" name="">
             <a:extLst xmlns:a="http://schemas.openxmlformats.org/drawingml/2006/main">
               <a:ext uri="{FF2B5EF4-FFF2-40B4-BE49-F238E27FC236}">
-                <a16:creationId xmlns:a16="http://schemas.microsoft.com/office/drawing/2014/main" id="{E7973ED8-15A5-417D-8EB7-A537961CE63E}"/>
+                <a16:creationId xmlns:a16="http://schemas.microsoft.com/office/drawing/2014/main" id="{F18A5426-8E51-4435-BE64-30AD42A6A9B9}"/>
               </a:ext>
             </a:extLst>
           </p:cNvPr>
@@ -8745,7 +8745,7 @@
           <p:cNvPr id="23" name="">
             <a:extLst xmlns:a="http://schemas.openxmlformats.org/drawingml/2006/main">
               <a:ext uri="{FF2B5EF4-FFF2-40B4-BE49-F238E27FC236}">
-                <a16:creationId xmlns:a16="http://schemas.microsoft.com/office/drawing/2014/main" id="{C22148F6-7488-445F-A5F8-77AF534F3FB0}"/>
+                <a16:creationId xmlns:a16="http://schemas.microsoft.com/office/drawing/2014/main" id="{2582EA55-0265-4A3A-836A-919FBF854C7B}"/>
               </a:ext>
             </a:extLst>
           </p:cNvPr>
@@ -8795,7 +8795,7 @@
           <p:cNvPr id="24" name="">
             <a:extLst xmlns:a="http://schemas.openxmlformats.org/drawingml/2006/main">
               <a:ext uri="{FF2B5EF4-FFF2-40B4-BE49-F238E27FC236}">
-                <a16:creationId xmlns:a16="http://schemas.microsoft.com/office/drawing/2014/main" id="{14E2AACE-0446-45E1-A78F-B4C7208763E1}"/>
+                <a16:creationId xmlns:a16="http://schemas.microsoft.com/office/drawing/2014/main" id="{D8C7E218-06D6-4484-BEBD-4EAB73E6B5A9}"/>
               </a:ext>
             </a:extLst>
           </p:cNvPr>
@@ -8845,7 +8845,7 @@
           <p:cNvPr id="25" name="">
             <a:extLst xmlns:a="http://schemas.openxmlformats.org/drawingml/2006/main">
               <a:ext uri="{FF2B5EF4-FFF2-40B4-BE49-F238E27FC236}">
-                <a16:creationId xmlns:a16="http://schemas.microsoft.com/office/drawing/2014/main" id="{EC8D9F97-6570-44B6-9A08-4E890835FAC6}"/>
+                <a16:creationId xmlns:a16="http://schemas.microsoft.com/office/drawing/2014/main" id="{94BF3B97-4980-4CB6-A4EC-365AA12BB120}"/>
               </a:ext>
             </a:extLst>
           </p:cNvPr>
@@ -8878,7 +8878,7 @@
           <p:cNvPr id="26" name="">
             <a:extLst xmlns:a="http://schemas.openxmlformats.org/drawingml/2006/main">
               <a:ext uri="{FF2B5EF4-FFF2-40B4-BE49-F238E27FC236}">
-                <a16:creationId xmlns:a16="http://schemas.microsoft.com/office/drawing/2014/main" id="{B1FAFF51-1CFF-4980-A4BB-87C5B854F175}"/>
+                <a16:creationId xmlns:a16="http://schemas.microsoft.com/office/drawing/2014/main" id="{3E1233AF-8DC8-46D5-9226-8B80322AB518}"/>
               </a:ext>
             </a:extLst>
           </p:cNvPr>
@@ -8928,7 +8928,7 @@
           <p:cNvPr id="27" name="">
             <a:extLst xmlns:a="http://schemas.openxmlformats.org/drawingml/2006/main">
               <a:ext uri="{FF2B5EF4-FFF2-40B4-BE49-F238E27FC236}">
-                <a16:creationId xmlns:a16="http://schemas.microsoft.com/office/drawing/2014/main" id="{EE47158E-3557-426C-938D-B8F03E85D7AC}"/>
+                <a16:creationId xmlns:a16="http://schemas.microsoft.com/office/drawing/2014/main" id="{30E8D1FA-6FC2-4EFE-B2B7-289BFEFD8231}"/>
               </a:ext>
             </a:extLst>
           </p:cNvPr>
@@ -8978,7 +8978,7 @@
           <p:cNvPr id="28" name="">
             <a:extLst xmlns:a="http://schemas.openxmlformats.org/drawingml/2006/main">
               <a:ext uri="{FF2B5EF4-FFF2-40B4-BE49-F238E27FC236}">
-                <a16:creationId xmlns:a16="http://schemas.microsoft.com/office/drawing/2014/main" id="{8DC3ECBB-0E7E-4BCA-AF8A-75A26BA524CB}"/>
+                <a16:creationId xmlns:a16="http://schemas.microsoft.com/office/drawing/2014/main" id="{BBBD81D3-10ED-406D-9412-6C1B45B40706}"/>
               </a:ext>
             </a:extLst>
           </p:cNvPr>
@@ -9011,7 +9011,7 @@
           <p:cNvPr id="29" name="">
             <a:extLst xmlns:a="http://schemas.openxmlformats.org/drawingml/2006/main">
               <a:ext uri="{FF2B5EF4-FFF2-40B4-BE49-F238E27FC236}">
-                <a16:creationId xmlns:a16="http://schemas.microsoft.com/office/drawing/2014/main" id="{A2B69390-86CB-41F8-808D-F8358A009513}"/>
+                <a16:creationId xmlns:a16="http://schemas.microsoft.com/office/drawing/2014/main" id="{0030DEFD-60CB-4382-976E-E532755A0042}"/>
               </a:ext>
             </a:extLst>
           </p:cNvPr>
@@ -9061,7 +9061,7 @@
           <p:cNvPr id="30" name="">
             <a:extLst xmlns:a="http://schemas.openxmlformats.org/drawingml/2006/main">
               <a:ext uri="{FF2B5EF4-FFF2-40B4-BE49-F238E27FC236}">
-                <a16:creationId xmlns:a16="http://schemas.microsoft.com/office/drawing/2014/main" id="{E4470727-DB03-4997-A98C-F12C91B49972}"/>
+                <a16:creationId xmlns:a16="http://schemas.microsoft.com/office/drawing/2014/main" id="{E3220EAC-7AE0-4680-AB76-545940A7A63F}"/>
               </a:ext>
             </a:extLst>
           </p:cNvPr>
@@ -9109,7 +9109,7 @@
     </p:spTree>
     <p:extLst>
       <p:ext uri="{BB962C8B-B14F-4D97-AF65-F5344CB8AC3E}">
-        <p14:creationId xmlns:p14="http://schemas.microsoft.com/office/powerpoint/2010/main" val="460966684"/>
+        <p14:creationId xmlns:p14="http://schemas.microsoft.com/office/powerpoint/2010/main" val="1117033473"/>
       </p:ext>
     </p:extLst>
   </p:cSld>
@@ -9140,7 +9140,7 @@
           <p:cNvPr id="13" name="">
             <a:extLst xmlns:a="http://schemas.openxmlformats.org/drawingml/2006/main">
               <a:ext uri="{FF2B5EF4-FFF2-40B4-BE49-F238E27FC236}">
-                <a16:creationId xmlns:a16="http://schemas.microsoft.com/office/drawing/2014/main" id="{663A95CB-27C1-4A75-A800-41A35CF31B82}"/>
+                <a16:creationId xmlns:a16="http://schemas.microsoft.com/office/drawing/2014/main" id="{8ABDC8AF-5B7F-429A-A904-8BB484A7E04A}"/>
               </a:ext>
             </a:extLst>
           </p:cNvPr>
@@ -9190,7 +9190,7 @@
           <p:cNvPr id="2" name="">
             <a:extLst xmlns:a="http://schemas.openxmlformats.org/drawingml/2006/main">
               <a:ext uri="{FF2B5EF4-FFF2-40B4-BE49-F238E27FC236}">
-                <a16:creationId xmlns:a16="http://schemas.microsoft.com/office/drawing/2014/main" id="{F21FB83D-6B78-4E61-91DF-E5DFC77C7030}"/>
+                <a16:creationId xmlns:a16="http://schemas.microsoft.com/office/drawing/2014/main" id="{B47D2722-C96D-45A2-BD47-613970350798}"/>
               </a:ext>
             </a:extLst>
           </p:cNvPr>
@@ -9240,7 +9240,7 @@
           <p:cNvPr id="3" name="">
             <a:extLst xmlns:a="http://schemas.openxmlformats.org/drawingml/2006/main">
               <a:ext uri="{FF2B5EF4-FFF2-40B4-BE49-F238E27FC236}">
-                <a16:creationId xmlns:a16="http://schemas.microsoft.com/office/drawing/2014/main" id="{AA1BAE1A-2B57-4397-9086-C51A55461737}"/>
+                <a16:creationId xmlns:a16="http://schemas.microsoft.com/office/drawing/2014/main" id="{0EE22F48-4311-4A73-A1F2-4645FCF2D961}"/>
               </a:ext>
             </a:extLst>
           </p:cNvPr>
@@ -9273,7 +9273,7 @@
           <p:cNvPr id="4" name="">
             <a:extLst xmlns:a="http://schemas.openxmlformats.org/drawingml/2006/main">
               <a:ext uri="{FF2B5EF4-FFF2-40B4-BE49-F238E27FC236}">
-                <a16:creationId xmlns:a16="http://schemas.microsoft.com/office/drawing/2014/main" id="{EB838340-BEDC-4C7C-978D-069498103DA1}"/>
+                <a16:creationId xmlns:a16="http://schemas.microsoft.com/office/drawing/2014/main" id="{143160D6-93D1-4563-AFE5-7C5AE0186387}"/>
               </a:ext>
             </a:extLst>
           </p:cNvPr>
@@ -9323,7 +9323,7 @@
           <p:cNvPr id="5" name="">
             <a:extLst xmlns:a="http://schemas.openxmlformats.org/drawingml/2006/main">
               <a:ext uri="{FF2B5EF4-FFF2-40B4-BE49-F238E27FC236}">
-                <a16:creationId xmlns:a16="http://schemas.microsoft.com/office/drawing/2014/main" id="{B757A888-FAA1-492F-B2F4-F35BB95683B3}"/>
+                <a16:creationId xmlns:a16="http://schemas.microsoft.com/office/drawing/2014/main" id="{9E1083BE-F543-41A4-9717-D79B9E6D79F5}"/>
               </a:ext>
             </a:extLst>
           </p:cNvPr>
@@ -9356,7 +9356,7 @@
           <p:cNvPr id="6" name="">
             <a:extLst xmlns:a="http://schemas.openxmlformats.org/drawingml/2006/main">
               <a:ext uri="{FF2B5EF4-FFF2-40B4-BE49-F238E27FC236}">
-                <a16:creationId xmlns:a16="http://schemas.microsoft.com/office/drawing/2014/main" id="{E3B9D8A8-5AF9-4528-BA37-AF9AFEC9916E}"/>
+                <a16:creationId xmlns:a16="http://schemas.microsoft.com/office/drawing/2014/main" id="{B4A8F5B8-DD01-4C5A-8D30-FD72753A2806}"/>
               </a:ext>
             </a:extLst>
           </p:cNvPr>
@@ -9406,7 +9406,7 @@
           <p:cNvPr id="7" name="">
             <a:extLst xmlns:a="http://schemas.openxmlformats.org/drawingml/2006/main">
               <a:ext uri="{FF2B5EF4-FFF2-40B4-BE49-F238E27FC236}">
-                <a16:creationId xmlns:a16="http://schemas.microsoft.com/office/drawing/2014/main" id="{C56B5DA3-C112-41E3-BD00-26004DE7626D}"/>
+                <a16:creationId xmlns:a16="http://schemas.microsoft.com/office/drawing/2014/main" id="{E3994E88-2669-4787-9F9C-F5A86E396D18}"/>
               </a:ext>
             </a:extLst>
           </p:cNvPr>
@@ -9607,7 +9607,7 @@
           <p:cNvPr id="8" name="">
             <a:extLst xmlns:a="http://schemas.openxmlformats.org/drawingml/2006/main">
               <a:ext uri="{FF2B5EF4-FFF2-40B4-BE49-F238E27FC236}">
-                <a16:creationId xmlns:a16="http://schemas.microsoft.com/office/drawing/2014/main" id="{43A878F7-93A8-48AC-B07E-AF40B4CC9300}"/>
+                <a16:creationId xmlns:a16="http://schemas.microsoft.com/office/drawing/2014/main" id="{747AFF6B-2F66-4F79-93F4-AD9FF82DBDF6}"/>
               </a:ext>
             </a:extLst>
           </p:cNvPr>
@@ -9640,7 +9640,7 @@
           <p:cNvPr id="9" name="">
             <a:extLst xmlns:a="http://schemas.openxmlformats.org/drawingml/2006/main">
               <a:ext uri="{FF2B5EF4-FFF2-40B4-BE49-F238E27FC236}">
-                <a16:creationId xmlns:a16="http://schemas.microsoft.com/office/drawing/2014/main" id="{2AD26A8F-7733-4C03-89C4-AC7FAC400FDD}"/>
+                <a16:creationId xmlns:a16="http://schemas.microsoft.com/office/drawing/2014/main" id="{756F05D0-8E9F-4A74-A351-642C8963A4D0}"/>
               </a:ext>
             </a:extLst>
           </p:cNvPr>
@@ -9690,7 +9690,7 @@
           <p:cNvPr id="10" name="">
             <a:extLst xmlns:a="http://schemas.openxmlformats.org/drawingml/2006/main">
               <a:ext uri="{FF2B5EF4-FFF2-40B4-BE49-F238E27FC236}">
-                <a16:creationId xmlns:a16="http://schemas.microsoft.com/office/drawing/2014/main" id="{9A709584-EB33-4893-8A5B-B3C057EB0919}"/>
+                <a16:creationId xmlns:a16="http://schemas.microsoft.com/office/drawing/2014/main" id="{8702125D-DA4D-4668-9D44-DB9777684A1B}"/>
               </a:ext>
             </a:extLst>
           </p:cNvPr>
@@ -9949,7 +9949,7 @@
           <p:cNvPr id="11" name="">
             <a:extLst xmlns:a="http://schemas.openxmlformats.org/drawingml/2006/main">
               <a:ext uri="{FF2B5EF4-FFF2-40B4-BE49-F238E27FC236}">
-                <a16:creationId xmlns:a16="http://schemas.microsoft.com/office/drawing/2014/main" id="{F0C009B0-E749-4564-AA51-2B9164CA5AA4}"/>
+                <a16:creationId xmlns:a16="http://schemas.microsoft.com/office/drawing/2014/main" id="{255FF070-F5E3-43D8-8A65-C94CF1E770E6}"/>
               </a:ext>
             </a:extLst>
           </p:cNvPr>
@@ -9999,7 +9999,7 @@
           <p:cNvPr id="12" name="">
             <a:extLst xmlns:a="http://schemas.openxmlformats.org/drawingml/2006/main">
               <a:ext uri="{FF2B5EF4-FFF2-40B4-BE49-F238E27FC236}">
-                <a16:creationId xmlns:a16="http://schemas.microsoft.com/office/drawing/2014/main" id="{3C45766C-9CDE-487E-8A53-CCFF0F5976CD}"/>
+                <a16:creationId xmlns:a16="http://schemas.microsoft.com/office/drawing/2014/main" id="{9A70A5DB-1E9D-4B95-A773-2A3A60152EFB}"/>
               </a:ext>
             </a:extLst>
           </p:cNvPr>
@@ -10047,7 +10047,7 @@
     </p:spTree>
     <p:extLst>
       <p:ext uri="{BB962C8B-B14F-4D97-AF65-F5344CB8AC3E}">
-        <p14:creationId xmlns:p14="http://schemas.microsoft.com/office/powerpoint/2010/main" val="2121332330"/>
+        <p14:creationId xmlns:p14="http://schemas.microsoft.com/office/powerpoint/2010/main" val="364642516"/>
       </p:ext>
     </p:extLst>
   </p:cSld>
@@ -10078,7 +10078,7 @@
           <p:cNvPr id="27" name="">
             <a:extLst xmlns:a="http://schemas.openxmlformats.org/drawingml/2006/main">
               <a:ext uri="{FF2B5EF4-FFF2-40B4-BE49-F238E27FC236}">
-                <a16:creationId xmlns:a16="http://schemas.microsoft.com/office/drawing/2014/main" id="{FDB50C52-06AB-4DA1-814D-F429C534E612}"/>
+                <a16:creationId xmlns:a16="http://schemas.microsoft.com/office/drawing/2014/main" id="{8ACDA5F3-B40E-4550-8C54-06AD626A385B}"/>
               </a:ext>
             </a:extLst>
           </p:cNvPr>
@@ -10128,7 +10128,7 @@
           <p:cNvPr id="2" name="">
             <a:extLst xmlns:a="http://schemas.openxmlformats.org/drawingml/2006/main">
               <a:ext uri="{FF2B5EF4-FFF2-40B4-BE49-F238E27FC236}">
-                <a16:creationId xmlns:a16="http://schemas.microsoft.com/office/drawing/2014/main" id="{250DAAB1-78CE-46F7-9FA7-46F6FA959098}"/>
+                <a16:creationId xmlns:a16="http://schemas.microsoft.com/office/drawing/2014/main" id="{E409B880-871A-48B2-8AFC-A08316306E76}"/>
               </a:ext>
             </a:extLst>
           </p:cNvPr>
@@ -10178,7 +10178,7 @@
           <p:cNvPr id="3" name="">
             <a:extLst xmlns:a="http://schemas.openxmlformats.org/drawingml/2006/main">
               <a:ext uri="{FF2B5EF4-FFF2-40B4-BE49-F238E27FC236}">
-                <a16:creationId xmlns:a16="http://schemas.microsoft.com/office/drawing/2014/main" id="{5FB29DE2-9BD5-42DC-9E2A-4D3B2BEAFF90}"/>
+                <a16:creationId xmlns:a16="http://schemas.microsoft.com/office/drawing/2014/main" id="{F643CD0C-F8CA-48AF-A69B-48A791E067AA}"/>
               </a:ext>
             </a:extLst>
           </p:cNvPr>
@@ -10211,7 +10211,7 @@
           <p:cNvPr id="4" name="">
             <a:extLst xmlns:a="http://schemas.openxmlformats.org/drawingml/2006/main">
               <a:ext uri="{FF2B5EF4-FFF2-40B4-BE49-F238E27FC236}">
-                <a16:creationId xmlns:a16="http://schemas.microsoft.com/office/drawing/2014/main" id="{DDE77656-3617-4732-911B-33921899584B}"/>
+                <a16:creationId xmlns:a16="http://schemas.microsoft.com/office/drawing/2014/main" id="{A0369FF4-E1A9-4D88-9F0C-93D89DE44566}"/>
               </a:ext>
             </a:extLst>
           </p:cNvPr>
@@ -10261,7 +10261,7 @@
           <p:cNvPr id="5" name="">
             <a:extLst xmlns:a="http://schemas.openxmlformats.org/drawingml/2006/main">
               <a:ext uri="{FF2B5EF4-FFF2-40B4-BE49-F238E27FC236}">
-                <a16:creationId xmlns:a16="http://schemas.microsoft.com/office/drawing/2014/main" id="{A6524EBC-FFF0-452B-A9ED-36E9A24FF997}"/>
+                <a16:creationId xmlns:a16="http://schemas.microsoft.com/office/drawing/2014/main" id="{A47BD7E5-CE5B-4DAF-A1AE-D505E765F067}"/>
               </a:ext>
             </a:extLst>
           </p:cNvPr>
@@ -10294,7 +10294,7 @@
           <p:cNvPr id="6" name="">
             <a:extLst xmlns:a="http://schemas.openxmlformats.org/drawingml/2006/main">
               <a:ext uri="{FF2B5EF4-FFF2-40B4-BE49-F238E27FC236}">
-                <a16:creationId xmlns:a16="http://schemas.microsoft.com/office/drawing/2014/main" id="{19AB693F-6133-4821-84E2-ED8A8026DD51}"/>
+                <a16:creationId xmlns:a16="http://schemas.microsoft.com/office/drawing/2014/main" id="{5DCED78F-3F0E-4DC7-8FB2-182106A77F5C}"/>
               </a:ext>
             </a:extLst>
           </p:cNvPr>
@@ -10327,7 +10327,7 @@
           <p:cNvPr id="7" name="">
             <a:extLst xmlns:a="http://schemas.openxmlformats.org/drawingml/2006/main">
               <a:ext uri="{FF2B5EF4-FFF2-40B4-BE49-F238E27FC236}">
-                <a16:creationId xmlns:a16="http://schemas.microsoft.com/office/drawing/2014/main" id="{C81EF1A8-3D03-47CA-9D30-3C4F398D1DBA}"/>
+                <a16:creationId xmlns:a16="http://schemas.microsoft.com/office/drawing/2014/main" id="{1D6AE6FC-961C-4B49-A6F4-62611F8FB478}"/>
               </a:ext>
             </a:extLst>
           </p:cNvPr>
@@ -10377,7 +10377,7 @@
           <p:cNvPr id="8" name="">
             <a:extLst xmlns:a="http://schemas.openxmlformats.org/drawingml/2006/main">
               <a:ext uri="{FF2B5EF4-FFF2-40B4-BE49-F238E27FC236}">
-                <a16:creationId xmlns:a16="http://schemas.microsoft.com/office/drawing/2014/main" id="{8941994D-500C-4D57-A425-8EA20F5EF06C}"/>
+                <a16:creationId xmlns:a16="http://schemas.microsoft.com/office/drawing/2014/main" id="{B43E0283-5B7C-4278-81A2-41CAB87859F3}"/>
               </a:ext>
             </a:extLst>
           </p:cNvPr>
@@ -10427,7 +10427,7 @@
           <p:cNvPr id="9" name="">
             <a:extLst xmlns:a="http://schemas.openxmlformats.org/drawingml/2006/main">
               <a:ext uri="{FF2B5EF4-FFF2-40B4-BE49-F238E27FC236}">
-                <a16:creationId xmlns:a16="http://schemas.microsoft.com/office/drawing/2014/main" id="{22A643EB-FCBF-4D99-A7E3-D8748BD4B0AF}"/>
+                <a16:creationId xmlns:a16="http://schemas.microsoft.com/office/drawing/2014/main" id="{BAFE3B31-F5D6-4DBD-8AF0-FFE3D36B97FA}"/>
               </a:ext>
             </a:extLst>
           </p:cNvPr>
@@ -10460,7 +10460,7 @@
           <p:cNvPr id="10" name="">
             <a:extLst xmlns:a="http://schemas.openxmlformats.org/drawingml/2006/main">
               <a:ext uri="{FF2B5EF4-FFF2-40B4-BE49-F238E27FC236}">
-                <a16:creationId xmlns:a16="http://schemas.microsoft.com/office/drawing/2014/main" id="{E8921D11-A595-40F1-BC53-3FFE4E1D0437}"/>
+                <a16:creationId xmlns:a16="http://schemas.microsoft.com/office/drawing/2014/main" id="{E90E13C3-D3A7-4F2B-9540-24156AB21C1E}"/>
               </a:ext>
             </a:extLst>
           </p:cNvPr>
@@ -10493,7 +10493,7 @@
           <p:cNvPr id="11" name="">
             <a:extLst xmlns:a="http://schemas.openxmlformats.org/drawingml/2006/main">
               <a:ext uri="{FF2B5EF4-FFF2-40B4-BE49-F238E27FC236}">
-                <a16:creationId xmlns:a16="http://schemas.microsoft.com/office/drawing/2014/main" id="{273703AA-8EFA-484E-ADEC-273672CF2FC7}"/>
+                <a16:creationId xmlns:a16="http://schemas.microsoft.com/office/drawing/2014/main" id="{B03480F8-5C3C-497D-A921-32AC7C08A152}"/>
               </a:ext>
             </a:extLst>
           </p:cNvPr>
@@ -10543,7 +10543,7 @@
           <p:cNvPr id="12" name="">
             <a:extLst xmlns:a="http://schemas.openxmlformats.org/drawingml/2006/main">
               <a:ext uri="{FF2B5EF4-FFF2-40B4-BE49-F238E27FC236}">
-                <a16:creationId xmlns:a16="http://schemas.microsoft.com/office/drawing/2014/main" id="{CA1D0B08-A23C-4732-8830-B5F541EC7933}"/>
+                <a16:creationId xmlns:a16="http://schemas.microsoft.com/office/drawing/2014/main" id="{FF7ECCF6-8CB2-490C-B84D-7AC77E225047}"/>
               </a:ext>
             </a:extLst>
           </p:cNvPr>
@@ -10593,7 +10593,7 @@
           <p:cNvPr id="13" name="">
             <a:extLst xmlns:a="http://schemas.openxmlformats.org/drawingml/2006/main">
               <a:ext uri="{FF2B5EF4-FFF2-40B4-BE49-F238E27FC236}">
-                <a16:creationId xmlns:a16="http://schemas.microsoft.com/office/drawing/2014/main" id="{511ACB8A-147C-4350-AE74-6FFEF2B686BA}"/>
+                <a16:creationId xmlns:a16="http://schemas.microsoft.com/office/drawing/2014/main" id="{94DEACE3-F230-4D7D-95F6-6F1B1DD8E8F1}"/>
               </a:ext>
             </a:extLst>
           </p:cNvPr>
@@ -10626,7 +10626,7 @@
           <p:cNvPr id="14" name="">
             <a:extLst xmlns:a="http://schemas.openxmlformats.org/drawingml/2006/main">
               <a:ext uri="{FF2B5EF4-FFF2-40B4-BE49-F238E27FC236}">
-                <a16:creationId xmlns:a16="http://schemas.microsoft.com/office/drawing/2014/main" id="{D14E833D-CC8A-4989-B3B3-26602F90949B}"/>
+                <a16:creationId xmlns:a16="http://schemas.microsoft.com/office/drawing/2014/main" id="{A766CA62-CCFE-4BC0-A980-0E1504D60F1C}"/>
               </a:ext>
             </a:extLst>
           </p:cNvPr>
@@ -10659,7 +10659,7 @@
           <p:cNvPr id="15" name="">
             <a:extLst xmlns:a="http://schemas.openxmlformats.org/drawingml/2006/main">
               <a:ext uri="{FF2B5EF4-FFF2-40B4-BE49-F238E27FC236}">
-                <a16:creationId xmlns:a16="http://schemas.microsoft.com/office/drawing/2014/main" id="{B9BB0164-668D-4D7E-A417-D66E924536F1}"/>
+                <a16:creationId xmlns:a16="http://schemas.microsoft.com/office/drawing/2014/main" id="{F99EE050-6F68-4D0A-997F-485599598965}"/>
               </a:ext>
             </a:extLst>
           </p:cNvPr>
@@ -10709,7 +10709,7 @@
           <p:cNvPr id="16" name="">
             <a:extLst xmlns:a="http://schemas.openxmlformats.org/drawingml/2006/main">
               <a:ext uri="{FF2B5EF4-FFF2-40B4-BE49-F238E27FC236}">
-                <a16:creationId xmlns:a16="http://schemas.microsoft.com/office/drawing/2014/main" id="{3808E3C4-4699-4828-844C-EE9A1B44774F}"/>
+                <a16:creationId xmlns:a16="http://schemas.microsoft.com/office/drawing/2014/main" id="{68AD246A-4F62-46FB-8502-9ABC195C69AE}"/>
               </a:ext>
             </a:extLst>
           </p:cNvPr>
@@ -10759,7 +10759,7 @@
           <p:cNvPr id="17" name="">
             <a:extLst xmlns:a="http://schemas.openxmlformats.org/drawingml/2006/main">
               <a:ext uri="{FF2B5EF4-FFF2-40B4-BE49-F238E27FC236}">
-                <a16:creationId xmlns:a16="http://schemas.microsoft.com/office/drawing/2014/main" id="{E7A810E9-42F9-4A9B-8C5A-C708F78E6484}"/>
+                <a16:creationId xmlns:a16="http://schemas.microsoft.com/office/drawing/2014/main" id="{9085D7B2-037A-41C6-8ED5-A783D78B74EE}"/>
               </a:ext>
             </a:extLst>
           </p:cNvPr>
@@ -10792,7 +10792,7 @@
           <p:cNvPr id="18" name="">
             <a:extLst xmlns:a="http://schemas.openxmlformats.org/drawingml/2006/main">
               <a:ext uri="{FF2B5EF4-FFF2-40B4-BE49-F238E27FC236}">
-                <a16:creationId xmlns:a16="http://schemas.microsoft.com/office/drawing/2014/main" id="{174DC14F-FE33-4647-9F18-EDAE38A3A7FF}"/>
+                <a16:creationId xmlns:a16="http://schemas.microsoft.com/office/drawing/2014/main" id="{3D8FD157-F99F-466F-AFFD-E5FA9D566F80}"/>
               </a:ext>
             </a:extLst>
           </p:cNvPr>
@@ -10825,7 +10825,7 @@
           <p:cNvPr id="19" name="">
             <a:extLst xmlns:a="http://schemas.openxmlformats.org/drawingml/2006/main">
               <a:ext uri="{FF2B5EF4-FFF2-40B4-BE49-F238E27FC236}">
-                <a16:creationId xmlns:a16="http://schemas.microsoft.com/office/drawing/2014/main" id="{B8E011D9-BCB8-4821-94E4-988F7E6C8FC8}"/>
+                <a16:creationId xmlns:a16="http://schemas.microsoft.com/office/drawing/2014/main" id="{1AA02A9D-5F47-424A-82AD-2424194B44BE}"/>
               </a:ext>
             </a:extLst>
           </p:cNvPr>
@@ -10858,7 +10858,7 @@
           <p:cNvPr id="20" name="">
             <a:extLst xmlns:a="http://schemas.openxmlformats.org/drawingml/2006/main">
               <a:ext uri="{FF2B5EF4-FFF2-40B4-BE49-F238E27FC236}">
-                <a16:creationId xmlns:a16="http://schemas.microsoft.com/office/drawing/2014/main" id="{08289159-A876-4AFD-8826-BAA00D66E0EF}"/>
+                <a16:creationId xmlns:a16="http://schemas.microsoft.com/office/drawing/2014/main" id="{FB18B24D-AA6A-4BFB-9696-450F70049334}"/>
               </a:ext>
             </a:extLst>
           </p:cNvPr>
@@ -10891,7 +10891,7 @@
           <p:cNvPr id="21" name="">
             <a:extLst xmlns:a="http://schemas.openxmlformats.org/drawingml/2006/main">
               <a:ext uri="{FF2B5EF4-FFF2-40B4-BE49-F238E27FC236}">
-                <a16:creationId xmlns:a16="http://schemas.microsoft.com/office/drawing/2014/main" id="{D3270DB3-054E-40A3-853E-9C1C172303D0}"/>
+                <a16:creationId xmlns:a16="http://schemas.microsoft.com/office/drawing/2014/main" id="{6F8C8D87-65DF-4DA4-BFF3-EC94EB5AB28C}"/>
               </a:ext>
             </a:extLst>
           </p:cNvPr>
@@ -10924,7 +10924,7 @@
           <p:cNvPr id="22" name="">
             <a:extLst xmlns:a="http://schemas.openxmlformats.org/drawingml/2006/main">
               <a:ext uri="{FF2B5EF4-FFF2-40B4-BE49-F238E27FC236}">
-                <a16:creationId xmlns:a16="http://schemas.microsoft.com/office/drawing/2014/main" id="{E71AE296-918F-4714-AC08-E604ACF846A6}"/>
+                <a16:creationId xmlns:a16="http://schemas.microsoft.com/office/drawing/2014/main" id="{3D6D5100-DA6B-4894-879A-ABFB5E859166}"/>
               </a:ext>
             </a:extLst>
           </p:cNvPr>
@@ -10957,7 +10957,7 @@
           <p:cNvPr id="23" name="">
             <a:extLst xmlns:a="http://schemas.openxmlformats.org/drawingml/2006/main">
               <a:ext uri="{FF2B5EF4-FFF2-40B4-BE49-F238E27FC236}">
-                <a16:creationId xmlns:a16="http://schemas.microsoft.com/office/drawing/2014/main" id="{6C10F986-3579-4333-8E4E-D580B902FED0}"/>
+                <a16:creationId xmlns:a16="http://schemas.microsoft.com/office/drawing/2014/main" id="{57C26708-86AF-465B-8FA5-C0DBD4D9F1D0}"/>
               </a:ext>
             </a:extLst>
           </p:cNvPr>
@@ -10990,7 +10990,7 @@
           <p:cNvPr id="24" name="">
             <a:extLst xmlns:a="http://schemas.openxmlformats.org/drawingml/2006/main">
               <a:ext uri="{FF2B5EF4-FFF2-40B4-BE49-F238E27FC236}">
-                <a16:creationId xmlns:a16="http://schemas.microsoft.com/office/drawing/2014/main" id="{CACF2F90-4DCC-41AF-A541-476B883F0BA4}"/>
+                <a16:creationId xmlns:a16="http://schemas.microsoft.com/office/drawing/2014/main" id="{2FEBF936-9777-48C3-9368-8CF88002B150}"/>
               </a:ext>
             </a:extLst>
           </p:cNvPr>
@@ -11023,7 +11023,7 @@
           <p:cNvPr id="25" name="">
             <a:extLst xmlns:a="http://schemas.openxmlformats.org/drawingml/2006/main">
               <a:ext uri="{FF2B5EF4-FFF2-40B4-BE49-F238E27FC236}">
-                <a16:creationId xmlns:a16="http://schemas.microsoft.com/office/drawing/2014/main" id="{FCA42D3D-B2A4-4E96-AB60-55295620B5CC}"/>
+                <a16:creationId xmlns:a16="http://schemas.microsoft.com/office/drawing/2014/main" id="{8A9A52E6-0FC5-4F6E-861A-A08EA4854968}"/>
               </a:ext>
             </a:extLst>
           </p:cNvPr>
@@ -11073,7 +11073,7 @@
           <p:cNvPr id="26" name="">
             <a:extLst xmlns:a="http://schemas.openxmlformats.org/drawingml/2006/main">
               <a:ext uri="{FF2B5EF4-FFF2-40B4-BE49-F238E27FC236}">
-                <a16:creationId xmlns:a16="http://schemas.microsoft.com/office/drawing/2014/main" id="{231FD020-DA69-4726-8EAD-54876AC222F8}"/>
+                <a16:creationId xmlns:a16="http://schemas.microsoft.com/office/drawing/2014/main" id="{3916D240-774C-4465-AB26-698BCB7383CE}"/>
               </a:ext>
             </a:extLst>
           </p:cNvPr>
@@ -11121,7 +11121,7 @@
     </p:spTree>
     <p:extLst>
       <p:ext uri="{BB962C8B-B14F-4D97-AF65-F5344CB8AC3E}">
-        <p14:creationId xmlns:p14="http://schemas.microsoft.com/office/powerpoint/2010/main" val="324251628"/>
+        <p14:creationId xmlns:p14="http://schemas.microsoft.com/office/powerpoint/2010/main" val="117688224"/>
       </p:ext>
     </p:extLst>
   </p:cSld>
@@ -11152,7 +11152,7 @@
           <p:cNvPr id="41" name="">
             <a:extLst xmlns:a="http://schemas.openxmlformats.org/drawingml/2006/main">
               <a:ext uri="{FF2B5EF4-FFF2-40B4-BE49-F238E27FC236}">
-                <a16:creationId xmlns:a16="http://schemas.microsoft.com/office/drawing/2014/main" id="{A97F7C7F-6A70-409D-B318-4DEC957BA611}"/>
+                <a16:creationId xmlns:a16="http://schemas.microsoft.com/office/drawing/2014/main" id="{DA08FDB0-AACB-4C84-8DCC-AA78F4B8E598}"/>
               </a:ext>
             </a:extLst>
           </p:cNvPr>
@@ -11202,7 +11202,7 @@
           <p:cNvPr id="2" name="">
             <a:extLst xmlns:a="http://schemas.openxmlformats.org/drawingml/2006/main">
               <a:ext uri="{FF2B5EF4-FFF2-40B4-BE49-F238E27FC236}">
-                <a16:creationId xmlns:a16="http://schemas.microsoft.com/office/drawing/2014/main" id="{76AC60EB-087D-492F-BD4C-CE6ED6266C8E}"/>
+                <a16:creationId xmlns:a16="http://schemas.microsoft.com/office/drawing/2014/main" id="{C072052A-7DA3-4E0A-B2AE-B578DCB374A6}"/>
               </a:ext>
             </a:extLst>
           </p:cNvPr>
@@ -11252,7 +11252,7 @@
           <p:cNvPr id="3" name="">
             <a:extLst xmlns:a="http://schemas.openxmlformats.org/drawingml/2006/main">
               <a:ext uri="{FF2B5EF4-FFF2-40B4-BE49-F238E27FC236}">
-                <a16:creationId xmlns:a16="http://schemas.microsoft.com/office/drawing/2014/main" id="{A35FFAB3-F49C-4136-B6AA-CAF9CFAD54FA}"/>
+                <a16:creationId xmlns:a16="http://schemas.microsoft.com/office/drawing/2014/main" id="{B89976DF-C653-4EF2-B7BF-2DC661529C51}"/>
               </a:ext>
             </a:extLst>
           </p:cNvPr>
@@ -11285,7 +11285,7 @@
           <p:cNvPr id="4" name="">
             <a:extLst xmlns:a="http://schemas.openxmlformats.org/drawingml/2006/main">
               <a:ext uri="{FF2B5EF4-FFF2-40B4-BE49-F238E27FC236}">
-                <a16:creationId xmlns:a16="http://schemas.microsoft.com/office/drawing/2014/main" id="{737133C3-1F1C-4D78-9E53-82A3CB659A79}"/>
+                <a16:creationId xmlns:a16="http://schemas.microsoft.com/office/drawing/2014/main" id="{11EE4691-CE03-4F1C-B8FD-103945771F39}"/>
               </a:ext>
             </a:extLst>
           </p:cNvPr>
@@ -11335,7 +11335,7 @@
           <p:cNvPr id="5" name="">
             <a:extLst xmlns:a="http://schemas.openxmlformats.org/drawingml/2006/main">
               <a:ext uri="{FF2B5EF4-FFF2-40B4-BE49-F238E27FC236}">
-                <a16:creationId xmlns:a16="http://schemas.microsoft.com/office/drawing/2014/main" id="{9B112CA3-F49F-4E22-9C4E-CFACD3BE8908}"/>
+                <a16:creationId xmlns:a16="http://schemas.microsoft.com/office/drawing/2014/main" id="{6FE51D4A-F9E5-447D-B098-65E8834C704D}"/>
               </a:ext>
             </a:extLst>
           </p:cNvPr>
@@ -11368,7 +11368,7 @@
           <p:cNvPr id="6" name="">
             <a:extLst xmlns:a="http://schemas.openxmlformats.org/drawingml/2006/main">
               <a:ext uri="{FF2B5EF4-FFF2-40B4-BE49-F238E27FC236}">
-                <a16:creationId xmlns:a16="http://schemas.microsoft.com/office/drawing/2014/main" id="{501ABFF7-1D66-48EB-86D2-3C12FEA07EC6}"/>
+                <a16:creationId xmlns:a16="http://schemas.microsoft.com/office/drawing/2014/main" id="{4B41A163-B0DE-4609-9CB9-0BBB7CBCDDF6}"/>
               </a:ext>
             </a:extLst>
           </p:cNvPr>
@@ -11418,7 +11418,7 @@
           <p:cNvPr id="7" name="">
             <a:extLst xmlns:a="http://schemas.openxmlformats.org/drawingml/2006/main">
               <a:ext uri="{FF2B5EF4-FFF2-40B4-BE49-F238E27FC236}">
-                <a16:creationId xmlns:a16="http://schemas.microsoft.com/office/drawing/2014/main" id="{20ABF5D6-5CF8-43D3-8CED-39265AD74192}"/>
+                <a16:creationId xmlns:a16="http://schemas.microsoft.com/office/drawing/2014/main" id="{1990BBAB-F0B3-4450-940E-5CA18BC36CDD}"/>
               </a:ext>
             </a:extLst>
           </p:cNvPr>
@@ -11468,7 +11468,7 @@
           <p:cNvPr id="8" name="">
             <a:extLst xmlns:a="http://schemas.openxmlformats.org/drawingml/2006/main">
               <a:ext uri="{FF2B5EF4-FFF2-40B4-BE49-F238E27FC236}">
-                <a16:creationId xmlns:a16="http://schemas.microsoft.com/office/drawing/2014/main" id="{4B741160-06F5-4EBB-8196-367018DE14C6}"/>
+                <a16:creationId xmlns:a16="http://schemas.microsoft.com/office/drawing/2014/main" id="{4F588676-7786-4C64-897B-5E61A096079B}"/>
               </a:ext>
             </a:extLst>
           </p:cNvPr>
@@ -11501,7 +11501,7 @@
           <p:cNvPr id="9" name="">
             <a:extLst xmlns:a="http://schemas.openxmlformats.org/drawingml/2006/main">
               <a:ext uri="{FF2B5EF4-FFF2-40B4-BE49-F238E27FC236}">
-                <a16:creationId xmlns:a16="http://schemas.microsoft.com/office/drawing/2014/main" id="{A418FB42-F557-4A49-83B4-A68A3C9D56E6}"/>
+                <a16:creationId xmlns:a16="http://schemas.microsoft.com/office/drawing/2014/main" id="{6EF4CB8B-BFB5-4D71-BD04-F38514256A89}"/>
               </a:ext>
             </a:extLst>
           </p:cNvPr>
@@ -11551,7 +11551,7 @@
           <p:cNvPr id="10" name="">
             <a:extLst xmlns:a="http://schemas.openxmlformats.org/drawingml/2006/main">
               <a:ext uri="{FF2B5EF4-FFF2-40B4-BE49-F238E27FC236}">
-                <a16:creationId xmlns:a16="http://schemas.microsoft.com/office/drawing/2014/main" id="{01E26FE1-64F2-4665-A286-372640B42BCD}"/>
+                <a16:creationId xmlns:a16="http://schemas.microsoft.com/office/drawing/2014/main" id="{E3F09D5D-CC05-4073-809C-B0098278E829}"/>
               </a:ext>
             </a:extLst>
           </p:cNvPr>
@@ -11601,7 +11601,7 @@
           <p:cNvPr id="11" name="">
             <a:extLst xmlns:a="http://schemas.openxmlformats.org/drawingml/2006/main">
               <a:ext uri="{FF2B5EF4-FFF2-40B4-BE49-F238E27FC236}">
-                <a16:creationId xmlns:a16="http://schemas.microsoft.com/office/drawing/2014/main" id="{65336C92-C9B8-48BD-A817-F574CB1CAD35}"/>
+                <a16:creationId xmlns:a16="http://schemas.microsoft.com/office/drawing/2014/main" id="{5FCB401D-19F3-44B2-9B16-67A09A6239D9}"/>
               </a:ext>
             </a:extLst>
           </p:cNvPr>
@@ -11634,7 +11634,7 @@
           <p:cNvPr id="12" name="">
             <a:extLst xmlns:a="http://schemas.openxmlformats.org/drawingml/2006/main">
               <a:ext uri="{FF2B5EF4-FFF2-40B4-BE49-F238E27FC236}">
-                <a16:creationId xmlns:a16="http://schemas.microsoft.com/office/drawing/2014/main" id="{ABB32A47-5002-4F25-97B2-52E3A29AFBE5}"/>
+                <a16:creationId xmlns:a16="http://schemas.microsoft.com/office/drawing/2014/main" id="{C7D410F2-18C1-424B-BCEA-F09AD2BFF4DB}"/>
               </a:ext>
             </a:extLst>
           </p:cNvPr>
@@ -11684,7 +11684,7 @@
           <p:cNvPr id="13" name="">
             <a:extLst xmlns:a="http://schemas.openxmlformats.org/drawingml/2006/main">
               <a:ext uri="{FF2B5EF4-FFF2-40B4-BE49-F238E27FC236}">
-                <a16:creationId xmlns:a16="http://schemas.microsoft.com/office/drawing/2014/main" id="{26C03B51-A713-438F-8203-C60664A763B9}"/>
+                <a16:creationId xmlns:a16="http://schemas.microsoft.com/office/drawing/2014/main" id="{1C04044C-3DC9-4B25-B1C3-C73735225EC2}"/>
               </a:ext>
             </a:extLst>
           </p:cNvPr>
@@ -11734,7 +11734,7 @@
           <p:cNvPr id="14" name="">
             <a:extLst xmlns:a="http://schemas.openxmlformats.org/drawingml/2006/main">
               <a:ext uri="{FF2B5EF4-FFF2-40B4-BE49-F238E27FC236}">
-                <a16:creationId xmlns:a16="http://schemas.microsoft.com/office/drawing/2014/main" id="{299B4D1F-B5D9-4F4D-AFF8-61854114A964}"/>
+                <a16:creationId xmlns:a16="http://schemas.microsoft.com/office/drawing/2014/main" id="{6DBBA4E9-C4EA-4280-9E5A-ACF52085FE28}"/>
               </a:ext>
             </a:extLst>
           </p:cNvPr>
@@ -11767,7 +11767,7 @@
           <p:cNvPr id="15" name="">
             <a:extLst xmlns:a="http://schemas.openxmlformats.org/drawingml/2006/main">
               <a:ext uri="{FF2B5EF4-FFF2-40B4-BE49-F238E27FC236}">
-                <a16:creationId xmlns:a16="http://schemas.microsoft.com/office/drawing/2014/main" id="{7EDE6BD0-041A-4D17-9B2A-E3B8DB90BFEA}"/>
+                <a16:creationId xmlns:a16="http://schemas.microsoft.com/office/drawing/2014/main" id="{DD10E527-E85F-412B-AA8C-C060B3586B36}"/>
               </a:ext>
             </a:extLst>
           </p:cNvPr>
@@ -11817,7 +11817,7 @@
           <p:cNvPr id="16" name="">
             <a:extLst xmlns:a="http://schemas.openxmlformats.org/drawingml/2006/main">
               <a:ext uri="{FF2B5EF4-FFF2-40B4-BE49-F238E27FC236}">
-                <a16:creationId xmlns:a16="http://schemas.microsoft.com/office/drawing/2014/main" id="{30DFE01F-E6F4-4D8B-9F1F-26B7D5C5A0CD}"/>
+                <a16:creationId xmlns:a16="http://schemas.microsoft.com/office/drawing/2014/main" id="{14EDED99-3F68-4CD9-8F31-90BDE59CE511}"/>
               </a:ext>
             </a:extLst>
           </p:cNvPr>
@@ -11867,7 +11867,7 @@
           <p:cNvPr id="17" name="">
             <a:extLst xmlns:a="http://schemas.openxmlformats.org/drawingml/2006/main">
               <a:ext uri="{FF2B5EF4-FFF2-40B4-BE49-F238E27FC236}">
-                <a16:creationId xmlns:a16="http://schemas.microsoft.com/office/drawing/2014/main" id="{147ADC1D-A000-4486-B5A4-57A38CD34383}"/>
+                <a16:creationId xmlns:a16="http://schemas.microsoft.com/office/drawing/2014/main" id="{14114DD8-90F8-4500-8EE8-DB8FEBDEA86E}"/>
               </a:ext>
             </a:extLst>
           </p:cNvPr>
@@ -11900,7 +11900,7 @@
           <p:cNvPr id="18" name="">
             <a:extLst xmlns:a="http://schemas.openxmlformats.org/drawingml/2006/main">
               <a:ext uri="{FF2B5EF4-FFF2-40B4-BE49-F238E27FC236}">
-                <a16:creationId xmlns:a16="http://schemas.microsoft.com/office/drawing/2014/main" id="{B66FB210-13A2-4303-8BF6-F452FB9E025A}"/>
+                <a16:creationId xmlns:a16="http://schemas.microsoft.com/office/drawing/2014/main" id="{E355BCA6-9117-4989-833B-267D858E7204}"/>
               </a:ext>
             </a:extLst>
           </p:cNvPr>
@@ -11950,7 +11950,7 @@
           <p:cNvPr id="19" name="">
             <a:extLst xmlns:a="http://schemas.openxmlformats.org/drawingml/2006/main">
               <a:ext uri="{FF2B5EF4-FFF2-40B4-BE49-F238E27FC236}">
-                <a16:creationId xmlns:a16="http://schemas.microsoft.com/office/drawing/2014/main" id="{73817053-C37D-4435-932B-69230E23C730}"/>
+                <a16:creationId xmlns:a16="http://schemas.microsoft.com/office/drawing/2014/main" id="{D33A4AE8-DDB0-4853-A7E5-621FF374EF66}"/>
               </a:ext>
             </a:extLst>
           </p:cNvPr>
@@ -12000,7 +12000,7 @@
           <p:cNvPr id="20" name="">
             <a:extLst xmlns:a="http://schemas.openxmlformats.org/drawingml/2006/main">
               <a:ext uri="{FF2B5EF4-FFF2-40B4-BE49-F238E27FC236}">
-                <a16:creationId xmlns:a16="http://schemas.microsoft.com/office/drawing/2014/main" id="{0C7EB84D-7740-4DEF-8461-0183CD359915}"/>
+                <a16:creationId xmlns:a16="http://schemas.microsoft.com/office/drawing/2014/main" id="{097E517C-0151-4C88-A6F5-E63EAFE4E6B6}"/>
               </a:ext>
             </a:extLst>
           </p:cNvPr>
@@ -12033,7 +12033,7 @@
           <p:cNvPr id="21" name="">
             <a:extLst xmlns:a="http://schemas.openxmlformats.org/drawingml/2006/main">
               <a:ext uri="{FF2B5EF4-FFF2-40B4-BE49-F238E27FC236}">
-                <a16:creationId xmlns:a16="http://schemas.microsoft.com/office/drawing/2014/main" id="{F149EBCE-44FA-4B8C-A840-173CDE0ACE75}"/>
+                <a16:creationId xmlns:a16="http://schemas.microsoft.com/office/drawing/2014/main" id="{212B1608-8A22-4800-9E1B-067CFA832F24}"/>
               </a:ext>
             </a:extLst>
           </p:cNvPr>
@@ -12083,7 +12083,7 @@
           <p:cNvPr id="22" name="">
             <a:extLst xmlns:a="http://schemas.openxmlformats.org/drawingml/2006/main">
               <a:ext uri="{FF2B5EF4-FFF2-40B4-BE49-F238E27FC236}">
-                <a16:creationId xmlns:a16="http://schemas.microsoft.com/office/drawing/2014/main" id="{8A9907EA-8244-4600-8FDC-649337AE9459}"/>
+                <a16:creationId xmlns:a16="http://schemas.microsoft.com/office/drawing/2014/main" id="{E2FCFDE0-3518-4212-827A-8D0625427A82}"/>
               </a:ext>
             </a:extLst>
           </p:cNvPr>
@@ -12133,7 +12133,7 @@
           <p:cNvPr id="23" name="">
             <a:extLst xmlns:a="http://schemas.openxmlformats.org/drawingml/2006/main">
               <a:ext uri="{FF2B5EF4-FFF2-40B4-BE49-F238E27FC236}">
-                <a16:creationId xmlns:a16="http://schemas.microsoft.com/office/drawing/2014/main" id="{6663F801-2E18-4B90-992B-BD91E6412986}"/>
+                <a16:creationId xmlns:a16="http://schemas.microsoft.com/office/drawing/2014/main" id="{69CBB17F-5F97-4493-BCE9-B914E521A502}"/>
               </a:ext>
             </a:extLst>
           </p:cNvPr>
@@ -12183,7 +12183,7 @@
           <p:cNvPr id="24" name="">
             <a:extLst xmlns:a="http://schemas.openxmlformats.org/drawingml/2006/main">
               <a:ext uri="{FF2B5EF4-FFF2-40B4-BE49-F238E27FC236}">
-                <a16:creationId xmlns:a16="http://schemas.microsoft.com/office/drawing/2014/main" id="{F6D97049-C8D6-475A-A841-DC78270DEFDD}"/>
+                <a16:creationId xmlns:a16="http://schemas.microsoft.com/office/drawing/2014/main" id="{5610DA31-BBE4-4AF2-953D-FDD4EF86B990}"/>
               </a:ext>
             </a:extLst>
           </p:cNvPr>
@@ -12233,7 +12233,7 @@
           <p:cNvPr id="25" name="">
             <a:extLst xmlns:a="http://schemas.openxmlformats.org/drawingml/2006/main">
               <a:ext uri="{FF2B5EF4-FFF2-40B4-BE49-F238E27FC236}">
-                <a16:creationId xmlns:a16="http://schemas.microsoft.com/office/drawing/2014/main" id="{214C4CE5-F8ED-4BAA-B230-1DC5C760F1E4}"/>
+                <a16:creationId xmlns:a16="http://schemas.microsoft.com/office/drawing/2014/main" id="{CCBFB5E6-5A28-4091-90F0-04A4D9C20B3E}"/>
               </a:ext>
             </a:extLst>
           </p:cNvPr>
@@ -12283,7 +12283,7 @@
           <p:cNvPr id="26" name="">
             <a:extLst xmlns:a="http://schemas.openxmlformats.org/drawingml/2006/main">
               <a:ext uri="{FF2B5EF4-FFF2-40B4-BE49-F238E27FC236}">
-                <a16:creationId xmlns:a16="http://schemas.microsoft.com/office/drawing/2014/main" id="{B2B14A2A-0740-4749-80D5-F1338BF65113}"/>
+                <a16:creationId xmlns:a16="http://schemas.microsoft.com/office/drawing/2014/main" id="{D77E436C-3F8D-405F-B1B5-59989B5A7EA1}"/>
               </a:ext>
             </a:extLst>
           </p:cNvPr>
@@ -12333,7 +12333,7 @@
           <p:cNvPr id="27" name="">
             <a:extLst xmlns:a="http://schemas.openxmlformats.org/drawingml/2006/main">
               <a:ext uri="{FF2B5EF4-FFF2-40B4-BE49-F238E27FC236}">
-                <a16:creationId xmlns:a16="http://schemas.microsoft.com/office/drawing/2014/main" id="{DCF6415E-3464-4B64-9A32-2D090B79C0E4}"/>
+                <a16:creationId xmlns:a16="http://schemas.microsoft.com/office/drawing/2014/main" id="{0963B7FA-203D-4D13-A630-697A59D2AD30}"/>
               </a:ext>
             </a:extLst>
           </p:cNvPr>
@@ -12383,7 +12383,7 @@
           <p:cNvPr id="28" name="">
             <a:extLst xmlns:a="http://schemas.openxmlformats.org/drawingml/2006/main">
               <a:ext uri="{FF2B5EF4-FFF2-40B4-BE49-F238E27FC236}">
-                <a16:creationId xmlns:a16="http://schemas.microsoft.com/office/drawing/2014/main" id="{D5F3F9D4-B53C-4098-AB46-4D8B2DF9BBCF}"/>
+                <a16:creationId xmlns:a16="http://schemas.microsoft.com/office/drawing/2014/main" id="{A6F0AB5A-BE34-4B02-8C89-B4DCE5E8F63C}"/>
               </a:ext>
             </a:extLst>
           </p:cNvPr>
@@ -12433,7 +12433,7 @@
           <p:cNvPr id="29" name="">
             <a:extLst xmlns:a="http://schemas.openxmlformats.org/drawingml/2006/main">
               <a:ext uri="{FF2B5EF4-FFF2-40B4-BE49-F238E27FC236}">
-                <a16:creationId xmlns:a16="http://schemas.microsoft.com/office/drawing/2014/main" id="{00EB0F05-0D84-47EA-9807-458C16F1B345}"/>
+                <a16:creationId xmlns:a16="http://schemas.microsoft.com/office/drawing/2014/main" id="{E71B5479-D76C-4A06-8EFF-CAABCE409454}"/>
               </a:ext>
             </a:extLst>
           </p:cNvPr>
@@ -12483,7 +12483,7 @@
           <p:cNvPr id="30" name="">
             <a:extLst xmlns:a="http://schemas.openxmlformats.org/drawingml/2006/main">
               <a:ext uri="{FF2B5EF4-FFF2-40B4-BE49-F238E27FC236}">
-                <a16:creationId xmlns:a16="http://schemas.microsoft.com/office/drawing/2014/main" id="{56290523-A2A5-47CA-B7E7-E589EADF3D1B}"/>
+                <a16:creationId xmlns:a16="http://schemas.microsoft.com/office/drawing/2014/main" id="{BBA9A9FC-399C-49BE-A21C-D335BF244990}"/>
               </a:ext>
             </a:extLst>
           </p:cNvPr>
@@ -12533,7 +12533,7 @@
           <p:cNvPr id="31" name="">
             <a:extLst xmlns:a="http://schemas.openxmlformats.org/drawingml/2006/main">
               <a:ext uri="{FF2B5EF4-FFF2-40B4-BE49-F238E27FC236}">
-                <a16:creationId xmlns:a16="http://schemas.microsoft.com/office/drawing/2014/main" id="{67772625-06F7-4286-9CEB-7F6C29FA283B}"/>
+                <a16:creationId xmlns:a16="http://schemas.microsoft.com/office/drawing/2014/main" id="{30E35364-73D9-47C7-9258-CE0A235F63DD}"/>
               </a:ext>
             </a:extLst>
           </p:cNvPr>
@@ -12583,7 +12583,7 @@
           <p:cNvPr id="32" name="">
             <a:extLst xmlns:a="http://schemas.openxmlformats.org/drawingml/2006/main">
               <a:ext uri="{FF2B5EF4-FFF2-40B4-BE49-F238E27FC236}">
-                <a16:creationId xmlns:a16="http://schemas.microsoft.com/office/drawing/2014/main" id="{B5859CF6-3C75-43C8-BE92-C322BD15622C}"/>
+                <a16:creationId xmlns:a16="http://schemas.microsoft.com/office/drawing/2014/main" id="{D43A6CC9-E873-44AB-B840-BDF580B61E00}"/>
               </a:ext>
             </a:extLst>
           </p:cNvPr>
@@ -12633,7 +12633,7 @@
           <p:cNvPr id="33" name="">
             <a:extLst xmlns:a="http://schemas.openxmlformats.org/drawingml/2006/main">
               <a:ext uri="{FF2B5EF4-FFF2-40B4-BE49-F238E27FC236}">
-                <a16:creationId xmlns:a16="http://schemas.microsoft.com/office/drawing/2014/main" id="{5E0F832D-3BF8-4CA4-AF8F-88CBAB4AF884}"/>
+                <a16:creationId xmlns:a16="http://schemas.microsoft.com/office/drawing/2014/main" id="{9A811247-1C96-43D0-AE67-71CD31550C27}"/>
               </a:ext>
             </a:extLst>
           </p:cNvPr>
@@ -12683,7 +12683,7 @@
           <p:cNvPr id="34" name="">
             <a:extLst xmlns:a="http://schemas.openxmlformats.org/drawingml/2006/main">
               <a:ext uri="{FF2B5EF4-FFF2-40B4-BE49-F238E27FC236}">
-                <a16:creationId xmlns:a16="http://schemas.microsoft.com/office/drawing/2014/main" id="{CEC6C14B-8F74-425C-AECE-3156D474AE1C}"/>
+                <a16:creationId xmlns:a16="http://schemas.microsoft.com/office/drawing/2014/main" id="{9CBEAF49-07F9-4D75-8A2D-B87A0ADB077E}"/>
               </a:ext>
             </a:extLst>
           </p:cNvPr>
@@ -12733,7 +12733,7 @@
           <p:cNvPr id="35" name="">
             <a:extLst xmlns:a="http://schemas.openxmlformats.org/drawingml/2006/main">
               <a:ext uri="{FF2B5EF4-FFF2-40B4-BE49-F238E27FC236}">
-                <a16:creationId xmlns:a16="http://schemas.microsoft.com/office/drawing/2014/main" id="{01F60380-FA2C-4725-935D-64D872B5F36D}"/>
+                <a16:creationId xmlns:a16="http://schemas.microsoft.com/office/drawing/2014/main" id="{677ABAAE-D4CC-4503-ACA4-AF28EBE23C79}"/>
               </a:ext>
             </a:extLst>
           </p:cNvPr>
@@ -12783,7 +12783,7 @@
           <p:cNvPr id="36" name="">
             <a:extLst xmlns:a="http://schemas.openxmlformats.org/drawingml/2006/main">
               <a:ext uri="{FF2B5EF4-FFF2-40B4-BE49-F238E27FC236}">
-                <a16:creationId xmlns:a16="http://schemas.microsoft.com/office/drawing/2014/main" id="{2F2AA273-3886-4F4C-AC22-658C613F4CF0}"/>
+                <a16:creationId xmlns:a16="http://schemas.microsoft.com/office/drawing/2014/main" id="{F1AA6BA7-B974-4007-A54C-4C815E0B75D0}"/>
               </a:ext>
             </a:extLst>
           </p:cNvPr>
@@ -12816,7 +12816,7 @@
           <p:cNvPr id="37" name="">
             <a:extLst xmlns:a="http://schemas.openxmlformats.org/drawingml/2006/main">
               <a:ext uri="{FF2B5EF4-FFF2-40B4-BE49-F238E27FC236}">
-                <a16:creationId xmlns:a16="http://schemas.microsoft.com/office/drawing/2014/main" id="{9F12F8DE-5E49-4CFD-A461-2A4E27B5AAFD}"/>
+                <a16:creationId xmlns:a16="http://schemas.microsoft.com/office/drawing/2014/main" id="{AB5F25FA-59D8-4095-98D2-F2EC2DEA47FD}"/>
               </a:ext>
             </a:extLst>
           </p:cNvPr>
@@ -12866,7 +12866,7 @@
           <p:cNvPr id="38" name="">
             <a:extLst xmlns:a="http://schemas.openxmlformats.org/drawingml/2006/main">
               <a:ext uri="{FF2B5EF4-FFF2-40B4-BE49-F238E27FC236}">
-                <a16:creationId xmlns:a16="http://schemas.microsoft.com/office/drawing/2014/main" id="{8F3B512A-0C9A-46E9-BFFD-E64E7AC5079F}"/>
+                <a16:creationId xmlns:a16="http://schemas.microsoft.com/office/drawing/2014/main" id="{755C3F38-DEC8-4576-937F-0538B4673298}"/>
               </a:ext>
             </a:extLst>
           </p:cNvPr>
@@ -12906,7 +12906,7 @@
                   <a:srgbClr val="111827"/>
                 </a:solidFill>
               </a:rPr>
-              <a:t>請貼上最終展示影片 URL：________________________________________</a:t>
+              <a:t>影片連結：________________________________________</a:t>
             </a:r>
           </a:p>
         </p:txBody>
@@ -12916,7 +12916,7 @@
           <p:cNvPr id="39" name="">
             <a:extLst xmlns:a="http://schemas.openxmlformats.org/drawingml/2006/main">
               <a:ext uri="{FF2B5EF4-FFF2-40B4-BE49-F238E27FC236}">
-                <a16:creationId xmlns:a16="http://schemas.microsoft.com/office/drawing/2014/main" id="{1BD53DA3-D287-451F-A35F-AAD1C8E0B15C}"/>
+                <a16:creationId xmlns:a16="http://schemas.microsoft.com/office/drawing/2014/main" id="{B249FFC8-346C-45C4-8EE5-8F48F490453C}"/>
               </a:ext>
             </a:extLst>
           </p:cNvPr>
@@ -12949,7 +12949,7 @@
           <p:cNvPr id="40" name="">
             <a:extLst xmlns:a="http://schemas.openxmlformats.org/drawingml/2006/main">
               <a:ext uri="{FF2B5EF4-FFF2-40B4-BE49-F238E27FC236}">
-                <a16:creationId xmlns:a16="http://schemas.microsoft.com/office/drawing/2014/main" id="{3C1346A8-2ACC-4C2B-970F-EB9F1FCBDCF2}"/>
+                <a16:creationId xmlns:a16="http://schemas.microsoft.com/office/drawing/2014/main" id="{BD8DCC5E-A69E-41AE-990E-25A90AF79FB3}"/>
               </a:ext>
             </a:extLst>
           </p:cNvPr>
@@ -13031,7 +13031,7 @@
     </p:spTree>
     <p:extLst>
       <p:ext uri="{BB962C8B-B14F-4D97-AF65-F5344CB8AC3E}">
-        <p14:creationId xmlns:p14="http://schemas.microsoft.com/office/powerpoint/2010/main" val="1523963759"/>
+        <p14:creationId xmlns:p14="http://schemas.microsoft.com/office/powerpoint/2010/main" val="1404641921"/>
       </p:ext>
     </p:extLst>
   </p:cSld>

</xml_diff>

<commit_message>
docs: add demo video link
</commit_message>
<xml_diff>
--- a/outputs/EGO1_Flappy_Bird_FPGA_8頁書面型PPT報告.pptx
+++ b/outputs/EGO1_Flappy_Bird_FPGA_8頁書面型PPT報告.pptx
@@ -2,20 +2,20 @@
 <file path=ppt/presentation.xml><?xml version="1.0" encoding="utf-8"?>
 <p:presentation xmlns:p="http://schemas.openxmlformats.org/presentationml/2006/main">
   <p:sldMasterIdLst>
-    <p:sldMasterId xmlns:r="http://schemas.openxmlformats.org/officeDocument/2006/relationships" id="2147483648" r:id="R85ebbdc84f3c4e0d"/>
+    <p:sldMasterId xmlns:r="http://schemas.openxmlformats.org/officeDocument/2006/relationships" id="2147483648" r:id="Rdc64008c44c3498d"/>
   </p:sldMasterIdLst>
   <p:notesMasterIdLst>
-    <p:notesMasterId xmlns:r="http://schemas.openxmlformats.org/officeDocument/2006/relationships" r:id="Rc8f5f22c0faa493f"/>
+    <p:notesMasterId xmlns:r="http://schemas.openxmlformats.org/officeDocument/2006/relationships" r:id="R2cde1cf157d24ff8"/>
   </p:notesMasterIdLst>
   <p:sldIdLst>
-    <p:sldId xmlns:r="http://schemas.openxmlformats.org/officeDocument/2006/relationships" id="256" r:id="R05b213a607574e0f"/>
-    <p:sldId xmlns:r="http://schemas.openxmlformats.org/officeDocument/2006/relationships" id="257" r:id="Rbbb0e83c15dd4cce"/>
-    <p:sldId xmlns:r="http://schemas.openxmlformats.org/officeDocument/2006/relationships" id="258" r:id="R9820f7fade56408b"/>
-    <p:sldId xmlns:r="http://schemas.openxmlformats.org/officeDocument/2006/relationships" id="259" r:id="Rf9387d3b1b004bcd"/>
-    <p:sldId xmlns:r="http://schemas.openxmlformats.org/officeDocument/2006/relationships" id="260" r:id="R075fbfefa9c340d7"/>
-    <p:sldId xmlns:r="http://schemas.openxmlformats.org/officeDocument/2006/relationships" id="261" r:id="R84f95f499af64ace"/>
-    <p:sldId xmlns:r="http://schemas.openxmlformats.org/officeDocument/2006/relationships" id="262" r:id="R42c4fe5e0c76448e"/>
-    <p:sldId xmlns:r="http://schemas.openxmlformats.org/officeDocument/2006/relationships" id="263" r:id="Rdab3ddeab09a4f5d"/>
+    <p:sldId xmlns:r="http://schemas.openxmlformats.org/officeDocument/2006/relationships" id="256" r:id="R6e73b08fbf9b4faf"/>
+    <p:sldId xmlns:r="http://schemas.openxmlformats.org/officeDocument/2006/relationships" id="257" r:id="R98ef6135473f4979"/>
+    <p:sldId xmlns:r="http://schemas.openxmlformats.org/officeDocument/2006/relationships" id="258" r:id="R25912f78b38d4f2a"/>
+    <p:sldId xmlns:r="http://schemas.openxmlformats.org/officeDocument/2006/relationships" id="259" r:id="Rd3e579e717ca4333"/>
+    <p:sldId xmlns:r="http://schemas.openxmlformats.org/officeDocument/2006/relationships" id="260" r:id="R742560edcf4c47e8"/>
+    <p:sldId xmlns:r="http://schemas.openxmlformats.org/officeDocument/2006/relationships" id="261" r:id="R138d8579ddf8426d"/>
+    <p:sldId xmlns:r="http://schemas.openxmlformats.org/officeDocument/2006/relationships" id="262" r:id="R76d76ce4309b4329"/>
+    <p:sldId xmlns:r="http://schemas.openxmlformats.org/officeDocument/2006/relationships" id="263" r:id="R4c046788dfde4a45"/>
   </p:sldIdLst>
   <p:sldSz cx="12192000" cy="6858000"/>
   <p:notesSz cx="6858000" cy="9144000"/>
@@ -1070,7 +1070,7 @@
   </p:cSld>
   <p:clrMap bg1="lt1" tx1="dk1" bg2="lt2" tx2="dk2" accent1="accent1" accent2="accent2" accent3="accent3" accent4="accent4" accent5="accent5" accent6="accent6" hlink="hlink" folHlink="folHlink"/>
   <p:sldLayoutIdLst>
-    <p:sldLayoutId xmlns:r="http://schemas.openxmlformats.org/officeDocument/2006/relationships" id="2147483649" r:id="Rba41b5d1dcef4358"/>
+    <p:sldLayoutId xmlns:r="http://schemas.openxmlformats.org/officeDocument/2006/relationships" id="2147483649" r:id="Rcd3c6b8faca649df"/>
   </p:sldLayoutIdLst>
   <p:txStyles>
     <p:titleStyle>
@@ -1621,7 +1621,7 @@
           <p:cNvPr id="17" name="">
             <a:extLst xmlns:a="http://schemas.openxmlformats.org/drawingml/2006/main">
               <a:ext uri="{FF2B5EF4-FFF2-40B4-BE49-F238E27FC236}">
-                <a16:creationId xmlns:a16="http://schemas.microsoft.com/office/drawing/2014/main" id="{F46EF24D-0269-4F44-A8DD-FD1D4D718B19}"/>
+                <a16:creationId xmlns:a16="http://schemas.microsoft.com/office/drawing/2014/main" id="{AA554BD6-F9A7-4EB1-9573-E088B6A9AD70}"/>
               </a:ext>
             </a:extLst>
           </p:cNvPr>
@@ -1688,7 +1688,7 @@
           <p:cNvPr id="2" name="">
             <a:extLst xmlns:a="http://schemas.openxmlformats.org/drawingml/2006/main">
               <a:ext uri="{FF2B5EF4-FFF2-40B4-BE49-F238E27FC236}">
-                <a16:creationId xmlns:a16="http://schemas.microsoft.com/office/drawing/2014/main" id="{C035E261-E5D1-42CC-BA88-BC4D62D00773}"/>
+                <a16:creationId xmlns:a16="http://schemas.microsoft.com/office/drawing/2014/main" id="{2336B6A5-E6AA-4EE2-8F58-3BA0F245C574}"/>
               </a:ext>
             </a:extLst>
           </p:cNvPr>
@@ -1738,7 +1738,7 @@
           <p:cNvPr id="3" name="">
             <a:extLst xmlns:a="http://schemas.openxmlformats.org/drawingml/2006/main">
               <a:ext uri="{FF2B5EF4-FFF2-40B4-BE49-F238E27FC236}">
-                <a16:creationId xmlns:a16="http://schemas.microsoft.com/office/drawing/2014/main" id="{D86ECC40-E641-4E3B-90EC-96C049A53E0E}"/>
+                <a16:creationId xmlns:a16="http://schemas.microsoft.com/office/drawing/2014/main" id="{53D5490D-2702-499F-A87F-04A31BD56DF3}"/>
               </a:ext>
             </a:extLst>
           </p:cNvPr>
@@ -1788,7 +1788,7 @@
           <p:cNvPr id="4" name="">
             <a:extLst xmlns:a="http://schemas.openxmlformats.org/drawingml/2006/main">
               <a:ext uri="{FF2B5EF4-FFF2-40B4-BE49-F238E27FC236}">
-                <a16:creationId xmlns:a16="http://schemas.microsoft.com/office/drawing/2014/main" id="{E72CF39D-5FF7-422C-8660-8FA5486AC9D0}"/>
+                <a16:creationId xmlns:a16="http://schemas.microsoft.com/office/drawing/2014/main" id="{B238A821-F73D-42EC-B67D-A9D7329613DD}"/>
               </a:ext>
             </a:extLst>
           </p:cNvPr>
@@ -1838,7 +1838,7 @@
           <p:cNvPr id="5" name="">
             <a:extLst xmlns:a="http://schemas.openxmlformats.org/drawingml/2006/main">
               <a:ext uri="{FF2B5EF4-FFF2-40B4-BE49-F238E27FC236}">
-                <a16:creationId xmlns:a16="http://schemas.microsoft.com/office/drawing/2014/main" id="{9EC1511A-AE85-4DC2-8078-81A12BC238C1}"/>
+                <a16:creationId xmlns:a16="http://schemas.microsoft.com/office/drawing/2014/main" id="{651EA773-7166-4C7D-A221-0E4A8243AE15}"/>
               </a:ext>
             </a:extLst>
           </p:cNvPr>
@@ -1888,7 +1888,7 @@
           <p:cNvPr id="6" name="">
             <a:extLst xmlns:a="http://schemas.openxmlformats.org/drawingml/2006/main">
               <a:ext uri="{FF2B5EF4-FFF2-40B4-BE49-F238E27FC236}">
-                <a16:creationId xmlns:a16="http://schemas.microsoft.com/office/drawing/2014/main" id="{56D01323-D867-4DF8-8658-F32CCC873597}"/>
+                <a16:creationId xmlns:a16="http://schemas.microsoft.com/office/drawing/2014/main" id="{B2B907C2-E672-4F07-9E5E-51324C931388}"/>
               </a:ext>
             </a:extLst>
           </p:cNvPr>
@@ -1938,7 +1938,7 @@
           <p:cNvPr id="7" name="">
             <a:extLst xmlns:a="http://schemas.openxmlformats.org/drawingml/2006/main">
               <a:ext uri="{FF2B5EF4-FFF2-40B4-BE49-F238E27FC236}">
-                <a16:creationId xmlns:a16="http://schemas.microsoft.com/office/drawing/2014/main" id="{85E34D44-5130-4DE6-9DAE-F0C024CB7AEB}"/>
+                <a16:creationId xmlns:a16="http://schemas.microsoft.com/office/drawing/2014/main" id="{E5191430-1FE5-4CC6-AA53-2090FD8EF62D}"/>
               </a:ext>
             </a:extLst>
           </p:cNvPr>
@@ -1988,7 +1988,7 @@
           <p:cNvPr id="8" name="">
             <a:extLst xmlns:a="http://schemas.openxmlformats.org/drawingml/2006/main">
               <a:ext uri="{FF2B5EF4-FFF2-40B4-BE49-F238E27FC236}">
-                <a16:creationId xmlns:a16="http://schemas.microsoft.com/office/drawing/2014/main" id="{C0D7CB71-68DC-4BFE-873B-FBBD943C9E0F}"/>
+                <a16:creationId xmlns:a16="http://schemas.microsoft.com/office/drawing/2014/main" id="{8AA603B2-4796-4D0A-BFA4-7B558CB656FE}"/>
               </a:ext>
             </a:extLst>
           </p:cNvPr>
@@ -2021,7 +2021,7 @@
           <p:cNvPr id="9" name="">
             <a:extLst xmlns:a="http://schemas.openxmlformats.org/drawingml/2006/main">
               <a:ext uri="{FF2B5EF4-FFF2-40B4-BE49-F238E27FC236}">
-                <a16:creationId xmlns:a16="http://schemas.microsoft.com/office/drawing/2014/main" id="{21C08C6F-D6E6-432C-8D7D-CD587E68D5B9}"/>
+                <a16:creationId xmlns:a16="http://schemas.microsoft.com/office/drawing/2014/main" id="{84CC9231-F226-404A-8A69-33BCFCDB62C9}"/>
               </a:ext>
             </a:extLst>
           </p:cNvPr>
@@ -2088,7 +2088,7 @@
           <p:cNvPr id="10" name="">
             <a:extLst xmlns:a="http://schemas.openxmlformats.org/drawingml/2006/main">
               <a:ext uri="{FF2B5EF4-FFF2-40B4-BE49-F238E27FC236}">
-                <a16:creationId xmlns:a16="http://schemas.microsoft.com/office/drawing/2014/main" id="{490A18A5-3309-425E-A117-E5CCD9B759F0}"/>
+                <a16:creationId xmlns:a16="http://schemas.microsoft.com/office/drawing/2014/main" id="{C0160785-AF65-4E17-9A7F-80F615FA7DB0}"/>
               </a:ext>
             </a:extLst>
           </p:cNvPr>
@@ -2121,7 +2121,7 @@
           <p:cNvPr id="11" name="">
             <a:extLst xmlns:a="http://schemas.openxmlformats.org/drawingml/2006/main">
               <a:ext uri="{FF2B5EF4-FFF2-40B4-BE49-F238E27FC236}">
-                <a16:creationId xmlns:a16="http://schemas.microsoft.com/office/drawing/2014/main" id="{58CE4695-7313-457F-A6FA-8F17FAC10B21}"/>
+                <a16:creationId xmlns:a16="http://schemas.microsoft.com/office/drawing/2014/main" id="{56ED33CA-B4E6-4B96-A2BA-485580FB1E9B}"/>
               </a:ext>
             </a:extLst>
           </p:cNvPr>
@@ -2188,7 +2188,7 @@
           <p:cNvPr id="12" name="">
             <a:extLst xmlns:a="http://schemas.openxmlformats.org/drawingml/2006/main">
               <a:ext uri="{FF2B5EF4-FFF2-40B4-BE49-F238E27FC236}">
-                <a16:creationId xmlns:a16="http://schemas.microsoft.com/office/drawing/2014/main" id="{4B57ED62-CAED-4E3A-97F9-3A5EAA4EF1B5}"/>
+                <a16:creationId xmlns:a16="http://schemas.microsoft.com/office/drawing/2014/main" id="{337F0A09-18A3-4AD6-9DDF-A42603EF468A}"/>
               </a:ext>
             </a:extLst>
           </p:cNvPr>
@@ -2221,7 +2221,7 @@
           <p:cNvPr id="13" name="">
             <a:extLst xmlns:a="http://schemas.openxmlformats.org/drawingml/2006/main">
               <a:ext uri="{FF2B5EF4-FFF2-40B4-BE49-F238E27FC236}">
-                <a16:creationId xmlns:a16="http://schemas.microsoft.com/office/drawing/2014/main" id="{73D5C423-20DB-4730-BB4A-2A5FB46A980E}"/>
+                <a16:creationId xmlns:a16="http://schemas.microsoft.com/office/drawing/2014/main" id="{78276C7D-C329-4280-AF51-67B130A0FE64}"/>
               </a:ext>
             </a:extLst>
           </p:cNvPr>
@@ -2288,7 +2288,7 @@
           <p:cNvPr id="14" name="">
             <a:extLst xmlns:a="http://schemas.openxmlformats.org/drawingml/2006/main">
               <a:ext uri="{FF2B5EF4-FFF2-40B4-BE49-F238E27FC236}">
-                <a16:creationId xmlns:a16="http://schemas.microsoft.com/office/drawing/2014/main" id="{9788711F-0E70-45BF-9D6F-AE3D7A42B638}"/>
+                <a16:creationId xmlns:a16="http://schemas.microsoft.com/office/drawing/2014/main" id="{BB5A3EA4-532E-45C0-A6AC-8075CF83B724}"/>
               </a:ext>
             </a:extLst>
           </p:cNvPr>
@@ -2321,7 +2321,7 @@
           <p:cNvPr id="15" name="">
             <a:extLst xmlns:a="http://schemas.openxmlformats.org/drawingml/2006/main">
               <a:ext uri="{FF2B5EF4-FFF2-40B4-BE49-F238E27FC236}">
-                <a16:creationId xmlns:a16="http://schemas.microsoft.com/office/drawing/2014/main" id="{032D8EAD-B9B2-4350-9DE2-117B58CD3FBA}"/>
+                <a16:creationId xmlns:a16="http://schemas.microsoft.com/office/drawing/2014/main" id="{54C83B70-B948-468E-B3CF-7E15B34D21C2}"/>
               </a:ext>
             </a:extLst>
           </p:cNvPr>
@@ -2388,7 +2388,7 @@
           <p:cNvPr id="16" name="">
             <a:extLst xmlns:a="http://schemas.openxmlformats.org/drawingml/2006/main">
               <a:ext uri="{FF2B5EF4-FFF2-40B4-BE49-F238E27FC236}">
-                <a16:creationId xmlns:a16="http://schemas.microsoft.com/office/drawing/2014/main" id="{D225635C-7CD5-4AC9-A82F-38B49D5028DF}"/>
+                <a16:creationId xmlns:a16="http://schemas.microsoft.com/office/drawing/2014/main" id="{FF62F70F-3E17-49BB-8CE1-F6B923979225}"/>
               </a:ext>
             </a:extLst>
           </p:cNvPr>
@@ -2436,7 +2436,7 @@
     </p:spTree>
     <p:extLst>
       <p:ext uri="{BB962C8B-B14F-4D97-AF65-F5344CB8AC3E}">
-        <p14:creationId xmlns:p14="http://schemas.microsoft.com/office/powerpoint/2010/main" val="1439702434"/>
+        <p14:creationId xmlns:p14="http://schemas.microsoft.com/office/powerpoint/2010/main" val="1678769162"/>
       </p:ext>
     </p:extLst>
   </p:cSld>
@@ -2467,7 +2467,7 @@
           <p:cNvPr id="43" name="">
             <a:extLst xmlns:a="http://schemas.openxmlformats.org/drawingml/2006/main">
               <a:ext uri="{FF2B5EF4-FFF2-40B4-BE49-F238E27FC236}">
-                <a16:creationId xmlns:a16="http://schemas.microsoft.com/office/drawing/2014/main" id="{3FA64805-9634-4CF4-A1EF-A2BEF8B8F0FB}"/>
+                <a16:creationId xmlns:a16="http://schemas.microsoft.com/office/drawing/2014/main" id="{DA2705C2-7043-48A3-BDF3-B254FDF81CC9}"/>
               </a:ext>
             </a:extLst>
           </p:cNvPr>
@@ -2517,7 +2517,7 @@
           <p:cNvPr id="2" name="">
             <a:extLst xmlns:a="http://schemas.openxmlformats.org/drawingml/2006/main">
               <a:ext uri="{FF2B5EF4-FFF2-40B4-BE49-F238E27FC236}">
-                <a16:creationId xmlns:a16="http://schemas.microsoft.com/office/drawing/2014/main" id="{4D1A95EE-7B0B-457B-891F-9F394C60E26E}"/>
+                <a16:creationId xmlns:a16="http://schemas.microsoft.com/office/drawing/2014/main" id="{8D87B63F-6A14-4F3B-A8E8-A65CE36B10A4}"/>
               </a:ext>
             </a:extLst>
           </p:cNvPr>
@@ -2567,7 +2567,7 @@
           <p:cNvPr id="3" name="">
             <a:extLst xmlns:a="http://schemas.openxmlformats.org/drawingml/2006/main">
               <a:ext uri="{FF2B5EF4-FFF2-40B4-BE49-F238E27FC236}">
-                <a16:creationId xmlns:a16="http://schemas.microsoft.com/office/drawing/2014/main" id="{68CE0315-0D90-4B60-AF8A-A3219BD811B8}"/>
+                <a16:creationId xmlns:a16="http://schemas.microsoft.com/office/drawing/2014/main" id="{194CD19F-A5DC-49CE-A80F-17597C1983D8}"/>
               </a:ext>
             </a:extLst>
           </p:cNvPr>
@@ -2600,7 +2600,7 @@
           <p:cNvPr id="4" name="">
             <a:extLst xmlns:a="http://schemas.openxmlformats.org/drawingml/2006/main">
               <a:ext uri="{FF2B5EF4-FFF2-40B4-BE49-F238E27FC236}">
-                <a16:creationId xmlns:a16="http://schemas.microsoft.com/office/drawing/2014/main" id="{D8114CA4-EA93-4A5C-84DB-5F6179283372}"/>
+                <a16:creationId xmlns:a16="http://schemas.microsoft.com/office/drawing/2014/main" id="{FDF52285-DCED-4C44-A47F-0CFFD391E89E}"/>
               </a:ext>
             </a:extLst>
           </p:cNvPr>
@@ -2650,7 +2650,7 @@
           <p:cNvPr id="5" name="">
             <a:extLst xmlns:a="http://schemas.openxmlformats.org/drawingml/2006/main">
               <a:ext uri="{FF2B5EF4-FFF2-40B4-BE49-F238E27FC236}">
-                <a16:creationId xmlns:a16="http://schemas.microsoft.com/office/drawing/2014/main" id="{A738ADCD-760B-460B-9A74-4720E48ED507}"/>
+                <a16:creationId xmlns:a16="http://schemas.microsoft.com/office/drawing/2014/main" id="{466A9943-8C1D-4CD3-AAFD-A82264DB7E6F}"/>
               </a:ext>
             </a:extLst>
           </p:cNvPr>
@@ -2683,7 +2683,7 @@
           <p:cNvPr id="6" name="">
             <a:extLst xmlns:a="http://schemas.openxmlformats.org/drawingml/2006/main">
               <a:ext uri="{FF2B5EF4-FFF2-40B4-BE49-F238E27FC236}">
-                <a16:creationId xmlns:a16="http://schemas.microsoft.com/office/drawing/2014/main" id="{5251623B-C2E7-41BF-8D26-1AFDBAD3FCF4}"/>
+                <a16:creationId xmlns:a16="http://schemas.microsoft.com/office/drawing/2014/main" id="{CB595CCC-F74F-4357-B21C-A464BEB5A0ED}"/>
               </a:ext>
             </a:extLst>
           </p:cNvPr>
@@ -2716,7 +2716,7 @@
           <p:cNvPr id="7" name="">
             <a:extLst xmlns:a="http://schemas.openxmlformats.org/drawingml/2006/main">
               <a:ext uri="{FF2B5EF4-FFF2-40B4-BE49-F238E27FC236}">
-                <a16:creationId xmlns:a16="http://schemas.microsoft.com/office/drawing/2014/main" id="{48AFAF1F-84AE-4C0D-BF8F-E5E861C7020F}"/>
+                <a16:creationId xmlns:a16="http://schemas.microsoft.com/office/drawing/2014/main" id="{7B8334F2-42A8-4A75-AFCA-8DC84943A1E1}"/>
               </a:ext>
             </a:extLst>
           </p:cNvPr>
@@ -2766,7 +2766,7 @@
           <p:cNvPr id="8" name="">
             <a:extLst xmlns:a="http://schemas.openxmlformats.org/drawingml/2006/main">
               <a:ext uri="{FF2B5EF4-FFF2-40B4-BE49-F238E27FC236}">
-                <a16:creationId xmlns:a16="http://schemas.microsoft.com/office/drawing/2014/main" id="{070F560B-9267-4720-BC4D-C33C3C04372B}"/>
+                <a16:creationId xmlns:a16="http://schemas.microsoft.com/office/drawing/2014/main" id="{A9355D56-1A65-4A82-9F1D-918A65B85EBC}"/>
               </a:ext>
             </a:extLst>
           </p:cNvPr>
@@ -2816,7 +2816,7 @@
           <p:cNvPr id="9" name="">
             <a:extLst xmlns:a="http://schemas.openxmlformats.org/drawingml/2006/main">
               <a:ext uri="{FF2B5EF4-FFF2-40B4-BE49-F238E27FC236}">
-                <a16:creationId xmlns:a16="http://schemas.microsoft.com/office/drawing/2014/main" id="{BAC346DC-47B7-4439-8057-3FFD2C02C42C}"/>
+                <a16:creationId xmlns:a16="http://schemas.microsoft.com/office/drawing/2014/main" id="{D3657707-20C3-45E3-8F1B-3C125212D7C1}"/>
               </a:ext>
             </a:extLst>
           </p:cNvPr>
@@ -2849,7 +2849,7 @@
           <p:cNvPr id="10" name="">
             <a:extLst xmlns:a="http://schemas.openxmlformats.org/drawingml/2006/main">
               <a:ext uri="{FF2B5EF4-FFF2-40B4-BE49-F238E27FC236}">
-                <a16:creationId xmlns:a16="http://schemas.microsoft.com/office/drawing/2014/main" id="{F848FBA1-FA06-4E91-A6E1-1C88051CE647}"/>
+                <a16:creationId xmlns:a16="http://schemas.microsoft.com/office/drawing/2014/main" id="{FC9B9C3C-6515-42F0-A386-BD30D03C2F3F}"/>
               </a:ext>
             </a:extLst>
           </p:cNvPr>
@@ -2882,7 +2882,7 @@
           <p:cNvPr id="11" name="">
             <a:extLst xmlns:a="http://schemas.openxmlformats.org/drawingml/2006/main">
               <a:ext uri="{FF2B5EF4-FFF2-40B4-BE49-F238E27FC236}">
-                <a16:creationId xmlns:a16="http://schemas.microsoft.com/office/drawing/2014/main" id="{ACF99C94-4575-4839-B452-3E0AC7520F1B}"/>
+                <a16:creationId xmlns:a16="http://schemas.microsoft.com/office/drawing/2014/main" id="{7AC12B7D-B0EA-413F-B57A-C90CF35EB43F}"/>
               </a:ext>
             </a:extLst>
           </p:cNvPr>
@@ -2932,7 +2932,7 @@
           <p:cNvPr id="12" name="">
             <a:extLst xmlns:a="http://schemas.openxmlformats.org/drawingml/2006/main">
               <a:ext uri="{FF2B5EF4-FFF2-40B4-BE49-F238E27FC236}">
-                <a16:creationId xmlns:a16="http://schemas.microsoft.com/office/drawing/2014/main" id="{3FDF74B4-E2B9-428C-86DF-7B55C55B28E5}"/>
+                <a16:creationId xmlns:a16="http://schemas.microsoft.com/office/drawing/2014/main" id="{8D36AE35-DFA8-42FE-A997-09700BB3F798}"/>
               </a:ext>
             </a:extLst>
           </p:cNvPr>
@@ -2982,7 +2982,7 @@
           <p:cNvPr id="13" name="">
             <a:extLst xmlns:a="http://schemas.openxmlformats.org/drawingml/2006/main">
               <a:ext uri="{FF2B5EF4-FFF2-40B4-BE49-F238E27FC236}">
-                <a16:creationId xmlns:a16="http://schemas.microsoft.com/office/drawing/2014/main" id="{A0127278-E905-48CC-8159-C1923AD834C3}"/>
+                <a16:creationId xmlns:a16="http://schemas.microsoft.com/office/drawing/2014/main" id="{E95FA998-502A-4C45-95BC-C042323ECF3B}"/>
               </a:ext>
             </a:extLst>
           </p:cNvPr>
@@ -3015,7 +3015,7 @@
           <p:cNvPr id="14" name="">
             <a:extLst xmlns:a="http://schemas.openxmlformats.org/drawingml/2006/main">
               <a:ext uri="{FF2B5EF4-FFF2-40B4-BE49-F238E27FC236}">
-                <a16:creationId xmlns:a16="http://schemas.microsoft.com/office/drawing/2014/main" id="{8B9888EE-EEDB-4F07-9574-226C6017666A}"/>
+                <a16:creationId xmlns:a16="http://schemas.microsoft.com/office/drawing/2014/main" id="{74FC2F24-C441-4B50-8EE9-C69891860AB9}"/>
               </a:ext>
             </a:extLst>
           </p:cNvPr>
@@ -3048,7 +3048,7 @@
           <p:cNvPr id="15" name="">
             <a:extLst xmlns:a="http://schemas.openxmlformats.org/drawingml/2006/main">
               <a:ext uri="{FF2B5EF4-FFF2-40B4-BE49-F238E27FC236}">
-                <a16:creationId xmlns:a16="http://schemas.microsoft.com/office/drawing/2014/main" id="{5650DA96-C8DD-4975-8FB1-DE1649A38EFD}"/>
+                <a16:creationId xmlns:a16="http://schemas.microsoft.com/office/drawing/2014/main" id="{67AA2D99-4CFE-47B7-AC1C-BA7ED676DAB8}"/>
               </a:ext>
             </a:extLst>
           </p:cNvPr>
@@ -3098,7 +3098,7 @@
           <p:cNvPr id="16" name="">
             <a:extLst xmlns:a="http://schemas.openxmlformats.org/drawingml/2006/main">
               <a:ext uri="{FF2B5EF4-FFF2-40B4-BE49-F238E27FC236}">
-                <a16:creationId xmlns:a16="http://schemas.microsoft.com/office/drawing/2014/main" id="{5E9E0316-1F22-421B-9E16-F0E73E3EDF28}"/>
+                <a16:creationId xmlns:a16="http://schemas.microsoft.com/office/drawing/2014/main" id="{3D7977F4-E4E5-41D7-AA91-D20092288544}"/>
               </a:ext>
             </a:extLst>
           </p:cNvPr>
@@ -3148,7 +3148,7 @@
           <p:cNvPr id="17" name="">
             <a:extLst xmlns:a="http://schemas.openxmlformats.org/drawingml/2006/main">
               <a:ext uri="{FF2B5EF4-FFF2-40B4-BE49-F238E27FC236}">
-                <a16:creationId xmlns:a16="http://schemas.microsoft.com/office/drawing/2014/main" id="{A4DA9179-F1C5-4D68-8179-38E99BDD0BED}"/>
+                <a16:creationId xmlns:a16="http://schemas.microsoft.com/office/drawing/2014/main" id="{A7FF5535-DAAF-4701-9762-4DCDDFC68C79}"/>
               </a:ext>
             </a:extLst>
           </p:cNvPr>
@@ -3181,7 +3181,7 @@
           <p:cNvPr id="18" name="">
             <a:extLst xmlns:a="http://schemas.openxmlformats.org/drawingml/2006/main">
               <a:ext uri="{FF2B5EF4-FFF2-40B4-BE49-F238E27FC236}">
-                <a16:creationId xmlns:a16="http://schemas.microsoft.com/office/drawing/2014/main" id="{8F8004E6-8441-4FAB-BE5C-1445EAC4D7DE}"/>
+                <a16:creationId xmlns:a16="http://schemas.microsoft.com/office/drawing/2014/main" id="{2099297E-07DC-4BAE-BC42-C903A4249304}"/>
               </a:ext>
             </a:extLst>
           </p:cNvPr>
@@ -3231,7 +3231,7 @@
           <p:cNvPr id="19" name="">
             <a:extLst xmlns:a="http://schemas.openxmlformats.org/drawingml/2006/main">
               <a:ext uri="{FF2B5EF4-FFF2-40B4-BE49-F238E27FC236}">
-                <a16:creationId xmlns:a16="http://schemas.microsoft.com/office/drawing/2014/main" id="{686D064D-2E94-4D18-A612-D4FB4F427D47}"/>
+                <a16:creationId xmlns:a16="http://schemas.microsoft.com/office/drawing/2014/main" id="{4EA63A85-00A3-48BB-8943-B8EB9A02775C}"/>
               </a:ext>
             </a:extLst>
           </p:cNvPr>
@@ -3281,7 +3281,7 @@
           <p:cNvPr id="20" name="">
             <a:extLst xmlns:a="http://schemas.openxmlformats.org/drawingml/2006/main">
               <a:ext uri="{FF2B5EF4-FFF2-40B4-BE49-F238E27FC236}">
-                <a16:creationId xmlns:a16="http://schemas.microsoft.com/office/drawing/2014/main" id="{45B2D16D-D459-4A74-B610-C2C1BC38E783}"/>
+                <a16:creationId xmlns:a16="http://schemas.microsoft.com/office/drawing/2014/main" id="{05A7F839-637E-4D56-9ED8-7825C91BD2C8}"/>
               </a:ext>
             </a:extLst>
           </p:cNvPr>
@@ -3314,7 +3314,7 @@
           <p:cNvPr id="21" name="">
             <a:extLst xmlns:a="http://schemas.openxmlformats.org/drawingml/2006/main">
               <a:ext uri="{FF2B5EF4-FFF2-40B4-BE49-F238E27FC236}">
-                <a16:creationId xmlns:a16="http://schemas.microsoft.com/office/drawing/2014/main" id="{65BAA40E-BF01-4F75-8859-B664E3C839AB}"/>
+                <a16:creationId xmlns:a16="http://schemas.microsoft.com/office/drawing/2014/main" id="{221D9DA7-3978-4D95-8E76-1B05A828B3EA}"/>
               </a:ext>
             </a:extLst>
           </p:cNvPr>
@@ -3364,7 +3364,7 @@
           <p:cNvPr id="22" name="">
             <a:extLst xmlns:a="http://schemas.openxmlformats.org/drawingml/2006/main">
               <a:ext uri="{FF2B5EF4-FFF2-40B4-BE49-F238E27FC236}">
-                <a16:creationId xmlns:a16="http://schemas.microsoft.com/office/drawing/2014/main" id="{A50176C6-6679-4ED7-BF38-2574CA31C9B6}"/>
+                <a16:creationId xmlns:a16="http://schemas.microsoft.com/office/drawing/2014/main" id="{B6BF3669-C2A8-41FB-87CE-5568D4B021FA}"/>
               </a:ext>
             </a:extLst>
           </p:cNvPr>
@@ -3414,7 +3414,7 @@
           <p:cNvPr id="23" name="">
             <a:extLst xmlns:a="http://schemas.openxmlformats.org/drawingml/2006/main">
               <a:ext uri="{FF2B5EF4-FFF2-40B4-BE49-F238E27FC236}">
-                <a16:creationId xmlns:a16="http://schemas.microsoft.com/office/drawing/2014/main" id="{D181EADF-F56E-4F80-BD3E-0DEF2BA8B506}"/>
+                <a16:creationId xmlns:a16="http://schemas.microsoft.com/office/drawing/2014/main" id="{5C7C8F30-24DA-438A-AA42-98ACA0614DB1}"/>
               </a:ext>
             </a:extLst>
           </p:cNvPr>
@@ -3447,7 +3447,7 @@
           <p:cNvPr id="24" name="">
             <a:extLst xmlns:a="http://schemas.openxmlformats.org/drawingml/2006/main">
               <a:ext uri="{FF2B5EF4-FFF2-40B4-BE49-F238E27FC236}">
-                <a16:creationId xmlns:a16="http://schemas.microsoft.com/office/drawing/2014/main" id="{E51DC7AF-3954-47CB-8A77-E2E5A25BAB5B}"/>
+                <a16:creationId xmlns:a16="http://schemas.microsoft.com/office/drawing/2014/main" id="{9908B164-86ED-412F-A9C1-AEDAE5BAD14B}"/>
               </a:ext>
             </a:extLst>
           </p:cNvPr>
@@ -3497,7 +3497,7 @@
           <p:cNvPr id="25" name="">
             <a:extLst xmlns:a="http://schemas.openxmlformats.org/drawingml/2006/main">
               <a:ext uri="{FF2B5EF4-FFF2-40B4-BE49-F238E27FC236}">
-                <a16:creationId xmlns:a16="http://schemas.microsoft.com/office/drawing/2014/main" id="{FF846FE4-6FF8-4347-A161-93914DCDCFF6}"/>
+                <a16:creationId xmlns:a16="http://schemas.microsoft.com/office/drawing/2014/main" id="{4C27DD27-6CDB-4A81-9616-954A26C2CF4A}"/>
               </a:ext>
             </a:extLst>
           </p:cNvPr>
@@ -3547,7 +3547,7 @@
           <p:cNvPr id="26" name="">
             <a:extLst xmlns:a="http://schemas.openxmlformats.org/drawingml/2006/main">
               <a:ext uri="{FF2B5EF4-FFF2-40B4-BE49-F238E27FC236}">
-                <a16:creationId xmlns:a16="http://schemas.microsoft.com/office/drawing/2014/main" id="{CC2B35E6-F1CB-4D90-BCF4-E4BF217D5418}"/>
+                <a16:creationId xmlns:a16="http://schemas.microsoft.com/office/drawing/2014/main" id="{E0AB7D04-3F8B-487A-9B26-D8C4B3360DB4}"/>
               </a:ext>
             </a:extLst>
           </p:cNvPr>
@@ -3580,7 +3580,7 @@
           <p:cNvPr id="27" name="">
             <a:extLst xmlns:a="http://schemas.openxmlformats.org/drawingml/2006/main">
               <a:ext uri="{FF2B5EF4-FFF2-40B4-BE49-F238E27FC236}">
-                <a16:creationId xmlns:a16="http://schemas.microsoft.com/office/drawing/2014/main" id="{0FC156BF-2313-45CC-99E2-310F76B573B3}"/>
+                <a16:creationId xmlns:a16="http://schemas.microsoft.com/office/drawing/2014/main" id="{CF648443-385D-4184-94B8-251438653D75}"/>
               </a:ext>
             </a:extLst>
           </p:cNvPr>
@@ -3630,7 +3630,7 @@
           <p:cNvPr id="28" name="">
             <a:extLst xmlns:a="http://schemas.openxmlformats.org/drawingml/2006/main">
               <a:ext uri="{FF2B5EF4-FFF2-40B4-BE49-F238E27FC236}">
-                <a16:creationId xmlns:a16="http://schemas.microsoft.com/office/drawing/2014/main" id="{970AE9A1-7725-4F5A-93ED-077294D4586B}"/>
+                <a16:creationId xmlns:a16="http://schemas.microsoft.com/office/drawing/2014/main" id="{0430FE33-C2DD-4BB7-919E-D03901756E4F}"/>
               </a:ext>
             </a:extLst>
           </p:cNvPr>
@@ -3680,7 +3680,7 @@
           <p:cNvPr id="29" name="">
             <a:extLst xmlns:a="http://schemas.openxmlformats.org/drawingml/2006/main">
               <a:ext uri="{FF2B5EF4-FFF2-40B4-BE49-F238E27FC236}">
-                <a16:creationId xmlns:a16="http://schemas.microsoft.com/office/drawing/2014/main" id="{C5F43AD4-5376-49F5-9970-3D09C5216805}"/>
+                <a16:creationId xmlns:a16="http://schemas.microsoft.com/office/drawing/2014/main" id="{8EE721E9-1625-44E4-8F2C-4A9313DF3772}"/>
               </a:ext>
             </a:extLst>
           </p:cNvPr>
@@ -3713,7 +3713,7 @@
           <p:cNvPr id="30" name="">
             <a:extLst xmlns:a="http://schemas.openxmlformats.org/drawingml/2006/main">
               <a:ext uri="{FF2B5EF4-FFF2-40B4-BE49-F238E27FC236}">
-                <a16:creationId xmlns:a16="http://schemas.microsoft.com/office/drawing/2014/main" id="{7EB800D6-5803-49C0-8E84-44E21F3C8383}"/>
+                <a16:creationId xmlns:a16="http://schemas.microsoft.com/office/drawing/2014/main" id="{38D4E137-BA6B-4F8E-824C-F2966B6E6959}"/>
               </a:ext>
             </a:extLst>
           </p:cNvPr>
@@ -3763,7 +3763,7 @@
           <p:cNvPr id="31" name="">
             <a:extLst xmlns:a="http://schemas.openxmlformats.org/drawingml/2006/main">
               <a:ext uri="{FF2B5EF4-FFF2-40B4-BE49-F238E27FC236}">
-                <a16:creationId xmlns:a16="http://schemas.microsoft.com/office/drawing/2014/main" id="{F0B67EEE-D756-4602-932F-8C104D3A6D50}"/>
+                <a16:creationId xmlns:a16="http://schemas.microsoft.com/office/drawing/2014/main" id="{173FF1AE-25F3-49E2-A5A9-A280C5146121}"/>
               </a:ext>
             </a:extLst>
           </p:cNvPr>
@@ -3813,7 +3813,7 @@
           <p:cNvPr id="32" name="">
             <a:extLst xmlns:a="http://schemas.openxmlformats.org/drawingml/2006/main">
               <a:ext uri="{FF2B5EF4-FFF2-40B4-BE49-F238E27FC236}">
-                <a16:creationId xmlns:a16="http://schemas.microsoft.com/office/drawing/2014/main" id="{8BED0AA9-4D95-4B03-A8FC-D0515D6D4361}"/>
+                <a16:creationId xmlns:a16="http://schemas.microsoft.com/office/drawing/2014/main" id="{B0107AC8-9A7F-49BF-9A57-83810D82E47C}"/>
               </a:ext>
             </a:extLst>
           </p:cNvPr>
@@ -3846,7 +3846,7 @@
           <p:cNvPr id="33" name="">
             <a:extLst xmlns:a="http://schemas.openxmlformats.org/drawingml/2006/main">
               <a:ext uri="{FF2B5EF4-FFF2-40B4-BE49-F238E27FC236}">
-                <a16:creationId xmlns:a16="http://schemas.microsoft.com/office/drawing/2014/main" id="{3036320B-01B5-40EB-8EFB-21805610D2AA}"/>
+                <a16:creationId xmlns:a16="http://schemas.microsoft.com/office/drawing/2014/main" id="{4FCEBE46-D2A2-4575-8C1E-3B088B4C0503}"/>
               </a:ext>
             </a:extLst>
           </p:cNvPr>
@@ -3896,7 +3896,7 @@
           <p:cNvPr id="34" name="">
             <a:extLst xmlns:a="http://schemas.openxmlformats.org/drawingml/2006/main">
               <a:ext uri="{FF2B5EF4-FFF2-40B4-BE49-F238E27FC236}">
-                <a16:creationId xmlns:a16="http://schemas.microsoft.com/office/drawing/2014/main" id="{93B378A2-245F-48C5-8AA5-A5EA8928E21B}"/>
+                <a16:creationId xmlns:a16="http://schemas.microsoft.com/office/drawing/2014/main" id="{5AB6ED17-F45E-48EC-A270-E0636BA77531}"/>
               </a:ext>
             </a:extLst>
           </p:cNvPr>
@@ -3946,7 +3946,7 @@
           <p:cNvPr id="35" name="">
             <a:extLst xmlns:a="http://schemas.openxmlformats.org/drawingml/2006/main">
               <a:ext uri="{FF2B5EF4-FFF2-40B4-BE49-F238E27FC236}">
-                <a16:creationId xmlns:a16="http://schemas.microsoft.com/office/drawing/2014/main" id="{CBCE89CD-58F3-4D19-B0D7-8E4414A308F6}"/>
+                <a16:creationId xmlns:a16="http://schemas.microsoft.com/office/drawing/2014/main" id="{C725265A-8EC4-45F3-9861-FD928897B176}"/>
               </a:ext>
             </a:extLst>
           </p:cNvPr>
@@ -3979,7 +3979,7 @@
           <p:cNvPr id="36" name="">
             <a:extLst xmlns:a="http://schemas.openxmlformats.org/drawingml/2006/main">
               <a:ext uri="{FF2B5EF4-FFF2-40B4-BE49-F238E27FC236}">
-                <a16:creationId xmlns:a16="http://schemas.microsoft.com/office/drawing/2014/main" id="{CBF17FF2-A5AC-431A-9F4F-1E074B605AA4}"/>
+                <a16:creationId xmlns:a16="http://schemas.microsoft.com/office/drawing/2014/main" id="{7A4B5EFC-E419-4C1F-A686-64153E385DF9}"/>
               </a:ext>
             </a:extLst>
           </p:cNvPr>
@@ -4029,7 +4029,7 @@
           <p:cNvPr id="37" name="">
             <a:extLst xmlns:a="http://schemas.openxmlformats.org/drawingml/2006/main">
               <a:ext uri="{FF2B5EF4-FFF2-40B4-BE49-F238E27FC236}">
-                <a16:creationId xmlns:a16="http://schemas.microsoft.com/office/drawing/2014/main" id="{117789B2-2CD1-4B69-8F90-DA686212A102}"/>
+                <a16:creationId xmlns:a16="http://schemas.microsoft.com/office/drawing/2014/main" id="{A8945F5B-BF71-4E44-84C0-25D2F08D61BD}"/>
               </a:ext>
             </a:extLst>
           </p:cNvPr>
@@ -4079,7 +4079,7 @@
           <p:cNvPr id="38" name="">
             <a:extLst xmlns:a="http://schemas.openxmlformats.org/drawingml/2006/main">
               <a:ext uri="{FF2B5EF4-FFF2-40B4-BE49-F238E27FC236}">
-                <a16:creationId xmlns:a16="http://schemas.microsoft.com/office/drawing/2014/main" id="{C9DE70F8-EA18-4D69-8972-675AF313C054}"/>
+                <a16:creationId xmlns:a16="http://schemas.microsoft.com/office/drawing/2014/main" id="{C8AB5C6A-B755-49A7-A7EA-EE10004673EF}"/>
               </a:ext>
             </a:extLst>
           </p:cNvPr>
@@ -4129,7 +4129,7 @@
           <p:cNvPr id="39" name="">
             <a:extLst xmlns:a="http://schemas.openxmlformats.org/drawingml/2006/main">
               <a:ext uri="{FF2B5EF4-FFF2-40B4-BE49-F238E27FC236}">
-                <a16:creationId xmlns:a16="http://schemas.microsoft.com/office/drawing/2014/main" id="{F6B580E1-8656-44AA-9036-0C7EC24959E5}"/>
+                <a16:creationId xmlns:a16="http://schemas.microsoft.com/office/drawing/2014/main" id="{C61BCE76-38DF-490B-907A-BB664B7BB4DF}"/>
               </a:ext>
             </a:extLst>
           </p:cNvPr>
@@ -4179,7 +4179,7 @@
           <p:cNvPr id="40" name="">
             <a:extLst xmlns:a="http://schemas.openxmlformats.org/drawingml/2006/main">
               <a:ext uri="{FF2B5EF4-FFF2-40B4-BE49-F238E27FC236}">
-                <a16:creationId xmlns:a16="http://schemas.microsoft.com/office/drawing/2014/main" id="{4829AD66-92C9-4CE7-8729-C0B83F97A0BE}"/>
+                <a16:creationId xmlns:a16="http://schemas.microsoft.com/office/drawing/2014/main" id="{B591E2FE-DBF7-45C8-AD1F-5F8F749400D2}"/>
               </a:ext>
             </a:extLst>
           </p:cNvPr>
@@ -4229,7 +4229,7 @@
           <p:cNvPr id="41" name="">
             <a:extLst xmlns:a="http://schemas.openxmlformats.org/drawingml/2006/main">
               <a:ext uri="{FF2B5EF4-FFF2-40B4-BE49-F238E27FC236}">
-                <a16:creationId xmlns:a16="http://schemas.microsoft.com/office/drawing/2014/main" id="{97A5F7E3-B8B3-4F0D-A134-7237A0F76079}"/>
+                <a16:creationId xmlns:a16="http://schemas.microsoft.com/office/drawing/2014/main" id="{764F63A2-0FCC-4301-BA0C-702B6EAEBECB}"/>
               </a:ext>
             </a:extLst>
           </p:cNvPr>
@@ -4279,7 +4279,7 @@
           <p:cNvPr id="42" name="">
             <a:extLst xmlns:a="http://schemas.openxmlformats.org/drawingml/2006/main">
               <a:ext uri="{FF2B5EF4-FFF2-40B4-BE49-F238E27FC236}">
-                <a16:creationId xmlns:a16="http://schemas.microsoft.com/office/drawing/2014/main" id="{26FDDF74-EFA5-4243-8C4A-F4ADF0A7E034}"/>
+                <a16:creationId xmlns:a16="http://schemas.microsoft.com/office/drawing/2014/main" id="{BAC01547-BB31-4DC8-9485-288795FFF416}"/>
               </a:ext>
             </a:extLst>
           </p:cNvPr>
@@ -4327,7 +4327,7 @@
     </p:spTree>
     <p:extLst>
       <p:ext uri="{BB962C8B-B14F-4D97-AF65-F5344CB8AC3E}">
-        <p14:creationId xmlns:p14="http://schemas.microsoft.com/office/powerpoint/2010/main" val="1550715453"/>
+        <p14:creationId xmlns:p14="http://schemas.microsoft.com/office/powerpoint/2010/main" val="1085490412"/>
       </p:ext>
     </p:extLst>
   </p:cSld>
@@ -4358,7 +4358,7 @@
           <p:cNvPr id="34" name="">
             <a:extLst xmlns:a="http://schemas.openxmlformats.org/drawingml/2006/main">
               <a:ext uri="{FF2B5EF4-FFF2-40B4-BE49-F238E27FC236}">
-                <a16:creationId xmlns:a16="http://schemas.microsoft.com/office/drawing/2014/main" id="{2754FACE-C555-4347-B8C7-5B69806214F4}"/>
+                <a16:creationId xmlns:a16="http://schemas.microsoft.com/office/drawing/2014/main" id="{1A1EE0C7-2D4C-4549-A7F4-B96E0D500997}"/>
               </a:ext>
             </a:extLst>
           </p:cNvPr>
@@ -4408,7 +4408,7 @@
           <p:cNvPr id="2" name="">
             <a:extLst xmlns:a="http://schemas.openxmlformats.org/drawingml/2006/main">
               <a:ext uri="{FF2B5EF4-FFF2-40B4-BE49-F238E27FC236}">
-                <a16:creationId xmlns:a16="http://schemas.microsoft.com/office/drawing/2014/main" id="{2F304DB5-C92B-4594-93E4-724BEC9710D9}"/>
+                <a16:creationId xmlns:a16="http://schemas.microsoft.com/office/drawing/2014/main" id="{7F14D122-362C-4FE4-8E51-5F764C7594ED}"/>
               </a:ext>
             </a:extLst>
           </p:cNvPr>
@@ -4458,7 +4458,7 @@
           <p:cNvPr id="3" name="">
             <a:extLst xmlns:a="http://schemas.openxmlformats.org/drawingml/2006/main">
               <a:ext uri="{FF2B5EF4-FFF2-40B4-BE49-F238E27FC236}">
-                <a16:creationId xmlns:a16="http://schemas.microsoft.com/office/drawing/2014/main" id="{01098B61-5DCA-4BD3-8565-AAAD461C8723}"/>
+                <a16:creationId xmlns:a16="http://schemas.microsoft.com/office/drawing/2014/main" id="{C16841F1-24B7-4FB6-B8CA-611CC83552A6}"/>
               </a:ext>
             </a:extLst>
           </p:cNvPr>
@@ -4491,7 +4491,7 @@
           <p:cNvPr id="4" name="">
             <a:extLst xmlns:a="http://schemas.openxmlformats.org/drawingml/2006/main">
               <a:ext uri="{FF2B5EF4-FFF2-40B4-BE49-F238E27FC236}">
-                <a16:creationId xmlns:a16="http://schemas.microsoft.com/office/drawing/2014/main" id="{0D9A6EA6-FC37-405A-90BE-4506246F672C}"/>
+                <a16:creationId xmlns:a16="http://schemas.microsoft.com/office/drawing/2014/main" id="{A1203707-AB2B-422B-BDA3-2C0FEED6096F}"/>
               </a:ext>
             </a:extLst>
           </p:cNvPr>
@@ -4541,7 +4541,7 @@
           <p:cNvPr id="5" name="">
             <a:extLst xmlns:a="http://schemas.openxmlformats.org/drawingml/2006/main">
               <a:ext uri="{FF2B5EF4-FFF2-40B4-BE49-F238E27FC236}">
-                <a16:creationId xmlns:a16="http://schemas.microsoft.com/office/drawing/2014/main" id="{60C9F1BB-433D-4500-89C1-C316B238933F}"/>
+                <a16:creationId xmlns:a16="http://schemas.microsoft.com/office/drawing/2014/main" id="{25541BA1-996B-472B-AD18-FE5F86333F12}"/>
               </a:ext>
             </a:extLst>
           </p:cNvPr>
@@ -4574,7 +4574,7 @@
           <p:cNvPr id="6" name="">
             <a:extLst xmlns:a="http://schemas.openxmlformats.org/drawingml/2006/main">
               <a:ext uri="{FF2B5EF4-FFF2-40B4-BE49-F238E27FC236}">
-                <a16:creationId xmlns:a16="http://schemas.microsoft.com/office/drawing/2014/main" id="{40F767D4-6245-4065-955E-C73D69E1A179}"/>
+                <a16:creationId xmlns:a16="http://schemas.microsoft.com/office/drawing/2014/main" id="{2378DD43-6FEE-4D9A-B0BF-E0078D90E09B}"/>
               </a:ext>
             </a:extLst>
           </p:cNvPr>
@@ -4641,7 +4641,7 @@
           <p:cNvPr id="7" name="">
             <a:extLst xmlns:a="http://schemas.openxmlformats.org/drawingml/2006/main">
               <a:ext uri="{FF2B5EF4-FFF2-40B4-BE49-F238E27FC236}">
-                <a16:creationId xmlns:a16="http://schemas.microsoft.com/office/drawing/2014/main" id="{4C677573-5743-463D-A63B-F00F4F4B8D65}"/>
+                <a16:creationId xmlns:a16="http://schemas.microsoft.com/office/drawing/2014/main" id="{DA3D02C9-7E56-4A11-AD46-6EA2AABF8D11}"/>
               </a:ext>
             </a:extLst>
           </p:cNvPr>
@@ -4691,7 +4691,7 @@
           <p:cNvPr id="8" name="">
             <a:extLst xmlns:a="http://schemas.openxmlformats.org/drawingml/2006/main">
               <a:ext uri="{FF2B5EF4-FFF2-40B4-BE49-F238E27FC236}">
-                <a16:creationId xmlns:a16="http://schemas.microsoft.com/office/drawing/2014/main" id="{FB6F61CF-BDE1-4BA0-BCE6-FEF7D2109DE1}"/>
+                <a16:creationId xmlns:a16="http://schemas.microsoft.com/office/drawing/2014/main" id="{0369E964-2916-4391-8947-4705C2FD9F0F}"/>
               </a:ext>
             </a:extLst>
           </p:cNvPr>
@@ -4724,7 +4724,7 @@
           <p:cNvPr id="9" name="">
             <a:extLst xmlns:a="http://schemas.openxmlformats.org/drawingml/2006/main">
               <a:ext uri="{FF2B5EF4-FFF2-40B4-BE49-F238E27FC236}">
-                <a16:creationId xmlns:a16="http://schemas.microsoft.com/office/drawing/2014/main" id="{58B59E91-EECC-4B10-8107-E1E65659365D}"/>
+                <a16:creationId xmlns:a16="http://schemas.microsoft.com/office/drawing/2014/main" id="{DC063D4E-2FA2-416B-9D61-64CEE7BEAF26}"/>
               </a:ext>
             </a:extLst>
           </p:cNvPr>
@@ -4791,7 +4791,7 @@
           <p:cNvPr id="10" name="">
             <a:extLst xmlns:a="http://schemas.openxmlformats.org/drawingml/2006/main">
               <a:ext uri="{FF2B5EF4-FFF2-40B4-BE49-F238E27FC236}">
-                <a16:creationId xmlns:a16="http://schemas.microsoft.com/office/drawing/2014/main" id="{695F1A2C-79D7-484F-867D-2FF7DDA0E2FE}"/>
+                <a16:creationId xmlns:a16="http://schemas.microsoft.com/office/drawing/2014/main" id="{7B8F7AAC-9A75-4934-82E5-D14004AEC2C1}"/>
               </a:ext>
             </a:extLst>
           </p:cNvPr>
@@ -4841,7 +4841,7 @@
           <p:cNvPr id="11" name="">
             <a:extLst xmlns:a="http://schemas.openxmlformats.org/drawingml/2006/main">
               <a:ext uri="{FF2B5EF4-FFF2-40B4-BE49-F238E27FC236}">
-                <a16:creationId xmlns:a16="http://schemas.microsoft.com/office/drawing/2014/main" id="{9D940973-4280-47C0-8EFB-A5E013C876D7}"/>
+                <a16:creationId xmlns:a16="http://schemas.microsoft.com/office/drawing/2014/main" id="{4E1C7A56-A58D-4B7A-9786-E9572F43CA94}"/>
               </a:ext>
             </a:extLst>
           </p:cNvPr>
@@ -4874,7 +4874,7 @@
           <p:cNvPr id="12" name="">
             <a:extLst xmlns:a="http://schemas.openxmlformats.org/drawingml/2006/main">
               <a:ext uri="{FF2B5EF4-FFF2-40B4-BE49-F238E27FC236}">
-                <a16:creationId xmlns:a16="http://schemas.microsoft.com/office/drawing/2014/main" id="{DBBC487D-FBCD-4DE9-BA3E-96D38CFC837E}"/>
+                <a16:creationId xmlns:a16="http://schemas.microsoft.com/office/drawing/2014/main" id="{B7C97523-44C5-46D7-95AB-ABD9322577E5}"/>
               </a:ext>
             </a:extLst>
           </p:cNvPr>
@@ -4941,7 +4941,7 @@
           <p:cNvPr id="13" name="">
             <a:extLst xmlns:a="http://schemas.openxmlformats.org/drawingml/2006/main">
               <a:ext uri="{FF2B5EF4-FFF2-40B4-BE49-F238E27FC236}">
-                <a16:creationId xmlns:a16="http://schemas.microsoft.com/office/drawing/2014/main" id="{4B333BAB-5257-4BD4-A702-07729FFF35E9}"/>
+                <a16:creationId xmlns:a16="http://schemas.microsoft.com/office/drawing/2014/main" id="{39B79AA9-1886-46BC-94E2-79B48A4F300F}"/>
               </a:ext>
             </a:extLst>
           </p:cNvPr>
@@ -4991,7 +4991,7 @@
           <p:cNvPr id="14" name="">
             <a:extLst xmlns:a="http://schemas.openxmlformats.org/drawingml/2006/main">
               <a:ext uri="{FF2B5EF4-FFF2-40B4-BE49-F238E27FC236}">
-                <a16:creationId xmlns:a16="http://schemas.microsoft.com/office/drawing/2014/main" id="{FDC47989-5BD1-477E-AFEB-441D47297594}"/>
+                <a16:creationId xmlns:a16="http://schemas.microsoft.com/office/drawing/2014/main" id="{56D4A2E6-7638-4CCA-9639-272388A90782}"/>
               </a:ext>
             </a:extLst>
           </p:cNvPr>
@@ -5024,7 +5024,7 @@
           <p:cNvPr id="15" name="">
             <a:extLst xmlns:a="http://schemas.openxmlformats.org/drawingml/2006/main">
               <a:ext uri="{FF2B5EF4-FFF2-40B4-BE49-F238E27FC236}">
-                <a16:creationId xmlns:a16="http://schemas.microsoft.com/office/drawing/2014/main" id="{69DC04A9-73AF-4898-92C4-259B3BE5A98F}"/>
+                <a16:creationId xmlns:a16="http://schemas.microsoft.com/office/drawing/2014/main" id="{DF9338E4-35E4-4B6C-8633-E191FA86AF00}"/>
               </a:ext>
             </a:extLst>
           </p:cNvPr>
@@ -5091,7 +5091,7 @@
           <p:cNvPr id="16" name="">
             <a:extLst xmlns:a="http://schemas.openxmlformats.org/drawingml/2006/main">
               <a:ext uri="{FF2B5EF4-FFF2-40B4-BE49-F238E27FC236}">
-                <a16:creationId xmlns:a16="http://schemas.microsoft.com/office/drawing/2014/main" id="{96B9C3E9-ABF7-4D28-98F4-384DB606C078}"/>
+                <a16:creationId xmlns:a16="http://schemas.microsoft.com/office/drawing/2014/main" id="{50110706-302B-4D3D-908B-1A7E53AE1C10}"/>
               </a:ext>
             </a:extLst>
           </p:cNvPr>
@@ -5141,7 +5141,7 @@
           <p:cNvPr id="17" name="">
             <a:extLst xmlns:a="http://schemas.openxmlformats.org/drawingml/2006/main">
               <a:ext uri="{FF2B5EF4-FFF2-40B4-BE49-F238E27FC236}">
-                <a16:creationId xmlns:a16="http://schemas.microsoft.com/office/drawing/2014/main" id="{79840B87-412F-465F-B894-8DFB1CBE928B}"/>
+                <a16:creationId xmlns:a16="http://schemas.microsoft.com/office/drawing/2014/main" id="{E7BA8426-7530-422A-B6EA-6C7B34983451}"/>
               </a:ext>
             </a:extLst>
           </p:cNvPr>
@@ -5174,7 +5174,7 @@
           <p:cNvPr id="18" name="">
             <a:extLst xmlns:a="http://schemas.openxmlformats.org/drawingml/2006/main">
               <a:ext uri="{FF2B5EF4-FFF2-40B4-BE49-F238E27FC236}">
-                <a16:creationId xmlns:a16="http://schemas.microsoft.com/office/drawing/2014/main" id="{BAFB6731-60A6-4287-AEA8-EEA8D6B5D996}"/>
+                <a16:creationId xmlns:a16="http://schemas.microsoft.com/office/drawing/2014/main" id="{47504211-EF14-4403-944D-354F46D7B155}"/>
               </a:ext>
             </a:extLst>
           </p:cNvPr>
@@ -5241,7 +5241,7 @@
           <p:cNvPr id="19" name="">
             <a:extLst xmlns:a="http://schemas.openxmlformats.org/drawingml/2006/main">
               <a:ext uri="{FF2B5EF4-FFF2-40B4-BE49-F238E27FC236}">
-                <a16:creationId xmlns:a16="http://schemas.microsoft.com/office/drawing/2014/main" id="{0F9C092F-3B8A-4956-AAA0-BE22BA07ED0D}"/>
+                <a16:creationId xmlns:a16="http://schemas.microsoft.com/office/drawing/2014/main" id="{F67CC6EE-7A7D-42AC-B98F-855C8F35FA1C}"/>
               </a:ext>
             </a:extLst>
           </p:cNvPr>
@@ -5291,7 +5291,7 @@
           <p:cNvPr id="20" name="">
             <a:extLst xmlns:a="http://schemas.openxmlformats.org/drawingml/2006/main">
               <a:ext uri="{FF2B5EF4-FFF2-40B4-BE49-F238E27FC236}">
-                <a16:creationId xmlns:a16="http://schemas.microsoft.com/office/drawing/2014/main" id="{CF9E9C75-CDBF-41A6-8010-6056A4B23B18}"/>
+                <a16:creationId xmlns:a16="http://schemas.microsoft.com/office/drawing/2014/main" id="{0AF2C0A3-0A5E-4D89-80C0-040CE255A057}"/>
               </a:ext>
             </a:extLst>
           </p:cNvPr>
@@ -5324,7 +5324,7 @@
           <p:cNvPr id="21" name="">
             <a:extLst xmlns:a="http://schemas.openxmlformats.org/drawingml/2006/main">
               <a:ext uri="{FF2B5EF4-FFF2-40B4-BE49-F238E27FC236}">
-                <a16:creationId xmlns:a16="http://schemas.microsoft.com/office/drawing/2014/main" id="{D08BC867-63AC-49D2-9477-6E807AAD2F85}"/>
+                <a16:creationId xmlns:a16="http://schemas.microsoft.com/office/drawing/2014/main" id="{760891E1-AE7E-4F6C-9122-12AED62D643A}"/>
               </a:ext>
             </a:extLst>
           </p:cNvPr>
@@ -5391,7 +5391,7 @@
           <p:cNvPr id="22" name="">
             <a:extLst xmlns:a="http://schemas.openxmlformats.org/drawingml/2006/main">
               <a:ext uri="{FF2B5EF4-FFF2-40B4-BE49-F238E27FC236}">
-                <a16:creationId xmlns:a16="http://schemas.microsoft.com/office/drawing/2014/main" id="{39F38D68-3F1A-4C45-8AE0-4A51F486C806}"/>
+                <a16:creationId xmlns:a16="http://schemas.microsoft.com/office/drawing/2014/main" id="{221E629C-A4E0-474F-8EA0-97F24F01FD4D}"/>
               </a:ext>
             </a:extLst>
           </p:cNvPr>
@@ -5441,7 +5441,7 @@
           <p:cNvPr id="23" name="">
             <a:extLst xmlns:a="http://schemas.openxmlformats.org/drawingml/2006/main">
               <a:ext uri="{FF2B5EF4-FFF2-40B4-BE49-F238E27FC236}">
-                <a16:creationId xmlns:a16="http://schemas.microsoft.com/office/drawing/2014/main" id="{0FD369E1-3A6F-4328-A330-1CF9345F70DB}"/>
+                <a16:creationId xmlns:a16="http://schemas.microsoft.com/office/drawing/2014/main" id="{81F085EA-083E-4791-A067-5F0BC405740F}"/>
               </a:ext>
             </a:extLst>
           </p:cNvPr>
@@ -5491,7 +5491,7 @@
           <p:cNvPr id="24" name="">
             <a:extLst xmlns:a="http://schemas.openxmlformats.org/drawingml/2006/main">
               <a:ext uri="{FF2B5EF4-FFF2-40B4-BE49-F238E27FC236}">
-                <a16:creationId xmlns:a16="http://schemas.microsoft.com/office/drawing/2014/main" id="{6898F5D4-5079-40BE-987F-626F538716D8}"/>
+                <a16:creationId xmlns:a16="http://schemas.microsoft.com/office/drawing/2014/main" id="{49E8F0E4-7463-445F-A2DF-EBE97BB6C79F}"/>
               </a:ext>
             </a:extLst>
           </p:cNvPr>
@@ -5541,7 +5541,7 @@
           <p:cNvPr id="25" name="">
             <a:extLst xmlns:a="http://schemas.openxmlformats.org/drawingml/2006/main">
               <a:ext uri="{FF2B5EF4-FFF2-40B4-BE49-F238E27FC236}">
-                <a16:creationId xmlns:a16="http://schemas.microsoft.com/office/drawing/2014/main" id="{DAA5FEB9-6D3E-42CA-85C3-191D67B9C5DA}"/>
+                <a16:creationId xmlns:a16="http://schemas.microsoft.com/office/drawing/2014/main" id="{B13871C8-F39B-48C1-90E1-6B00C646F5B5}"/>
               </a:ext>
             </a:extLst>
           </p:cNvPr>
@@ -5591,7 +5591,7 @@
           <p:cNvPr id="26" name="">
             <a:extLst xmlns:a="http://schemas.openxmlformats.org/drawingml/2006/main">
               <a:ext uri="{FF2B5EF4-FFF2-40B4-BE49-F238E27FC236}">
-                <a16:creationId xmlns:a16="http://schemas.microsoft.com/office/drawing/2014/main" id="{6F37F575-5EEA-4466-A3DF-F26AF3E91813}"/>
+                <a16:creationId xmlns:a16="http://schemas.microsoft.com/office/drawing/2014/main" id="{405AEE2B-449B-4ABE-B397-95D686EC7327}"/>
               </a:ext>
             </a:extLst>
           </p:cNvPr>
@@ -5641,7 +5641,7 @@
           <p:cNvPr id="27" name="">
             <a:extLst xmlns:a="http://schemas.openxmlformats.org/drawingml/2006/main">
               <a:ext uri="{FF2B5EF4-FFF2-40B4-BE49-F238E27FC236}">
-                <a16:creationId xmlns:a16="http://schemas.microsoft.com/office/drawing/2014/main" id="{7984DDE3-04E3-4FC9-B333-1D7B52D14FBB}"/>
+                <a16:creationId xmlns:a16="http://schemas.microsoft.com/office/drawing/2014/main" id="{2BEEB970-CDAC-4ED5-B07D-34A69DBFA995}"/>
               </a:ext>
             </a:extLst>
           </p:cNvPr>
@@ -5691,7 +5691,7 @@
           <p:cNvPr id="28" name="">
             <a:extLst xmlns:a="http://schemas.openxmlformats.org/drawingml/2006/main">
               <a:ext uri="{FF2B5EF4-FFF2-40B4-BE49-F238E27FC236}">
-                <a16:creationId xmlns:a16="http://schemas.microsoft.com/office/drawing/2014/main" id="{318EC3D4-43B0-4E70-8464-6FC95131ABE5}"/>
+                <a16:creationId xmlns:a16="http://schemas.microsoft.com/office/drawing/2014/main" id="{20DD2A21-EA4F-433F-9ED4-DAB4AA428131}"/>
               </a:ext>
             </a:extLst>
           </p:cNvPr>
@@ -5741,7 +5741,7 @@
           <p:cNvPr id="29" name="">
             <a:extLst xmlns:a="http://schemas.openxmlformats.org/drawingml/2006/main">
               <a:ext uri="{FF2B5EF4-FFF2-40B4-BE49-F238E27FC236}">
-                <a16:creationId xmlns:a16="http://schemas.microsoft.com/office/drawing/2014/main" id="{9A5FCA80-86EE-4D30-B1E3-A6BB2593933B}"/>
+                <a16:creationId xmlns:a16="http://schemas.microsoft.com/office/drawing/2014/main" id="{850D2462-0741-4863-B301-BD88AADFF210}"/>
               </a:ext>
             </a:extLst>
           </p:cNvPr>
@@ -5791,7 +5791,7 @@
           <p:cNvPr id="30" name="">
             <a:extLst xmlns:a="http://schemas.openxmlformats.org/drawingml/2006/main">
               <a:ext uri="{FF2B5EF4-FFF2-40B4-BE49-F238E27FC236}">
-                <a16:creationId xmlns:a16="http://schemas.microsoft.com/office/drawing/2014/main" id="{E0F2D2E9-96D8-4F4D-83DF-3ADC83786EA1}"/>
+                <a16:creationId xmlns:a16="http://schemas.microsoft.com/office/drawing/2014/main" id="{1C6CDE50-ABCE-4DF1-9A42-8470C43E2921}"/>
               </a:ext>
             </a:extLst>
           </p:cNvPr>
@@ -5841,7 +5841,7 @@
           <p:cNvPr id="31" name="">
             <a:extLst xmlns:a="http://schemas.openxmlformats.org/drawingml/2006/main">
               <a:ext uri="{FF2B5EF4-FFF2-40B4-BE49-F238E27FC236}">
-                <a16:creationId xmlns:a16="http://schemas.microsoft.com/office/drawing/2014/main" id="{66F2E610-E891-4D43-A361-01F769BA7CAF}"/>
+                <a16:creationId xmlns:a16="http://schemas.microsoft.com/office/drawing/2014/main" id="{4C24C3F3-94DA-44F4-AB54-C64DE062DD4D}"/>
               </a:ext>
             </a:extLst>
           </p:cNvPr>
@@ -5874,7 +5874,7 @@
           <p:cNvPr id="32" name="">
             <a:extLst xmlns:a="http://schemas.openxmlformats.org/drawingml/2006/main">
               <a:ext uri="{FF2B5EF4-FFF2-40B4-BE49-F238E27FC236}">
-                <a16:creationId xmlns:a16="http://schemas.microsoft.com/office/drawing/2014/main" id="{4F720E52-155A-4FCC-9FBC-A1DBAFD84824}"/>
+                <a16:creationId xmlns:a16="http://schemas.microsoft.com/office/drawing/2014/main" id="{9DB47AE4-8B92-4E25-9C07-1E50B3DF67E2}"/>
               </a:ext>
             </a:extLst>
           </p:cNvPr>
@@ -5924,7 +5924,7 @@
           <p:cNvPr id="33" name="">
             <a:extLst xmlns:a="http://schemas.openxmlformats.org/drawingml/2006/main">
               <a:ext uri="{FF2B5EF4-FFF2-40B4-BE49-F238E27FC236}">
-                <a16:creationId xmlns:a16="http://schemas.microsoft.com/office/drawing/2014/main" id="{85149C0C-878F-461F-B14A-D4AA01AD8682}"/>
+                <a16:creationId xmlns:a16="http://schemas.microsoft.com/office/drawing/2014/main" id="{E4C733C6-199D-4495-84C4-463247D56DFE}"/>
               </a:ext>
             </a:extLst>
           </p:cNvPr>
@@ -6091,7 +6091,7 @@
     </p:spTree>
     <p:extLst>
       <p:ext uri="{BB962C8B-B14F-4D97-AF65-F5344CB8AC3E}">
-        <p14:creationId xmlns:p14="http://schemas.microsoft.com/office/powerpoint/2010/main" val="2126419949"/>
+        <p14:creationId xmlns:p14="http://schemas.microsoft.com/office/powerpoint/2010/main" val="1063480119"/>
       </p:ext>
     </p:extLst>
   </p:cSld>
@@ -6122,7 +6122,7 @@
           <p:cNvPr id="30" name="">
             <a:extLst xmlns:a="http://schemas.openxmlformats.org/drawingml/2006/main">
               <a:ext uri="{FF2B5EF4-FFF2-40B4-BE49-F238E27FC236}">
-                <a16:creationId xmlns:a16="http://schemas.microsoft.com/office/drawing/2014/main" id="{990F244A-FC76-4030-8F19-E9984749AB0A}"/>
+                <a16:creationId xmlns:a16="http://schemas.microsoft.com/office/drawing/2014/main" id="{05A2E853-0BE2-4A17-88FF-B9FBD3C4799C}"/>
               </a:ext>
             </a:extLst>
           </p:cNvPr>
@@ -6172,7 +6172,7 @@
           <p:cNvPr id="2" name="">
             <a:extLst xmlns:a="http://schemas.openxmlformats.org/drawingml/2006/main">
               <a:ext uri="{FF2B5EF4-FFF2-40B4-BE49-F238E27FC236}">
-                <a16:creationId xmlns:a16="http://schemas.microsoft.com/office/drawing/2014/main" id="{FEC91A94-E0B6-4119-80F2-75838631D9A4}"/>
+                <a16:creationId xmlns:a16="http://schemas.microsoft.com/office/drawing/2014/main" id="{A6D0B279-E550-4605-94D5-1F4664C98241}"/>
               </a:ext>
             </a:extLst>
           </p:cNvPr>
@@ -6222,7 +6222,7 @@
           <p:cNvPr id="3" name="">
             <a:extLst xmlns:a="http://schemas.openxmlformats.org/drawingml/2006/main">
               <a:ext uri="{FF2B5EF4-FFF2-40B4-BE49-F238E27FC236}">
-                <a16:creationId xmlns:a16="http://schemas.microsoft.com/office/drawing/2014/main" id="{A975CEE1-1B70-4CCC-A70E-E58D47FBB921}"/>
+                <a16:creationId xmlns:a16="http://schemas.microsoft.com/office/drawing/2014/main" id="{864C7599-2460-4803-80CC-203188E6094E}"/>
               </a:ext>
             </a:extLst>
           </p:cNvPr>
@@ -6255,7 +6255,7 @@
           <p:cNvPr id="4" name="">
             <a:extLst xmlns:a="http://schemas.openxmlformats.org/drawingml/2006/main">
               <a:ext uri="{FF2B5EF4-FFF2-40B4-BE49-F238E27FC236}">
-                <a16:creationId xmlns:a16="http://schemas.microsoft.com/office/drawing/2014/main" id="{D373F6D9-F455-45D1-B5EB-8EA5C3AC4213}"/>
+                <a16:creationId xmlns:a16="http://schemas.microsoft.com/office/drawing/2014/main" id="{87AC2277-03F1-4DFC-9480-7B26AA8AE7A3}"/>
               </a:ext>
             </a:extLst>
           </p:cNvPr>
@@ -6305,7 +6305,7 @@
           <p:cNvPr id="5" name="">
             <a:extLst xmlns:a="http://schemas.openxmlformats.org/drawingml/2006/main">
               <a:ext uri="{FF2B5EF4-FFF2-40B4-BE49-F238E27FC236}">
-                <a16:creationId xmlns:a16="http://schemas.microsoft.com/office/drawing/2014/main" id="{982C86F9-A41F-458B-BC92-F17FD5D1BABF}"/>
+                <a16:creationId xmlns:a16="http://schemas.microsoft.com/office/drawing/2014/main" id="{E56B9559-2C0B-41B0-A960-E2C23033DAF6}"/>
               </a:ext>
             </a:extLst>
           </p:cNvPr>
@@ -6338,7 +6338,7 @@
           <p:cNvPr id="6" name="">
             <a:extLst xmlns:a="http://schemas.openxmlformats.org/drawingml/2006/main">
               <a:ext uri="{FF2B5EF4-FFF2-40B4-BE49-F238E27FC236}">
-                <a16:creationId xmlns:a16="http://schemas.microsoft.com/office/drawing/2014/main" id="{25AAA023-F847-4BC7-90BC-E3CEC48A0695}"/>
+                <a16:creationId xmlns:a16="http://schemas.microsoft.com/office/drawing/2014/main" id="{483F8C96-1102-4F10-B11D-29709D532B89}"/>
               </a:ext>
             </a:extLst>
           </p:cNvPr>
@@ -6405,7 +6405,7 @@
           <p:cNvPr id="7" name="">
             <a:extLst xmlns:a="http://schemas.openxmlformats.org/drawingml/2006/main">
               <a:ext uri="{FF2B5EF4-FFF2-40B4-BE49-F238E27FC236}">
-                <a16:creationId xmlns:a16="http://schemas.microsoft.com/office/drawing/2014/main" id="{E5F554F9-F3BB-4453-97CD-86416A744DE9}"/>
+                <a16:creationId xmlns:a16="http://schemas.microsoft.com/office/drawing/2014/main" id="{2A9806B0-24B4-48A6-BF3B-A9AB0DE4317C}"/>
               </a:ext>
             </a:extLst>
           </p:cNvPr>
@@ -6455,7 +6455,7 @@
           <p:cNvPr id="8" name="">
             <a:extLst xmlns:a="http://schemas.openxmlformats.org/drawingml/2006/main">
               <a:ext uri="{FF2B5EF4-FFF2-40B4-BE49-F238E27FC236}">
-                <a16:creationId xmlns:a16="http://schemas.microsoft.com/office/drawing/2014/main" id="{080475C5-6417-4D79-824B-128B0111B830}"/>
+                <a16:creationId xmlns:a16="http://schemas.microsoft.com/office/drawing/2014/main" id="{30CE1734-56B0-41C8-863D-569943FE8223}"/>
               </a:ext>
             </a:extLst>
           </p:cNvPr>
@@ -6488,7 +6488,7 @@
           <p:cNvPr id="9" name="">
             <a:extLst xmlns:a="http://schemas.openxmlformats.org/drawingml/2006/main">
               <a:ext uri="{FF2B5EF4-FFF2-40B4-BE49-F238E27FC236}">
-                <a16:creationId xmlns:a16="http://schemas.microsoft.com/office/drawing/2014/main" id="{BC4D328F-3AD4-46E9-B1EE-F94DA79B3ECF}"/>
+                <a16:creationId xmlns:a16="http://schemas.microsoft.com/office/drawing/2014/main" id="{5CCC2E22-7457-46CE-96E3-CF866A115856}"/>
               </a:ext>
             </a:extLst>
           </p:cNvPr>
@@ -6555,7 +6555,7 @@
           <p:cNvPr id="10" name="">
             <a:extLst xmlns:a="http://schemas.openxmlformats.org/drawingml/2006/main">
               <a:ext uri="{FF2B5EF4-FFF2-40B4-BE49-F238E27FC236}">
-                <a16:creationId xmlns:a16="http://schemas.microsoft.com/office/drawing/2014/main" id="{034C565A-9E88-45C8-9D53-4CD9BBD5B154}"/>
+                <a16:creationId xmlns:a16="http://schemas.microsoft.com/office/drawing/2014/main" id="{4E147A28-0774-4425-A431-A2001B7B4B81}"/>
               </a:ext>
             </a:extLst>
           </p:cNvPr>
@@ -6605,7 +6605,7 @@
           <p:cNvPr id="11" name="">
             <a:extLst xmlns:a="http://schemas.openxmlformats.org/drawingml/2006/main">
               <a:ext uri="{FF2B5EF4-FFF2-40B4-BE49-F238E27FC236}">
-                <a16:creationId xmlns:a16="http://schemas.microsoft.com/office/drawing/2014/main" id="{0568D7E7-B823-4523-957A-47DAF3A9AD19}"/>
+                <a16:creationId xmlns:a16="http://schemas.microsoft.com/office/drawing/2014/main" id="{A5FCF2CF-02AD-4FFE-9B15-D7F74B2CF0F7}"/>
               </a:ext>
             </a:extLst>
           </p:cNvPr>
@@ -6638,7 +6638,7 @@
           <p:cNvPr id="12" name="">
             <a:extLst xmlns:a="http://schemas.openxmlformats.org/drawingml/2006/main">
               <a:ext uri="{FF2B5EF4-FFF2-40B4-BE49-F238E27FC236}">
-                <a16:creationId xmlns:a16="http://schemas.microsoft.com/office/drawing/2014/main" id="{D77C0706-C9E8-4886-875E-14431A961AA8}"/>
+                <a16:creationId xmlns:a16="http://schemas.microsoft.com/office/drawing/2014/main" id="{E38D90FB-977B-421B-B77A-5A4FFA554DFD}"/>
               </a:ext>
             </a:extLst>
           </p:cNvPr>
@@ -6705,7 +6705,7 @@
           <p:cNvPr id="13" name="">
             <a:extLst xmlns:a="http://schemas.openxmlformats.org/drawingml/2006/main">
               <a:ext uri="{FF2B5EF4-FFF2-40B4-BE49-F238E27FC236}">
-                <a16:creationId xmlns:a16="http://schemas.microsoft.com/office/drawing/2014/main" id="{04D1C0F7-6D95-4F4F-B456-5A26A58E08DF}"/>
+                <a16:creationId xmlns:a16="http://schemas.microsoft.com/office/drawing/2014/main" id="{43916B55-3ED1-4432-8FC5-F37D8319C6C3}"/>
               </a:ext>
             </a:extLst>
           </p:cNvPr>
@@ -6755,7 +6755,7 @@
           <p:cNvPr id="14" name="">
             <a:extLst xmlns:a="http://schemas.openxmlformats.org/drawingml/2006/main">
               <a:ext uri="{FF2B5EF4-FFF2-40B4-BE49-F238E27FC236}">
-                <a16:creationId xmlns:a16="http://schemas.microsoft.com/office/drawing/2014/main" id="{E436E097-4C4E-4C7F-92FE-AC8E13812B64}"/>
+                <a16:creationId xmlns:a16="http://schemas.microsoft.com/office/drawing/2014/main" id="{83836DB7-C821-4CD6-96F8-DB38FC705366}"/>
               </a:ext>
             </a:extLst>
           </p:cNvPr>
@@ -6805,7 +6805,7 @@
           <p:cNvPr id="15" name="">
             <a:extLst xmlns:a="http://schemas.openxmlformats.org/drawingml/2006/main">
               <a:ext uri="{FF2B5EF4-FFF2-40B4-BE49-F238E27FC236}">
-                <a16:creationId xmlns:a16="http://schemas.microsoft.com/office/drawing/2014/main" id="{A9D8928B-BA18-4C9D-AA7A-2C4D4CD45F27}"/>
+                <a16:creationId xmlns:a16="http://schemas.microsoft.com/office/drawing/2014/main" id="{FBB1AC1D-A94C-44D3-9533-B132C126B72A}"/>
               </a:ext>
             </a:extLst>
           </p:cNvPr>
@@ -6855,7 +6855,7 @@
           <p:cNvPr id="16" name="">
             <a:extLst xmlns:a="http://schemas.openxmlformats.org/drawingml/2006/main">
               <a:ext uri="{FF2B5EF4-FFF2-40B4-BE49-F238E27FC236}">
-                <a16:creationId xmlns:a16="http://schemas.microsoft.com/office/drawing/2014/main" id="{7D4D56DF-DD8A-488A-BC0B-948691C254F2}"/>
+                <a16:creationId xmlns:a16="http://schemas.microsoft.com/office/drawing/2014/main" id="{89B25284-6E70-44FB-B84C-8321D0CED29F}"/>
               </a:ext>
             </a:extLst>
           </p:cNvPr>
@@ -6888,7 +6888,7 @@
           <p:cNvPr id="17" name="">
             <a:extLst xmlns:a="http://schemas.openxmlformats.org/drawingml/2006/main">
               <a:ext uri="{FF2B5EF4-FFF2-40B4-BE49-F238E27FC236}">
-                <a16:creationId xmlns:a16="http://schemas.microsoft.com/office/drawing/2014/main" id="{760FFE4E-FE64-40DC-B710-38EE5FBA2B73}"/>
+                <a16:creationId xmlns:a16="http://schemas.microsoft.com/office/drawing/2014/main" id="{E5EEAADE-535D-49B0-BFA5-92B49CD6FDA0}"/>
               </a:ext>
             </a:extLst>
           </p:cNvPr>
@@ -6938,7 +6938,7 @@
           <p:cNvPr id="18" name="">
             <a:extLst xmlns:a="http://schemas.openxmlformats.org/drawingml/2006/main">
               <a:ext uri="{FF2B5EF4-FFF2-40B4-BE49-F238E27FC236}">
-                <a16:creationId xmlns:a16="http://schemas.microsoft.com/office/drawing/2014/main" id="{3A262A4D-9878-453D-85C5-50F606BC9C54}"/>
+                <a16:creationId xmlns:a16="http://schemas.microsoft.com/office/drawing/2014/main" id="{3855E9C1-593A-401D-8C6D-C3B48FF976F1}"/>
               </a:ext>
             </a:extLst>
           </p:cNvPr>
@@ -7095,7 +7095,7 @@
           <p:cNvPr id="19" name="">
             <a:extLst xmlns:a="http://schemas.openxmlformats.org/drawingml/2006/main">
               <a:ext uri="{FF2B5EF4-FFF2-40B4-BE49-F238E27FC236}">
-                <a16:creationId xmlns:a16="http://schemas.microsoft.com/office/drawing/2014/main" id="{0C54AB50-FAE1-4733-8982-237FEFA04257}"/>
+                <a16:creationId xmlns:a16="http://schemas.microsoft.com/office/drawing/2014/main" id="{76D96BF3-9677-452E-B61F-962CD4F48BBC}"/>
               </a:ext>
             </a:extLst>
           </p:cNvPr>
@@ -7128,7 +7128,7 @@
           <p:cNvPr id="20" name="">
             <a:extLst xmlns:a="http://schemas.openxmlformats.org/drawingml/2006/main">
               <a:ext uri="{FF2B5EF4-FFF2-40B4-BE49-F238E27FC236}">
-                <a16:creationId xmlns:a16="http://schemas.microsoft.com/office/drawing/2014/main" id="{165ED311-4EAC-4EC1-AEDC-84F4D26DF764}"/>
+                <a16:creationId xmlns:a16="http://schemas.microsoft.com/office/drawing/2014/main" id="{032DFDFE-A05D-42BD-B9E6-BC1D48E0B9C0}"/>
               </a:ext>
             </a:extLst>
           </p:cNvPr>
@@ -7178,7 +7178,7 @@
           <p:cNvPr id="21" name="">
             <a:extLst xmlns:a="http://schemas.openxmlformats.org/drawingml/2006/main">
               <a:ext uri="{FF2B5EF4-FFF2-40B4-BE49-F238E27FC236}">
-                <a16:creationId xmlns:a16="http://schemas.microsoft.com/office/drawing/2014/main" id="{D535E00C-A74C-45B0-ADD5-12D9566C403F}"/>
+                <a16:creationId xmlns:a16="http://schemas.microsoft.com/office/drawing/2014/main" id="{D8D84042-D7E5-429D-8FC7-B9D3B10A730F}"/>
               </a:ext>
             </a:extLst>
           </p:cNvPr>
@@ -7211,7 +7211,7 @@
           <p:cNvPr id="22" name="">
             <a:extLst xmlns:a="http://schemas.openxmlformats.org/drawingml/2006/main">
               <a:ext uri="{FF2B5EF4-FFF2-40B4-BE49-F238E27FC236}">
-                <a16:creationId xmlns:a16="http://schemas.microsoft.com/office/drawing/2014/main" id="{9DA23D28-4A45-4D5E-94C9-6B33E6FBBA2B}"/>
+                <a16:creationId xmlns:a16="http://schemas.microsoft.com/office/drawing/2014/main" id="{9A837F6D-55CD-40E1-9645-B588CDD9A6DA}"/>
               </a:ext>
             </a:extLst>
           </p:cNvPr>
@@ -7261,7 +7261,7 @@
           <p:cNvPr id="23" name="">
             <a:extLst xmlns:a="http://schemas.openxmlformats.org/drawingml/2006/main">
               <a:ext uri="{FF2B5EF4-FFF2-40B4-BE49-F238E27FC236}">
-                <a16:creationId xmlns:a16="http://schemas.microsoft.com/office/drawing/2014/main" id="{56DA8AD5-1EE2-4FA0-A82F-3CEA89476291}"/>
+                <a16:creationId xmlns:a16="http://schemas.microsoft.com/office/drawing/2014/main" id="{66C17449-6B3C-4573-99B1-62F353372AC8}"/>
               </a:ext>
             </a:extLst>
           </p:cNvPr>
@@ -7311,7 +7311,7 @@
           <p:cNvPr id="24" name="">
             <a:extLst xmlns:a="http://schemas.openxmlformats.org/drawingml/2006/main">
               <a:ext uri="{FF2B5EF4-FFF2-40B4-BE49-F238E27FC236}">
-                <a16:creationId xmlns:a16="http://schemas.microsoft.com/office/drawing/2014/main" id="{59C5792B-B87A-446E-9CCD-8C6642D54B47}"/>
+                <a16:creationId xmlns:a16="http://schemas.microsoft.com/office/drawing/2014/main" id="{0A239590-6B17-4E0B-AE60-6BDE20019900}"/>
               </a:ext>
             </a:extLst>
           </p:cNvPr>
@@ -7344,7 +7344,7 @@
           <p:cNvPr id="25" name="">
             <a:extLst xmlns:a="http://schemas.openxmlformats.org/drawingml/2006/main">
               <a:ext uri="{FF2B5EF4-FFF2-40B4-BE49-F238E27FC236}">
-                <a16:creationId xmlns:a16="http://schemas.microsoft.com/office/drawing/2014/main" id="{C1DAD70A-3DAE-44E6-8645-7E012EBEAEB6}"/>
+                <a16:creationId xmlns:a16="http://schemas.microsoft.com/office/drawing/2014/main" id="{54A9FE80-5829-4C1C-83CD-C01332DE89B5}"/>
               </a:ext>
             </a:extLst>
           </p:cNvPr>
@@ -7394,7 +7394,7 @@
           <p:cNvPr id="26" name="">
             <a:extLst xmlns:a="http://schemas.openxmlformats.org/drawingml/2006/main">
               <a:ext uri="{FF2B5EF4-FFF2-40B4-BE49-F238E27FC236}">
-                <a16:creationId xmlns:a16="http://schemas.microsoft.com/office/drawing/2014/main" id="{95DEA273-A012-4618-BF6F-17CEB4C64B26}"/>
+                <a16:creationId xmlns:a16="http://schemas.microsoft.com/office/drawing/2014/main" id="{2E7AD204-F5C8-452A-B873-F34E1BB79549}"/>
               </a:ext>
             </a:extLst>
           </p:cNvPr>
@@ -7444,7 +7444,7 @@
           <p:cNvPr id="27" name="">
             <a:extLst xmlns:a="http://schemas.openxmlformats.org/drawingml/2006/main">
               <a:ext uri="{FF2B5EF4-FFF2-40B4-BE49-F238E27FC236}">
-                <a16:creationId xmlns:a16="http://schemas.microsoft.com/office/drawing/2014/main" id="{CC69BC08-0497-4FFD-95A4-92432058BE6B}"/>
+                <a16:creationId xmlns:a16="http://schemas.microsoft.com/office/drawing/2014/main" id="{65215BAC-258A-407E-BE09-82D560FB7449}"/>
               </a:ext>
             </a:extLst>
           </p:cNvPr>
@@ -7477,7 +7477,7 @@
           <p:cNvPr id="28" name="">
             <a:extLst xmlns:a="http://schemas.openxmlformats.org/drawingml/2006/main">
               <a:ext uri="{FF2B5EF4-FFF2-40B4-BE49-F238E27FC236}">
-                <a16:creationId xmlns:a16="http://schemas.microsoft.com/office/drawing/2014/main" id="{036575B7-FED9-4359-B27E-0FC9B30FF3F9}"/>
+                <a16:creationId xmlns:a16="http://schemas.microsoft.com/office/drawing/2014/main" id="{F538748D-7E71-41DF-8A94-ABD8BC276877}"/>
               </a:ext>
             </a:extLst>
           </p:cNvPr>
@@ -7527,7 +7527,7 @@
           <p:cNvPr id="29" name="">
             <a:extLst xmlns:a="http://schemas.openxmlformats.org/drawingml/2006/main">
               <a:ext uri="{FF2B5EF4-FFF2-40B4-BE49-F238E27FC236}">
-                <a16:creationId xmlns:a16="http://schemas.microsoft.com/office/drawing/2014/main" id="{F8454301-F40F-4296-ABA1-856B4D6D5430}"/>
+                <a16:creationId xmlns:a16="http://schemas.microsoft.com/office/drawing/2014/main" id="{DEB035E7-B5CC-4394-A732-7722A00FF24A}"/>
               </a:ext>
             </a:extLst>
           </p:cNvPr>
@@ -7575,7 +7575,7 @@
     </p:spTree>
     <p:extLst>
       <p:ext uri="{BB962C8B-B14F-4D97-AF65-F5344CB8AC3E}">
-        <p14:creationId xmlns:p14="http://schemas.microsoft.com/office/powerpoint/2010/main" val="1025461567"/>
+        <p14:creationId xmlns:p14="http://schemas.microsoft.com/office/powerpoint/2010/main" val="275473887"/>
       </p:ext>
     </p:extLst>
   </p:cSld>
@@ -7606,7 +7606,7 @@
           <p:cNvPr id="31" name="">
             <a:extLst xmlns:a="http://schemas.openxmlformats.org/drawingml/2006/main">
               <a:ext uri="{FF2B5EF4-FFF2-40B4-BE49-F238E27FC236}">
-                <a16:creationId xmlns:a16="http://schemas.microsoft.com/office/drawing/2014/main" id="{18E7F13F-0682-4C18-911B-08B76DEDEDEF}"/>
+                <a16:creationId xmlns:a16="http://schemas.microsoft.com/office/drawing/2014/main" id="{CAED069E-7257-4B90-884D-61D72D4B15A2}"/>
               </a:ext>
             </a:extLst>
           </p:cNvPr>
@@ -7656,7 +7656,7 @@
           <p:cNvPr id="2" name="">
             <a:extLst xmlns:a="http://schemas.openxmlformats.org/drawingml/2006/main">
               <a:ext uri="{FF2B5EF4-FFF2-40B4-BE49-F238E27FC236}">
-                <a16:creationId xmlns:a16="http://schemas.microsoft.com/office/drawing/2014/main" id="{F2C75958-FB72-4EBB-91EA-EAF7AF7C55AF}"/>
+                <a16:creationId xmlns:a16="http://schemas.microsoft.com/office/drawing/2014/main" id="{683EFDF3-D88F-4CB3-96F7-FAAC63279E33}"/>
               </a:ext>
             </a:extLst>
           </p:cNvPr>
@@ -7706,7 +7706,7 @@
           <p:cNvPr id="3" name="">
             <a:extLst xmlns:a="http://schemas.openxmlformats.org/drawingml/2006/main">
               <a:ext uri="{FF2B5EF4-FFF2-40B4-BE49-F238E27FC236}">
-                <a16:creationId xmlns:a16="http://schemas.microsoft.com/office/drawing/2014/main" id="{281000BE-CE84-4A8A-9954-CBDE1215505C}"/>
+                <a16:creationId xmlns:a16="http://schemas.microsoft.com/office/drawing/2014/main" id="{BAFB9520-2D1C-4B30-B601-86F22876D0D1}"/>
               </a:ext>
             </a:extLst>
           </p:cNvPr>
@@ -7739,7 +7739,7 @@
           <p:cNvPr id="4" name="">
             <a:extLst xmlns:a="http://schemas.openxmlformats.org/drawingml/2006/main">
               <a:ext uri="{FF2B5EF4-FFF2-40B4-BE49-F238E27FC236}">
-                <a16:creationId xmlns:a16="http://schemas.microsoft.com/office/drawing/2014/main" id="{92AF17DC-1878-44AC-8BDD-09DD22D57FCE}"/>
+                <a16:creationId xmlns:a16="http://schemas.microsoft.com/office/drawing/2014/main" id="{9E353B71-3DD2-41E1-B3EC-B7C2481F3B90}"/>
               </a:ext>
             </a:extLst>
           </p:cNvPr>
@@ -7789,7 +7789,7 @@
           <p:cNvPr id="5" name="">
             <a:extLst xmlns:a="http://schemas.openxmlformats.org/drawingml/2006/main">
               <a:ext uri="{FF2B5EF4-FFF2-40B4-BE49-F238E27FC236}">
-                <a16:creationId xmlns:a16="http://schemas.microsoft.com/office/drawing/2014/main" id="{107EFD28-DCAA-425F-9913-64BE60BB1A7E}"/>
+                <a16:creationId xmlns:a16="http://schemas.microsoft.com/office/drawing/2014/main" id="{F0AF8F29-8F96-4B01-BB2C-5EB477F239E8}"/>
               </a:ext>
             </a:extLst>
           </p:cNvPr>
@@ -7822,7 +7822,7 @@
           <p:cNvPr id="6" name="">
             <a:extLst xmlns:a="http://schemas.openxmlformats.org/drawingml/2006/main">
               <a:ext uri="{FF2B5EF4-FFF2-40B4-BE49-F238E27FC236}">
-                <a16:creationId xmlns:a16="http://schemas.microsoft.com/office/drawing/2014/main" id="{8E3BCFBB-C47D-4BAA-B0F7-20328D72CCA0}"/>
+                <a16:creationId xmlns:a16="http://schemas.microsoft.com/office/drawing/2014/main" id="{00553A3B-5A9C-4CBB-9FD5-FD2840F0962E}"/>
               </a:ext>
             </a:extLst>
           </p:cNvPr>
@@ -7872,7 +7872,7 @@
           <p:cNvPr id="7" name="">
             <a:extLst xmlns:a="http://schemas.openxmlformats.org/drawingml/2006/main">
               <a:ext uri="{FF2B5EF4-FFF2-40B4-BE49-F238E27FC236}">
-                <a16:creationId xmlns:a16="http://schemas.microsoft.com/office/drawing/2014/main" id="{590A4930-C07D-4A2A-BEA9-33863AE76DED}"/>
+                <a16:creationId xmlns:a16="http://schemas.microsoft.com/office/drawing/2014/main" id="{E24168FA-1ED4-48ED-A760-F962332F6C29}"/>
               </a:ext>
             </a:extLst>
           </p:cNvPr>
@@ -8046,7 +8046,7 @@
           <p:cNvPr id="8" name="">
             <a:extLst xmlns:a="http://schemas.openxmlformats.org/drawingml/2006/main">
               <a:ext uri="{FF2B5EF4-FFF2-40B4-BE49-F238E27FC236}">
-                <a16:creationId xmlns:a16="http://schemas.microsoft.com/office/drawing/2014/main" id="{8C2F393B-C12B-4036-BBF2-9C1FC980B416}"/>
+                <a16:creationId xmlns:a16="http://schemas.microsoft.com/office/drawing/2014/main" id="{646D9D2A-5CDD-4686-A7FD-A7BB25854D53}"/>
               </a:ext>
             </a:extLst>
           </p:cNvPr>
@@ -8096,7 +8096,7 @@
           <p:cNvPr id="9" name="">
             <a:extLst xmlns:a="http://schemas.openxmlformats.org/drawingml/2006/main">
               <a:ext uri="{FF2B5EF4-FFF2-40B4-BE49-F238E27FC236}">
-                <a16:creationId xmlns:a16="http://schemas.microsoft.com/office/drawing/2014/main" id="{573F64A0-8B4C-40E8-A2E8-7D15BDFDAAD8}"/>
+                <a16:creationId xmlns:a16="http://schemas.microsoft.com/office/drawing/2014/main" id="{1FE00AAF-66C5-43D6-AF08-1C1912CAA568}"/>
               </a:ext>
             </a:extLst>
           </p:cNvPr>
@@ -8146,7 +8146,7 @@
           <p:cNvPr id="10" name="">
             <a:extLst xmlns:a="http://schemas.openxmlformats.org/drawingml/2006/main">
               <a:ext uri="{FF2B5EF4-FFF2-40B4-BE49-F238E27FC236}">
-                <a16:creationId xmlns:a16="http://schemas.microsoft.com/office/drawing/2014/main" id="{02148D8A-203C-46AD-A3FF-1E2DD97404B4}"/>
+                <a16:creationId xmlns:a16="http://schemas.microsoft.com/office/drawing/2014/main" id="{A33C29C8-11F0-48F7-BC2E-77A2C566495C}"/>
               </a:ext>
             </a:extLst>
           </p:cNvPr>
@@ -8196,7 +8196,7 @@
           <p:cNvPr id="11" name="">
             <a:extLst xmlns:a="http://schemas.openxmlformats.org/drawingml/2006/main">
               <a:ext uri="{FF2B5EF4-FFF2-40B4-BE49-F238E27FC236}">
-                <a16:creationId xmlns:a16="http://schemas.microsoft.com/office/drawing/2014/main" id="{0D21905C-7E6F-4964-84C1-670A8B5C2DF4}"/>
+                <a16:creationId xmlns:a16="http://schemas.microsoft.com/office/drawing/2014/main" id="{DAF1C5F0-314D-4C17-BE05-03517DD0CE6A}"/>
               </a:ext>
             </a:extLst>
           </p:cNvPr>
@@ -8246,7 +8246,7 @@
           <p:cNvPr id="12" name="">
             <a:extLst xmlns:a="http://schemas.openxmlformats.org/drawingml/2006/main">
               <a:ext uri="{FF2B5EF4-FFF2-40B4-BE49-F238E27FC236}">
-                <a16:creationId xmlns:a16="http://schemas.microsoft.com/office/drawing/2014/main" id="{02C447E9-48DD-48A6-8884-C85032E0D0B0}"/>
+                <a16:creationId xmlns:a16="http://schemas.microsoft.com/office/drawing/2014/main" id="{6F1569BC-A34A-4A3A-BFA1-4547B19E6C81}"/>
               </a:ext>
             </a:extLst>
           </p:cNvPr>
@@ -8296,7 +8296,7 @@
           <p:cNvPr id="13" name="">
             <a:extLst xmlns:a="http://schemas.openxmlformats.org/drawingml/2006/main">
               <a:ext uri="{FF2B5EF4-FFF2-40B4-BE49-F238E27FC236}">
-                <a16:creationId xmlns:a16="http://schemas.microsoft.com/office/drawing/2014/main" id="{346650B3-3D5D-4157-B3E1-3C5667C0E61A}"/>
+                <a16:creationId xmlns:a16="http://schemas.microsoft.com/office/drawing/2014/main" id="{6B39EFFB-8FA7-4551-A7AC-79E81178F568}"/>
               </a:ext>
             </a:extLst>
           </p:cNvPr>
@@ -8346,7 +8346,7 @@
           <p:cNvPr id="14" name="">
             <a:extLst xmlns:a="http://schemas.openxmlformats.org/drawingml/2006/main">
               <a:ext uri="{FF2B5EF4-FFF2-40B4-BE49-F238E27FC236}">
-                <a16:creationId xmlns:a16="http://schemas.microsoft.com/office/drawing/2014/main" id="{F50B81B6-7FE9-498A-A8A9-8A085401F363}"/>
+                <a16:creationId xmlns:a16="http://schemas.microsoft.com/office/drawing/2014/main" id="{191FD670-DF74-4AA2-8F6D-4BCCBC09A280}"/>
               </a:ext>
             </a:extLst>
           </p:cNvPr>
@@ -8396,7 +8396,7 @@
           <p:cNvPr id="15" name="">
             <a:extLst xmlns:a="http://schemas.openxmlformats.org/drawingml/2006/main">
               <a:ext uri="{FF2B5EF4-FFF2-40B4-BE49-F238E27FC236}">
-                <a16:creationId xmlns:a16="http://schemas.microsoft.com/office/drawing/2014/main" id="{9C1DB864-2252-495A-86DC-3D6DBB6C1DC5}"/>
+                <a16:creationId xmlns:a16="http://schemas.microsoft.com/office/drawing/2014/main" id="{A847041B-8143-4FBA-8930-CD1E5E67B44D}"/>
               </a:ext>
             </a:extLst>
           </p:cNvPr>
@@ -8446,7 +8446,7 @@
           <p:cNvPr id="16" name="">
             <a:extLst xmlns:a="http://schemas.openxmlformats.org/drawingml/2006/main">
               <a:ext uri="{FF2B5EF4-FFF2-40B4-BE49-F238E27FC236}">
-                <a16:creationId xmlns:a16="http://schemas.microsoft.com/office/drawing/2014/main" id="{3D210D0B-E1E7-4993-8F10-7DE668DA5A5E}"/>
+                <a16:creationId xmlns:a16="http://schemas.microsoft.com/office/drawing/2014/main" id="{FCF14017-D71D-413A-A8B6-5BFADA8BB605}"/>
               </a:ext>
             </a:extLst>
           </p:cNvPr>
@@ -8479,7 +8479,7 @@
           <p:cNvPr id="17" name="">
             <a:extLst xmlns:a="http://schemas.openxmlformats.org/drawingml/2006/main">
               <a:ext uri="{FF2B5EF4-FFF2-40B4-BE49-F238E27FC236}">
-                <a16:creationId xmlns:a16="http://schemas.microsoft.com/office/drawing/2014/main" id="{045EC39B-0C13-42BD-AD09-E1C5849C2C29}"/>
+                <a16:creationId xmlns:a16="http://schemas.microsoft.com/office/drawing/2014/main" id="{8750EB86-F371-442A-AE61-2B3F63972915}"/>
               </a:ext>
             </a:extLst>
           </p:cNvPr>
@@ -8529,7 +8529,7 @@
           <p:cNvPr id="18" name="">
             <a:extLst xmlns:a="http://schemas.openxmlformats.org/drawingml/2006/main">
               <a:ext uri="{FF2B5EF4-FFF2-40B4-BE49-F238E27FC236}">
-                <a16:creationId xmlns:a16="http://schemas.microsoft.com/office/drawing/2014/main" id="{F333FCCD-47F6-40AF-AFBC-8E6F11D30134}"/>
+                <a16:creationId xmlns:a16="http://schemas.microsoft.com/office/drawing/2014/main" id="{DC18E8F2-6B23-47CC-B095-E4C864C43E2E}"/>
               </a:ext>
             </a:extLst>
           </p:cNvPr>
@@ -8579,7 +8579,7 @@
           <p:cNvPr id="19" name="">
             <a:extLst xmlns:a="http://schemas.openxmlformats.org/drawingml/2006/main">
               <a:ext uri="{FF2B5EF4-FFF2-40B4-BE49-F238E27FC236}">
-                <a16:creationId xmlns:a16="http://schemas.microsoft.com/office/drawing/2014/main" id="{A2C7B5FD-3FD0-4050-9B03-FD0E0FCA3896}"/>
+                <a16:creationId xmlns:a16="http://schemas.microsoft.com/office/drawing/2014/main" id="{0F6FF2D0-FF3F-46F0-BBC1-7BFE802E725D}"/>
               </a:ext>
             </a:extLst>
           </p:cNvPr>
@@ -8612,7 +8612,7 @@
           <p:cNvPr id="20" name="">
             <a:extLst xmlns:a="http://schemas.openxmlformats.org/drawingml/2006/main">
               <a:ext uri="{FF2B5EF4-FFF2-40B4-BE49-F238E27FC236}">
-                <a16:creationId xmlns:a16="http://schemas.microsoft.com/office/drawing/2014/main" id="{B0D420FD-B125-4D46-818A-1B44E419ECFE}"/>
+                <a16:creationId xmlns:a16="http://schemas.microsoft.com/office/drawing/2014/main" id="{A78CAEDA-6A07-40D7-83E4-8E4A2DF1FD0B}"/>
               </a:ext>
             </a:extLst>
           </p:cNvPr>
@@ -8662,7 +8662,7 @@
           <p:cNvPr id="21" name="">
             <a:extLst xmlns:a="http://schemas.openxmlformats.org/drawingml/2006/main">
               <a:ext uri="{FF2B5EF4-FFF2-40B4-BE49-F238E27FC236}">
-                <a16:creationId xmlns:a16="http://schemas.microsoft.com/office/drawing/2014/main" id="{D4F28CF3-FB3A-4154-A88A-D29D17E3A02A}"/>
+                <a16:creationId xmlns:a16="http://schemas.microsoft.com/office/drawing/2014/main" id="{A5477313-F3B5-4221-99C6-E4884609DB70}"/>
               </a:ext>
             </a:extLst>
           </p:cNvPr>
@@ -8712,7 +8712,7 @@
           <p:cNvPr id="22" name="">
             <a:extLst xmlns:a="http://schemas.openxmlformats.org/drawingml/2006/main">
               <a:ext uri="{FF2B5EF4-FFF2-40B4-BE49-F238E27FC236}">
-                <a16:creationId xmlns:a16="http://schemas.microsoft.com/office/drawing/2014/main" id="{F18A5426-8E51-4435-BE64-30AD42A6A9B9}"/>
+                <a16:creationId xmlns:a16="http://schemas.microsoft.com/office/drawing/2014/main" id="{49719017-9AEE-449B-87CE-837F03EBCFBC}"/>
               </a:ext>
             </a:extLst>
           </p:cNvPr>
@@ -8745,7 +8745,7 @@
           <p:cNvPr id="23" name="">
             <a:extLst xmlns:a="http://schemas.openxmlformats.org/drawingml/2006/main">
               <a:ext uri="{FF2B5EF4-FFF2-40B4-BE49-F238E27FC236}">
-                <a16:creationId xmlns:a16="http://schemas.microsoft.com/office/drawing/2014/main" id="{2582EA55-0265-4A3A-836A-919FBF854C7B}"/>
+                <a16:creationId xmlns:a16="http://schemas.microsoft.com/office/drawing/2014/main" id="{2891152B-67DF-4753-BBF5-34553DD25847}"/>
               </a:ext>
             </a:extLst>
           </p:cNvPr>
@@ -8795,7 +8795,7 @@
           <p:cNvPr id="24" name="">
             <a:extLst xmlns:a="http://schemas.openxmlformats.org/drawingml/2006/main">
               <a:ext uri="{FF2B5EF4-FFF2-40B4-BE49-F238E27FC236}">
-                <a16:creationId xmlns:a16="http://schemas.microsoft.com/office/drawing/2014/main" id="{D8C7E218-06D6-4484-BEBD-4EAB73E6B5A9}"/>
+                <a16:creationId xmlns:a16="http://schemas.microsoft.com/office/drawing/2014/main" id="{D516A02A-BE4B-4A96-9A43-91CA770A8469}"/>
               </a:ext>
             </a:extLst>
           </p:cNvPr>
@@ -8845,7 +8845,7 @@
           <p:cNvPr id="25" name="">
             <a:extLst xmlns:a="http://schemas.openxmlformats.org/drawingml/2006/main">
               <a:ext uri="{FF2B5EF4-FFF2-40B4-BE49-F238E27FC236}">
-                <a16:creationId xmlns:a16="http://schemas.microsoft.com/office/drawing/2014/main" id="{94BF3B97-4980-4CB6-A4EC-365AA12BB120}"/>
+                <a16:creationId xmlns:a16="http://schemas.microsoft.com/office/drawing/2014/main" id="{1D94B19E-2F95-4DDB-B701-3CD84EAD5314}"/>
               </a:ext>
             </a:extLst>
           </p:cNvPr>
@@ -8878,7 +8878,7 @@
           <p:cNvPr id="26" name="">
             <a:extLst xmlns:a="http://schemas.openxmlformats.org/drawingml/2006/main">
               <a:ext uri="{FF2B5EF4-FFF2-40B4-BE49-F238E27FC236}">
-                <a16:creationId xmlns:a16="http://schemas.microsoft.com/office/drawing/2014/main" id="{3E1233AF-8DC8-46D5-9226-8B80322AB518}"/>
+                <a16:creationId xmlns:a16="http://schemas.microsoft.com/office/drawing/2014/main" id="{591552E4-3893-45BD-8629-DA46647D99F2}"/>
               </a:ext>
             </a:extLst>
           </p:cNvPr>
@@ -8928,7 +8928,7 @@
           <p:cNvPr id="27" name="">
             <a:extLst xmlns:a="http://schemas.openxmlformats.org/drawingml/2006/main">
               <a:ext uri="{FF2B5EF4-FFF2-40B4-BE49-F238E27FC236}">
-                <a16:creationId xmlns:a16="http://schemas.microsoft.com/office/drawing/2014/main" id="{30E8D1FA-6FC2-4EFE-B2B7-289BFEFD8231}"/>
+                <a16:creationId xmlns:a16="http://schemas.microsoft.com/office/drawing/2014/main" id="{054FFD6D-F0C8-47B7-8FEE-8952C56D9041}"/>
               </a:ext>
             </a:extLst>
           </p:cNvPr>
@@ -8978,7 +8978,7 @@
           <p:cNvPr id="28" name="">
             <a:extLst xmlns:a="http://schemas.openxmlformats.org/drawingml/2006/main">
               <a:ext uri="{FF2B5EF4-FFF2-40B4-BE49-F238E27FC236}">
-                <a16:creationId xmlns:a16="http://schemas.microsoft.com/office/drawing/2014/main" id="{BBBD81D3-10ED-406D-9412-6C1B45B40706}"/>
+                <a16:creationId xmlns:a16="http://schemas.microsoft.com/office/drawing/2014/main" id="{B708106F-003F-48F5-BE2D-41E15D8AA774}"/>
               </a:ext>
             </a:extLst>
           </p:cNvPr>
@@ -9011,7 +9011,7 @@
           <p:cNvPr id="29" name="">
             <a:extLst xmlns:a="http://schemas.openxmlformats.org/drawingml/2006/main">
               <a:ext uri="{FF2B5EF4-FFF2-40B4-BE49-F238E27FC236}">
-                <a16:creationId xmlns:a16="http://schemas.microsoft.com/office/drawing/2014/main" id="{0030DEFD-60CB-4382-976E-E532755A0042}"/>
+                <a16:creationId xmlns:a16="http://schemas.microsoft.com/office/drawing/2014/main" id="{781012F3-99F2-40B1-BE60-C5D145E27759}"/>
               </a:ext>
             </a:extLst>
           </p:cNvPr>
@@ -9061,7 +9061,7 @@
           <p:cNvPr id="30" name="">
             <a:extLst xmlns:a="http://schemas.openxmlformats.org/drawingml/2006/main">
               <a:ext uri="{FF2B5EF4-FFF2-40B4-BE49-F238E27FC236}">
-                <a16:creationId xmlns:a16="http://schemas.microsoft.com/office/drawing/2014/main" id="{E3220EAC-7AE0-4680-AB76-545940A7A63F}"/>
+                <a16:creationId xmlns:a16="http://schemas.microsoft.com/office/drawing/2014/main" id="{735D294B-E576-4271-81CE-07368EE43598}"/>
               </a:ext>
             </a:extLst>
           </p:cNvPr>
@@ -9109,7 +9109,7 @@
     </p:spTree>
     <p:extLst>
       <p:ext uri="{BB962C8B-B14F-4D97-AF65-F5344CB8AC3E}">
-        <p14:creationId xmlns:p14="http://schemas.microsoft.com/office/powerpoint/2010/main" val="1117033473"/>
+        <p14:creationId xmlns:p14="http://schemas.microsoft.com/office/powerpoint/2010/main" val="1670724504"/>
       </p:ext>
     </p:extLst>
   </p:cSld>
@@ -9140,7 +9140,7 @@
           <p:cNvPr id="13" name="">
             <a:extLst xmlns:a="http://schemas.openxmlformats.org/drawingml/2006/main">
               <a:ext uri="{FF2B5EF4-FFF2-40B4-BE49-F238E27FC236}">
-                <a16:creationId xmlns:a16="http://schemas.microsoft.com/office/drawing/2014/main" id="{8ABDC8AF-5B7F-429A-A904-8BB484A7E04A}"/>
+                <a16:creationId xmlns:a16="http://schemas.microsoft.com/office/drawing/2014/main" id="{6E4985EA-376F-4EC3-9CCA-FDE5838F4539}"/>
               </a:ext>
             </a:extLst>
           </p:cNvPr>
@@ -9190,7 +9190,7 @@
           <p:cNvPr id="2" name="">
             <a:extLst xmlns:a="http://schemas.openxmlformats.org/drawingml/2006/main">
               <a:ext uri="{FF2B5EF4-FFF2-40B4-BE49-F238E27FC236}">
-                <a16:creationId xmlns:a16="http://schemas.microsoft.com/office/drawing/2014/main" id="{B47D2722-C96D-45A2-BD47-613970350798}"/>
+                <a16:creationId xmlns:a16="http://schemas.microsoft.com/office/drawing/2014/main" id="{7A3D4A5E-1DA3-49BA-BFDF-D120DA24741E}"/>
               </a:ext>
             </a:extLst>
           </p:cNvPr>
@@ -9240,7 +9240,7 @@
           <p:cNvPr id="3" name="">
             <a:extLst xmlns:a="http://schemas.openxmlformats.org/drawingml/2006/main">
               <a:ext uri="{FF2B5EF4-FFF2-40B4-BE49-F238E27FC236}">
-                <a16:creationId xmlns:a16="http://schemas.microsoft.com/office/drawing/2014/main" id="{0EE22F48-4311-4A73-A1F2-4645FCF2D961}"/>
+                <a16:creationId xmlns:a16="http://schemas.microsoft.com/office/drawing/2014/main" id="{358F21FB-F7BC-46D5-99CA-9AE35FEF677F}"/>
               </a:ext>
             </a:extLst>
           </p:cNvPr>
@@ -9273,7 +9273,7 @@
           <p:cNvPr id="4" name="">
             <a:extLst xmlns:a="http://schemas.openxmlformats.org/drawingml/2006/main">
               <a:ext uri="{FF2B5EF4-FFF2-40B4-BE49-F238E27FC236}">
-                <a16:creationId xmlns:a16="http://schemas.microsoft.com/office/drawing/2014/main" id="{143160D6-93D1-4563-AFE5-7C5AE0186387}"/>
+                <a16:creationId xmlns:a16="http://schemas.microsoft.com/office/drawing/2014/main" id="{4729FF76-1BA5-4525-8BAF-68ED5D58E8C2}"/>
               </a:ext>
             </a:extLst>
           </p:cNvPr>
@@ -9323,7 +9323,7 @@
           <p:cNvPr id="5" name="">
             <a:extLst xmlns:a="http://schemas.openxmlformats.org/drawingml/2006/main">
               <a:ext uri="{FF2B5EF4-FFF2-40B4-BE49-F238E27FC236}">
-                <a16:creationId xmlns:a16="http://schemas.microsoft.com/office/drawing/2014/main" id="{9E1083BE-F543-41A4-9717-D79B9E6D79F5}"/>
+                <a16:creationId xmlns:a16="http://schemas.microsoft.com/office/drawing/2014/main" id="{20088739-5947-4BF1-A5FA-574BDE22D054}"/>
               </a:ext>
             </a:extLst>
           </p:cNvPr>
@@ -9356,7 +9356,7 @@
           <p:cNvPr id="6" name="">
             <a:extLst xmlns:a="http://schemas.openxmlformats.org/drawingml/2006/main">
               <a:ext uri="{FF2B5EF4-FFF2-40B4-BE49-F238E27FC236}">
-                <a16:creationId xmlns:a16="http://schemas.microsoft.com/office/drawing/2014/main" id="{B4A8F5B8-DD01-4C5A-8D30-FD72753A2806}"/>
+                <a16:creationId xmlns:a16="http://schemas.microsoft.com/office/drawing/2014/main" id="{9203E538-A420-4E22-9168-6278A19C765D}"/>
               </a:ext>
             </a:extLst>
           </p:cNvPr>
@@ -9406,7 +9406,7 @@
           <p:cNvPr id="7" name="">
             <a:extLst xmlns:a="http://schemas.openxmlformats.org/drawingml/2006/main">
               <a:ext uri="{FF2B5EF4-FFF2-40B4-BE49-F238E27FC236}">
-                <a16:creationId xmlns:a16="http://schemas.microsoft.com/office/drawing/2014/main" id="{E3994E88-2669-4787-9F9C-F5A86E396D18}"/>
+                <a16:creationId xmlns:a16="http://schemas.microsoft.com/office/drawing/2014/main" id="{EBF08DF9-7823-487A-B6E4-0D5B21513872}"/>
               </a:ext>
             </a:extLst>
           </p:cNvPr>
@@ -9607,7 +9607,7 @@
           <p:cNvPr id="8" name="">
             <a:extLst xmlns:a="http://schemas.openxmlformats.org/drawingml/2006/main">
               <a:ext uri="{FF2B5EF4-FFF2-40B4-BE49-F238E27FC236}">
-                <a16:creationId xmlns:a16="http://schemas.microsoft.com/office/drawing/2014/main" id="{747AFF6B-2F66-4F79-93F4-AD9FF82DBDF6}"/>
+                <a16:creationId xmlns:a16="http://schemas.microsoft.com/office/drawing/2014/main" id="{1186B290-267A-46F8-A116-316AF1109F8A}"/>
               </a:ext>
             </a:extLst>
           </p:cNvPr>
@@ -9640,7 +9640,7 @@
           <p:cNvPr id="9" name="">
             <a:extLst xmlns:a="http://schemas.openxmlformats.org/drawingml/2006/main">
               <a:ext uri="{FF2B5EF4-FFF2-40B4-BE49-F238E27FC236}">
-                <a16:creationId xmlns:a16="http://schemas.microsoft.com/office/drawing/2014/main" id="{756F05D0-8E9F-4A74-A351-642C8963A4D0}"/>
+                <a16:creationId xmlns:a16="http://schemas.microsoft.com/office/drawing/2014/main" id="{247C5501-A8F6-479C-9F3D-5BED72FAD33D}"/>
               </a:ext>
             </a:extLst>
           </p:cNvPr>
@@ -9690,7 +9690,7 @@
           <p:cNvPr id="10" name="">
             <a:extLst xmlns:a="http://schemas.openxmlformats.org/drawingml/2006/main">
               <a:ext uri="{FF2B5EF4-FFF2-40B4-BE49-F238E27FC236}">
-                <a16:creationId xmlns:a16="http://schemas.microsoft.com/office/drawing/2014/main" id="{8702125D-DA4D-4668-9D44-DB9777684A1B}"/>
+                <a16:creationId xmlns:a16="http://schemas.microsoft.com/office/drawing/2014/main" id="{A642E6F1-EF1D-432E-83C2-983219F5CE3C}"/>
               </a:ext>
             </a:extLst>
           </p:cNvPr>
@@ -9949,7 +9949,7 @@
           <p:cNvPr id="11" name="">
             <a:extLst xmlns:a="http://schemas.openxmlformats.org/drawingml/2006/main">
               <a:ext uri="{FF2B5EF4-FFF2-40B4-BE49-F238E27FC236}">
-                <a16:creationId xmlns:a16="http://schemas.microsoft.com/office/drawing/2014/main" id="{255FF070-F5E3-43D8-8A65-C94CF1E770E6}"/>
+                <a16:creationId xmlns:a16="http://schemas.microsoft.com/office/drawing/2014/main" id="{325442D0-6AC6-4E4A-8503-CCE8D81A302F}"/>
               </a:ext>
             </a:extLst>
           </p:cNvPr>
@@ -9999,7 +9999,7 @@
           <p:cNvPr id="12" name="">
             <a:extLst xmlns:a="http://schemas.openxmlformats.org/drawingml/2006/main">
               <a:ext uri="{FF2B5EF4-FFF2-40B4-BE49-F238E27FC236}">
-                <a16:creationId xmlns:a16="http://schemas.microsoft.com/office/drawing/2014/main" id="{9A70A5DB-1E9D-4B95-A773-2A3A60152EFB}"/>
+                <a16:creationId xmlns:a16="http://schemas.microsoft.com/office/drawing/2014/main" id="{CB24E53B-C1DD-4965-B70D-9BDA81307377}"/>
               </a:ext>
             </a:extLst>
           </p:cNvPr>
@@ -10047,7 +10047,7 @@
     </p:spTree>
     <p:extLst>
       <p:ext uri="{BB962C8B-B14F-4D97-AF65-F5344CB8AC3E}">
-        <p14:creationId xmlns:p14="http://schemas.microsoft.com/office/powerpoint/2010/main" val="364642516"/>
+        <p14:creationId xmlns:p14="http://schemas.microsoft.com/office/powerpoint/2010/main" val="540712871"/>
       </p:ext>
     </p:extLst>
   </p:cSld>
@@ -10078,7 +10078,7 @@
           <p:cNvPr id="27" name="">
             <a:extLst xmlns:a="http://schemas.openxmlformats.org/drawingml/2006/main">
               <a:ext uri="{FF2B5EF4-FFF2-40B4-BE49-F238E27FC236}">
-                <a16:creationId xmlns:a16="http://schemas.microsoft.com/office/drawing/2014/main" id="{8ACDA5F3-B40E-4550-8C54-06AD626A385B}"/>
+                <a16:creationId xmlns:a16="http://schemas.microsoft.com/office/drawing/2014/main" id="{7B21836C-64A2-4F14-834C-A6DD92F241E6}"/>
               </a:ext>
             </a:extLst>
           </p:cNvPr>
@@ -10128,7 +10128,7 @@
           <p:cNvPr id="2" name="">
             <a:extLst xmlns:a="http://schemas.openxmlformats.org/drawingml/2006/main">
               <a:ext uri="{FF2B5EF4-FFF2-40B4-BE49-F238E27FC236}">
-                <a16:creationId xmlns:a16="http://schemas.microsoft.com/office/drawing/2014/main" id="{E409B880-871A-48B2-8AFC-A08316306E76}"/>
+                <a16:creationId xmlns:a16="http://schemas.microsoft.com/office/drawing/2014/main" id="{69B15E43-E20C-41D5-8DD9-C335BD597C2F}"/>
               </a:ext>
             </a:extLst>
           </p:cNvPr>
@@ -10178,7 +10178,7 @@
           <p:cNvPr id="3" name="">
             <a:extLst xmlns:a="http://schemas.openxmlformats.org/drawingml/2006/main">
               <a:ext uri="{FF2B5EF4-FFF2-40B4-BE49-F238E27FC236}">
-                <a16:creationId xmlns:a16="http://schemas.microsoft.com/office/drawing/2014/main" id="{F643CD0C-F8CA-48AF-A69B-48A791E067AA}"/>
+                <a16:creationId xmlns:a16="http://schemas.microsoft.com/office/drawing/2014/main" id="{96313B76-B038-4478-85E9-D348B6ECE1E3}"/>
               </a:ext>
             </a:extLst>
           </p:cNvPr>
@@ -10211,7 +10211,7 @@
           <p:cNvPr id="4" name="">
             <a:extLst xmlns:a="http://schemas.openxmlformats.org/drawingml/2006/main">
               <a:ext uri="{FF2B5EF4-FFF2-40B4-BE49-F238E27FC236}">
-                <a16:creationId xmlns:a16="http://schemas.microsoft.com/office/drawing/2014/main" id="{A0369FF4-E1A9-4D88-9F0C-93D89DE44566}"/>
+                <a16:creationId xmlns:a16="http://schemas.microsoft.com/office/drawing/2014/main" id="{A82003C4-2CFB-4D06-9CFD-AD6F8D38EFF2}"/>
               </a:ext>
             </a:extLst>
           </p:cNvPr>
@@ -10261,7 +10261,7 @@
           <p:cNvPr id="5" name="">
             <a:extLst xmlns:a="http://schemas.openxmlformats.org/drawingml/2006/main">
               <a:ext uri="{FF2B5EF4-FFF2-40B4-BE49-F238E27FC236}">
-                <a16:creationId xmlns:a16="http://schemas.microsoft.com/office/drawing/2014/main" id="{A47BD7E5-CE5B-4DAF-A1AE-D505E765F067}"/>
+                <a16:creationId xmlns:a16="http://schemas.microsoft.com/office/drawing/2014/main" id="{33CF3E05-CA44-4EC2-B502-A1823A9B40D4}"/>
               </a:ext>
             </a:extLst>
           </p:cNvPr>
@@ -10294,7 +10294,7 @@
           <p:cNvPr id="6" name="">
             <a:extLst xmlns:a="http://schemas.openxmlformats.org/drawingml/2006/main">
               <a:ext uri="{FF2B5EF4-FFF2-40B4-BE49-F238E27FC236}">
-                <a16:creationId xmlns:a16="http://schemas.microsoft.com/office/drawing/2014/main" id="{5DCED78F-3F0E-4DC7-8FB2-182106A77F5C}"/>
+                <a16:creationId xmlns:a16="http://schemas.microsoft.com/office/drawing/2014/main" id="{91632526-73A3-4E77-B98A-460FD3AFFCED}"/>
               </a:ext>
             </a:extLst>
           </p:cNvPr>
@@ -10327,7 +10327,7 @@
           <p:cNvPr id="7" name="">
             <a:extLst xmlns:a="http://schemas.openxmlformats.org/drawingml/2006/main">
               <a:ext uri="{FF2B5EF4-FFF2-40B4-BE49-F238E27FC236}">
-                <a16:creationId xmlns:a16="http://schemas.microsoft.com/office/drawing/2014/main" id="{1D6AE6FC-961C-4B49-A6F4-62611F8FB478}"/>
+                <a16:creationId xmlns:a16="http://schemas.microsoft.com/office/drawing/2014/main" id="{FCB0B545-9D27-4C03-B17F-AA441976E05C}"/>
               </a:ext>
             </a:extLst>
           </p:cNvPr>
@@ -10377,7 +10377,7 @@
           <p:cNvPr id="8" name="">
             <a:extLst xmlns:a="http://schemas.openxmlformats.org/drawingml/2006/main">
               <a:ext uri="{FF2B5EF4-FFF2-40B4-BE49-F238E27FC236}">
-                <a16:creationId xmlns:a16="http://schemas.microsoft.com/office/drawing/2014/main" id="{B43E0283-5B7C-4278-81A2-41CAB87859F3}"/>
+                <a16:creationId xmlns:a16="http://schemas.microsoft.com/office/drawing/2014/main" id="{F0B3A353-0806-4E23-AF5D-68E4CE6B81FF}"/>
               </a:ext>
             </a:extLst>
           </p:cNvPr>
@@ -10427,7 +10427,7 @@
           <p:cNvPr id="9" name="">
             <a:extLst xmlns:a="http://schemas.openxmlformats.org/drawingml/2006/main">
               <a:ext uri="{FF2B5EF4-FFF2-40B4-BE49-F238E27FC236}">
-                <a16:creationId xmlns:a16="http://schemas.microsoft.com/office/drawing/2014/main" id="{BAFE3B31-F5D6-4DBD-8AF0-FFE3D36B97FA}"/>
+                <a16:creationId xmlns:a16="http://schemas.microsoft.com/office/drawing/2014/main" id="{D7DDCB4C-7FA3-49ED-9C31-8A806AD5EA93}"/>
               </a:ext>
             </a:extLst>
           </p:cNvPr>
@@ -10460,7 +10460,7 @@
           <p:cNvPr id="10" name="">
             <a:extLst xmlns:a="http://schemas.openxmlformats.org/drawingml/2006/main">
               <a:ext uri="{FF2B5EF4-FFF2-40B4-BE49-F238E27FC236}">
-                <a16:creationId xmlns:a16="http://schemas.microsoft.com/office/drawing/2014/main" id="{E90E13C3-D3A7-4F2B-9540-24156AB21C1E}"/>
+                <a16:creationId xmlns:a16="http://schemas.microsoft.com/office/drawing/2014/main" id="{D1C6DB7F-8279-49D7-ABB4-98AC7658D4B7}"/>
               </a:ext>
             </a:extLst>
           </p:cNvPr>
@@ -10493,7 +10493,7 @@
           <p:cNvPr id="11" name="">
             <a:extLst xmlns:a="http://schemas.openxmlformats.org/drawingml/2006/main">
               <a:ext uri="{FF2B5EF4-FFF2-40B4-BE49-F238E27FC236}">
-                <a16:creationId xmlns:a16="http://schemas.microsoft.com/office/drawing/2014/main" id="{B03480F8-5C3C-497D-A921-32AC7C08A152}"/>
+                <a16:creationId xmlns:a16="http://schemas.microsoft.com/office/drawing/2014/main" id="{02ECBFF8-504F-47FA-A4E2-DDB94A8A26C4}"/>
               </a:ext>
             </a:extLst>
           </p:cNvPr>
@@ -10543,7 +10543,7 @@
           <p:cNvPr id="12" name="">
             <a:extLst xmlns:a="http://schemas.openxmlformats.org/drawingml/2006/main">
               <a:ext uri="{FF2B5EF4-FFF2-40B4-BE49-F238E27FC236}">
-                <a16:creationId xmlns:a16="http://schemas.microsoft.com/office/drawing/2014/main" id="{FF7ECCF6-8CB2-490C-B84D-7AC77E225047}"/>
+                <a16:creationId xmlns:a16="http://schemas.microsoft.com/office/drawing/2014/main" id="{D571CDCA-DEFD-44E5-AA7E-5C7C12E48F6C}"/>
               </a:ext>
             </a:extLst>
           </p:cNvPr>
@@ -10593,7 +10593,7 @@
           <p:cNvPr id="13" name="">
             <a:extLst xmlns:a="http://schemas.openxmlformats.org/drawingml/2006/main">
               <a:ext uri="{FF2B5EF4-FFF2-40B4-BE49-F238E27FC236}">
-                <a16:creationId xmlns:a16="http://schemas.microsoft.com/office/drawing/2014/main" id="{94DEACE3-F230-4D7D-95F6-6F1B1DD8E8F1}"/>
+                <a16:creationId xmlns:a16="http://schemas.microsoft.com/office/drawing/2014/main" id="{578AE4A8-5261-43FF-B430-6CF77CA9B7CE}"/>
               </a:ext>
             </a:extLst>
           </p:cNvPr>
@@ -10626,7 +10626,7 @@
           <p:cNvPr id="14" name="">
             <a:extLst xmlns:a="http://schemas.openxmlformats.org/drawingml/2006/main">
               <a:ext uri="{FF2B5EF4-FFF2-40B4-BE49-F238E27FC236}">
-                <a16:creationId xmlns:a16="http://schemas.microsoft.com/office/drawing/2014/main" id="{A766CA62-CCFE-4BC0-A980-0E1504D60F1C}"/>
+                <a16:creationId xmlns:a16="http://schemas.microsoft.com/office/drawing/2014/main" id="{3FDF3DAD-8F2D-411F-8954-0F62A97E06B9}"/>
               </a:ext>
             </a:extLst>
           </p:cNvPr>
@@ -10659,7 +10659,7 @@
           <p:cNvPr id="15" name="">
             <a:extLst xmlns:a="http://schemas.openxmlformats.org/drawingml/2006/main">
               <a:ext uri="{FF2B5EF4-FFF2-40B4-BE49-F238E27FC236}">
-                <a16:creationId xmlns:a16="http://schemas.microsoft.com/office/drawing/2014/main" id="{F99EE050-6F68-4D0A-997F-485599598965}"/>
+                <a16:creationId xmlns:a16="http://schemas.microsoft.com/office/drawing/2014/main" id="{FA5D2DB3-CE1D-4566-BDE9-514B8389B354}"/>
               </a:ext>
             </a:extLst>
           </p:cNvPr>
@@ -10709,7 +10709,7 @@
           <p:cNvPr id="16" name="">
             <a:extLst xmlns:a="http://schemas.openxmlformats.org/drawingml/2006/main">
               <a:ext uri="{FF2B5EF4-FFF2-40B4-BE49-F238E27FC236}">
-                <a16:creationId xmlns:a16="http://schemas.microsoft.com/office/drawing/2014/main" id="{68AD246A-4F62-46FB-8502-9ABC195C69AE}"/>
+                <a16:creationId xmlns:a16="http://schemas.microsoft.com/office/drawing/2014/main" id="{A7D8EF70-E604-432A-823D-A80863888591}"/>
               </a:ext>
             </a:extLst>
           </p:cNvPr>
@@ -10759,7 +10759,7 @@
           <p:cNvPr id="17" name="">
             <a:extLst xmlns:a="http://schemas.openxmlformats.org/drawingml/2006/main">
               <a:ext uri="{FF2B5EF4-FFF2-40B4-BE49-F238E27FC236}">
-                <a16:creationId xmlns:a16="http://schemas.microsoft.com/office/drawing/2014/main" id="{9085D7B2-037A-41C6-8ED5-A783D78B74EE}"/>
+                <a16:creationId xmlns:a16="http://schemas.microsoft.com/office/drawing/2014/main" id="{5B7E07FE-94E9-460D-A7D7-7389ACB74A33}"/>
               </a:ext>
             </a:extLst>
           </p:cNvPr>
@@ -10792,7 +10792,7 @@
           <p:cNvPr id="18" name="">
             <a:extLst xmlns:a="http://schemas.openxmlformats.org/drawingml/2006/main">
               <a:ext uri="{FF2B5EF4-FFF2-40B4-BE49-F238E27FC236}">
-                <a16:creationId xmlns:a16="http://schemas.microsoft.com/office/drawing/2014/main" id="{3D8FD157-F99F-466F-AFFD-E5FA9D566F80}"/>
+                <a16:creationId xmlns:a16="http://schemas.microsoft.com/office/drawing/2014/main" id="{AE501813-17DB-49F4-B122-754B7972FC36}"/>
               </a:ext>
             </a:extLst>
           </p:cNvPr>
@@ -10825,7 +10825,7 @@
           <p:cNvPr id="19" name="">
             <a:extLst xmlns:a="http://schemas.openxmlformats.org/drawingml/2006/main">
               <a:ext uri="{FF2B5EF4-FFF2-40B4-BE49-F238E27FC236}">
-                <a16:creationId xmlns:a16="http://schemas.microsoft.com/office/drawing/2014/main" id="{1AA02A9D-5F47-424A-82AD-2424194B44BE}"/>
+                <a16:creationId xmlns:a16="http://schemas.microsoft.com/office/drawing/2014/main" id="{E26583A2-7928-4CB8-9E21-A172DECBA5D5}"/>
               </a:ext>
             </a:extLst>
           </p:cNvPr>
@@ -10858,7 +10858,7 @@
           <p:cNvPr id="20" name="">
             <a:extLst xmlns:a="http://schemas.openxmlformats.org/drawingml/2006/main">
               <a:ext uri="{FF2B5EF4-FFF2-40B4-BE49-F238E27FC236}">
-                <a16:creationId xmlns:a16="http://schemas.microsoft.com/office/drawing/2014/main" id="{FB18B24D-AA6A-4BFB-9696-450F70049334}"/>
+                <a16:creationId xmlns:a16="http://schemas.microsoft.com/office/drawing/2014/main" id="{3313040F-FCAF-47C3-99C2-3B46D85C9E43}"/>
               </a:ext>
             </a:extLst>
           </p:cNvPr>
@@ -10891,7 +10891,7 @@
           <p:cNvPr id="21" name="">
             <a:extLst xmlns:a="http://schemas.openxmlformats.org/drawingml/2006/main">
               <a:ext uri="{FF2B5EF4-FFF2-40B4-BE49-F238E27FC236}">
-                <a16:creationId xmlns:a16="http://schemas.microsoft.com/office/drawing/2014/main" id="{6F8C8D87-65DF-4DA4-BFF3-EC94EB5AB28C}"/>
+                <a16:creationId xmlns:a16="http://schemas.microsoft.com/office/drawing/2014/main" id="{3420D7A1-5244-48E4-A0AF-4F1739F71E67}"/>
               </a:ext>
             </a:extLst>
           </p:cNvPr>
@@ -10924,7 +10924,7 @@
           <p:cNvPr id="22" name="">
             <a:extLst xmlns:a="http://schemas.openxmlformats.org/drawingml/2006/main">
               <a:ext uri="{FF2B5EF4-FFF2-40B4-BE49-F238E27FC236}">
-                <a16:creationId xmlns:a16="http://schemas.microsoft.com/office/drawing/2014/main" id="{3D6D5100-DA6B-4894-879A-ABFB5E859166}"/>
+                <a16:creationId xmlns:a16="http://schemas.microsoft.com/office/drawing/2014/main" id="{7BD0F43D-F2FE-4496-9C38-73CC1649739C}"/>
               </a:ext>
             </a:extLst>
           </p:cNvPr>
@@ -10957,7 +10957,7 @@
           <p:cNvPr id="23" name="">
             <a:extLst xmlns:a="http://schemas.openxmlformats.org/drawingml/2006/main">
               <a:ext uri="{FF2B5EF4-FFF2-40B4-BE49-F238E27FC236}">
-                <a16:creationId xmlns:a16="http://schemas.microsoft.com/office/drawing/2014/main" id="{57C26708-86AF-465B-8FA5-C0DBD4D9F1D0}"/>
+                <a16:creationId xmlns:a16="http://schemas.microsoft.com/office/drawing/2014/main" id="{9115A392-6125-42B6-BDA2-C3977A22FAE9}"/>
               </a:ext>
             </a:extLst>
           </p:cNvPr>
@@ -10990,7 +10990,7 @@
           <p:cNvPr id="24" name="">
             <a:extLst xmlns:a="http://schemas.openxmlformats.org/drawingml/2006/main">
               <a:ext uri="{FF2B5EF4-FFF2-40B4-BE49-F238E27FC236}">
-                <a16:creationId xmlns:a16="http://schemas.microsoft.com/office/drawing/2014/main" id="{2FEBF936-9777-48C3-9368-8CF88002B150}"/>
+                <a16:creationId xmlns:a16="http://schemas.microsoft.com/office/drawing/2014/main" id="{654A00C7-27BF-4C50-B309-C7B812B172A3}"/>
               </a:ext>
             </a:extLst>
           </p:cNvPr>
@@ -11023,7 +11023,7 @@
           <p:cNvPr id="25" name="">
             <a:extLst xmlns:a="http://schemas.openxmlformats.org/drawingml/2006/main">
               <a:ext uri="{FF2B5EF4-FFF2-40B4-BE49-F238E27FC236}">
-                <a16:creationId xmlns:a16="http://schemas.microsoft.com/office/drawing/2014/main" id="{8A9A52E6-0FC5-4F6E-861A-A08EA4854968}"/>
+                <a16:creationId xmlns:a16="http://schemas.microsoft.com/office/drawing/2014/main" id="{19A4A743-B537-4EC6-BD35-CF07A73F0C47}"/>
               </a:ext>
             </a:extLst>
           </p:cNvPr>
@@ -11073,7 +11073,7 @@
           <p:cNvPr id="26" name="">
             <a:extLst xmlns:a="http://schemas.openxmlformats.org/drawingml/2006/main">
               <a:ext uri="{FF2B5EF4-FFF2-40B4-BE49-F238E27FC236}">
-                <a16:creationId xmlns:a16="http://schemas.microsoft.com/office/drawing/2014/main" id="{3916D240-774C-4465-AB26-698BCB7383CE}"/>
+                <a16:creationId xmlns:a16="http://schemas.microsoft.com/office/drawing/2014/main" id="{2B31D6A2-87B5-4B6F-8FE7-FCCE06780210}"/>
               </a:ext>
             </a:extLst>
           </p:cNvPr>
@@ -11121,7 +11121,7 @@
     </p:spTree>
     <p:extLst>
       <p:ext uri="{BB962C8B-B14F-4D97-AF65-F5344CB8AC3E}">
-        <p14:creationId xmlns:p14="http://schemas.microsoft.com/office/powerpoint/2010/main" val="117688224"/>
+        <p14:creationId xmlns:p14="http://schemas.microsoft.com/office/powerpoint/2010/main" val="493876413"/>
       </p:ext>
     </p:extLst>
   </p:cSld>
@@ -11152,7 +11152,7 @@
           <p:cNvPr id="41" name="">
             <a:extLst xmlns:a="http://schemas.openxmlformats.org/drawingml/2006/main">
               <a:ext uri="{FF2B5EF4-FFF2-40B4-BE49-F238E27FC236}">
-                <a16:creationId xmlns:a16="http://schemas.microsoft.com/office/drawing/2014/main" id="{DA08FDB0-AACB-4C84-8DCC-AA78F4B8E598}"/>
+                <a16:creationId xmlns:a16="http://schemas.microsoft.com/office/drawing/2014/main" id="{BF24E3F3-846C-4DE2-8BAB-94D79EF60A39}"/>
               </a:ext>
             </a:extLst>
           </p:cNvPr>
@@ -11202,7 +11202,7 @@
           <p:cNvPr id="2" name="">
             <a:extLst xmlns:a="http://schemas.openxmlformats.org/drawingml/2006/main">
               <a:ext uri="{FF2B5EF4-FFF2-40B4-BE49-F238E27FC236}">
-                <a16:creationId xmlns:a16="http://schemas.microsoft.com/office/drawing/2014/main" id="{C072052A-7DA3-4E0A-B2AE-B578DCB374A6}"/>
+                <a16:creationId xmlns:a16="http://schemas.microsoft.com/office/drawing/2014/main" id="{97C88D8A-284E-4A23-A8D0-7A4C4B07FC53}"/>
               </a:ext>
             </a:extLst>
           </p:cNvPr>
@@ -11252,7 +11252,7 @@
           <p:cNvPr id="3" name="">
             <a:extLst xmlns:a="http://schemas.openxmlformats.org/drawingml/2006/main">
               <a:ext uri="{FF2B5EF4-FFF2-40B4-BE49-F238E27FC236}">
-                <a16:creationId xmlns:a16="http://schemas.microsoft.com/office/drawing/2014/main" id="{B89976DF-C653-4EF2-B7BF-2DC661529C51}"/>
+                <a16:creationId xmlns:a16="http://schemas.microsoft.com/office/drawing/2014/main" id="{FA121870-852D-4088-8F4E-C5669D0DD5F6}"/>
               </a:ext>
             </a:extLst>
           </p:cNvPr>
@@ -11285,7 +11285,7 @@
           <p:cNvPr id="4" name="">
             <a:extLst xmlns:a="http://schemas.openxmlformats.org/drawingml/2006/main">
               <a:ext uri="{FF2B5EF4-FFF2-40B4-BE49-F238E27FC236}">
-                <a16:creationId xmlns:a16="http://schemas.microsoft.com/office/drawing/2014/main" id="{11EE4691-CE03-4F1C-B8FD-103945771F39}"/>
+                <a16:creationId xmlns:a16="http://schemas.microsoft.com/office/drawing/2014/main" id="{76B9D1F9-28A9-4EDD-8247-866ACD92E559}"/>
               </a:ext>
             </a:extLst>
           </p:cNvPr>
@@ -11335,7 +11335,7 @@
           <p:cNvPr id="5" name="">
             <a:extLst xmlns:a="http://schemas.openxmlformats.org/drawingml/2006/main">
               <a:ext uri="{FF2B5EF4-FFF2-40B4-BE49-F238E27FC236}">
-                <a16:creationId xmlns:a16="http://schemas.microsoft.com/office/drawing/2014/main" id="{6FE51D4A-F9E5-447D-B098-65E8834C704D}"/>
+                <a16:creationId xmlns:a16="http://schemas.microsoft.com/office/drawing/2014/main" id="{632EB12F-1952-4A1C-951E-B582BAE84AA4}"/>
               </a:ext>
             </a:extLst>
           </p:cNvPr>
@@ -11368,7 +11368,7 @@
           <p:cNvPr id="6" name="">
             <a:extLst xmlns:a="http://schemas.openxmlformats.org/drawingml/2006/main">
               <a:ext uri="{FF2B5EF4-FFF2-40B4-BE49-F238E27FC236}">
-                <a16:creationId xmlns:a16="http://schemas.microsoft.com/office/drawing/2014/main" id="{4B41A163-B0DE-4609-9CB9-0BBB7CBCDDF6}"/>
+                <a16:creationId xmlns:a16="http://schemas.microsoft.com/office/drawing/2014/main" id="{2E5C815E-EFA5-41C4-82E7-5CDDBF6DF328}"/>
               </a:ext>
             </a:extLst>
           </p:cNvPr>
@@ -11418,7 +11418,7 @@
           <p:cNvPr id="7" name="">
             <a:extLst xmlns:a="http://schemas.openxmlformats.org/drawingml/2006/main">
               <a:ext uri="{FF2B5EF4-FFF2-40B4-BE49-F238E27FC236}">
-                <a16:creationId xmlns:a16="http://schemas.microsoft.com/office/drawing/2014/main" id="{1990BBAB-F0B3-4450-940E-5CA18BC36CDD}"/>
+                <a16:creationId xmlns:a16="http://schemas.microsoft.com/office/drawing/2014/main" id="{A03BFB16-6F33-44A8-9826-B51B7BDF1E2D}"/>
               </a:ext>
             </a:extLst>
           </p:cNvPr>
@@ -11468,7 +11468,7 @@
           <p:cNvPr id="8" name="">
             <a:extLst xmlns:a="http://schemas.openxmlformats.org/drawingml/2006/main">
               <a:ext uri="{FF2B5EF4-FFF2-40B4-BE49-F238E27FC236}">
-                <a16:creationId xmlns:a16="http://schemas.microsoft.com/office/drawing/2014/main" id="{4F588676-7786-4C64-897B-5E61A096079B}"/>
+                <a16:creationId xmlns:a16="http://schemas.microsoft.com/office/drawing/2014/main" id="{0BB2C0C6-5B7E-46BE-8DA8-816473010E33}"/>
               </a:ext>
             </a:extLst>
           </p:cNvPr>
@@ -11501,7 +11501,7 @@
           <p:cNvPr id="9" name="">
             <a:extLst xmlns:a="http://schemas.openxmlformats.org/drawingml/2006/main">
               <a:ext uri="{FF2B5EF4-FFF2-40B4-BE49-F238E27FC236}">
-                <a16:creationId xmlns:a16="http://schemas.microsoft.com/office/drawing/2014/main" id="{6EF4CB8B-BFB5-4D71-BD04-F38514256A89}"/>
+                <a16:creationId xmlns:a16="http://schemas.microsoft.com/office/drawing/2014/main" id="{11C4680C-6017-4600-9ADE-26C07BCCE785}"/>
               </a:ext>
             </a:extLst>
           </p:cNvPr>
@@ -11551,7 +11551,7 @@
           <p:cNvPr id="10" name="">
             <a:extLst xmlns:a="http://schemas.openxmlformats.org/drawingml/2006/main">
               <a:ext uri="{FF2B5EF4-FFF2-40B4-BE49-F238E27FC236}">
-                <a16:creationId xmlns:a16="http://schemas.microsoft.com/office/drawing/2014/main" id="{E3F09D5D-CC05-4073-809C-B0098278E829}"/>
+                <a16:creationId xmlns:a16="http://schemas.microsoft.com/office/drawing/2014/main" id="{92066D55-E968-4EDE-BB16-DF2A77F51CCE}"/>
               </a:ext>
             </a:extLst>
           </p:cNvPr>
@@ -11601,7 +11601,7 @@
           <p:cNvPr id="11" name="">
             <a:extLst xmlns:a="http://schemas.openxmlformats.org/drawingml/2006/main">
               <a:ext uri="{FF2B5EF4-FFF2-40B4-BE49-F238E27FC236}">
-                <a16:creationId xmlns:a16="http://schemas.microsoft.com/office/drawing/2014/main" id="{5FCB401D-19F3-44B2-9B16-67A09A6239D9}"/>
+                <a16:creationId xmlns:a16="http://schemas.microsoft.com/office/drawing/2014/main" id="{852B1328-A15F-49DB-972A-59B82BC073B2}"/>
               </a:ext>
             </a:extLst>
           </p:cNvPr>
@@ -11634,7 +11634,7 @@
           <p:cNvPr id="12" name="">
             <a:extLst xmlns:a="http://schemas.openxmlformats.org/drawingml/2006/main">
               <a:ext uri="{FF2B5EF4-FFF2-40B4-BE49-F238E27FC236}">
-                <a16:creationId xmlns:a16="http://schemas.microsoft.com/office/drawing/2014/main" id="{C7D410F2-18C1-424B-BCEA-F09AD2BFF4DB}"/>
+                <a16:creationId xmlns:a16="http://schemas.microsoft.com/office/drawing/2014/main" id="{C6964C81-97E3-4E9B-A7C4-E0B5E175FDD6}"/>
               </a:ext>
             </a:extLst>
           </p:cNvPr>
@@ -11684,7 +11684,7 @@
           <p:cNvPr id="13" name="">
             <a:extLst xmlns:a="http://schemas.openxmlformats.org/drawingml/2006/main">
               <a:ext uri="{FF2B5EF4-FFF2-40B4-BE49-F238E27FC236}">
-                <a16:creationId xmlns:a16="http://schemas.microsoft.com/office/drawing/2014/main" id="{1C04044C-3DC9-4B25-B1C3-C73735225EC2}"/>
+                <a16:creationId xmlns:a16="http://schemas.microsoft.com/office/drawing/2014/main" id="{8B0620B2-B450-49AA-92D4-ED84A79A1216}"/>
               </a:ext>
             </a:extLst>
           </p:cNvPr>
@@ -11734,7 +11734,7 @@
           <p:cNvPr id="14" name="">
             <a:extLst xmlns:a="http://schemas.openxmlformats.org/drawingml/2006/main">
               <a:ext uri="{FF2B5EF4-FFF2-40B4-BE49-F238E27FC236}">
-                <a16:creationId xmlns:a16="http://schemas.microsoft.com/office/drawing/2014/main" id="{6DBBA4E9-C4EA-4280-9E5A-ACF52085FE28}"/>
+                <a16:creationId xmlns:a16="http://schemas.microsoft.com/office/drawing/2014/main" id="{EE7D169D-9D1B-41F0-9528-CDE3E0675486}"/>
               </a:ext>
             </a:extLst>
           </p:cNvPr>
@@ -11767,7 +11767,7 @@
           <p:cNvPr id="15" name="">
             <a:extLst xmlns:a="http://schemas.openxmlformats.org/drawingml/2006/main">
               <a:ext uri="{FF2B5EF4-FFF2-40B4-BE49-F238E27FC236}">
-                <a16:creationId xmlns:a16="http://schemas.microsoft.com/office/drawing/2014/main" id="{DD10E527-E85F-412B-AA8C-C060B3586B36}"/>
+                <a16:creationId xmlns:a16="http://schemas.microsoft.com/office/drawing/2014/main" id="{F765C4E8-85AC-4E28-8B12-C79DDDE38FAC}"/>
               </a:ext>
             </a:extLst>
           </p:cNvPr>
@@ -11817,7 +11817,7 @@
           <p:cNvPr id="16" name="">
             <a:extLst xmlns:a="http://schemas.openxmlformats.org/drawingml/2006/main">
               <a:ext uri="{FF2B5EF4-FFF2-40B4-BE49-F238E27FC236}">
-                <a16:creationId xmlns:a16="http://schemas.microsoft.com/office/drawing/2014/main" id="{14EDED99-3F68-4CD9-8F31-90BDE59CE511}"/>
+                <a16:creationId xmlns:a16="http://schemas.microsoft.com/office/drawing/2014/main" id="{A3252428-5EE5-44F4-8059-A4485197E467}"/>
               </a:ext>
             </a:extLst>
           </p:cNvPr>
@@ -11867,7 +11867,7 @@
           <p:cNvPr id="17" name="">
             <a:extLst xmlns:a="http://schemas.openxmlformats.org/drawingml/2006/main">
               <a:ext uri="{FF2B5EF4-FFF2-40B4-BE49-F238E27FC236}">
-                <a16:creationId xmlns:a16="http://schemas.microsoft.com/office/drawing/2014/main" id="{14114DD8-90F8-4500-8EE8-DB8FEBDEA86E}"/>
+                <a16:creationId xmlns:a16="http://schemas.microsoft.com/office/drawing/2014/main" id="{D9F29920-2A11-45D5-8EFF-A4CF6B57DADA}"/>
               </a:ext>
             </a:extLst>
           </p:cNvPr>
@@ -11900,7 +11900,7 @@
           <p:cNvPr id="18" name="">
             <a:extLst xmlns:a="http://schemas.openxmlformats.org/drawingml/2006/main">
               <a:ext uri="{FF2B5EF4-FFF2-40B4-BE49-F238E27FC236}">
-                <a16:creationId xmlns:a16="http://schemas.microsoft.com/office/drawing/2014/main" id="{E355BCA6-9117-4989-833B-267D858E7204}"/>
+                <a16:creationId xmlns:a16="http://schemas.microsoft.com/office/drawing/2014/main" id="{356A866C-CC5C-407E-A47A-CB4376588C2C}"/>
               </a:ext>
             </a:extLst>
           </p:cNvPr>
@@ -11950,7 +11950,7 @@
           <p:cNvPr id="19" name="">
             <a:extLst xmlns:a="http://schemas.openxmlformats.org/drawingml/2006/main">
               <a:ext uri="{FF2B5EF4-FFF2-40B4-BE49-F238E27FC236}">
-                <a16:creationId xmlns:a16="http://schemas.microsoft.com/office/drawing/2014/main" id="{D33A4AE8-DDB0-4853-A7E5-621FF374EF66}"/>
+                <a16:creationId xmlns:a16="http://schemas.microsoft.com/office/drawing/2014/main" id="{747A851E-D2E5-494E-B2A7-6272E4DE931F}"/>
               </a:ext>
             </a:extLst>
           </p:cNvPr>
@@ -12000,7 +12000,7 @@
           <p:cNvPr id="20" name="">
             <a:extLst xmlns:a="http://schemas.openxmlformats.org/drawingml/2006/main">
               <a:ext uri="{FF2B5EF4-FFF2-40B4-BE49-F238E27FC236}">
-                <a16:creationId xmlns:a16="http://schemas.microsoft.com/office/drawing/2014/main" id="{097E517C-0151-4C88-A6F5-E63EAFE4E6B6}"/>
+                <a16:creationId xmlns:a16="http://schemas.microsoft.com/office/drawing/2014/main" id="{8325A8B7-3223-4900-89D1-F0CC3811C871}"/>
               </a:ext>
             </a:extLst>
           </p:cNvPr>
@@ -12033,7 +12033,7 @@
           <p:cNvPr id="21" name="">
             <a:extLst xmlns:a="http://schemas.openxmlformats.org/drawingml/2006/main">
               <a:ext uri="{FF2B5EF4-FFF2-40B4-BE49-F238E27FC236}">
-                <a16:creationId xmlns:a16="http://schemas.microsoft.com/office/drawing/2014/main" id="{212B1608-8A22-4800-9E1B-067CFA832F24}"/>
+                <a16:creationId xmlns:a16="http://schemas.microsoft.com/office/drawing/2014/main" id="{48789570-8ABF-49B7-A59A-B5DDE615AFE7}"/>
               </a:ext>
             </a:extLst>
           </p:cNvPr>
@@ -12083,7 +12083,7 @@
           <p:cNvPr id="22" name="">
             <a:extLst xmlns:a="http://schemas.openxmlformats.org/drawingml/2006/main">
               <a:ext uri="{FF2B5EF4-FFF2-40B4-BE49-F238E27FC236}">
-                <a16:creationId xmlns:a16="http://schemas.microsoft.com/office/drawing/2014/main" id="{E2FCFDE0-3518-4212-827A-8D0625427A82}"/>
+                <a16:creationId xmlns:a16="http://schemas.microsoft.com/office/drawing/2014/main" id="{6CF862C7-4D31-47CB-A607-9C010286917E}"/>
               </a:ext>
             </a:extLst>
           </p:cNvPr>
@@ -12133,7 +12133,7 @@
           <p:cNvPr id="23" name="">
             <a:extLst xmlns:a="http://schemas.openxmlformats.org/drawingml/2006/main">
               <a:ext uri="{FF2B5EF4-FFF2-40B4-BE49-F238E27FC236}">
-                <a16:creationId xmlns:a16="http://schemas.microsoft.com/office/drawing/2014/main" id="{69CBB17F-5F97-4493-BCE9-B914E521A502}"/>
+                <a16:creationId xmlns:a16="http://schemas.microsoft.com/office/drawing/2014/main" id="{2BC24E9C-4244-48BF-A936-FE4FC12C594D}"/>
               </a:ext>
             </a:extLst>
           </p:cNvPr>
@@ -12183,7 +12183,7 @@
           <p:cNvPr id="24" name="">
             <a:extLst xmlns:a="http://schemas.openxmlformats.org/drawingml/2006/main">
               <a:ext uri="{FF2B5EF4-FFF2-40B4-BE49-F238E27FC236}">
-                <a16:creationId xmlns:a16="http://schemas.microsoft.com/office/drawing/2014/main" id="{5610DA31-BBE4-4AF2-953D-FDD4EF86B990}"/>
+                <a16:creationId xmlns:a16="http://schemas.microsoft.com/office/drawing/2014/main" id="{2DACAA98-0FE2-4847-8C91-756599119891}"/>
               </a:ext>
             </a:extLst>
           </p:cNvPr>
@@ -12233,7 +12233,7 @@
           <p:cNvPr id="25" name="">
             <a:extLst xmlns:a="http://schemas.openxmlformats.org/drawingml/2006/main">
               <a:ext uri="{FF2B5EF4-FFF2-40B4-BE49-F238E27FC236}">
-                <a16:creationId xmlns:a16="http://schemas.microsoft.com/office/drawing/2014/main" id="{CCBFB5E6-5A28-4091-90F0-04A4D9C20B3E}"/>
+                <a16:creationId xmlns:a16="http://schemas.microsoft.com/office/drawing/2014/main" id="{C37EFB2C-9DC1-4846-8458-AD6A6750CF94}"/>
               </a:ext>
             </a:extLst>
           </p:cNvPr>
@@ -12283,7 +12283,7 @@
           <p:cNvPr id="26" name="">
             <a:extLst xmlns:a="http://schemas.openxmlformats.org/drawingml/2006/main">
               <a:ext uri="{FF2B5EF4-FFF2-40B4-BE49-F238E27FC236}">
-                <a16:creationId xmlns:a16="http://schemas.microsoft.com/office/drawing/2014/main" id="{D77E436C-3F8D-405F-B1B5-59989B5A7EA1}"/>
+                <a16:creationId xmlns:a16="http://schemas.microsoft.com/office/drawing/2014/main" id="{2124F82A-C35F-4360-BE2C-0B6BF5560F32}"/>
               </a:ext>
             </a:extLst>
           </p:cNvPr>
@@ -12333,7 +12333,7 @@
           <p:cNvPr id="27" name="">
             <a:extLst xmlns:a="http://schemas.openxmlformats.org/drawingml/2006/main">
               <a:ext uri="{FF2B5EF4-FFF2-40B4-BE49-F238E27FC236}">
-                <a16:creationId xmlns:a16="http://schemas.microsoft.com/office/drawing/2014/main" id="{0963B7FA-203D-4D13-A630-697A59D2AD30}"/>
+                <a16:creationId xmlns:a16="http://schemas.microsoft.com/office/drawing/2014/main" id="{571B5EC6-4C64-4C0B-9A51-86FFDA964046}"/>
               </a:ext>
             </a:extLst>
           </p:cNvPr>
@@ -12383,7 +12383,7 @@
           <p:cNvPr id="28" name="">
             <a:extLst xmlns:a="http://schemas.openxmlformats.org/drawingml/2006/main">
               <a:ext uri="{FF2B5EF4-FFF2-40B4-BE49-F238E27FC236}">
-                <a16:creationId xmlns:a16="http://schemas.microsoft.com/office/drawing/2014/main" id="{A6F0AB5A-BE34-4B02-8C89-B4DCE5E8F63C}"/>
+                <a16:creationId xmlns:a16="http://schemas.microsoft.com/office/drawing/2014/main" id="{BD4EFABE-5DEB-4260-BBD9-13566F0AFB05}"/>
               </a:ext>
             </a:extLst>
           </p:cNvPr>
@@ -12433,7 +12433,7 @@
           <p:cNvPr id="29" name="">
             <a:extLst xmlns:a="http://schemas.openxmlformats.org/drawingml/2006/main">
               <a:ext uri="{FF2B5EF4-FFF2-40B4-BE49-F238E27FC236}">
-                <a16:creationId xmlns:a16="http://schemas.microsoft.com/office/drawing/2014/main" id="{E71B5479-D76C-4A06-8EFF-CAABCE409454}"/>
+                <a16:creationId xmlns:a16="http://schemas.microsoft.com/office/drawing/2014/main" id="{913D5B2B-1330-4EFF-8960-5F8B41F3C691}"/>
               </a:ext>
             </a:extLst>
           </p:cNvPr>
@@ -12483,7 +12483,7 @@
           <p:cNvPr id="30" name="">
             <a:extLst xmlns:a="http://schemas.openxmlformats.org/drawingml/2006/main">
               <a:ext uri="{FF2B5EF4-FFF2-40B4-BE49-F238E27FC236}">
-                <a16:creationId xmlns:a16="http://schemas.microsoft.com/office/drawing/2014/main" id="{BBA9A9FC-399C-49BE-A21C-D335BF244990}"/>
+                <a16:creationId xmlns:a16="http://schemas.microsoft.com/office/drawing/2014/main" id="{331B8DAB-2B81-463E-87F3-D50231AA1A68}"/>
               </a:ext>
             </a:extLst>
           </p:cNvPr>
@@ -12533,7 +12533,7 @@
           <p:cNvPr id="31" name="">
             <a:extLst xmlns:a="http://schemas.openxmlformats.org/drawingml/2006/main">
               <a:ext uri="{FF2B5EF4-FFF2-40B4-BE49-F238E27FC236}">
-                <a16:creationId xmlns:a16="http://schemas.microsoft.com/office/drawing/2014/main" id="{30E35364-73D9-47C7-9258-CE0A235F63DD}"/>
+                <a16:creationId xmlns:a16="http://schemas.microsoft.com/office/drawing/2014/main" id="{FC25B350-0252-4541-9633-0A51EE44AA7A}"/>
               </a:ext>
             </a:extLst>
           </p:cNvPr>
@@ -12583,7 +12583,7 @@
           <p:cNvPr id="32" name="">
             <a:extLst xmlns:a="http://schemas.openxmlformats.org/drawingml/2006/main">
               <a:ext uri="{FF2B5EF4-FFF2-40B4-BE49-F238E27FC236}">
-                <a16:creationId xmlns:a16="http://schemas.microsoft.com/office/drawing/2014/main" id="{D43A6CC9-E873-44AB-B840-BDF580B61E00}"/>
+                <a16:creationId xmlns:a16="http://schemas.microsoft.com/office/drawing/2014/main" id="{9472D220-30F0-44B6-880D-ABD8B5DE09D0}"/>
               </a:ext>
             </a:extLst>
           </p:cNvPr>
@@ -12633,7 +12633,7 @@
           <p:cNvPr id="33" name="">
             <a:extLst xmlns:a="http://schemas.openxmlformats.org/drawingml/2006/main">
               <a:ext uri="{FF2B5EF4-FFF2-40B4-BE49-F238E27FC236}">
-                <a16:creationId xmlns:a16="http://schemas.microsoft.com/office/drawing/2014/main" id="{9A811247-1C96-43D0-AE67-71CD31550C27}"/>
+                <a16:creationId xmlns:a16="http://schemas.microsoft.com/office/drawing/2014/main" id="{466EEB09-4651-4595-8FCF-EE42C32611FF}"/>
               </a:ext>
             </a:extLst>
           </p:cNvPr>
@@ -12683,7 +12683,7 @@
           <p:cNvPr id="34" name="">
             <a:extLst xmlns:a="http://schemas.openxmlformats.org/drawingml/2006/main">
               <a:ext uri="{FF2B5EF4-FFF2-40B4-BE49-F238E27FC236}">
-                <a16:creationId xmlns:a16="http://schemas.microsoft.com/office/drawing/2014/main" id="{9CBEAF49-07F9-4D75-8A2D-B87A0ADB077E}"/>
+                <a16:creationId xmlns:a16="http://schemas.microsoft.com/office/drawing/2014/main" id="{94A36EA1-C50B-4E00-88D3-9AE52E2F0190}"/>
               </a:ext>
             </a:extLst>
           </p:cNvPr>
@@ -12733,7 +12733,7 @@
           <p:cNvPr id="35" name="">
             <a:extLst xmlns:a="http://schemas.openxmlformats.org/drawingml/2006/main">
               <a:ext uri="{FF2B5EF4-FFF2-40B4-BE49-F238E27FC236}">
-                <a16:creationId xmlns:a16="http://schemas.microsoft.com/office/drawing/2014/main" id="{677ABAAE-D4CC-4503-ACA4-AF28EBE23C79}"/>
+                <a16:creationId xmlns:a16="http://schemas.microsoft.com/office/drawing/2014/main" id="{7E94C157-0CFF-4C4C-92A1-98CB79076672}"/>
               </a:ext>
             </a:extLst>
           </p:cNvPr>
@@ -12783,7 +12783,7 @@
           <p:cNvPr id="36" name="">
             <a:extLst xmlns:a="http://schemas.openxmlformats.org/drawingml/2006/main">
               <a:ext uri="{FF2B5EF4-FFF2-40B4-BE49-F238E27FC236}">
-                <a16:creationId xmlns:a16="http://schemas.microsoft.com/office/drawing/2014/main" id="{F1AA6BA7-B974-4007-A54C-4C815E0B75D0}"/>
+                <a16:creationId xmlns:a16="http://schemas.microsoft.com/office/drawing/2014/main" id="{78D8C0B6-AAF0-455C-872D-A4B2C0C91F35}"/>
               </a:ext>
             </a:extLst>
           </p:cNvPr>
@@ -12816,7 +12816,7 @@
           <p:cNvPr id="37" name="">
             <a:extLst xmlns:a="http://schemas.openxmlformats.org/drawingml/2006/main">
               <a:ext uri="{FF2B5EF4-FFF2-40B4-BE49-F238E27FC236}">
-                <a16:creationId xmlns:a16="http://schemas.microsoft.com/office/drawing/2014/main" id="{AB5F25FA-59D8-4095-98D2-F2EC2DEA47FD}"/>
+                <a16:creationId xmlns:a16="http://schemas.microsoft.com/office/drawing/2014/main" id="{7C466EAD-01E8-47CD-8C9E-411CD5448217}"/>
               </a:ext>
             </a:extLst>
           </p:cNvPr>
@@ -12866,7 +12866,7 @@
           <p:cNvPr id="38" name="">
             <a:extLst xmlns:a="http://schemas.openxmlformats.org/drawingml/2006/main">
               <a:ext uri="{FF2B5EF4-FFF2-40B4-BE49-F238E27FC236}">
-                <a16:creationId xmlns:a16="http://schemas.microsoft.com/office/drawing/2014/main" id="{755C3F38-DEC8-4576-937F-0538B4673298}"/>
+                <a16:creationId xmlns:a16="http://schemas.microsoft.com/office/drawing/2014/main" id="{27C471EC-AE51-4B0F-9CBA-FA96AF3AB6FD}"/>
               </a:ext>
             </a:extLst>
           </p:cNvPr>
@@ -12906,7 +12906,7 @@
                   <a:srgbClr val="111827"/>
                 </a:solidFill>
               </a:rPr>
-              <a:t>影片連結：________________________________________</a:t>
+              <a:t>影片連結：https://www.youtube.com/shorts/fV_7Foybtv8</a:t>
             </a:r>
           </a:p>
         </p:txBody>
@@ -12916,7 +12916,7 @@
           <p:cNvPr id="39" name="">
             <a:extLst xmlns:a="http://schemas.openxmlformats.org/drawingml/2006/main">
               <a:ext uri="{FF2B5EF4-FFF2-40B4-BE49-F238E27FC236}">
-                <a16:creationId xmlns:a16="http://schemas.microsoft.com/office/drawing/2014/main" id="{B249FFC8-346C-45C4-8EE5-8F48F490453C}"/>
+                <a16:creationId xmlns:a16="http://schemas.microsoft.com/office/drawing/2014/main" id="{A87E6233-B4E6-448E-9858-1C20C20C7815}"/>
               </a:ext>
             </a:extLst>
           </p:cNvPr>
@@ -12949,7 +12949,7 @@
           <p:cNvPr id="40" name="">
             <a:extLst xmlns:a="http://schemas.openxmlformats.org/drawingml/2006/main">
               <a:ext uri="{FF2B5EF4-FFF2-40B4-BE49-F238E27FC236}">
-                <a16:creationId xmlns:a16="http://schemas.microsoft.com/office/drawing/2014/main" id="{BD8DCC5E-A69E-41AE-990E-25A90AF79FB3}"/>
+                <a16:creationId xmlns:a16="http://schemas.microsoft.com/office/drawing/2014/main" id="{C643FD90-2AF9-4E05-B111-3066F2154743}"/>
               </a:ext>
             </a:extLst>
           </p:cNvPr>
@@ -13031,7 +13031,7 @@
     </p:spTree>
     <p:extLst>
       <p:ext uri="{BB962C8B-B14F-4D97-AF65-F5344CB8AC3E}">
-        <p14:creationId xmlns:p14="http://schemas.microsoft.com/office/powerpoint/2010/main" val="1404641921"/>
+        <p14:creationId xmlns:p14="http://schemas.microsoft.com/office/powerpoint/2010/main" val="2097778559"/>
       </p:ext>
     </p:extLst>
   </p:cSld>

</xml_diff>